<commit_message>
Plain-prose descriptions with euro equivalents, English-only titles, cover flags fit
Co-Authored-By: Claude Fable 5.1 <noreply@anthropic.com>
Claude-Session: https://claude.ai/code/session_01REVwghctKjYh8VQ919ThdA
</commit_message>
<xml_diff>
--- a/policies/Re-attracting_Former_Teachers.pptx
+++ b/policies/Re-attracting_Former_Teachers.pptx
@@ -609,7 +609,8 @@
             <a:r>
               <a:rPr lang="en-US" dirty="0"/>
               <a:t>Netherlands — Financial incentives — Target: Switchers, Leavers.
-Primary source: text of the 'Regeling tegemoetkoming herintreders primair onderwijs' on wetten.overheid.nl (BWBR0040130), plus the OCW newsletter of 3 July 2019 announcing a new application round. Conditions: appointment from 1 August 2017, contract of at least six months, no work as a primary-school teacher in the 12 months before appointment; grant of up to EUR 2,500 per returner paid to the school board for guidance and support costs; EUR 1.25 million available until 31 December 2018 (max. 500 returners).</a:t>
+Primary source: text of the 'Regeling tegemoetkoming herintreders primair onderwijs' on wetten.overheid.nl (BWBR0040130), plus the OCW newsletter of 3 July 2019 announcing a new application round. Conditions: appointment from 1 August 2017, contract of at least six months, no work as a primary-school teacher in the 12 months before appointment; grant of up to EUR 2,500 per returner paid to the school board for guidance and support costs; EUR 1.25 million available until 31 December 2018 (max. 500 returners).
+Euro amounts in brackets are approximate conversions, rounded, for orientation only.</a:t>
             </a:r>
             <a:endParaRPr lang="en-US" dirty="0"/>
           </a:p>
@@ -698,7 +699,8 @@
             <a:r>
               <a:rPr lang="en-US" dirty="0"/>
               <a:t>New Zealand — Flexible re-certification — Target: Switchers, Leavers.
-Sources: Ministry of Education 'Education Workforce' page 'Returning to teaching after a break' (no TER required even after five or more years away when there is a job offer; 20 half-days of relief teaching allowed while renewing; fees and levies covered until 30 June 2028) and the Government press release 'Backing teachers: Teacher registrations funded' (352 teachers supported to return since October 2024; NZD 53.3 million over three financial years from 1 July 2025).</a:t>
+Sources: Ministry of Education 'Education Workforce' page 'Returning to teaching after a break' (no TER required even after five or more years away when there is a job offer; 20 half-days of relief teaching allowed while renewing; fees and levies covered until 30 June 2028) and the Government press release 'Backing teachers: Teacher registrations funded' (352 teachers supported to return since October 2024; NZD 53.3 million over three financial years from 1 July 2025).
+Euro amounts in brackets are approximate conversions, rounded, for orientation only.</a:t>
             </a:r>
             <a:endParaRPr lang="en-US" dirty="0"/>
           </a:p>
@@ -787,7 +789,8 @@
             <a:r>
               <a:rPr lang="en-US" dirty="0"/>
               <a:t>Portugal — Financial incentives — Target: Retired.
-Primary sources: Decreto-Lei n.º 51/2024 of 28 August (Diário da República) and DGAE notice on the procedure for assigning teaching service to retired teachers. Key provisions: fixed-term public-employment contracts with retired/pensioned teachers holding professional qualification, for shortage recruitment groups or under-staffed schools, with authorisation from the member of Government responsible for education; not applicable to those retired for more than five years; annual quota fixed by joint order (Finance, Public Administration, Education); pension maintained plus an additional payment corresponding to the 1st index of the salary scale according to weekly teaching hours. The figure of 62 retirees comes from Público, 5 November 2024 (press source).</a:t>
+Primary sources: Decreto-Lei n.º 51/2024 of 28 August (Diário da República) and DGAE notice on the procedure for assigning teaching service to retired teachers. Key provisions: fixed-term public-employment contracts with retired/pensioned teachers holding professional qualification, for shortage recruitment groups or under-staffed schools, with authorisation from the member of Government responsible for education; not applicable to those retired for more than five years; annual quota fixed by joint order (Finance, Public Administration, Education); pension maintained plus an additional payment corresponding to the 1st index of the salary scale according to weekly teaching hours. The figure of 62 retirees comes from Público, 5 November 2024 (press source).
+Euro amounts in brackets are approximate conversions, rounded, for orientation only.</a:t>
             </a:r>
             <a:endParaRPr lang="en-US" dirty="0"/>
           </a:p>
@@ -876,7 +879,8 @@
             <a:r>
               <a:rPr lang="en-US" dirty="0"/>
               <a:t>Singapore — Flexible positions — Target: Switchers, Leavers, Retired.
-Sources: MOE careers page for the Flexi-Adjunct Teaching Scheme (qualification: PGDE or Diploma in Education from NIE, other professional teaching qualifications considered; appointments from 1 day to 10 weeks; teaching or mixed duties; pro-rated leave after 90 days of cumulative service; registration via the Relief Employment Management System) and MOE parliamentary reply of 23 September 2025 (2022-2024: around 220 teachers on average engaged as Flexi-Adjunct Teachers within 12 months of leaving the Education Service). Launch year of the scheme not stated on the page.</a:t>
+Sources: MOE careers page for the Flexi-Adjunct Teaching Scheme (qualification: PGDE or Diploma in Education from NIE, other professional teaching qualifications considered; appointments from 1 day to 10 weeks; teaching or mixed duties; pro-rated leave after 90 days of cumulative service; registration via the Relief Employment Management System) and MOE parliamentary reply of 23 September 2025 (2022-2024: around 220 teachers on average engaged as Flexi-Adjunct Teachers within 12 months of leaving the Education Service). Launch year of the scheme not stated on the page.
+Euro amounts in brackets are approximate conversions, rounded, for orientation only.</a:t>
             </a:r>
             <a:endParaRPr lang="en-US" dirty="0"/>
           </a:p>
@@ -965,7 +969,8 @@
             <a:r>
               <a:rPr lang="en-US" dirty="0"/>
               <a:t>Sweden — Support &amp; training — Target: Switchers, Leavers.
-Sources: Skolverket course page 'Återvändande lärare och förskollärare – webbaserad utbildning' (available since October 2018; two tracks; participants choose modules; certificate per module; aimed at returners with legitimation or a qualifying degree) and Skolverket's 2020 report on the government assignment. No participation figures found on the pages.</a:t>
+Sources: Skolverket course page 'Återvändande lärare och förskollärare – webbaserad utbildning' (available since October 2018; two tracks; participants choose modules; certificate per module; aimed at returners with legitimation or a qualifying degree) and Skolverket's 2020 report on the government assignment. No participation figures found on the pages.
+Euro amounts in brackets are approximate conversions, rounded, for orientation only.</a:t>
             </a:r>
             <a:endParaRPr lang="en-US" dirty="0"/>
           </a:p>
@@ -1054,7 +1059,8 @@
             <a:r>
               <a:rPr lang="en-US" dirty="0"/>
               <a:t>Switzerland (Canton of Zurich) — Support &amp; training — Target: Switchers, Leavers.
-Source: PH Zürich 'Wiedereinstieg' page (with the Wiedereinstiegsberatung offer). Teachers returning after at least eight years can use the induction (Berufseinführung) offer free of charge in their first school year, with financial participation of the Volksschulamt of the Canton of Zurich; the positioning assessment is subsidised by the Volksschulamt (first hour free, hours 2-6 charged); workplace mentoring (Fachbegleitung) up to 25 hours. No take-up figures published on the page.</a:t>
+Source: PH Zürich 'Wiedereinstieg' page (with the Wiedereinstiegsberatung offer). Teachers returning after at least eight years can use the induction (Berufseinführung) offer free of charge in their first school year, with financial participation of the Volksschulamt of the Canton of Zurich; the positioning assessment is subsidised by the Volksschulamt (first hour free, hours 2-6 charged); workplace mentoring (Fachbegleitung) up to 25 hours. No take-up figures published on the page.
+Euro amounts in brackets are approximate conversions, rounded, for orientation only.</a:t>
             </a:r>
             <a:endParaRPr lang="en-US" dirty="0"/>
           </a:p>
@@ -1143,7 +1149,8 @@
             <a:r>
               <a:rPr lang="en-US" dirty="0"/>
               <a:t>United Kingdom (England) — Information &amp; nudges — Target: Switchers, Leavers.
-Sources: DfE 'Get Into Teaching' page 'Get support returning to teaching' (eligibility: previously taught or trained to teach in the UK; free one-to-one support with applications, courses such as NPQs, vacancies, webinars) and the House of Commons Education Committee report 'Teacher recruitment, training and retention' (returners 35-40% of entrants in recent years; about 17,500 FTE qualified returners in 2023, 38% of qualified entrants). The January 2022 'Come back to teaching' campaign is documented by local-authority pages (e.g. Warwickshire County Council).</a:t>
+Sources: DfE 'Get Into Teaching' page 'Get support returning to teaching' (eligibility: previously taught or trained to teach in the UK; free one-to-one support with applications, courses such as NPQs, vacancies, webinars) and the House of Commons Education Committee report 'Teacher recruitment, training and retention' (returners 35-40% of entrants in recent years; about 17,500 FTE qualified returners in 2023, 38% of qualified entrants). The January 2022 'Come back to teaching' campaign is documented by local-authority pages (e.g. Warwickshire County Council).
+Euro amounts in brackets are approximate conversions, rounded, for orientation only.</a:t>
             </a:r>
             <a:endParaRPr lang="en-US" dirty="0"/>
           </a:p>
@@ -1232,7 +1239,8 @@
             <a:r>
               <a:rPr lang="en-US" dirty="0"/>
               <a:t>United States (Georgia) — Financial incentives — Target: Retired.
-Sources: Teachers Retirement System of Georgia 'HB 385 Employment' page (30+ years of service, retired for one year, full-time classroom teacher in a highest-need area determined by the RESA, effective 1 July 2022 to 30 June 2026, employer pays contributions, no additional creditable service; HB 385 sunsets 30 June 2026 and SB 150 was passed in the 2026 session) and the Georgia Department of Audits and Accounts report 'Retired Teachers Return to Work' (about 350 full-time retirees employed each year, less than 1% of the workforce), summarised by Georgia Public Broadcasting, 7 May 2025.</a:t>
+Sources: Teachers Retirement System of Georgia 'HB 385 Employment' page (30+ years of service, retired for one year, full-time classroom teacher in a highest-need area determined by the RESA, effective 1 July 2022 to 30 June 2026, employer pays contributions, no additional creditable service; HB 385 sunsets 30 June 2026 and SB 150 was passed in the 2026 session) and the Georgia Department of Audits and Accounts report 'Retired Teachers Return to Work' (about 350 full-time retirees employed each year, less than 1% of the workforce), summarised by Georgia Public Broadcasting, 7 May 2025.
+Euro amounts in brackets are approximate conversions, rounded, for orientation only.</a:t>
             </a:r>
             <a:endParaRPr lang="en-US" dirty="0"/>
           </a:p>
@@ -1321,7 +1329,8 @@
             <a:r>
               <a:rPr lang="en-US" dirty="0"/>
               <a:t>United States (Colorado) — Flexible positions — Target: Retired.
-Source: Institute of Education Sciences, REL Central, 'Impacts of the Retired Mentors for New Teachers program' (DeCesare, McClelland &amp; Randel, 2017, REL 2017-225). Design: 77 classroom teachers across 11 schools randomly assigned to mentoring by retired, highly effective district educators or to the district's business-as-usual mentoring. Results: no effect on retention; effect size 0.06 on maths achievement (significant at end of year one, not at end of year two); no effect on reading. Programme start year not stated on the summary page.</a:t>
+Source: Institute of Education Sciences, REL Central, 'Impacts of the Retired Mentors for New Teachers program' (DeCesare, McClelland &amp; Randel, 2017, REL 2017-225). Design: 77 classroom teachers across 11 schools randomly assigned to mentoring by retired, highly effective district educators or to the district's business-as-usual mentoring. Results: no effect on retention; effect size 0.06 on maths achievement (significant at end of year one, not at end of year two); no effect on reading. Programme start year not stated on the summary page.
+Euro amounts in brackets are approximate conversions, rounded, for orientation only.</a:t>
             </a:r>
             <a:endParaRPr lang="en-US" dirty="0"/>
           </a:p>
@@ -1586,7 +1595,8 @@
             <a:r>
               <a:rPr lang="en-US" dirty="0"/>
               <a:t>Australia (Victoria) — Support &amp; training — Target: Switchers, Leavers, Retired.
-Secondary instruments: financial (honorarium up to AUD 12,000) and information/nudges (re-engagement team contacts every registrant). Eligibility: VIT registration or Working with Children Check. Teachers returning from extended parental absence instead get a temporary resumption of up to 40 days on their substantive salary. Extra reference: Victorian Government 'Support for returning teachers' page, https://www.vic.gov.au/returning-teacher-support-services</a:t>
+Secondary instruments: financial (honorarium up to AUD 12,000) and information/nudges (re-engagement team contacts every registrant). Eligibility: VIT registration or Working with Children Check. Teachers returning from extended parental absence instead get a temporary resumption of up to 40 days on their substantive salary. Extra reference: Victorian Government 'Support for returning teachers' page, https://www.vic.gov.au/returning-teacher-support-services
+Euro amounts in brackets are approximate conversions, rounded, for orientation only.</a:t>
             </a:r>
             <a:endParaRPr lang="en-US" dirty="0"/>
           </a:p>
@@ -1675,7 +1685,8 @@
             <a:r>
               <a:rPr lang="en-US" dirty="0"/>
               <a:t>Canada (Quebec) — Financial incentives — Target: Retired.
-Primary source: Gouvernement du Québec page 'Retour à l'emploi des retraités du réseau de l'éducation' (incentive introduced 21 September 2020, made permanent; 700 retirees in 2020-21; pay at the scale held at departure from day one; daily maximum about CAD 412 vs CAD 212.15 usual substitute rate; no penalty on pension). The 2023 letter (signed 25 August 2023 by Minister Bernard Drainville), the 5,000+ figure and the CAD 578 daily incentive for retirees at the top of the scale on contracts of at least one month are reported by Le Devoir (press source).</a:t>
+Primary source: Gouvernement du Québec page 'Retour à l'emploi des retraités du réseau de l'éducation' (incentive introduced 21 September 2020, made permanent; 700 retirees in 2020-21; pay at the scale held at departure from day one; daily maximum about CAD 412 vs CAD 212.15 usual substitute rate; no penalty on pension). The 2023 letter (signed 25 August 2023 by Minister Bernard Drainville), the 5,000+ figure and the CAD 578 daily incentive for retirees at the top of the scale on contracts of at least one month are reported by Le Devoir (press source).
+Euro amounts in brackets are approximate conversions, rounded, for orientation only.</a:t>
             </a:r>
             <a:endParaRPr lang="en-US" dirty="0"/>
           </a:p>
@@ -1764,7 +1775,8 @@
             <a:r>
               <a:rPr lang="en-US" dirty="0"/>
               <a:t>China — Flexible positions — Target: Retired.
-Primary sources: MoE/MoF notice of 19 July 2018 issuing the implementation plan (eligibility: mainly principals, teaching researchers, special-grade and backbone teachers, generally 65 or under; 10,000 recruits planned 2018-2020; first cohort autumn 2018), and the 2024 implementation notice (7,000 recruits; central funding of CNY 20,000 per person per year at compulsory-education level, used for work stipend, travel and accident insurance). The 2023 National Silver-Age Teachers Action Plan (10 ministries) sets a target of roughly 120,000 silver-age teachers across all education levels within about three years.</a:t>
+Primary sources: MoE/MoF notice of 19 July 2018 issuing the implementation plan (eligibility: mainly principals, teaching researchers, special-grade and backbone teachers, generally 65 or under; 10,000 recruits planned 2018-2020; first cohort autumn 2018), and the 2024 implementation notice (7,000 recruits; central funding of CNY 20,000 per person per year at compulsory-education level, used for work stipend, travel and accident insurance). The 2023 National Silver-Age Teachers Action Plan (10 ministries) sets a target of roughly 120,000 silver-age teachers across all education levels within about three years.
+Euro amounts in brackets are approximate conversions, rounded, for orientation only.</a:t>
             </a:r>
             <a:endParaRPr lang="en-US" dirty="0"/>
           </a:p>
@@ -1853,7 +1865,8 @@
             <a:r>
               <a:rPr lang="en-US" dirty="0"/>
               <a:t>Germany (Lower Saxony) — Financial incentives — Target: Retired.
-Sources: Lower Saxony Ministry of Education press releases. The 2022 release (Lehrkräfte-Gewinnungspaket) reports the Landtag decision to raise the Hinzuverdienstgrenze from 125% to 150% of pensionable pay from 1 October 2022, initially limited to two years, letting pensioned teachers teach on average 9-10 hours without pension reduction, plus a 15% rise in overtime pay. The 2024/25 release states that the earnings ceiling for pensioned teachers was removed as of 31 October 2024. Context: a 2023 survey by Deutsches Schulportal found that 13 of 16 Länder actively approach retired teachers and that more than 5,000 teachers nationwide had been won to stay or return (https://deutsches-schulportal.de/bildungswesen/laenderueberblick-umfrage-lehrermangel-pensionierte-lehrer/).</a:t>
+Sources: Lower Saxony Ministry of Education press releases. The 2022 release (Lehrkräfte-Gewinnungspaket) reports the Landtag decision to raise the Hinzuverdienstgrenze from 125% to 150% of pensionable pay from 1 October 2022, initially limited to two years, letting pensioned teachers teach on average 9-10 hours without pension reduction, plus a 15% rise in overtime pay. The 2024/25 release states that the earnings ceiling for pensioned teachers was removed as of 31 October 2024. Context: a 2023 survey by Deutsches Schulportal found that 13 of 16 Länder actively approach retired teachers and that more than 5,000 teachers nationwide had been won to stay or return (https://deutsches-schulportal.de/bildungswesen/laenderueberblick-umfrage-lehrermangel-pensionierte-lehrer/).
+Euro amounts in brackets are approximate conversions, rounded, for orientation only.</a:t>
             </a:r>
             <a:endParaRPr lang="en-US" dirty="0"/>
           </a:p>
@@ -1942,7 +1955,8 @@
             <a:r>
               <a:rPr lang="en-US" dirty="0"/>
               <a:t>Germany (Lower Saxony) — Information &amp; nudges — Target: Retired.
-Source: Ministry press release 'Umfangreicher Erfahrungsschatz – Kultusministerin Hamburg informiert Lehrkräfte kurz vor dem Ruhestand über Möglichkeiten der Weiterbeschäftigung' and the letter itself (PDF). The information sheet ('Anlage zum Brief') covers staying in service (deferral of up to three years for civil servants, on application before the end of the preceding school half-year) and fixed-term re-employment under the collective agreement immediately after retirement. This matches the 'leaflet with the retirement paperwork' type of nudge.</a:t>
+Source: Ministry press release 'Umfangreicher Erfahrungsschatz – Kultusministerin Hamburg informiert Lehrkräfte kurz vor dem Ruhestand über Möglichkeiten der Weiterbeschäftigung' and the letter itself (PDF). The information sheet ('Anlage zum Brief') covers staying in service (deferral of up to three years for civil servants, on application before the end of the preceding school half-year) and fixed-term re-employment under the collective agreement immediately after retirement. This matches the 'leaflet with the retirement paperwork' type of nudge.
+Euro amounts in brackets are approximate conversions, rounded, for orientation only.</a:t>
             </a:r>
             <a:endParaRPr lang="en-US" dirty="0"/>
           </a:p>
@@ -2031,7 +2045,8 @@
             <a:r>
               <a:rPr lang="en-US" dirty="0"/>
               <a:t>Ireland — Financial incentives — Target: Retired.
-Source: Department of Education (gov.ie) 'Working as a substitute while receiving a teacher's pension'. Circular numbers (0003/2021, 04/2024, 17/2026) as cited by the Department and by the Retired Teachers' Association of Ireland (https://rtaireland.ie/pension-abatement/). Abatement applies only where earnings plus pension exceed pensionable pay at retirement (uprated); it stops as soon as the retiree stops working.</a:t>
+Source: Department of Education (gov.ie) 'Working as a substitute while receiving a teacher's pension'. Circular numbers (0003/2021, 04/2024, 17/2026) as cited by the Department and by the Retired Teachers' Association of Ireland (https://rtaireland.ie/pension-abatement/). Abatement applies only where earnings plus pension exceed pensionable pay at retirement (uprated); it stops as soon as the retiree stops working.
+Euro amounts in brackets are approximate conversions, rounded, for orientation only.</a:t>
             </a:r>
             <a:endParaRPr lang="en-US" dirty="0"/>
           </a:p>
@@ -2120,7 +2135,8 @@
             <a:r>
               <a:rPr lang="en-US" dirty="0"/>
               <a:t>Japan — Flexible re-certification — Target: Switchers, Leavers.
-Sources: MEXT explanatory document on the abolition of the licence renewal system (licences valid on 1 July 2022, including dormant ones, become licences without expiry, no procedure needed) and Saitama Prefectural Board of Education 'paper teacher seminar' page. The counts of boards of education running paper-teacher programmes (50 in FY2023, 58 planned in FY2024, about 70%) are MEXT figures reported by AERA (press source); treat as indicative. MEXT archive on the former renewal system: https://www.mext.go.jp/a_menu/shotou/koushin/</a:t>
+Sources: MEXT explanatory document on the abolition of the licence renewal system (licences valid on 1 July 2022, including dormant ones, become licences without expiry, no procedure needed) and Saitama Prefectural Board of Education 'paper teacher seminar' page. The counts of boards of education running paper-teacher programmes (50 in FY2023, 58 planned in FY2024, about 70%) are MEXT figures reported by AERA (press source); treat as indicative. MEXT archive on the former renewal system: https://www.mext.go.jp/a_menu/shotou/koushin/
+Euro amounts in brackets are approximate conversions, rounded, for orientation only.</a:t>
             </a:r>
             <a:endParaRPr lang="en-US" dirty="0"/>
           </a:p>
@@ -2626,8 +2642,8 @@
         </p:blipFill>
         <p:spPr>
           <a:xfrm>
-            <a:off x="-26060" y="5074920"/>
-            <a:ext cx="713232" cy="534924"/>
+            <a:off x="655168" y="5074920"/>
+            <a:ext cx="658368" cy="493776"/>
           </a:xfrm>
           <a:prstGeom prst="rect">
             <a:avLst/>
@@ -2650,8 +2666,8 @@
         </p:blipFill>
         <p:spPr>
           <a:xfrm>
-            <a:off x="860908" y="5074920"/>
-            <a:ext cx="713232" cy="534924"/>
+            <a:off x="1441552" y="5074920"/>
+            <a:ext cx="658368" cy="493776"/>
           </a:xfrm>
           <a:prstGeom prst="rect">
             <a:avLst/>
@@ -2674,8 +2690,8 @@
         </p:blipFill>
         <p:spPr>
           <a:xfrm>
-            <a:off x="1747876" y="5074920"/>
-            <a:ext cx="713232" cy="534924"/>
+            <a:off x="2227936" y="5074920"/>
+            <a:ext cx="658368" cy="493776"/>
           </a:xfrm>
           <a:prstGeom prst="rect">
             <a:avLst/>
@@ -2698,8 +2714,8 @@
         </p:blipFill>
         <p:spPr>
           <a:xfrm>
-            <a:off x="2634844" y="5074920"/>
-            <a:ext cx="713232" cy="534924"/>
+            <a:off x="3014320" y="5074920"/>
+            <a:ext cx="658368" cy="493776"/>
           </a:xfrm>
           <a:prstGeom prst="rect">
             <a:avLst/>
@@ -2722,8 +2738,8 @@
         </p:blipFill>
         <p:spPr>
           <a:xfrm>
-            <a:off x="3521812" y="5074920"/>
-            <a:ext cx="713232" cy="534924"/>
+            <a:off x="3800704" y="5074920"/>
+            <a:ext cx="658368" cy="493776"/>
           </a:xfrm>
           <a:prstGeom prst="rect">
             <a:avLst/>
@@ -2746,8 +2762,8 @@
         </p:blipFill>
         <p:spPr>
           <a:xfrm>
-            <a:off x="4408780" y="5074920"/>
-            <a:ext cx="713232" cy="534924"/>
+            <a:off x="4587088" y="5074920"/>
+            <a:ext cx="658368" cy="493776"/>
           </a:xfrm>
           <a:prstGeom prst="rect">
             <a:avLst/>
@@ -2770,8 +2786,8 @@
         </p:blipFill>
         <p:spPr>
           <a:xfrm>
-            <a:off x="5295748" y="5074920"/>
-            <a:ext cx="713232" cy="534924"/>
+            <a:off x="5373472" y="5074920"/>
+            <a:ext cx="658368" cy="493776"/>
           </a:xfrm>
           <a:prstGeom prst="rect">
             <a:avLst/>
@@ -2794,8 +2810,8 @@
         </p:blipFill>
         <p:spPr>
           <a:xfrm>
-            <a:off x="6182716" y="5074920"/>
-            <a:ext cx="713232" cy="534924"/>
+            <a:off x="6159856" y="5074920"/>
+            <a:ext cx="658368" cy="493776"/>
           </a:xfrm>
           <a:prstGeom prst="rect">
             <a:avLst/>
@@ -2818,8 +2834,8 @@
         </p:blipFill>
         <p:spPr>
           <a:xfrm>
-            <a:off x="7069684" y="5074920"/>
-            <a:ext cx="713232" cy="534924"/>
+            <a:off x="6946240" y="5074920"/>
+            <a:ext cx="658368" cy="493776"/>
           </a:xfrm>
           <a:prstGeom prst="rect">
             <a:avLst/>
@@ -2842,8 +2858,8 @@
         </p:blipFill>
         <p:spPr>
           <a:xfrm>
-            <a:off x="7956652" y="5074920"/>
-            <a:ext cx="713232" cy="534924"/>
+            <a:off x="7732624" y="5074920"/>
+            <a:ext cx="658368" cy="493776"/>
           </a:xfrm>
           <a:prstGeom prst="rect">
             <a:avLst/>
@@ -2866,8 +2882,8 @@
         </p:blipFill>
         <p:spPr>
           <a:xfrm>
-            <a:off x="8843620" y="5074920"/>
-            <a:ext cx="713232" cy="534924"/>
+            <a:off x="8519008" y="5074920"/>
+            <a:ext cx="658368" cy="493776"/>
           </a:xfrm>
           <a:prstGeom prst="rect">
             <a:avLst/>
@@ -2890,8 +2906,8 @@
         </p:blipFill>
         <p:spPr>
           <a:xfrm>
-            <a:off x="9730588" y="5074920"/>
-            <a:ext cx="713232" cy="534924"/>
+            <a:off x="9305392" y="5074920"/>
+            <a:ext cx="658368" cy="493776"/>
           </a:xfrm>
           <a:prstGeom prst="rect">
             <a:avLst/>
@@ -2914,8 +2930,8 @@
         </p:blipFill>
         <p:spPr>
           <a:xfrm>
-            <a:off x="10617556" y="5074920"/>
-            <a:ext cx="713232" cy="534924"/>
+            <a:off x="10091776" y="5074920"/>
+            <a:ext cx="658368" cy="493776"/>
           </a:xfrm>
           <a:prstGeom prst="rect">
             <a:avLst/>
@@ -2938,8 +2954,8 @@
         </p:blipFill>
         <p:spPr>
           <a:xfrm>
-            <a:off x="11504524" y="5074920"/>
-            <a:ext cx="713232" cy="534924"/>
+            <a:off x="10878160" y="5074920"/>
+            <a:ext cx="658368" cy="493776"/>
           </a:xfrm>
           <a:prstGeom prst="rect">
             <a:avLst/>
@@ -3277,7 +3293,7 @@
                 <a:ea typeface="Cambria" pitchFamily="34" charset="-122"/>
                 <a:cs typeface="Cambria" pitchFamily="34" charset="-120"/>
               </a:rPr>
-              <a:t>Regeling tegemoetkoming herintreders primair onderwijs (2017–2020)</a:t>
+              <a:t>Grant to primary schools for re-hiring former teachers, 2017–2020</a:t>
             </a:r>
             <a:endParaRPr lang="en-US" sz="2100" dirty="0"/>
           </a:p>
@@ -3306,15 +3322,12 @@
           <a:p>
             <a:pPr indent="0" marL="0">
               <a:lnSpc>
-                <a:spcPct val="104000"/>
+                <a:spcPct val="106000"/>
               </a:lnSpc>
-              <a:spcAft>
-                <a:spcPts val="400"/>
-              </a:spcAft>
-              <a:buNone/>
-            </a:pPr>
-            <a:r>
-              <a:rPr lang="en-US" sz="1500" b="1" dirty="0">
+              <a:buNone/>
+            </a:pPr>
+            <a:r>
+              <a:rPr lang="en-US" sz="1500" dirty="0">
                 <a:solidFill>
                   <a:srgbClr val="24313A"/>
                 </a:solidFill>
@@ -3322,156 +3335,7 @@
                 <a:ea typeface="Calibri" pitchFamily="34" charset="-122"/>
                 <a:cs typeface="Calibri" pitchFamily="34" charset="-120"/>
               </a:rPr>
-              <a:t>What it is: </a:t>
-            </a:r>
-            <a:pPr indent="0" marL="0">
-              <a:lnSpc>
-                <a:spcPct val="104000"/>
-              </a:lnSpc>
-              <a:spcAft>
-                <a:spcPts val="400"/>
-              </a:spcAft>
-              <a:buNone/>
-            </a:pPr>
-            <a:r>
-              <a:rPr lang="en-US" sz="1500" dirty="0">
-                <a:solidFill>
-                  <a:srgbClr val="24313A"/>
-                </a:solidFill>
-                <a:latin typeface="Calibri" pitchFamily="34" charset="0"/>
-                <a:ea typeface="Calibri" pitchFamily="34" charset="-122"/>
-                <a:cs typeface="Calibri" pitchFamily="34" charset="-120"/>
-              </a:rPr>
-              <a:t>A grant to primary schools for every former teacher they re-hire, paid by the Ministry of Education (OCW).</a:t>
-            </a:r>
-            <a:endParaRPr lang="en-US" sz="1500" dirty="0"/>
-          </a:p>
-          <a:p>
-            <a:pPr indent="0" marL="0">
-              <a:lnSpc>
-                <a:spcPct val="104000"/>
-              </a:lnSpc>
-              <a:spcAft>
-                <a:spcPts val="400"/>
-              </a:spcAft>
-              <a:buNone/>
-            </a:pPr>
-            <a:r>
-              <a:rPr lang="en-US" sz="1500" b="1" dirty="0">
-                <a:solidFill>
-                  <a:srgbClr val="24313A"/>
-                </a:solidFill>
-                <a:latin typeface="Calibri" pitchFamily="34" charset="0"/>
-                <a:ea typeface="Calibri" pitchFamily="34" charset="-122"/>
-                <a:cs typeface="Calibri" pitchFamily="34" charset="-120"/>
-              </a:rPr>
-              <a:t>How it works: </a:t>
-            </a:r>
-            <a:pPr indent="0" marL="0">
-              <a:lnSpc>
-                <a:spcPct val="104000"/>
-              </a:lnSpc>
-              <a:spcAft>
-                <a:spcPts val="400"/>
-              </a:spcAft>
-              <a:buNone/>
-            </a:pPr>
-            <a:r>
-              <a:rPr lang="en-US" sz="1500" dirty="0">
-                <a:solidFill>
-                  <a:srgbClr val="24313A"/>
-                </a:solidFill>
-                <a:latin typeface="Calibri" pitchFamily="34" charset="0"/>
-                <a:ea typeface="Calibri" pitchFamily="34" charset="-122"/>
-                <a:cs typeface="Calibri" pitchFamily="34" charset="-120"/>
-              </a:rPr>
-              <a:t>A school board that hires a ‘herintreder’ (a qualified teacher who had not taught in primary education for 12+ months) on a contract of at least six months applies for the grant and uses it for the returner's guidance and support (coaching, refresher training) in the first months.</a:t>
-            </a:r>
-            <a:endParaRPr lang="en-US" sz="1500" dirty="0"/>
-          </a:p>
-          <a:p>
-            <a:pPr indent="0" marL="0">
-              <a:lnSpc>
-                <a:spcPct val="104000"/>
-              </a:lnSpc>
-              <a:spcAft>
-                <a:spcPts val="400"/>
-              </a:spcAft>
-              <a:buNone/>
-            </a:pPr>
-            <a:r>
-              <a:rPr lang="en-US" sz="1500" b="1" dirty="0">
-                <a:solidFill>
-                  <a:srgbClr val="24313A"/>
-                </a:solidFill>
-                <a:latin typeface="Calibri" pitchFamily="34" charset="0"/>
-                <a:ea typeface="Calibri" pitchFamily="34" charset="-122"/>
-                <a:cs typeface="Calibri" pitchFamily="34" charset="-120"/>
-              </a:rPr>
-              <a:t>Means: </a:t>
-            </a:r>
-            <a:pPr indent="0" marL="0">
-              <a:lnSpc>
-                <a:spcPct val="104000"/>
-              </a:lnSpc>
-              <a:spcAft>
-                <a:spcPts val="400"/>
-              </a:spcAft>
-              <a:buNone/>
-            </a:pPr>
-            <a:r>
-              <a:rPr lang="en-US" sz="1500" dirty="0">
-                <a:solidFill>
-                  <a:srgbClr val="24313A"/>
-                </a:solidFill>
-                <a:latin typeface="Calibri" pitchFamily="34" charset="0"/>
-                <a:ea typeface="Calibri" pitchFamily="34" charset="-122"/>
-                <a:cs typeface="Calibri" pitchFamily="34" charset="-120"/>
-              </a:rPr>
-              <a:t>Up to EUR 2,500 per returner; EUR 1.25 million for up to 500 returners in the first round.</a:t>
-            </a:r>
-            <a:endParaRPr lang="en-US" sz="1500" dirty="0"/>
-          </a:p>
-          <a:p>
-            <a:pPr indent="0" marL="0">
-              <a:lnSpc>
-                <a:spcPct val="104000"/>
-              </a:lnSpc>
-              <a:spcAft>
-                <a:spcPts val="400"/>
-              </a:spcAft>
-              <a:buNone/>
-            </a:pPr>
-            <a:r>
-              <a:rPr lang="en-US" sz="1500" b="1" dirty="0">
-                <a:solidFill>
-                  <a:srgbClr val="24313A"/>
-                </a:solidFill>
-                <a:latin typeface="Calibri" pitchFamily="34" charset="0"/>
-                <a:ea typeface="Calibri" pitchFamily="34" charset="-122"/>
-                <a:cs typeface="Calibri" pitchFamily="34" charset="-120"/>
-              </a:rPr>
-              <a:t>Since: </a:t>
-            </a:r>
-            <a:pPr indent="0" marL="0">
-              <a:lnSpc>
-                <a:spcPct val="104000"/>
-              </a:lnSpc>
-              <a:spcAft>
-                <a:spcPts val="400"/>
-              </a:spcAft>
-              <a:buNone/>
-            </a:pPr>
-            <a:r>
-              <a:rPr lang="en-US" sz="1500" dirty="0">
-                <a:solidFill>
-                  <a:srgbClr val="24313A"/>
-                </a:solidFill>
-                <a:latin typeface="Calibri" pitchFamily="34" charset="0"/>
-                <a:ea typeface="Calibri" pitchFamily="34" charset="-122"/>
-                <a:cs typeface="Calibri" pitchFamily="34" charset="-120"/>
-              </a:rPr>
-              <a:t>1 November 2017 to 1 January 2020 (closed), with an extra application round in 2019.</a:t>
+              <a:t>Between November 2017 and January 2020 the Dutch Ministry of Education paid primary schools a grant for every former teacher they re-hired. A school board qualified if it hired a qualified teacher who had not worked in primary education for at least twelve months, on a contract of at least six months. The grant was up to 2,500 euros per returner and had to be spent on that person's guidance and support during the first months back, such as coaching or refresher training, so that both the teacher and the school found the return easier. The first round set aside 1.25 million euros, enough for 500 returners, and a further application round opened in 2019. The scheme is now closed.</a:t>
             </a:r>
             <a:endParaRPr lang="en-US" sz="1500" dirty="0"/>
           </a:p>
@@ -4037,15 +3901,12 @@
           <a:p>
             <a:pPr indent="0" marL="0">
               <a:lnSpc>
-                <a:spcPct val="104000"/>
+                <a:spcPct val="106000"/>
               </a:lnSpc>
-              <a:spcAft>
-                <a:spcPts val="400"/>
-              </a:spcAft>
-              <a:buNone/>
-            </a:pPr>
-            <a:r>
-              <a:rPr lang="en-US" sz="1500" b="1" dirty="0">
+              <a:buNone/>
+            </a:pPr>
+            <a:r>
+              <a:rPr lang="en-US" sz="1500" dirty="0">
                 <a:solidFill>
                   <a:srgbClr val="24313A"/>
                 </a:solidFill>
@@ -4053,156 +3914,7 @@
                 <a:ea typeface="Calibri" pitchFamily="34" charset="-122"/>
                 <a:cs typeface="Calibri" pitchFamily="34" charset="-120"/>
               </a:rPr>
-              <a:t>What it is: </a:t>
-            </a:r>
-            <a:pPr indent="0" marL="0">
-              <a:lnSpc>
-                <a:spcPct val="104000"/>
-              </a:lnSpc>
-              <a:spcAft>
-                <a:spcPts val="400"/>
-              </a:spcAft>
-              <a:buNone/>
-            </a:pPr>
-            <a:r>
-              <a:rPr lang="en-US" sz="1500" dirty="0">
-                <a:solidFill>
-                  <a:srgbClr val="24313A"/>
-                </a:solidFill>
-                <a:latin typeface="Calibri" pitchFamily="34" charset="0"/>
-                <a:ea typeface="Calibri" pitchFamily="34" charset="-122"/>
-                <a:cs typeface="Calibri" pitchFamily="34" charset="-120"/>
-              </a:rPr>
-              <a:t>A simplified way for teachers who left the profession to get their practising certificate back, set by the Ministry of Education and the Teaching Council.</a:t>
-            </a:r>
-            <a:endParaRPr lang="en-US" sz="1500" dirty="0"/>
-          </a:p>
-          <a:p>
-            <a:pPr indent="0" marL="0">
-              <a:lnSpc>
-                <a:spcPct val="104000"/>
-              </a:lnSpc>
-              <a:spcAft>
-                <a:spcPts val="400"/>
-              </a:spcAft>
-              <a:buNone/>
-            </a:pPr>
-            <a:r>
-              <a:rPr lang="en-US" sz="1500" b="1" dirty="0">
-                <a:solidFill>
-                  <a:srgbClr val="24313A"/>
-                </a:solidFill>
-                <a:latin typeface="Calibri" pitchFamily="34" charset="0"/>
-                <a:ea typeface="Calibri" pitchFamily="34" charset="-122"/>
-                <a:cs typeface="Calibri" pitchFamily="34" charset="-120"/>
-              </a:rPr>
-              <a:t>How it works: </a:t>
-            </a:r>
-            <a:pPr indent="0" marL="0">
-              <a:lnSpc>
-                <a:spcPct val="104000"/>
-              </a:lnSpc>
-              <a:spcAft>
-                <a:spcPts val="400"/>
-              </a:spcAft>
-              <a:buNone/>
-            </a:pPr>
-            <a:r>
-              <a:rPr lang="en-US" sz="1500" dirty="0">
-                <a:solidFill>
-                  <a:srgbClr val="24313A"/>
-                </a:solidFill>
-                <a:latin typeface="Calibri" pitchFamily="34" charset="0"/>
-                <a:ea typeface="Calibri" pitchFamily="34" charset="-122"/>
-                <a:cs typeface="Calibri" pitchFamily="34" charset="-120"/>
-              </a:rPr>
-              <a:t>A registered teacher who has not taught for 5+ years no longer has to complete the Teacher Education Refresh course. With a job offer they renew the certificate, may relief-teach up to 20 half-days while it is processed, and agree a ‘Future-Ready Teaching Plan’ with the principal instead.</a:t>
-            </a:r>
-            <a:endParaRPr lang="en-US" sz="1500" dirty="0"/>
-          </a:p>
-          <a:p>
-            <a:pPr indent="0" marL="0">
-              <a:lnSpc>
-                <a:spcPct val="104000"/>
-              </a:lnSpc>
-              <a:spcAft>
-                <a:spcPts val="400"/>
-              </a:spcAft>
-              <a:buNone/>
-            </a:pPr>
-            <a:r>
-              <a:rPr lang="en-US" sz="1500" b="1" dirty="0">
-                <a:solidFill>
-                  <a:srgbClr val="24313A"/>
-                </a:solidFill>
-                <a:latin typeface="Calibri" pitchFamily="34" charset="0"/>
-                <a:ea typeface="Calibri" pitchFamily="34" charset="-122"/>
-                <a:cs typeface="Calibri" pitchFamily="34" charset="-120"/>
-              </a:rPr>
-              <a:t>Means: </a:t>
-            </a:r>
-            <a:pPr indent="0" marL="0">
-              <a:lnSpc>
-                <a:spcPct val="104000"/>
-              </a:lnSpc>
-              <a:spcAft>
-                <a:spcPts val="400"/>
-              </a:spcAft>
-              <a:buNone/>
-            </a:pPr>
-            <a:r>
-              <a:rPr lang="en-US" sz="1500" dirty="0">
-                <a:solidFill>
-                  <a:srgbClr val="24313A"/>
-                </a:solidFill>
-                <a:latin typeface="Calibri" pitchFamily="34" charset="0"/>
-                <a:ea typeface="Calibri" pitchFamily="34" charset="-122"/>
-                <a:cs typeface="Calibri" pitchFamily="34" charset="-120"/>
-              </a:rPr>
-              <a:t>The Government pays the certificate and Limited Authority to Teach fees (NZD 53.3 million for 2025–28).</a:t>
-            </a:r>
-            <a:endParaRPr lang="en-US" sz="1500" dirty="0"/>
-          </a:p>
-          <a:p>
-            <a:pPr indent="0" marL="0">
-              <a:lnSpc>
-                <a:spcPct val="104000"/>
-              </a:lnSpc>
-              <a:spcAft>
-                <a:spcPts val="400"/>
-              </a:spcAft>
-              <a:buNone/>
-            </a:pPr>
-            <a:r>
-              <a:rPr lang="en-US" sz="1500" b="1" dirty="0">
-                <a:solidFill>
-                  <a:srgbClr val="24313A"/>
-                </a:solidFill>
-                <a:latin typeface="Calibri" pitchFamily="34" charset="0"/>
-                <a:ea typeface="Calibri" pitchFamily="34" charset="-122"/>
-                <a:cs typeface="Calibri" pitchFamily="34" charset="-120"/>
-              </a:rPr>
-              <a:t>Since: </a:t>
-            </a:r>
-            <a:pPr indent="0" marL="0">
-              <a:lnSpc>
-                <a:spcPct val="104000"/>
-              </a:lnSpc>
-              <a:spcAft>
-                <a:spcPts val="400"/>
-              </a:spcAft>
-              <a:buNone/>
-            </a:pPr>
-            <a:r>
-              <a:rPr lang="en-US" sz="1500" dirty="0">
-                <a:solidFill>
-                  <a:srgbClr val="24313A"/>
-                </a:solidFill>
-                <a:latin typeface="Calibri" pitchFamily="34" charset="0"/>
-                <a:ea typeface="Calibri" pitchFamily="34" charset="-122"/>
-                <a:cs typeface="Calibri" pitchFamily="34" charset="-120"/>
-              </a:rPr>
-              <a:t>Fees covered from October 2024; 352 teachers had returned by April 2025.</a:t>
+              <a:t>New Zealand has made it much simpler for a registered teacher who has been away from the classroom to get back the licence needed to teach, called a practising certificate. Teachers who had not taught for five years or more used to have to complete a Teacher Education Refresh course first. Now, if they have a job offer, they simply renew their certificate, can do substitute teaching for up to twenty half-days while the renewal is processed, and agree a short ‘Future-Ready Teaching Plan’ with the school principal instead of taking the course. Since October 2024 the Government has also paid the certificate fees of returning teachers, and 352 teachers had come back by April 2025. Budget 2025 extended this by covering all teacher registration fees and levies until June 2028, at a cost of 53.3 million New Zealand dollars (about 29 million euros).</a:t>
             </a:r>
             <a:endParaRPr lang="en-US" sz="1500" dirty="0"/>
           </a:p>
@@ -4739,7 +4451,7 @@
                 <a:ea typeface="Cambria" pitchFamily="34" charset="-122"/>
                 <a:cs typeface="Cambria" pitchFamily="34" charset="-120"/>
               </a:rPr>
-              <a:t>Decreto-Lei n.º 51/2024: contracting retired teachers for shortage areas (2024/25–)</a:t>
+              <a:t>Decree-Law 51/2024: schools may hire retired teachers for shortage posts, 2024/25–</a:t>
             </a:r>
             <a:endParaRPr lang="en-US" sz="2100" dirty="0"/>
           </a:p>
@@ -4768,15 +4480,12 @@
           <a:p>
             <a:pPr indent="0" marL="0">
               <a:lnSpc>
-                <a:spcPct val="104000"/>
+                <a:spcPct val="106000"/>
               </a:lnSpc>
-              <a:spcAft>
-                <a:spcPts val="400"/>
-              </a:spcAft>
-              <a:buNone/>
-            </a:pPr>
-            <a:r>
-              <a:rPr lang="en-US" sz="1500" b="1" dirty="0">
+              <a:buNone/>
+            </a:pPr>
+            <a:r>
+              <a:rPr lang="en-US" sz="1500" dirty="0">
                 <a:solidFill>
                   <a:srgbClr val="24313A"/>
                 </a:solidFill>
@@ -4784,156 +4493,7 @@
                 <a:ea typeface="Calibri" pitchFamily="34" charset="-122"/>
                 <a:cs typeface="Calibri" pitchFamily="34" charset="-120"/>
               </a:rPr>
-              <a:t>What it is: </a:t>
-            </a:r>
-            <a:pPr indent="0" marL="0">
-              <a:lnSpc>
-                <a:spcPct val="104000"/>
-              </a:lnSpc>
-              <a:spcAft>
-                <a:spcPts val="400"/>
-              </a:spcAft>
-              <a:buNone/>
-            </a:pPr>
-            <a:r>
-              <a:rPr lang="en-US" sz="1500" dirty="0">
-                <a:solidFill>
-                  <a:srgbClr val="24313A"/>
-                </a:solidFill>
-                <a:latin typeface="Calibri" pitchFamily="34" charset="0"/>
-                <a:ea typeface="Calibri" pitchFamily="34" charset="-122"/>
-                <a:cs typeface="Calibri" pitchFamily="34" charset="-120"/>
-              </a:rPr>
-              <a:t>A decree-law that lets schools hire retired teachers on fixed-term contracts to fill shortage posts, part of the ‘+Aulas +Sucesso’ plan.</a:t>
-            </a:r>
-            <a:endParaRPr lang="en-US" sz="1500" dirty="0"/>
-          </a:p>
-          <a:p>
-            <a:pPr indent="0" marL="0">
-              <a:lnSpc>
-                <a:spcPct val="104000"/>
-              </a:lnSpc>
-              <a:spcAft>
-                <a:spcPts val="400"/>
-              </a:spcAft>
-              <a:buNone/>
-            </a:pPr>
-            <a:r>
-              <a:rPr lang="en-US" sz="1500" b="1" dirty="0">
-                <a:solidFill>
-                  <a:srgbClr val="24313A"/>
-                </a:solidFill>
-                <a:latin typeface="Calibri" pitchFamily="34" charset="0"/>
-                <a:ea typeface="Calibri" pitchFamily="34" charset="-122"/>
-                <a:cs typeface="Calibri" pitchFamily="34" charset="-120"/>
-              </a:rPr>
-              <a:t>How it works: </a:t>
-            </a:r>
-            <a:pPr indent="0" marL="0">
-              <a:lnSpc>
-                <a:spcPct val="104000"/>
-              </a:lnSpc>
-              <a:spcAft>
-                <a:spcPts val="400"/>
-              </a:spcAft>
-              <a:buNone/>
-            </a:pPr>
-            <a:r>
-              <a:rPr lang="en-US" sz="1500" dirty="0">
-                <a:solidFill>
-                  <a:srgbClr val="24313A"/>
-                </a:solidFill>
-                <a:latin typeface="Calibri" pitchFamily="34" charset="0"/>
-                <a:ea typeface="Calibri" pitchFamily="34" charset="-122"/>
-                <a:cs typeface="Calibri" pitchFamily="34" charset="-120"/>
-              </a:rPr>
-              <a:t>A school with an unfilled post in a shortage subject, or an under-staffed school, applies through an online DGAE form; the ministry authorises within an annual quota. Only teachers retired for five years or less can be hired.</a:t>
-            </a:r>
-            <a:endParaRPr lang="en-US" sz="1500" dirty="0"/>
-          </a:p>
-          <a:p>
-            <a:pPr indent="0" marL="0">
-              <a:lnSpc>
-                <a:spcPct val="104000"/>
-              </a:lnSpc>
-              <a:spcAft>
-                <a:spcPts val="400"/>
-              </a:spcAft>
-              <a:buNone/>
-            </a:pPr>
-            <a:r>
-              <a:rPr lang="en-US" sz="1500" b="1" dirty="0">
-                <a:solidFill>
-                  <a:srgbClr val="24313A"/>
-                </a:solidFill>
-                <a:latin typeface="Calibri" pitchFamily="34" charset="0"/>
-                <a:ea typeface="Calibri" pitchFamily="34" charset="-122"/>
-                <a:cs typeface="Calibri" pitchFamily="34" charset="-120"/>
-              </a:rPr>
-              <a:t>Means: </a:t>
-            </a:r>
-            <a:pPr indent="0" marL="0">
-              <a:lnSpc>
-                <a:spcPct val="104000"/>
-              </a:lnSpc>
-              <a:spcAft>
-                <a:spcPts val="400"/>
-              </a:spcAft>
-              <a:buNone/>
-            </a:pPr>
-            <a:r>
-              <a:rPr lang="en-US" sz="1500" dirty="0">
-                <a:solidFill>
-                  <a:srgbClr val="24313A"/>
-                </a:solidFill>
-                <a:latin typeface="Calibri" pitchFamily="34" charset="0"/>
-                <a:ea typeface="Calibri" pitchFamily="34" charset="-122"/>
-                <a:cs typeface="Calibri" pitchFamily="34" charset="-120"/>
-              </a:rPr>
-              <a:t>The retiree keeps the full pension and gets an extra payment tied to the first step of the teacher salary scale, proportional to the weekly hours taught.</a:t>
-            </a:r>
-            <a:endParaRPr lang="en-US" sz="1500" dirty="0"/>
-          </a:p>
-          <a:p>
-            <a:pPr indent="0" marL="0">
-              <a:lnSpc>
-                <a:spcPct val="104000"/>
-              </a:lnSpc>
-              <a:spcAft>
-                <a:spcPts val="400"/>
-              </a:spcAft>
-              <a:buNone/>
-            </a:pPr>
-            <a:r>
-              <a:rPr lang="en-US" sz="1500" b="1" dirty="0">
-                <a:solidFill>
-                  <a:srgbClr val="24313A"/>
-                </a:solidFill>
-                <a:latin typeface="Calibri" pitchFamily="34" charset="0"/>
-                <a:ea typeface="Calibri" pitchFamily="34" charset="-122"/>
-                <a:cs typeface="Calibri" pitchFamily="34" charset="-120"/>
-              </a:rPr>
-              <a:t>Since: </a:t>
-            </a:r>
-            <a:pPr indent="0" marL="0">
-              <a:lnSpc>
-                <a:spcPct val="104000"/>
-              </a:lnSpc>
-              <a:spcAft>
-                <a:spcPts val="400"/>
-              </a:spcAft>
-              <a:buNone/>
-            </a:pPr>
-            <a:r>
-              <a:rPr lang="en-US" sz="1500" dirty="0">
-                <a:solidFill>
-                  <a:srgbClr val="24313A"/>
-                </a:solidFill>
-                <a:latin typeface="Calibri" pitchFamily="34" charset="0"/>
-                <a:ea typeface="Calibri" pitchFamily="34" charset="-122"/>
-                <a:cs typeface="Calibri" pitchFamily="34" charset="-120"/>
-              </a:rPr>
-              <a:t>28 August 2024 (school year 2024/25); 62 retirees cleared in the first round (Público, November 2024).</a:t>
+              <a:t>Since the 2024/25 school year Portuguese public schools have been allowed to hire retired teachers on fixed-term contracts to fill posts they cannot staff. A school with an unfilled post in a shortage subject, or a school officially classed as under-staffed, applies through an online form of the schools' administration directorate, and the ministry authorises the contract within a yearly quota agreed with the Finance ministry. Only teachers who retired five years ago or less can be hired. The retiree keeps the full pension and, on top of it, receives a payment linked to the first step of the teacher salary scale in proportion to the hours taught each week. The measure was created by a decree-law of 28 August 2024 as part of the government's ‘More Lessons, More Success’ plan against teacher shortages; according to the newspaper Público, 62 retirees were cleared to return in the first round.</a:t>
             </a:r>
             <a:endParaRPr lang="en-US" sz="1500" dirty="0"/>
           </a:p>
@@ -5499,15 +5059,12 @@
           <a:p>
             <a:pPr indent="0" marL="0">
               <a:lnSpc>
-                <a:spcPct val="104000"/>
+                <a:spcPct val="106000"/>
               </a:lnSpc>
-              <a:spcAft>
-                <a:spcPts val="400"/>
-              </a:spcAft>
-              <a:buNone/>
-            </a:pPr>
-            <a:r>
-              <a:rPr lang="en-US" sz="1500" b="1" dirty="0">
+              <a:buNone/>
+            </a:pPr>
+            <a:r>
+              <a:rPr lang="en-US" sz="1500" dirty="0">
                 <a:solidFill>
                   <a:srgbClr val="24313A"/>
                 </a:solidFill>
@@ -5515,156 +5072,7 @@
                 <a:ea typeface="Calibri" pitchFamily="34" charset="-122"/>
                 <a:cs typeface="Calibri" pitchFamily="34" charset="-120"/>
               </a:rPr>
-              <a:t>What it is: </a:t>
-            </a:r>
-            <a:pPr indent="0" marL="0">
-              <a:lnSpc>
-                <a:spcPct val="104000"/>
-              </a:lnSpc>
-              <a:spcAft>
-                <a:spcPts val="400"/>
-              </a:spcAft>
-              <a:buNone/>
-            </a:pPr>
-            <a:r>
-              <a:rPr lang="en-US" sz="1500" dirty="0">
-                <a:solidFill>
-                  <a:srgbClr val="24313A"/>
-                </a:solidFill>
-                <a:latin typeface="Calibri" pitchFamily="34" charset="0"/>
-                <a:ea typeface="Calibri" pitchFamily="34" charset="-122"/>
-                <a:cs typeface="Calibri" pitchFamily="34" charset="-120"/>
-              </a:rPr>
-              <a:t>A registry of former teachers whom schools can hire for short, flexible stints, run by the Ministry of Education.</a:t>
-            </a:r>
-            <a:endParaRPr lang="en-US" sz="1500" dirty="0"/>
-          </a:p>
-          <a:p>
-            <a:pPr indent="0" marL="0">
-              <a:lnSpc>
-                <a:spcPct val="104000"/>
-              </a:lnSpc>
-              <a:spcAft>
-                <a:spcPts val="400"/>
-              </a:spcAft>
-              <a:buNone/>
-            </a:pPr>
-            <a:r>
-              <a:rPr lang="en-US" sz="1500" b="1" dirty="0">
-                <a:solidFill>
-                  <a:srgbClr val="24313A"/>
-                </a:solidFill>
-                <a:latin typeface="Calibri" pitchFamily="34" charset="0"/>
-                <a:ea typeface="Calibri" pitchFamily="34" charset="-122"/>
-                <a:cs typeface="Calibri" pitchFamily="34" charset="-120"/>
-              </a:rPr>
-              <a:t>How it works: </a:t>
-            </a:r>
-            <a:pPr indent="0" marL="0">
-              <a:lnSpc>
-                <a:spcPct val="104000"/>
-              </a:lnSpc>
-              <a:spcAft>
-                <a:spcPts val="400"/>
-              </a:spcAft>
-              <a:buNone/>
-            </a:pPr>
-            <a:r>
-              <a:rPr lang="en-US" sz="1500" dirty="0">
-                <a:solidFill>
-                  <a:srgbClr val="24313A"/>
-                </a:solidFill>
-                <a:latin typeface="Calibri" pitchFamily="34" charset="0"/>
-                <a:ea typeface="Calibri" pitchFamily="34" charset="-122"/>
-                <a:cs typeface="Calibri" pitchFamily="34" charset="-120"/>
-              </a:rPr>
-              <a:t>A trained ex-teacher (NIE diploma, including retirees) registers through the MOE relief portal; schools then contact them directly for appointments of 1 day to 10 weeks, for teaching only or mixed duties agreed with the school. A companion Contract Adjunct scheme offers 1–1.5-year contracts.</a:t>
-            </a:r>
-            <a:endParaRPr lang="en-US" sz="1500" dirty="0"/>
-          </a:p>
-          <a:p>
-            <a:pPr indent="0" marL="0">
-              <a:lnSpc>
-                <a:spcPct val="104000"/>
-              </a:lnSpc>
-              <a:spcAft>
-                <a:spcPts val="400"/>
-              </a:spcAft>
-              <a:buNone/>
-            </a:pPr>
-            <a:r>
-              <a:rPr lang="en-US" sz="1500" b="1" dirty="0">
-                <a:solidFill>
-                  <a:srgbClr val="24313A"/>
-                </a:solidFill>
-                <a:latin typeface="Calibri" pitchFamily="34" charset="0"/>
-                <a:ea typeface="Calibri" pitchFamily="34" charset="-122"/>
-                <a:cs typeface="Calibri" pitchFamily="34" charset="-120"/>
-              </a:rPr>
-              <a:t>Means: </a:t>
-            </a:r>
-            <a:pPr indent="0" marL="0">
-              <a:lnSpc>
-                <a:spcPct val="104000"/>
-              </a:lnSpc>
-              <a:spcAft>
-                <a:spcPts val="400"/>
-              </a:spcAft>
-              <a:buNone/>
-            </a:pPr>
-            <a:r>
-              <a:rPr lang="en-US" sz="1500" dirty="0">
-                <a:solidFill>
-                  <a:srgbClr val="24313A"/>
-                </a:solidFill>
-                <a:latin typeface="Calibri" pitchFamily="34" charset="0"/>
-                <a:ea typeface="Calibri" pitchFamily="34" charset="-122"/>
-                <a:cs typeface="Calibri" pitchFamily="34" charset="-120"/>
-              </a:rPr>
-              <a:t>Daily-rate pay with pro-rated leave after 90 days of cumulative service.</a:t>
-            </a:r>
-            <a:endParaRPr lang="en-US" sz="1500" dirty="0"/>
-          </a:p>
-          <a:p>
-            <a:pPr indent="0" marL="0">
-              <a:lnSpc>
-                <a:spcPct val="104000"/>
-              </a:lnSpc>
-              <a:spcAft>
-                <a:spcPts val="400"/>
-              </a:spcAft>
-              <a:buNone/>
-            </a:pPr>
-            <a:r>
-              <a:rPr lang="en-US" sz="1500" b="1" dirty="0">
-                <a:solidFill>
-                  <a:srgbClr val="24313A"/>
-                </a:solidFill>
-                <a:latin typeface="Calibri" pitchFamily="34" charset="0"/>
-                <a:ea typeface="Calibri" pitchFamily="34" charset="-122"/>
-                <a:cs typeface="Calibri" pitchFamily="34" charset="-120"/>
-              </a:rPr>
-              <a:t>Since: </a:t>
-            </a:r>
-            <a:pPr indent="0" marL="0">
-              <a:lnSpc>
-                <a:spcPct val="104000"/>
-              </a:lnSpc>
-              <a:spcAft>
-                <a:spcPts val="400"/>
-              </a:spcAft>
-              <a:buNone/>
-            </a:pPr>
-            <a:r>
-              <a:rPr lang="en-US" sz="1500" dirty="0">
-                <a:solidFill>
-                  <a:srgbClr val="24313A"/>
-                </a:solidFill>
-                <a:latin typeface="Calibri" pitchFamily="34" charset="0"/>
-                <a:ea typeface="Calibri" pitchFamily="34" charset="-122"/>
-                <a:cs typeface="Calibri" pitchFamily="34" charset="-120"/>
-              </a:rPr>
-              <a:t>Ongoing (start year not stated); about 220 recent leavers a year joined in 2022–24.</a:t>
+              <a:t>Singapore's Ministry of Education keeps a register of former teachers whom schools can call on for short and flexible periods of work. Any trained ex-teacher, including retirees, who holds a teaching diploma from the National Institute of Education can register through the ministry's relief-employment portal; schools then contact them directly for appointments lasting from a single day to ten weeks, either for teaching only or for a mix of teaching and other duties agreed with the school. They are paid a daily rate and earn pro-rated leave after ninety days of cumulative service. A companion scheme offers former teachers contracts of one year to eighteen months. The ministry told Parliament in 2025 that between 2022 and 2024 about 220 teachers a year had joined the scheme within twelve months of leaving the service.</a:t>
             </a:r>
             <a:endParaRPr lang="en-US" sz="1500" dirty="0"/>
           </a:p>
@@ -6230,15 +5638,12 @@
           <a:p>
             <a:pPr indent="0" marL="0">
               <a:lnSpc>
-                <a:spcPct val="104000"/>
+                <a:spcPct val="106000"/>
               </a:lnSpc>
-              <a:spcAft>
-                <a:spcPts val="400"/>
-              </a:spcAft>
-              <a:buNone/>
-            </a:pPr>
-            <a:r>
-              <a:rPr lang="en-US" sz="1500" b="1" dirty="0">
+              <a:buNone/>
+            </a:pPr>
+            <a:r>
+              <a:rPr lang="en-US" sz="1500" dirty="0">
                 <a:solidFill>
                   <a:srgbClr val="24313A"/>
                 </a:solidFill>
@@ -6246,156 +5651,7 @@
                 <a:ea typeface="Calibri" pitchFamily="34" charset="-122"/>
                 <a:cs typeface="Calibri" pitchFamily="34" charset="-120"/>
               </a:rPr>
-              <a:t>What it is: </a:t>
-            </a:r>
-            <a:pPr indent="0" marL="0">
-              <a:lnSpc>
-                <a:spcPct val="104000"/>
-              </a:lnSpc>
-              <a:spcAft>
-                <a:spcPts val="400"/>
-              </a:spcAft>
-              <a:buNone/>
-            </a:pPr>
-            <a:r>
-              <a:rPr lang="en-US" sz="1500" dirty="0">
-                <a:solidFill>
-                  <a:srgbClr val="24313A"/>
-                </a:solidFill>
-                <a:latin typeface="Calibri" pitchFamily="34" charset="0"/>
-                <a:ea typeface="Calibri" pitchFamily="34" charset="-122"/>
-                <a:cs typeface="Calibri" pitchFamily="34" charset="-120"/>
-              </a:rPr>
-              <a:t>An online refresher course for teachers and preschool teachers who want to return to the profession, built by Skolverket at the Government's request.</a:t>
-            </a:r>
-            <a:endParaRPr lang="en-US" sz="1500" dirty="0"/>
-          </a:p>
-          <a:p>
-            <a:pPr indent="0" marL="0">
-              <a:lnSpc>
-                <a:spcPct val="104000"/>
-              </a:lnSpc>
-              <a:spcAft>
-                <a:spcPts val="400"/>
-              </a:spcAft>
-              <a:buNone/>
-            </a:pPr>
-            <a:r>
-              <a:rPr lang="en-US" sz="1500" b="1" dirty="0">
-                <a:solidFill>
-                  <a:srgbClr val="24313A"/>
-                </a:solidFill>
-                <a:latin typeface="Calibri" pitchFamily="34" charset="0"/>
-                <a:ea typeface="Calibri" pitchFamily="34" charset="-122"/>
-                <a:cs typeface="Calibri" pitchFamily="34" charset="-120"/>
-              </a:rPr>
-              <a:t>How it works: </a:t>
-            </a:r>
-            <a:pPr indent="0" marL="0">
-              <a:lnSpc>
-                <a:spcPct val="104000"/>
-              </a:lnSpc>
-              <a:spcAft>
-                <a:spcPts val="400"/>
-              </a:spcAft>
-              <a:buNone/>
-            </a:pPr>
-            <a:r>
-              <a:rPr lang="en-US" sz="1500" dirty="0">
-                <a:solidFill>
-                  <a:srgbClr val="24313A"/>
-                </a:solidFill>
-                <a:latin typeface="Calibri" pitchFamily="34" charset="0"/>
-                <a:ea typeface="Calibri" pitchFamily="34" charset="-122"/>
-                <a:cs typeface="Calibri" pitchFamily="34" charset="-120"/>
-              </a:rPr>
-              <a:t>The returner logs into Skolverket's learning platform, picks the school or preschool track and takes the modules they need in any order; the modules update them on the curricula, laws and steering documents that changed while they were away, with a certificate per module.</a:t>
-            </a:r>
-            <a:endParaRPr lang="en-US" sz="1500" dirty="0"/>
-          </a:p>
-          <a:p>
-            <a:pPr indent="0" marL="0">
-              <a:lnSpc>
-                <a:spcPct val="104000"/>
-              </a:lnSpc>
-              <a:spcAft>
-                <a:spcPts val="400"/>
-              </a:spcAft>
-              <a:buNone/>
-            </a:pPr>
-            <a:r>
-              <a:rPr lang="en-US" sz="1500" b="1" dirty="0">
-                <a:solidFill>
-                  <a:srgbClr val="24313A"/>
-                </a:solidFill>
-                <a:latin typeface="Calibri" pitchFamily="34" charset="0"/>
-                <a:ea typeface="Calibri" pitchFamily="34" charset="-122"/>
-                <a:cs typeface="Calibri" pitchFamily="34" charset="-120"/>
-              </a:rPr>
-              <a:t>Means: </a:t>
-            </a:r>
-            <a:pPr indent="0" marL="0">
-              <a:lnSpc>
-                <a:spcPct val="104000"/>
-              </a:lnSpc>
-              <a:spcAft>
-                <a:spcPts val="400"/>
-              </a:spcAft>
-              <a:buNone/>
-            </a:pPr>
-            <a:r>
-              <a:rPr lang="en-US" sz="1500" dirty="0">
-                <a:solidFill>
-                  <a:srgbClr val="24313A"/>
-                </a:solidFill>
-                <a:latin typeface="Calibri" pitchFamily="34" charset="0"/>
-                <a:ea typeface="Calibri" pitchFamily="34" charset="-122"/>
-                <a:cs typeface="Calibri" pitchFamily="34" charset="-120"/>
-              </a:rPr>
-              <a:t>Self-paced web platform, open to anyone with a teaching licence or qualifying degree.</a:t>
-            </a:r>
-            <a:endParaRPr lang="en-US" sz="1500" dirty="0"/>
-          </a:p>
-          <a:p>
-            <a:pPr indent="0" marL="0">
-              <a:lnSpc>
-                <a:spcPct val="104000"/>
-              </a:lnSpc>
-              <a:spcAft>
-                <a:spcPts val="400"/>
-              </a:spcAft>
-              <a:buNone/>
-            </a:pPr>
-            <a:r>
-              <a:rPr lang="en-US" sz="1500" b="1" dirty="0">
-                <a:solidFill>
-                  <a:srgbClr val="24313A"/>
-                </a:solidFill>
-                <a:latin typeface="Calibri" pitchFamily="34" charset="0"/>
-                <a:ea typeface="Calibri" pitchFamily="34" charset="-122"/>
-                <a:cs typeface="Calibri" pitchFamily="34" charset="-120"/>
-              </a:rPr>
-              <a:t>Since: </a:t>
-            </a:r>
-            <a:pPr indent="0" marL="0">
-              <a:lnSpc>
-                <a:spcPct val="104000"/>
-              </a:lnSpc>
-              <a:spcAft>
-                <a:spcPts val="400"/>
-              </a:spcAft>
-              <a:buNone/>
-            </a:pPr>
-            <a:r>
-              <a:rPr lang="en-US" sz="1500" dirty="0">
-                <a:solidFill>
-                  <a:srgbClr val="24313A"/>
-                </a:solidFill>
-                <a:latin typeface="Calibri" pitchFamily="34" charset="0"/>
-                <a:ea typeface="Calibri" pitchFamily="34" charset="-122"/>
-                <a:cs typeface="Calibri" pitchFamily="34" charset="-120"/>
-              </a:rPr>
-              <a:t>October 2018 (assignment reported to the Government in 2020).</a:t>
+              <a:t>Sweden's National Agency for Education, Skolverket, runs an online refresher course for qualified teachers and preschool teachers who want to return to the profession after working elsewhere. It was built at the request of the Government and has been available on the agency's learning platform since October 2018. A returner logs in, chooses the track for schools or for preschools, and takes only the modules they need, in any order. The modules bring them up to date on the curricula, laws and official guidelines that changed while they were away, and a certificate is issued for each module completed. The course is open to anyone holding a Swedish teaching licence or a qualifying degree, and its purpose is to lower the threshold for the many trained teachers now working outside schools to come back.</a:t>
             </a:r>
             <a:endParaRPr lang="en-US" sz="1500" dirty="0"/>
           </a:p>
@@ -6971,7 +6227,7 @@
                 <a:ea typeface="Cambria" pitchFamily="34" charset="-122"/>
                 <a:cs typeface="Cambria" pitchFamily="34" charset="-120"/>
               </a:rPr>
-              <a:t>PH Zürich ‘Wiedereinstieg’ re-entry programme for returning teachers</a:t>
+              <a:t>Re-entry counselling and induction for returning teachers (Zurich University of Teacher Education)</a:t>
             </a:r>
             <a:endParaRPr lang="en-US" sz="2100" dirty="0"/>
           </a:p>
@@ -7000,15 +6256,12 @@
           <a:p>
             <a:pPr indent="0" marL="0">
               <a:lnSpc>
-                <a:spcPct val="104000"/>
+                <a:spcPct val="106000"/>
               </a:lnSpc>
-              <a:spcAft>
-                <a:spcPts val="400"/>
-              </a:spcAft>
-              <a:buNone/>
-            </a:pPr>
-            <a:r>
-              <a:rPr lang="en-US" sz="1500" b="1" dirty="0">
+              <a:buNone/>
+            </a:pPr>
+            <a:r>
+              <a:rPr lang="en-US" sz="1500" dirty="0">
                 <a:solidFill>
                   <a:srgbClr val="24313A"/>
                 </a:solidFill>
@@ -7016,156 +6269,7 @@
                 <a:ea typeface="Calibri" pitchFamily="34" charset="-122"/>
                 <a:cs typeface="Calibri" pitchFamily="34" charset="-120"/>
               </a:rPr>
-              <a:t>What it is: </a:t>
-            </a:r>
-            <a:pPr indent="0" marL="0">
-              <a:lnSpc>
-                <a:spcPct val="104000"/>
-              </a:lnSpc>
-              <a:spcAft>
-                <a:spcPts val="400"/>
-              </a:spcAft>
-              <a:buNone/>
-            </a:pPr>
-            <a:r>
-              <a:rPr lang="en-US" sz="1500" dirty="0">
-                <a:solidFill>
-                  <a:srgbClr val="24313A"/>
-                </a:solidFill>
-                <a:latin typeface="Calibri" pitchFamily="34" charset="0"/>
-                <a:ea typeface="Calibri" pitchFamily="34" charset="-122"/>
-                <a:cs typeface="Calibri" pitchFamily="34" charset="-120"/>
-              </a:rPr>
-              <a:t>A counselling and induction package for teachers who return to the classroom after a long break, run by PH Zürich with the cantonal school office.</a:t>
-            </a:r>
-            <a:endParaRPr lang="en-US" sz="1500" dirty="0"/>
-          </a:p>
-          <a:p>
-            <a:pPr indent="0" marL="0">
-              <a:lnSpc>
-                <a:spcPct val="104000"/>
-              </a:lnSpc>
-              <a:spcAft>
-                <a:spcPts val="400"/>
-              </a:spcAft>
-              <a:buNone/>
-            </a:pPr>
-            <a:r>
-              <a:rPr lang="en-US" sz="1500" b="1" dirty="0">
-                <a:solidFill>
-                  <a:srgbClr val="24313A"/>
-                </a:solidFill>
-                <a:latin typeface="Calibri" pitchFamily="34" charset="0"/>
-                <a:ea typeface="Calibri" pitchFamily="34" charset="-122"/>
-                <a:cs typeface="Calibri" pitchFamily="34" charset="-120"/>
-              </a:rPr>
-              <a:t>How it works: </a:t>
-            </a:r>
-            <a:pPr indent="0" marL="0">
-              <a:lnSpc>
-                <a:spcPct val="104000"/>
-              </a:lnSpc>
-              <a:spcAft>
-                <a:spcPts val="400"/>
-              </a:spcAft>
-              <a:buNone/>
-            </a:pPr>
-            <a:r>
-              <a:rPr lang="en-US" sz="1500" dirty="0">
-                <a:solidFill>
-                  <a:srgbClr val="24313A"/>
-                </a:solidFill>
-                <a:latin typeface="Calibri" pitchFamily="34" charset="0"/>
-                <a:ea typeface="Calibri" pitchFamily="34" charset="-122"/>
-                <a:cs typeface="Calibri" pitchFamily="34" charset="-120"/>
-              </a:rPr>
-              <a:t>The returner starts with a re-entry consultation and a ‘Standortbestimmung’ (positioning session) that checks readiness and needs. During the first year back they get workplace mentoring (up to 25 hours), supervision, subject coaching and optional courses on assessment, classroom management and parent work.</a:t>
-            </a:r>
-            <a:endParaRPr lang="en-US" sz="1500" dirty="0"/>
-          </a:p>
-          <a:p>
-            <a:pPr indent="0" marL="0">
-              <a:lnSpc>
-                <a:spcPct val="104000"/>
-              </a:lnSpc>
-              <a:spcAft>
-                <a:spcPts val="400"/>
-              </a:spcAft>
-              <a:buNone/>
-            </a:pPr>
-            <a:r>
-              <a:rPr lang="en-US" sz="1500" b="1" dirty="0">
-                <a:solidFill>
-                  <a:srgbClr val="24313A"/>
-                </a:solidFill>
-                <a:latin typeface="Calibri" pitchFamily="34" charset="0"/>
-                <a:ea typeface="Calibri" pitchFamily="34" charset="-122"/>
-                <a:cs typeface="Calibri" pitchFamily="34" charset="-120"/>
-              </a:rPr>
-              <a:t>Means: </a:t>
-            </a:r>
-            <a:pPr indent="0" marL="0">
-              <a:lnSpc>
-                <a:spcPct val="104000"/>
-              </a:lnSpc>
-              <a:spcAft>
-                <a:spcPts val="400"/>
-              </a:spcAft>
-              <a:buNone/>
-            </a:pPr>
-            <a:r>
-              <a:rPr lang="en-US" sz="1500" dirty="0">
-                <a:solidFill>
-                  <a:srgbClr val="24313A"/>
-                </a:solidFill>
-                <a:latin typeface="Calibri" pitchFamily="34" charset="0"/>
-                <a:ea typeface="Calibri" pitchFamily="34" charset="-122"/>
-                <a:cs typeface="Calibri" pitchFamily="34" charset="-120"/>
-              </a:rPr>
-              <a:t>Free of charge in the first school year for teachers away 8+ years, co-funded by the Canton of Zurich; first consultation hour free.</a:t>
-            </a:r>
-            <a:endParaRPr lang="en-US" sz="1500" dirty="0"/>
-          </a:p>
-          <a:p>
-            <a:pPr indent="0" marL="0">
-              <a:lnSpc>
-                <a:spcPct val="104000"/>
-              </a:lnSpc>
-              <a:spcAft>
-                <a:spcPts val="400"/>
-              </a:spcAft>
-              <a:buNone/>
-            </a:pPr>
-            <a:r>
-              <a:rPr lang="en-US" sz="1500" b="1" dirty="0">
-                <a:solidFill>
-                  <a:srgbClr val="24313A"/>
-                </a:solidFill>
-                <a:latin typeface="Calibri" pitchFamily="34" charset="0"/>
-                <a:ea typeface="Calibri" pitchFamily="34" charset="-122"/>
-                <a:cs typeface="Calibri" pitchFamily="34" charset="-120"/>
-              </a:rPr>
-              <a:t>Since: </a:t>
-            </a:r>
-            <a:pPr indent="0" marL="0">
-              <a:lnSpc>
-                <a:spcPct val="104000"/>
-              </a:lnSpc>
-              <a:spcAft>
-                <a:spcPts val="400"/>
-              </a:spcAft>
-              <a:buNone/>
-            </a:pPr>
-            <a:r>
-              <a:rPr lang="en-US" sz="1500" dirty="0">
-                <a:solidFill>
-                  <a:srgbClr val="24313A"/>
-                </a:solidFill>
-                <a:latin typeface="Calibri" pitchFamily="34" charset="0"/>
-                <a:ea typeface="Calibri" pitchFamily="34" charset="-122"/>
-                <a:cs typeface="Calibri" pitchFamily="34" charset="-120"/>
-              </a:rPr>
-              <a:t>Ongoing offer (start year not stated on the page).</a:t>
+              <a:t>The Zurich University of Teacher Education, together with the school office of the Canton of Zurich, offers a package of advice and support for teachers who want to return to the classroom after a long break or after working in another field. It begins with a re-entry consultation and an assessment interview that checks whether returning makes sense and what preparation is needed; the first hour is free and the rest is subsidised by the canton. During the first school year back, a teacher who has been away for eight years or more can use the university's induction programme free of charge: up to twenty-five hours of mentoring by an experienced colleague at the school, individual and group supervision, coaching in their subject, and optional courses on grading, classroom management and working with parents.</a:t>
             </a:r>
             <a:endParaRPr lang="en-US" sz="1500" dirty="0"/>
           </a:p>
@@ -7727,15 +6831,12 @@
           <a:p>
             <a:pPr indent="0" marL="0">
               <a:lnSpc>
-                <a:spcPct val="104000"/>
+                <a:spcPct val="106000"/>
               </a:lnSpc>
-              <a:spcAft>
-                <a:spcPts val="400"/>
-              </a:spcAft>
-              <a:buNone/>
-            </a:pPr>
-            <a:r>
-              <a:rPr lang="en-US" sz="1500" b="1" dirty="0">
+              <a:buNone/>
+            </a:pPr>
+            <a:r>
+              <a:rPr lang="en-US" sz="1500" dirty="0">
                 <a:solidFill>
                   <a:srgbClr val="24313A"/>
                 </a:solidFill>
@@ -7743,156 +6844,7 @@
                 <a:ea typeface="Calibri" pitchFamily="34" charset="-122"/>
                 <a:cs typeface="Calibri" pitchFamily="34" charset="-120"/>
               </a:rPr>
-              <a:t>What it is: </a:t>
-            </a:r>
-            <a:pPr indent="0" marL="0">
-              <a:lnSpc>
-                <a:spcPct val="104000"/>
-              </a:lnSpc>
-              <a:spcAft>
-                <a:spcPts val="400"/>
-              </a:spcAft>
-              <a:buNone/>
-            </a:pPr>
-            <a:r>
-              <a:rPr lang="en-US" sz="1500" dirty="0">
-                <a:solidFill>
-                  <a:srgbClr val="24313A"/>
-                </a:solidFill>
-                <a:latin typeface="Calibri" pitchFamily="34" charset="0"/>
-                <a:ea typeface="Calibri" pitchFamily="34" charset="-122"/>
-                <a:cs typeface="Calibri" pitchFamily="34" charset="-120"/>
-              </a:rPr>
-              <a:t>A free personal adviser for anyone who has taught or trained to teach in the UK and wants to return, provided by the Department for Education's ‘Get Into Teaching’ service.</a:t>
-            </a:r>
-            <a:endParaRPr lang="en-US" sz="1500" dirty="0"/>
-          </a:p>
-          <a:p>
-            <a:pPr indent="0" marL="0">
-              <a:lnSpc>
-                <a:spcPct val="104000"/>
-              </a:lnSpc>
-              <a:spcAft>
-                <a:spcPts val="400"/>
-              </a:spcAft>
-              <a:buNone/>
-            </a:pPr>
-            <a:r>
-              <a:rPr lang="en-US" sz="1500" b="1" dirty="0">
-                <a:solidFill>
-                  <a:srgbClr val="24313A"/>
-                </a:solidFill>
-                <a:latin typeface="Calibri" pitchFamily="34" charset="0"/>
-                <a:ea typeface="Calibri" pitchFamily="34" charset="-122"/>
-                <a:cs typeface="Calibri" pitchFamily="34" charset="-120"/>
-              </a:rPr>
-              <a:t>How it works: </a:t>
-            </a:r>
-            <a:pPr indent="0" marL="0">
-              <a:lnSpc>
-                <a:spcPct val="104000"/>
-              </a:lnSpc>
-              <a:spcAft>
-                <a:spcPts val="400"/>
-              </a:spcAft>
-              <a:buNone/>
-            </a:pPr>
-            <a:r>
-              <a:rPr lang="en-US" sz="1500" dirty="0">
-                <a:solidFill>
-                  <a:srgbClr val="24313A"/>
-                </a:solidFill>
-                <a:latin typeface="Calibri" pitchFamily="34" charset="0"/>
-                <a:ea typeface="Calibri" pitchFamily="34" charset="-122"/>
-                <a:cs typeface="Calibri" pitchFamily="34" charset="-120"/>
-              </a:rPr>
-              <a:t>The former teacher calls or signs up online; the adviser then works with them one-to-one by phone, text or e-mail: reviewing skills gained during the break, helping with applications and interviews, pointing to refresher courses and NPQs, and flagging vacancies and webinars.</a:t>
-            </a:r>
-            <a:endParaRPr lang="en-US" sz="1500" dirty="0"/>
-          </a:p>
-          <a:p>
-            <a:pPr indent="0" marL="0">
-              <a:lnSpc>
-                <a:spcPct val="104000"/>
-              </a:lnSpc>
-              <a:spcAft>
-                <a:spcPts val="400"/>
-              </a:spcAft>
-              <a:buNone/>
-            </a:pPr>
-            <a:r>
-              <a:rPr lang="en-US" sz="1500" b="1" dirty="0">
-                <a:solidFill>
-                  <a:srgbClr val="24313A"/>
-                </a:solidFill>
-                <a:latin typeface="Calibri" pitchFamily="34" charset="0"/>
-                <a:ea typeface="Calibri" pitchFamily="34" charset="-122"/>
-                <a:cs typeface="Calibri" pitchFamily="34" charset="-120"/>
-              </a:rPr>
-              <a:t>Means: </a:t>
-            </a:r>
-            <a:pPr indent="0" marL="0">
-              <a:lnSpc>
-                <a:spcPct val="104000"/>
-              </a:lnSpc>
-              <a:spcAft>
-                <a:spcPts val="400"/>
-              </a:spcAft>
-              <a:buNone/>
-            </a:pPr>
-            <a:r>
-              <a:rPr lang="en-US" sz="1500" dirty="0">
-                <a:solidFill>
-                  <a:srgbClr val="24313A"/>
-                </a:solidFill>
-                <a:latin typeface="Calibri" pitchFamily="34" charset="0"/>
-                <a:ea typeface="Calibri" pitchFamily="34" charset="-122"/>
-                <a:cs typeface="Calibri" pitchFamily="34" charset="-120"/>
-              </a:rPr>
-              <a:t>Adviser service and outreach campaigns (e.g. ‘Come back to teaching’, January 2022).</a:t>
-            </a:r>
-            <a:endParaRPr lang="en-US" sz="1500" dirty="0"/>
-          </a:p>
-          <a:p>
-            <a:pPr indent="0" marL="0">
-              <a:lnSpc>
-                <a:spcPct val="104000"/>
-              </a:lnSpc>
-              <a:spcAft>
-                <a:spcPts val="400"/>
-              </a:spcAft>
-              <a:buNone/>
-            </a:pPr>
-            <a:r>
-              <a:rPr lang="en-US" sz="1500" b="1" dirty="0">
-                <a:solidFill>
-                  <a:srgbClr val="24313A"/>
-                </a:solidFill>
-                <a:latin typeface="Calibri" pitchFamily="34" charset="0"/>
-                <a:ea typeface="Calibri" pitchFamily="34" charset="-122"/>
-                <a:cs typeface="Calibri" pitchFamily="34" charset="-120"/>
-              </a:rPr>
-              <a:t>Since: </a:t>
-            </a:r>
-            <a:pPr indent="0" marL="0">
-              <a:lnSpc>
-                <a:spcPct val="104000"/>
-              </a:lnSpc>
-              <a:spcAft>
-                <a:spcPts val="400"/>
-              </a:spcAft>
-              <a:buNone/>
-            </a:pPr>
-            <a:r>
-              <a:rPr lang="en-US" sz="1500" dirty="0">
-                <a:solidFill>
-                  <a:srgbClr val="24313A"/>
-                </a:solidFill>
-                <a:latin typeface="Calibri" pitchFamily="34" charset="0"/>
-                <a:ea typeface="Calibri" pitchFamily="34" charset="-122"/>
-                <a:cs typeface="Calibri" pitchFamily="34" charset="-120"/>
-              </a:rPr>
-              <a:t>Ongoing; returners are a major supply source: about 17,500 FTE in 2023, 38% of qualified entrants.</a:t>
+              <a:t>Anyone who has taught or trained to teach in the United Kingdom and is thinking of coming back can ask the Department for Education for a free personal Return to Teaching Adviser through its ‘Get Into Teaching’ service. The former teacher calls or signs up online, and the adviser then works with them one to one, by phone, text or e-mail and for as long as they need: reviewing the skills they gained while away, helping them write applications and prepare for interviews, pointing them to refresher courses and professional qualifications, and alerting them to vacancies and webinars. The Department used the same channel in its ‘Come back to teaching’ campaign of January 2022. Returners are a major source of teachers in England: about 17,500 full-time-equivalent teachers came back in 2023, some 38 percent of all qualified entrants that year.</a:t>
             </a:r>
             <a:endParaRPr lang="en-US" sz="1500" dirty="0"/>
           </a:p>
@@ -8497,15 +7449,12 @@
           <a:p>
             <a:pPr indent="0" marL="0">
               <a:lnSpc>
-                <a:spcPct val="104000"/>
+                <a:spcPct val="106000"/>
               </a:lnSpc>
-              <a:spcAft>
-                <a:spcPts val="400"/>
-              </a:spcAft>
-              <a:buNone/>
-            </a:pPr>
-            <a:r>
-              <a:rPr lang="en-US" sz="1500" b="1" dirty="0">
+              <a:buNone/>
+            </a:pPr>
+            <a:r>
+              <a:rPr lang="en-US" sz="1500" dirty="0">
                 <a:solidFill>
                   <a:srgbClr val="24313A"/>
                 </a:solidFill>
@@ -8513,156 +7462,7 @@
                 <a:ea typeface="Calibri" pitchFamily="34" charset="-122"/>
                 <a:cs typeface="Calibri" pitchFamily="34" charset="-120"/>
               </a:rPr>
-              <a:t>What it is: </a:t>
-            </a:r>
-            <a:pPr indent="0" marL="0">
-              <a:lnSpc>
-                <a:spcPct val="104000"/>
-              </a:lnSpc>
-              <a:spcAft>
-                <a:spcPts val="400"/>
-              </a:spcAft>
-              <a:buNone/>
-            </a:pPr>
-            <a:r>
-              <a:rPr lang="en-US" sz="1500" dirty="0">
-                <a:solidFill>
-                  <a:srgbClr val="24313A"/>
-                </a:solidFill>
-                <a:latin typeface="Calibri" pitchFamily="34" charset="0"/>
-                <a:ea typeface="Calibri" pitchFamily="34" charset="-122"/>
-                <a:cs typeface="Calibri" pitchFamily="34" charset="-120"/>
-              </a:rPr>
-              <a:t>A state law that lets retired teachers go back to full-time teaching in shortage subjects while keeping their full pension.</a:t>
-            </a:r>
-            <a:endParaRPr lang="en-US" sz="1500" dirty="0"/>
-          </a:p>
-          <a:p>
-            <a:pPr indent="0" marL="0">
-              <a:lnSpc>
-                <a:spcPct val="104000"/>
-              </a:lnSpc>
-              <a:spcAft>
-                <a:spcPts val="400"/>
-              </a:spcAft>
-              <a:buNone/>
-            </a:pPr>
-            <a:r>
-              <a:rPr lang="en-US" sz="1500" b="1" dirty="0">
-                <a:solidFill>
-                  <a:srgbClr val="24313A"/>
-                </a:solidFill>
-                <a:latin typeface="Calibri" pitchFamily="34" charset="0"/>
-                <a:ea typeface="Calibri" pitchFamily="34" charset="-122"/>
-                <a:cs typeface="Calibri" pitchFamily="34" charset="-120"/>
-              </a:rPr>
-              <a:t>How it works: </a:t>
-            </a:r>
-            <a:pPr indent="0" marL="0">
-              <a:lnSpc>
-                <a:spcPct val="104000"/>
-              </a:lnSpc>
-              <a:spcAft>
-                <a:spcPts val="400"/>
-              </a:spcAft>
-              <a:buNone/>
-            </a:pPr>
-            <a:r>
-              <a:rPr lang="en-US" sz="1500" dirty="0">
-                <a:solidFill>
-                  <a:srgbClr val="24313A"/>
-                </a:solidFill>
-                <a:latin typeface="Calibri" pitchFamily="34" charset="0"/>
-                <a:ea typeface="Calibri" pitchFamily="34" charset="-122"/>
-                <a:cs typeface="Calibri" pitchFamily="34" charset="-120"/>
-              </a:rPr>
-              <a:t>A teacher who retired with 30+ years of service and has been retired at least one year can be hired as a full-time pre-K–12 classroom teacher in one of the three highest-need subjects of their region (typically special education, maths, science, English, elementary), drawing pension plus full salary.</a:t>
-            </a:r>
-            <a:endParaRPr lang="en-US" sz="1500" dirty="0"/>
-          </a:p>
-          <a:p>
-            <a:pPr indent="0" marL="0">
-              <a:lnSpc>
-                <a:spcPct val="104000"/>
-              </a:lnSpc>
-              <a:spcAft>
-                <a:spcPts val="400"/>
-              </a:spcAft>
-              <a:buNone/>
-            </a:pPr>
-            <a:r>
-              <a:rPr lang="en-US" sz="1500" b="1" dirty="0">
-                <a:solidFill>
-                  <a:srgbClr val="24313A"/>
-                </a:solidFill>
-                <a:latin typeface="Calibri" pitchFamily="34" charset="0"/>
-                <a:ea typeface="Calibri" pitchFamily="34" charset="-122"/>
-                <a:cs typeface="Calibri" pitchFamily="34" charset="-120"/>
-              </a:rPr>
-              <a:t>Means: </a:t>
-            </a:r>
-            <a:pPr indent="0" marL="0">
-              <a:lnSpc>
-                <a:spcPct val="104000"/>
-              </a:lnSpc>
-              <a:spcAft>
-                <a:spcPts val="400"/>
-              </a:spcAft>
-              <a:buNone/>
-            </a:pPr>
-            <a:r>
-              <a:rPr lang="en-US" sz="1500" dirty="0">
-                <a:solidFill>
-                  <a:srgbClr val="24313A"/>
-                </a:solidFill>
-                <a:latin typeface="Calibri" pitchFamily="34" charset="0"/>
-                <a:ea typeface="Calibri" pitchFamily="34" charset="-122"/>
-                <a:cs typeface="Calibri" pitchFamily="34" charset="-120"/>
-              </a:rPr>
-              <a:t>Pension-rule change; the employer pays both contributions and the retiree earns no further service credit.</a:t>
-            </a:r>
-            <a:endParaRPr lang="en-US" sz="1500" dirty="0"/>
-          </a:p>
-          <a:p>
-            <a:pPr indent="0" marL="0">
-              <a:lnSpc>
-                <a:spcPct val="104000"/>
-              </a:lnSpc>
-              <a:spcAft>
-                <a:spcPts val="400"/>
-              </a:spcAft>
-              <a:buNone/>
-            </a:pPr>
-            <a:r>
-              <a:rPr lang="en-US" sz="1500" b="1" dirty="0">
-                <a:solidFill>
-                  <a:srgbClr val="24313A"/>
-                </a:solidFill>
-                <a:latin typeface="Calibri" pitchFamily="34" charset="0"/>
-                <a:ea typeface="Calibri" pitchFamily="34" charset="-122"/>
-                <a:cs typeface="Calibri" pitchFamily="34" charset="-120"/>
-              </a:rPr>
-              <a:t>Since: </a:t>
-            </a:r>
-            <a:pPr indent="0" marL="0">
-              <a:lnSpc>
-                <a:spcPct val="104000"/>
-              </a:lnSpc>
-              <a:spcAft>
-                <a:spcPts val="400"/>
-              </a:spcAft>
-              <a:buNone/>
-            </a:pPr>
-            <a:r>
-              <a:rPr lang="en-US" sz="1500" dirty="0">
-                <a:solidFill>
-                  <a:srgbClr val="24313A"/>
-                </a:solidFill>
-                <a:latin typeface="Calibri" pitchFamily="34" charset="0"/>
-                <a:ea typeface="Calibri" pitchFamily="34" charset="-122"/>
-                <a:cs typeface="Calibri" pitchFamily="34" charset="-120"/>
-              </a:rPr>
-              <a:t>1 July 2022 to 30 June 2026 (succeeded by SB 150); about 350 retirees a year, under 1% of the workforce (2025 audit).</a:t>
+              <a:t>Since 1 July 2022 the state of Georgia has let retired teachers go back to full-time classroom teaching in shortage subjects without giving up their pension. A teacher who retired with thirty or more years of service and has been retired for at least a year can be hired as a full-time teacher in one of the three subjects of greatest need in their region, typically special education, mathematics, science, English or elementary teaching, and receives a full salary on top of the full pension. The school district pays the pension contributions and the retiree earns no further pension rights. A state audit in 2025 found that about 350 retirees a year had used the law, less than one percent of Georgia's teachers. The law expires on 30 June 2026 and is being replaced by a new one, Senate Bill 150.</a:t>
             </a:r>
             <a:endParaRPr lang="en-US" sz="1500" dirty="0"/>
           </a:p>
@@ -9267,15 +8067,12 @@
           <a:p>
             <a:pPr indent="0" marL="0">
               <a:lnSpc>
-                <a:spcPct val="104000"/>
+                <a:spcPct val="106000"/>
               </a:lnSpc>
-              <a:spcAft>
-                <a:spcPts val="400"/>
-              </a:spcAft>
-              <a:buNone/>
-            </a:pPr>
-            <a:r>
-              <a:rPr lang="en-US" sz="1500" b="1" dirty="0">
+              <a:buNone/>
+            </a:pPr>
+            <a:r>
+              <a:rPr lang="en-US" sz="1500" dirty="0">
                 <a:solidFill>
                   <a:srgbClr val="24313A"/>
                 </a:solidFill>
@@ -9283,156 +8080,7 @@
                 <a:ea typeface="Calibri" pitchFamily="34" charset="-122"/>
                 <a:cs typeface="Calibri" pitchFamily="34" charset="-120"/>
               </a:rPr>
-              <a:t>What it is: </a:t>
-            </a:r>
-            <a:pPr indent="0" marL="0">
-              <a:lnSpc>
-                <a:spcPct val="104000"/>
-              </a:lnSpc>
-              <a:spcAft>
-                <a:spcPts val="400"/>
-              </a:spcAft>
-              <a:buNone/>
-            </a:pPr>
-            <a:r>
-              <a:rPr lang="en-US" sz="1500" dirty="0">
-                <a:solidFill>
-                  <a:srgbClr val="24313A"/>
-                </a:solidFill>
-                <a:latin typeface="Calibri" pitchFamily="34" charset="0"/>
-                <a:ea typeface="Calibri" pitchFamily="34" charset="-122"/>
-                <a:cs typeface="Calibri" pitchFamily="34" charset="-120"/>
-              </a:rPr>
-              <a:t>A district programme that pays recently retired teachers to mentor new teachers, run by Aurora Public Schools.</a:t>
-            </a:r>
-            <a:endParaRPr lang="en-US" sz="1500" dirty="0"/>
-          </a:p>
-          <a:p>
-            <a:pPr indent="0" marL="0">
-              <a:lnSpc>
-                <a:spcPct val="104000"/>
-              </a:lnSpc>
-              <a:spcAft>
-                <a:spcPts val="400"/>
-              </a:spcAft>
-              <a:buNone/>
-            </a:pPr>
-            <a:r>
-              <a:rPr lang="en-US" sz="1500" b="1" dirty="0">
-                <a:solidFill>
-                  <a:srgbClr val="24313A"/>
-                </a:solidFill>
-                <a:latin typeface="Calibri" pitchFamily="34" charset="0"/>
-                <a:ea typeface="Calibri" pitchFamily="34" charset="-122"/>
-                <a:cs typeface="Calibri" pitchFamily="34" charset="-120"/>
-              </a:rPr>
-              <a:t>How it works: </a:t>
-            </a:r>
-            <a:pPr indent="0" marL="0">
-              <a:lnSpc>
-                <a:spcPct val="104000"/>
-              </a:lnSpc>
-              <a:spcAft>
-                <a:spcPts val="400"/>
-              </a:spcAft>
-              <a:buNone/>
-            </a:pPr>
-            <a:r>
-              <a:rPr lang="en-US" sz="1500" dirty="0">
-                <a:solidFill>
-                  <a:srgbClr val="24313A"/>
-                </a:solidFill>
-                <a:latin typeface="Calibri" pitchFamily="34" charset="0"/>
-                <a:ea typeface="Calibri" pitchFamily="34" charset="-122"/>
-                <a:cs typeface="Calibri" pitchFamily="34" charset="-120"/>
-              </a:rPr>
-              <a:t>Retired, highly effective Aurora teachers are hired part-time to mentor probationary teachers in high-need Title I elementary schools for two years, with weekly meetings and classroom observations, far more than the district's usual one-year ‘buddy’ mentoring.</a:t>
-            </a:r>
-            <a:endParaRPr lang="en-US" sz="1500" dirty="0"/>
-          </a:p>
-          <a:p>
-            <a:pPr indent="0" marL="0">
-              <a:lnSpc>
-                <a:spcPct val="104000"/>
-              </a:lnSpc>
-              <a:spcAft>
-                <a:spcPts val="400"/>
-              </a:spcAft>
-              <a:buNone/>
-            </a:pPr>
-            <a:r>
-              <a:rPr lang="en-US" sz="1500" b="1" dirty="0">
-                <a:solidFill>
-                  <a:srgbClr val="24313A"/>
-                </a:solidFill>
-                <a:latin typeface="Calibri" pitchFamily="34" charset="0"/>
-                <a:ea typeface="Calibri" pitchFamily="34" charset="-122"/>
-                <a:cs typeface="Calibri" pitchFamily="34" charset="-120"/>
-              </a:rPr>
-              <a:t>Means: </a:t>
-            </a:r>
-            <a:pPr indent="0" marL="0">
-              <a:lnSpc>
-                <a:spcPct val="104000"/>
-              </a:lnSpc>
-              <a:spcAft>
-                <a:spcPts val="400"/>
-              </a:spcAft>
-              <a:buNone/>
-            </a:pPr>
-            <a:r>
-              <a:rPr lang="en-US" sz="1500" dirty="0">
-                <a:solidFill>
-                  <a:srgbClr val="24313A"/>
-                </a:solidFill>
-                <a:latin typeface="Calibri" pitchFamily="34" charset="0"/>
-                <a:ea typeface="Calibri" pitchFamily="34" charset="-122"/>
-                <a:cs typeface="Calibri" pitchFamily="34" charset="-120"/>
-              </a:rPr>
-              <a:t>Paid, part-time mentor posts for retirees.</a:t>
-            </a:r>
-            <a:endParaRPr lang="en-US" sz="1500" dirty="0"/>
-          </a:p>
-          <a:p>
-            <a:pPr indent="0" marL="0">
-              <a:lnSpc>
-                <a:spcPct val="104000"/>
-              </a:lnSpc>
-              <a:spcAft>
-                <a:spcPts val="400"/>
-              </a:spcAft>
-              <a:buNone/>
-            </a:pPr>
-            <a:r>
-              <a:rPr lang="en-US" sz="1500" b="1" dirty="0">
-                <a:solidFill>
-                  <a:srgbClr val="24313A"/>
-                </a:solidFill>
-                <a:latin typeface="Calibri" pitchFamily="34" charset="0"/>
-                <a:ea typeface="Calibri" pitchFamily="34" charset="-122"/>
-                <a:cs typeface="Calibri" pitchFamily="34" charset="-120"/>
-              </a:rPr>
-              <a:t>Since: </a:t>
-            </a:r>
-            <a:pPr indent="0" marL="0">
-              <a:lnSpc>
-                <a:spcPct val="104000"/>
-              </a:lnSpc>
-              <a:spcAft>
-                <a:spcPts val="400"/>
-              </a:spcAft>
-              <a:buNone/>
-            </a:pPr>
-            <a:r>
-              <a:rPr lang="en-US" sz="1500" dirty="0">
-                <a:solidFill>
-                  <a:srgbClr val="24313A"/>
-                </a:solidFill>
-                <a:latin typeface="Calibri" pitchFamily="34" charset="0"/>
-                <a:ea typeface="Calibri" pitchFamily="34" charset="-122"/>
-                <a:cs typeface="Calibri" pitchFamily="34" charset="-120"/>
-              </a:rPr>
-              <a:t>Evaluated in a randomised trial by REL Central (IES, 2017) with 77 teachers in 11 schools: small maths gain after year one (effect size 0.06, not sustained), no effect on reading or on new-teacher retention.</a:t>
+              <a:t>Aurora Public Schools, a district in Colorado, pays recently retired teachers to mentor new teachers. Retired teachers with a strong record in the district are hired part-time to accompany first- and second-year teachers in high-poverty elementary schools for two years, meeting them every week and observing their lessons, which is far more support than the district's usual one-year ‘buddy’ scheme. For the retiree it is a paid, part-time way back into the school system; for the district it is a way to keep expertise in the classroom. A randomised trial run by the Regional Educational Laboratory Central for the US Institute of Education Sciences, published in 2017, followed 77 new teachers in 11 schools: it found a small gain in pupils' mathematics results after the first year that did not last, no effect on reading and no effect on whether the new teachers stayed.</a:t>
             </a:r>
             <a:endParaRPr lang="en-US" sz="1500" dirty="0"/>
           </a:p>
@@ -10602,7 +9250,7 @@
                           <a:ea typeface="Calibri" pitchFamily="34" charset="-122"/>
                           <a:cs typeface="Calibri" pitchFamily="34" charset="-120"/>
                         </a:rPr>
-                        <a:t>Silver-Age Lecturing Plan (银龄讲学计划), 2018–</a:t>
+                        <a:t>Silver-Age Lecturing Plan: retired teachers posted to rural schools, 2018–</a:t>
                       </a:r>
                       <a:endParaRPr lang="en-US" sz="950" dirty="0">
                         <a:latin typeface="Calibri" charset="0"/>
@@ -10876,7 +9524,7 @@
                           <a:ea typeface="Calibri" pitchFamily="34" charset="-122"/>
                           <a:cs typeface="Calibri" pitchFamily="34" charset="-120"/>
                         </a:rPr>
-                        <a:t>Raising and then abolishing the earnings ceiling for retired teachers (Hinzuverdienstgrenze), 2022–2024</a:t>
+                        <a:t>Higher, then no, earnings ceiling for retired teachers who keep teaching, 2022–2024</a:t>
                       </a:r>
                       <a:endParaRPr lang="en-US" sz="950" dirty="0">
                         <a:latin typeface="Calibri" charset="0"/>
@@ -11972,7 +10620,7 @@
                           <a:ea typeface="Calibri" pitchFamily="34" charset="-122"/>
                           <a:cs typeface="Calibri" pitchFamily="34" charset="-120"/>
                         </a:rPr>
-                        <a:t>Regeling tegemoetkoming herintreders primair onderwijs (2017–2020)</a:t>
+                        <a:t>Grant to primary schools for re-hiring former teachers, 2017–2020</a:t>
                       </a:r>
                       <a:endParaRPr lang="en-US" sz="950" dirty="0">
                         <a:latin typeface="Calibri" charset="0"/>
@@ -12520,7 +11168,7 @@
                           <a:ea typeface="Calibri" pitchFamily="34" charset="-122"/>
                           <a:cs typeface="Calibri" pitchFamily="34" charset="-120"/>
                         </a:rPr>
-                        <a:t>Decreto-Lei n.º 51/2024: contracting retired teachers for shortage areas (2024/25–)</a:t>
+                        <a:t>Decree-Law 51/2024: schools may hire retired teachers for shortage posts, 2024/25–</a:t>
                       </a:r>
                       <a:endParaRPr lang="en-US" sz="950" dirty="0">
                         <a:latin typeface="Calibri" charset="0"/>
@@ -13342,7 +11990,7 @@
                           <a:ea typeface="Calibri" pitchFamily="34" charset="-122"/>
                           <a:cs typeface="Calibri" pitchFamily="34" charset="-120"/>
                         </a:rPr>
-                        <a:t>PH Zürich ‘Wiedereinstieg’ re-entry programme for returning teachers</a:t>
+                        <a:t>Re-entry counselling and induction for returning teachers (Zurich University of Teacher Education)</a:t>
                       </a:r>
                       <a:endParaRPr lang="en-US" sz="950" dirty="0">
                         <a:latin typeface="Calibri" charset="0"/>
@@ -16052,15 +14700,12 @@
           <a:p>
             <a:pPr indent="0" marL="0">
               <a:lnSpc>
-                <a:spcPct val="104000"/>
+                <a:spcPct val="106000"/>
               </a:lnSpc>
-              <a:spcAft>
-                <a:spcPts val="400"/>
-              </a:spcAft>
-              <a:buNone/>
-            </a:pPr>
-            <a:r>
-              <a:rPr lang="en-US" sz="1500" b="1" dirty="0">
+              <a:buNone/>
+            </a:pPr>
+            <a:r>
+              <a:rPr lang="en-US" sz="1500" dirty="0">
                 <a:solidFill>
                   <a:srgbClr val="24313A"/>
                 </a:solidFill>
@@ -16068,156 +14713,7 @@
                 <a:ea typeface="Calibri" pitchFamily="34" charset="-122"/>
                 <a:cs typeface="Calibri" pitchFamily="34" charset="-120"/>
               </a:rPr>
-              <a:t>What it is: </a:t>
-            </a:r>
-            <a:pPr indent="0" marL="0">
-              <a:lnSpc>
-                <a:spcPct val="104000"/>
-              </a:lnSpc>
-              <a:spcAft>
-                <a:spcPts val="400"/>
-              </a:spcAft>
-              <a:buNone/>
-            </a:pPr>
-            <a:r>
-              <a:rPr lang="en-US" sz="1500" dirty="0">
-                <a:solidFill>
-                  <a:srgbClr val="24313A"/>
-                </a:solidFill>
-                <a:latin typeface="Calibri" pitchFamily="34" charset="0"/>
-                <a:ea typeface="Calibri" pitchFamily="34" charset="-122"/>
-                <a:cs typeface="Calibri" pitchFamily="34" charset="-120"/>
-              </a:rPr>
-              <a:t>A paid ‘try-out’ placement in a public school for teachers who left the classroom, run by Victoria's Department of Education.</a:t>
-            </a:r>
-            <a:endParaRPr lang="en-US" sz="1500" dirty="0"/>
-          </a:p>
-          <a:p>
-            <a:pPr indent="0" marL="0">
-              <a:lnSpc>
-                <a:spcPct val="104000"/>
-              </a:lnSpc>
-              <a:spcAft>
-                <a:spcPts val="400"/>
-              </a:spcAft>
-              <a:buNone/>
-            </a:pPr>
-            <a:r>
-              <a:rPr lang="en-US" sz="1500" b="1" dirty="0">
-                <a:solidFill>
-                  <a:srgbClr val="24313A"/>
-                </a:solidFill>
-                <a:latin typeface="Calibri" pitchFamily="34" charset="0"/>
-                <a:ea typeface="Calibri" pitchFamily="34" charset="-122"/>
-                <a:cs typeface="Calibri" pitchFamily="34" charset="-120"/>
-              </a:rPr>
-              <a:t>How it works: </a:t>
-            </a:r>
-            <a:pPr indent="0" marL="0">
-              <a:lnSpc>
-                <a:spcPct val="104000"/>
-              </a:lnSpc>
-              <a:spcAft>
-                <a:spcPts val="400"/>
-              </a:spcAft>
-              <a:buNone/>
-            </a:pPr>
-            <a:r>
-              <a:rPr lang="en-US" sz="1500" dirty="0">
-                <a:solidFill>
-                  <a:srgbClr val="24313A"/>
-                </a:solidFill>
-                <a:latin typeface="Calibri" pitchFamily="34" charset="0"/>
-                <a:ea typeface="Calibri" pitchFamily="34" charset="-122"/>
-                <a:cs typeface="Calibri" pitchFamily="34" charset="-120"/>
-              </a:rPr>
-              <a:t>A qualified teacher who has been out of a teaching job for 12+ months (career break or retirement) registers online; the TREI team contacts them, offers free coaching (CV, interviews, curriculum refresher) and arranges up to 40 days in a government school to observe lessons, teach and be mentored by current staff before applying for a real vacancy.</a:t>
-            </a:r>
-            <a:endParaRPr lang="en-US" sz="1500" dirty="0"/>
-          </a:p>
-          <a:p>
-            <a:pPr indent="0" marL="0">
-              <a:lnSpc>
-                <a:spcPct val="104000"/>
-              </a:lnSpc>
-              <a:spcAft>
-                <a:spcPts val="400"/>
-              </a:spcAft>
-              <a:buNone/>
-            </a:pPr>
-            <a:r>
-              <a:rPr lang="en-US" sz="1500" b="1" dirty="0">
-                <a:solidFill>
-                  <a:srgbClr val="24313A"/>
-                </a:solidFill>
-                <a:latin typeface="Calibri" pitchFamily="34" charset="0"/>
-                <a:ea typeface="Calibri" pitchFamily="34" charset="-122"/>
-                <a:cs typeface="Calibri" pitchFamily="34" charset="-120"/>
-              </a:rPr>
-              <a:t>Means: </a:t>
-            </a:r>
-            <a:pPr indent="0" marL="0">
-              <a:lnSpc>
-                <a:spcPct val="104000"/>
-              </a:lnSpc>
-              <a:spcAft>
-                <a:spcPts val="400"/>
-              </a:spcAft>
-              <a:buNone/>
-            </a:pPr>
-            <a:r>
-              <a:rPr lang="en-US" sz="1500" dirty="0">
-                <a:solidFill>
-                  <a:srgbClr val="24313A"/>
-                </a:solidFill>
-                <a:latin typeface="Calibri" pitchFamily="34" charset="0"/>
-                <a:ea typeface="Calibri" pitchFamily="34" charset="-122"/>
-                <a:cs typeface="Calibri" pitchFamily="34" charset="-120"/>
-              </a:rPr>
-              <a:t>An honorarium of up to AUD 12,000 for the 40 days; AUD 12 million in the 2023/24 state budget.</a:t>
-            </a:r>
-            <a:endParaRPr lang="en-US" sz="1500" dirty="0"/>
-          </a:p>
-          <a:p>
-            <a:pPr indent="0" marL="0">
-              <a:lnSpc>
-                <a:spcPct val="104000"/>
-              </a:lnSpc>
-              <a:spcAft>
-                <a:spcPts val="400"/>
-              </a:spcAft>
-              <a:buNone/>
-            </a:pPr>
-            <a:r>
-              <a:rPr lang="en-US" sz="1500" b="1" dirty="0">
-                <a:solidFill>
-                  <a:srgbClr val="24313A"/>
-                </a:solidFill>
-                <a:latin typeface="Calibri" pitchFamily="34" charset="0"/>
-                <a:ea typeface="Calibri" pitchFamily="34" charset="-122"/>
-                <a:cs typeface="Calibri" pitchFamily="34" charset="-120"/>
-              </a:rPr>
-              <a:t>Since: </a:t>
-            </a:r>
-            <a:pPr indent="0" marL="0">
-              <a:lnSpc>
-                <a:spcPct val="104000"/>
-              </a:lnSpc>
-              <a:spcAft>
-                <a:spcPts val="400"/>
-              </a:spcAft>
-              <a:buNone/>
-            </a:pPr>
-            <a:r>
-              <a:rPr lang="en-US" sz="1500" dirty="0">
-                <a:solidFill>
-                  <a:srgbClr val="24313A"/>
-                </a:solidFill>
-                <a:latin typeface="Calibri" pitchFamily="34" charset="0"/>
-                <a:ea typeface="Calibri" pitchFamily="34" charset="-122"/>
-                <a:cs typeface="Calibri" pitchFamily="34" charset="-120"/>
-              </a:rPr>
-              <a:t>Late 2022 (placements funded to June 2025); 1,100+ expressions of interest in the first months.</a:t>
+              <a:t>The Teacher Re-Engagement Initiative is a scheme of the Department of Education of the state of Victoria for qualified teachers who stopped teaching at least a year ago, whether they retired or moved to another job. It lets them spend up to forty paid days in a public school to get used to the classroom again before they apply for a real post. After a teacher registers, a team from the department calls them, offers free coaching on writing a CV, preparing for interviews and the current curriculum, and finds them a school; during the forty days they observe lessons, teach and are guided by serving teachers. Those returning from retirement or a career break are paid up to 12,000 Australian dollars (about 7,200 euros) for the forty days. The initiative began in late 2022, received more than 1,100 expressions of interest in its first months and was given 12 million Australian dollars (about 7.2 million euros) in the 2023/24 state budget; placements ran until June 2025.</a:t>
             </a:r>
             <a:endParaRPr lang="en-US" sz="1500" dirty="0"/>
           </a:p>
@@ -16779,15 +15275,12 @@
           <a:p>
             <a:pPr indent="0" marL="0">
               <a:lnSpc>
-                <a:spcPct val="104000"/>
+                <a:spcPct val="106000"/>
               </a:lnSpc>
-              <a:spcAft>
-                <a:spcPts val="400"/>
-              </a:spcAft>
-              <a:buNone/>
-            </a:pPr>
-            <a:r>
-              <a:rPr lang="en-US" sz="1500" b="1" dirty="0">
+              <a:buNone/>
+            </a:pPr>
+            <a:r>
+              <a:rPr lang="en-US" sz="1500" dirty="0">
                 <a:solidFill>
                   <a:srgbClr val="24313A"/>
                 </a:solidFill>
@@ -16795,156 +15288,7 @@
                 <a:ea typeface="Calibri" pitchFamily="34" charset="-122"/>
                 <a:cs typeface="Calibri" pitchFamily="34" charset="-120"/>
               </a:rPr>
-              <a:t>What it is: </a:t>
-            </a:r>
-            <a:pPr indent="0" marL="0">
-              <a:lnSpc>
-                <a:spcPct val="104000"/>
-              </a:lnSpc>
-              <a:spcAft>
-                <a:spcPts val="400"/>
-              </a:spcAft>
-              <a:buNone/>
-            </a:pPr>
-            <a:r>
-              <a:rPr lang="en-US" sz="1500" dirty="0">
-                <a:solidFill>
-                  <a:srgbClr val="24313A"/>
-                </a:solidFill>
-                <a:latin typeface="Calibri" pitchFamily="34" charset="0"/>
-                <a:ea typeface="Calibri" pitchFamily="34" charset="-122"/>
-                <a:cs typeface="Calibri" pitchFamily="34" charset="-120"/>
-              </a:rPr>
-              <a:t>A pay premium for retired teachers who come back to substitute or teach, set by the Quebec Ministry of Education.</a:t>
-            </a:r>
-            <a:endParaRPr lang="en-US" sz="1500" dirty="0"/>
-          </a:p>
-          <a:p>
-            <a:pPr indent="0" marL="0">
-              <a:lnSpc>
-                <a:spcPct val="104000"/>
-              </a:lnSpc>
-              <a:spcAft>
-                <a:spcPts val="400"/>
-              </a:spcAft>
-              <a:buNone/>
-            </a:pPr>
-            <a:r>
-              <a:rPr lang="en-US" sz="1500" b="1" dirty="0">
-                <a:solidFill>
-                  <a:srgbClr val="24313A"/>
-                </a:solidFill>
-                <a:latin typeface="Calibri" pitchFamily="34" charset="0"/>
-                <a:ea typeface="Calibri" pitchFamily="34" charset="-122"/>
-                <a:cs typeface="Calibri" pitchFamily="34" charset="-120"/>
-              </a:rPr>
-              <a:t>How it works: </a:t>
-            </a:r>
-            <a:pPr indent="0" marL="0">
-              <a:lnSpc>
-                <a:spcPct val="104000"/>
-              </a:lnSpc>
-              <a:spcAft>
-                <a:spcPts val="400"/>
-              </a:spcAft>
-              <a:buNone/>
-            </a:pPr>
-            <a:r>
-              <a:rPr lang="en-US" sz="1500" dirty="0">
-                <a:solidFill>
-                  <a:srgbClr val="24313A"/>
-                </a:solidFill>
-                <a:latin typeface="Calibri" pitchFamily="34" charset="0"/>
-                <a:ea typeface="Calibri" pitchFamily="34" charset="-122"/>
-                <a:cs typeface="Calibri" pitchFamily="34" charset="-120"/>
-              </a:rPr>
-              <a:t>Any retiree with a teaching authorisation who works again in a public school is paid from day one at the salary step they had when they retired (about CAD 412 a day instead of the usual CAD 212 substitute rate) and keeps the full pension. In August 2023 the minister also wrote to every retired teacher inviting them back.</a:t>
-            </a:r>
-            <a:endParaRPr lang="en-US" sz="1500" dirty="0"/>
-          </a:p>
-          <a:p>
-            <a:pPr indent="0" marL="0">
-              <a:lnSpc>
-                <a:spcPct val="104000"/>
-              </a:lnSpc>
-              <a:spcAft>
-                <a:spcPts val="400"/>
-              </a:spcAft>
-              <a:buNone/>
-            </a:pPr>
-            <a:r>
-              <a:rPr lang="en-US" sz="1500" b="1" dirty="0">
-                <a:solidFill>
-                  <a:srgbClr val="24313A"/>
-                </a:solidFill>
-                <a:latin typeface="Calibri" pitchFamily="34" charset="0"/>
-                <a:ea typeface="Calibri" pitchFamily="34" charset="-122"/>
-                <a:cs typeface="Calibri" pitchFamily="34" charset="-120"/>
-              </a:rPr>
-              <a:t>Means: </a:t>
-            </a:r>
-            <a:pPr indent="0" marL="0">
-              <a:lnSpc>
-                <a:spcPct val="104000"/>
-              </a:lnSpc>
-              <a:spcAft>
-                <a:spcPts val="400"/>
-              </a:spcAft>
-              <a:buNone/>
-            </a:pPr>
-            <a:r>
-              <a:rPr lang="en-US" sz="1500" dirty="0">
-                <a:solidFill>
-                  <a:srgbClr val="24313A"/>
-                </a:solidFill>
-                <a:latin typeface="Calibri" pitchFamily="34" charset="0"/>
-                <a:ea typeface="Calibri" pitchFamily="34" charset="-122"/>
-                <a:cs typeface="Calibri" pitchFamily="34" charset="-120"/>
-              </a:rPr>
-              <a:t>Higher daily pay (top rate CAD 578 in 2023–24) with no pension penalty.</a:t>
-            </a:r>
-            <a:endParaRPr lang="en-US" sz="1500" dirty="0"/>
-          </a:p>
-          <a:p>
-            <a:pPr indent="0" marL="0">
-              <a:lnSpc>
-                <a:spcPct val="104000"/>
-              </a:lnSpc>
-              <a:spcAft>
-                <a:spcPts val="400"/>
-              </a:spcAft>
-              <a:buNone/>
-            </a:pPr>
-            <a:r>
-              <a:rPr lang="en-US" sz="1500" b="1" dirty="0">
-                <a:solidFill>
-                  <a:srgbClr val="24313A"/>
-                </a:solidFill>
-                <a:latin typeface="Calibri" pitchFamily="34" charset="0"/>
-                <a:ea typeface="Calibri" pitchFamily="34" charset="-122"/>
-                <a:cs typeface="Calibri" pitchFamily="34" charset="-120"/>
-              </a:rPr>
-              <a:t>Since: </a:t>
-            </a:r>
-            <a:pPr indent="0" marL="0">
-              <a:lnSpc>
-                <a:spcPct val="104000"/>
-              </a:lnSpc>
-              <a:spcAft>
-                <a:spcPts val="400"/>
-              </a:spcAft>
-              <a:buNone/>
-            </a:pPr>
-            <a:r>
-              <a:rPr lang="en-US" sz="1500" dirty="0">
-                <a:solidFill>
-                  <a:srgbClr val="24313A"/>
-                </a:solidFill>
-                <a:latin typeface="Calibri" pitchFamily="34" charset="0"/>
-                <a:ea typeface="Calibri" pitchFamily="34" charset="-122"/>
-                <a:cs typeface="Calibri" pitchFamily="34" charset="-120"/>
-              </a:rPr>
-              <a:t>21 September 2020 (pandemic measure made permanent); 700 retirees returned in 2020–21 and over 5,000 worked in schools in 2022–23.</a:t>
+              <a:t>Quebec pays retired teachers who come back to work in public schools much better than an ordinary substitute. From their first day of substitute teaching they are paid at the salary step they had reached when they retired, roughly 412 Canadian dollars a day (about 275 euros) instead of the usual substitute rate of 212 dollars (about 140 euros), and they keep their full pension. The measure was introduced on 21 September 2020, during the pandemic, brought 700 retirees back that school year and was later made permanent. In August 2023 the Minister of Education also wrote personally to every retired teacher inviting them to return; more than 5,000 retirees had worked in schools the previous year, mostly as substitutes or on part-time contracts, and the top daily rate was raised to 578 dollars (about 385 euros).</a:t>
             </a:r>
             <a:endParaRPr lang="en-US" sz="1500" dirty="0"/>
           </a:p>
@@ -17481,7 +15825,7 @@
                 <a:ea typeface="Cambria" pitchFamily="34" charset="-122"/>
                 <a:cs typeface="Cambria" pitchFamily="34" charset="-120"/>
               </a:rPr>
-              <a:t>Silver-Age Lecturing Plan (银龄讲学计划), 2018–</a:t>
+              <a:t>Silver-Age Lecturing Plan: retired teachers posted to rural schools, 2018–</a:t>
             </a:r>
             <a:endParaRPr lang="en-US" sz="2100" dirty="0"/>
           </a:p>
@@ -17510,15 +15854,12 @@
           <a:p>
             <a:pPr indent="0" marL="0">
               <a:lnSpc>
-                <a:spcPct val="104000"/>
+                <a:spcPct val="106000"/>
               </a:lnSpc>
-              <a:spcAft>
-                <a:spcPts val="400"/>
-              </a:spcAft>
-              <a:buNone/>
-            </a:pPr>
-            <a:r>
-              <a:rPr lang="en-US" sz="1500" b="1" dirty="0">
+              <a:buNone/>
+            </a:pPr>
+            <a:r>
+              <a:rPr lang="en-US" sz="1500" dirty="0">
                 <a:solidFill>
                   <a:srgbClr val="24313A"/>
                 </a:solidFill>
@@ -17526,156 +15867,7 @@
                 <a:ea typeface="Calibri" pitchFamily="34" charset="-122"/>
                 <a:cs typeface="Calibri" pitchFamily="34" charset="-120"/>
               </a:rPr>
-              <a:t>What it is: </a:t>
-            </a:r>
-            <a:pPr indent="0" marL="0">
-              <a:lnSpc>
-                <a:spcPct val="104000"/>
-              </a:lnSpc>
-              <a:spcAft>
-                <a:spcPts val="400"/>
-              </a:spcAft>
-              <a:buNone/>
-            </a:pPr>
-            <a:r>
-              <a:rPr lang="en-US" sz="1500" dirty="0">
-                <a:solidFill>
-                  <a:srgbClr val="24313A"/>
-                </a:solidFill>
-                <a:latin typeface="Calibri" pitchFamily="34" charset="0"/>
-                <a:ea typeface="Calibri" pitchFamily="34" charset="-122"/>
-                <a:cs typeface="Calibri" pitchFamily="34" charset="-120"/>
-              </a:rPr>
-              <a:t>A national programme that sends retired teachers to teach in poor rural schools, run by the Ministries of Education and Finance.</a:t>
-            </a:r>
-            <a:endParaRPr lang="en-US" sz="1500" dirty="0"/>
-          </a:p>
-          <a:p>
-            <a:pPr indent="0" marL="0">
-              <a:lnSpc>
-                <a:spcPct val="104000"/>
-              </a:lnSpc>
-              <a:spcAft>
-                <a:spcPts val="400"/>
-              </a:spcAft>
-              <a:buNone/>
-            </a:pPr>
-            <a:r>
-              <a:rPr lang="en-US" sz="1500" b="1" dirty="0">
-                <a:solidFill>
-                  <a:srgbClr val="24313A"/>
-                </a:solidFill>
-                <a:latin typeface="Calibri" pitchFamily="34" charset="0"/>
-                <a:ea typeface="Calibri" pitchFamily="34" charset="-122"/>
-                <a:cs typeface="Calibri" pitchFamily="34" charset="-120"/>
-              </a:rPr>
-              <a:t>How it works: </a:t>
-            </a:r>
-            <a:pPr indent="0" marL="0">
-              <a:lnSpc>
-                <a:spcPct val="104000"/>
-              </a:lnSpc>
-              <a:spcAft>
-                <a:spcPts val="400"/>
-              </a:spcAft>
-              <a:buNone/>
-            </a:pPr>
-            <a:r>
-              <a:rPr lang="en-US" sz="1500" dirty="0">
-                <a:solidFill>
-                  <a:srgbClr val="24313A"/>
-                </a:solidFill>
-                <a:latin typeface="Calibri" pitchFamily="34" charset="0"/>
-                <a:ea typeface="Calibri" pitchFamily="34" charset="-122"/>
-                <a:cs typeface="Calibri" pitchFamily="34" charset="-120"/>
-              </a:rPr>
-              <a:t>Retired principals, senior and ‘special-grade’ teachers aged 65 or under apply to a provincial call and are posted for at least one school year to a rural compulsory-education school, where they teach, coach young teachers and advise on school management.</a:t>
-            </a:r>
-            <a:endParaRPr lang="en-US" sz="1500" dirty="0"/>
-          </a:p>
-          <a:p>
-            <a:pPr indent="0" marL="0">
-              <a:lnSpc>
-                <a:spcPct val="104000"/>
-              </a:lnSpc>
-              <a:spcAft>
-                <a:spcPts val="400"/>
-              </a:spcAft>
-              <a:buNone/>
-            </a:pPr>
-            <a:r>
-              <a:rPr lang="en-US" sz="1500" b="1" dirty="0">
-                <a:solidFill>
-                  <a:srgbClr val="24313A"/>
-                </a:solidFill>
-                <a:latin typeface="Calibri" pitchFamily="34" charset="0"/>
-                <a:ea typeface="Calibri" pitchFamily="34" charset="-122"/>
-                <a:cs typeface="Calibri" pitchFamily="34" charset="-120"/>
-              </a:rPr>
-              <a:t>Means: </a:t>
-            </a:r>
-            <a:pPr indent="0" marL="0">
-              <a:lnSpc>
-                <a:spcPct val="104000"/>
-              </a:lnSpc>
-              <a:spcAft>
-                <a:spcPts val="400"/>
-              </a:spcAft>
-              <a:buNone/>
-            </a:pPr>
-            <a:r>
-              <a:rPr lang="en-US" sz="1500" dirty="0">
-                <a:solidFill>
-                  <a:srgbClr val="24313A"/>
-                </a:solidFill>
-                <a:latin typeface="Calibri" pitchFamily="34" charset="0"/>
-                <a:ea typeface="Calibri" pitchFamily="34" charset="-122"/>
-                <a:cs typeface="Calibri" pitchFamily="34" charset="-120"/>
-              </a:rPr>
-              <a:t>They keep their pension and receive a central-government allowance of CNY 20,000 a year (stipend, travel, insurance).</a:t>
-            </a:r>
-            <a:endParaRPr lang="en-US" sz="1500" dirty="0"/>
-          </a:p>
-          <a:p>
-            <a:pPr indent="0" marL="0">
-              <a:lnSpc>
-                <a:spcPct val="104000"/>
-              </a:lnSpc>
-              <a:spcAft>
-                <a:spcPts val="400"/>
-              </a:spcAft>
-              <a:buNone/>
-            </a:pPr>
-            <a:r>
-              <a:rPr lang="en-US" sz="1500" b="1" dirty="0">
-                <a:solidFill>
-                  <a:srgbClr val="24313A"/>
-                </a:solidFill>
-                <a:latin typeface="Calibri" pitchFamily="34" charset="0"/>
-                <a:ea typeface="Calibri" pitchFamily="34" charset="-122"/>
-                <a:cs typeface="Calibri" pitchFamily="34" charset="-120"/>
-              </a:rPr>
-              <a:t>Since: </a:t>
-            </a:r>
-            <a:pPr indent="0" marL="0">
-              <a:lnSpc>
-                <a:spcPct val="104000"/>
-              </a:lnSpc>
-              <a:spcAft>
-                <a:spcPts val="400"/>
-              </a:spcAft>
-              <a:buNone/>
-            </a:pPr>
-            <a:r>
-              <a:rPr lang="en-US" sz="1500" dirty="0">
-                <a:solidFill>
-                  <a:srgbClr val="24313A"/>
-                </a:solidFill>
-                <a:latin typeface="Calibri" pitchFamily="34" charset="0"/>
-                <a:ea typeface="Calibri" pitchFamily="34" charset="-122"/>
-                <a:cs typeface="Calibri" pitchFamily="34" charset="-120"/>
-              </a:rPr>
-              <a:t>2018 (10,000 posts planned for 2018–20; 7,000 recruited in 2024); expanded in 2023 into the National Silver-Age Teachers Action Plan.</a:t>
+              <a:t>The Silver-Age Lecturing Plan sends retired teachers to work in poor rural schools. Retired principals, senior teachers and ‘special-grade’ teachers aged 65 or under apply to a call issued by their province and are posted for at least one school year to a rural primary or lower-secondary school, where they teach, coach the school's young teachers and advise the head on running the school. They keep their pension and receive an allowance from the central government of 20,000 yuan a year (about 2,500 euros) to cover a stipend, travel and insurance. The plan was launched in 2018 by the Ministries of Education and Finance with a target of 10,000 posts over three years; 7,000 teachers were recruited in the 2024 round alone, and in 2023 it was folded into a broader National Silver-Age Teachers Action Plan covering all levels of education.</a:t>
             </a:r>
             <a:endParaRPr lang="en-US" sz="1500" dirty="0"/>
           </a:p>
@@ -18251,7 +16443,7 @@
                 <a:ea typeface="Cambria" pitchFamily="34" charset="-122"/>
                 <a:cs typeface="Cambria" pitchFamily="34" charset="-120"/>
               </a:rPr>
-              <a:t>Raising and then abolishing the earnings ceiling for retired teachers (Hinzuverdienstgrenze), 2022–2024</a:t>
+              <a:t>Higher, then no, earnings ceiling for retired teachers who keep teaching, 2022–2024</a:t>
             </a:r>
             <a:endParaRPr lang="en-US" sz="2100" dirty="0"/>
           </a:p>
@@ -18280,15 +16472,12 @@
           <a:p>
             <a:pPr indent="0" marL="0">
               <a:lnSpc>
-                <a:spcPct val="104000"/>
+                <a:spcPct val="106000"/>
               </a:lnSpc>
-              <a:spcAft>
-                <a:spcPts val="400"/>
-              </a:spcAft>
-              <a:buNone/>
-            </a:pPr>
-            <a:r>
-              <a:rPr lang="en-US" sz="1500" b="1" dirty="0">
+              <a:buNone/>
+            </a:pPr>
+            <a:r>
+              <a:rPr lang="en-US" sz="1500" dirty="0">
                 <a:solidFill>
                   <a:srgbClr val="24313A"/>
                 </a:solidFill>
@@ -18296,156 +16485,7 @@
                 <a:ea typeface="Calibri" pitchFamily="34" charset="-122"/>
                 <a:cs typeface="Calibri" pitchFamily="34" charset="-120"/>
               </a:rPr>
-              <a:t>What it is: </a:t>
-            </a:r>
-            <a:pPr indent="0" marL="0">
-              <a:lnSpc>
-                <a:spcPct val="104000"/>
-              </a:lnSpc>
-              <a:spcAft>
-                <a:spcPts val="400"/>
-              </a:spcAft>
-              <a:buNone/>
-            </a:pPr>
-            <a:r>
-              <a:rPr lang="en-US" sz="1500" dirty="0">
-                <a:solidFill>
-                  <a:srgbClr val="24313A"/>
-                </a:solidFill>
-                <a:latin typeface="Calibri" pitchFamily="34" charset="0"/>
-                <a:ea typeface="Calibri" pitchFamily="34" charset="-122"/>
-                <a:cs typeface="Calibri" pitchFamily="34" charset="-120"/>
-              </a:rPr>
-              <a:t>A change in pension rules so that retired teachers can earn more from teaching without losing pension, passed by the Lower Saxony parliament.</a:t>
-            </a:r>
-            <a:endParaRPr lang="en-US" sz="1500" dirty="0"/>
-          </a:p>
-          <a:p>
-            <a:pPr indent="0" marL="0">
-              <a:lnSpc>
-                <a:spcPct val="104000"/>
-              </a:lnSpc>
-              <a:spcAft>
-                <a:spcPts val="400"/>
-              </a:spcAft>
-              <a:buNone/>
-            </a:pPr>
-            <a:r>
-              <a:rPr lang="en-US" sz="1500" b="1" dirty="0">
-                <a:solidFill>
-                  <a:srgbClr val="24313A"/>
-                </a:solidFill>
-                <a:latin typeface="Calibri" pitchFamily="34" charset="0"/>
-                <a:ea typeface="Calibri" pitchFamily="34" charset="-122"/>
-                <a:cs typeface="Calibri" pitchFamily="34" charset="-120"/>
-              </a:rPr>
-              <a:t>How it works: </a:t>
-            </a:r>
-            <a:pPr indent="0" marL="0">
-              <a:lnSpc>
-                <a:spcPct val="104000"/>
-              </a:lnSpc>
-              <a:spcAft>
-                <a:spcPts val="400"/>
-              </a:spcAft>
-              <a:buNone/>
-            </a:pPr>
-            <a:r>
-              <a:rPr lang="en-US" sz="1500" dirty="0">
-                <a:solidFill>
-                  <a:srgbClr val="24313A"/>
-                </a:solidFill>
-                <a:latin typeface="Calibri" pitchFamily="34" charset="0"/>
-                <a:ea typeface="Calibri" pitchFamily="34" charset="-122"/>
-                <a:cs typeface="Calibri" pitchFamily="34" charset="-120"/>
-              </a:rPr>
-              <a:t>A pensioner's pay plus pension may not exceed a ceiling; above it the pension is cut. The ceiling rose from 100% to 125% of former pay (2019) and to 150% from 1 October 2022, which lets a pensioner teach about 9–10 hours a week with no cut; on 31 October 2024 the ceiling was abolished altogether.</a:t>
-            </a:r>
-            <a:endParaRPr lang="en-US" sz="1500" dirty="0"/>
-          </a:p>
-          <a:p>
-            <a:pPr indent="0" marL="0">
-              <a:lnSpc>
-                <a:spcPct val="104000"/>
-              </a:lnSpc>
-              <a:spcAft>
-                <a:spcPts val="400"/>
-              </a:spcAft>
-              <a:buNone/>
-            </a:pPr>
-            <a:r>
-              <a:rPr lang="en-US" sz="1500" b="1" dirty="0">
-                <a:solidFill>
-                  <a:srgbClr val="24313A"/>
-                </a:solidFill>
-                <a:latin typeface="Calibri" pitchFamily="34" charset="0"/>
-                <a:ea typeface="Calibri" pitchFamily="34" charset="-122"/>
-                <a:cs typeface="Calibri" pitchFamily="34" charset="-120"/>
-              </a:rPr>
-              <a:t>Means: </a:t>
-            </a:r>
-            <a:pPr indent="0" marL="0">
-              <a:lnSpc>
-                <a:spcPct val="104000"/>
-              </a:lnSpc>
-              <a:spcAft>
-                <a:spcPts val="400"/>
-              </a:spcAft>
-              <a:buNone/>
-            </a:pPr>
-            <a:r>
-              <a:rPr lang="en-US" sz="1500" dirty="0">
-                <a:solidFill>
-                  <a:srgbClr val="24313A"/>
-                </a:solidFill>
-                <a:latin typeface="Calibri" pitchFamily="34" charset="0"/>
-                <a:ea typeface="Calibri" pitchFamily="34" charset="-122"/>
-                <a:cs typeface="Calibri" pitchFamily="34" charset="-120"/>
-              </a:rPr>
-              <a:t>Amendment of the civil-service pension law, plus 15% higher overtime pay for teachers.</a:t>
-            </a:r>
-            <a:endParaRPr lang="en-US" sz="1500" dirty="0"/>
-          </a:p>
-          <a:p>
-            <a:pPr indent="0" marL="0">
-              <a:lnSpc>
-                <a:spcPct val="104000"/>
-              </a:lnSpc>
-              <a:spcAft>
-                <a:spcPts val="400"/>
-              </a:spcAft>
-              <a:buNone/>
-            </a:pPr>
-            <a:r>
-              <a:rPr lang="en-US" sz="1500" b="1" dirty="0">
-                <a:solidFill>
-                  <a:srgbClr val="24313A"/>
-                </a:solidFill>
-                <a:latin typeface="Calibri" pitchFamily="34" charset="0"/>
-                <a:ea typeface="Calibri" pitchFamily="34" charset="-122"/>
-                <a:cs typeface="Calibri" pitchFamily="34" charset="-120"/>
-              </a:rPr>
-              <a:t>Since: </a:t>
-            </a:r>
-            <a:pPr indent="0" marL="0">
-              <a:lnSpc>
-                <a:spcPct val="104000"/>
-              </a:lnSpc>
-              <a:spcAft>
-                <a:spcPts val="400"/>
-              </a:spcAft>
-              <a:buNone/>
-            </a:pPr>
-            <a:r>
-              <a:rPr lang="en-US" sz="1500" dirty="0">
-                <a:solidFill>
-                  <a:srgbClr val="24313A"/>
-                </a:solidFill>
-                <a:latin typeface="Calibri" pitchFamily="34" charset="0"/>
-                <a:ea typeface="Calibri" pitchFamily="34" charset="-122"/>
-                <a:cs typeface="Calibri" pitchFamily="34" charset="-120"/>
-              </a:rPr>
-              <a:t>1 October 2022; unlimited earnings since 31 October 2024.</a:t>
+              <a:t>In Lower Saxony a retired teacher who went back to teaching used to lose part of the pension as soon as pay and pension together exceeded a ceiling set by the state's pension law. To make returning worthwhile, the state parliament raised that ceiling step by step: from 100 to 125 percent of the teacher's former pay in 2019, and to 150 percent from 1 October 2022 as part of a teacher-recruitment package, which allowed a pensioner to teach about nine or ten hours a week without any deduction. Overtime pay for serving teachers was raised by 15 percent at the same time. Since 31 October 2024 the ceiling for retired teachers has been abolished altogether, so they can now earn as much as they like from teaching while keeping their full pension.</a:t>
             </a:r>
             <a:endParaRPr lang="en-US" sz="1500" dirty="0"/>
           </a:p>
@@ -19050,15 +17090,12 @@
           <a:p>
             <a:pPr indent="0" marL="0">
               <a:lnSpc>
-                <a:spcPct val="104000"/>
+                <a:spcPct val="106000"/>
               </a:lnSpc>
-              <a:spcAft>
-                <a:spcPts val="400"/>
-              </a:spcAft>
-              <a:buNone/>
-            </a:pPr>
-            <a:r>
-              <a:rPr lang="en-US" sz="1500" b="1" dirty="0">
+              <a:buNone/>
+            </a:pPr>
+            <a:r>
+              <a:rPr lang="en-US" sz="1500" dirty="0">
                 <a:solidFill>
                   <a:srgbClr val="24313A"/>
                 </a:solidFill>
@@ -19066,156 +17103,7 @@
                 <a:ea typeface="Calibri" pitchFamily="34" charset="-122"/>
                 <a:cs typeface="Calibri" pitchFamily="34" charset="-120"/>
               </a:rPr>
-              <a:t>What it is: </a:t>
-            </a:r>
-            <a:pPr indent="0" marL="0">
-              <a:lnSpc>
-                <a:spcPct val="104000"/>
-              </a:lnSpc>
-              <a:spcAft>
-                <a:spcPts val="400"/>
-              </a:spcAft>
-              <a:buNone/>
-            </a:pPr>
-            <a:r>
-              <a:rPr lang="en-US" sz="1500" dirty="0">
-                <a:solidFill>
-                  <a:srgbClr val="24313A"/>
-                </a:solidFill>
-                <a:latin typeface="Calibri" pitchFamily="34" charset="0"/>
-                <a:ea typeface="Calibri" pitchFamily="34" charset="-122"/>
-                <a:cs typeface="Calibri" pitchFamily="34" charset="-120"/>
-              </a:rPr>
-              <a:t>A personal letter from the Minister of Education to every teacher about to retire, asking them to keep teaching or come back.</a:t>
-            </a:r>
-            <a:endParaRPr lang="en-US" sz="1500" dirty="0"/>
-          </a:p>
-          <a:p>
-            <a:pPr indent="0" marL="0">
-              <a:lnSpc>
-                <a:spcPct val="104000"/>
-              </a:lnSpc>
-              <a:spcAft>
-                <a:spcPts val="400"/>
-              </a:spcAft>
-              <a:buNone/>
-            </a:pPr>
-            <a:r>
-              <a:rPr lang="en-US" sz="1500" b="1" dirty="0">
-                <a:solidFill>
-                  <a:srgbClr val="24313A"/>
-                </a:solidFill>
-                <a:latin typeface="Calibri" pitchFamily="34" charset="0"/>
-                <a:ea typeface="Calibri" pitchFamily="34" charset="-122"/>
-                <a:cs typeface="Calibri" pitchFamily="34" charset="-120"/>
-              </a:rPr>
-              <a:t>How it works: </a:t>
-            </a:r>
-            <a:pPr indent="0" marL="0">
-              <a:lnSpc>
-                <a:spcPct val="104000"/>
-              </a:lnSpc>
-              <a:spcAft>
-                <a:spcPts val="400"/>
-              </a:spcAft>
-              <a:buNone/>
-            </a:pPr>
-            <a:r>
-              <a:rPr lang="en-US" sz="1500" dirty="0">
-                <a:solidFill>
-                  <a:srgbClr val="24313A"/>
-                </a:solidFill>
-                <a:latin typeface="Calibri" pitchFamily="34" charset="0"/>
-                <a:ea typeface="Calibri" pitchFamily="34" charset="-122"/>
-                <a:cs typeface="Calibri" pitchFamily="34" charset="-120"/>
-              </a:rPr>
-              <a:t>The letter thanks them and explains, with an information sheet and a registration guide, the two options: postpone retirement by up to three years (civil servants, on request) or retire and be re-hired at once on a fixed-term contract, keeping the pension under the relaxed earnings rules.</a:t>
-            </a:r>
-            <a:endParaRPr lang="en-US" sz="1500" dirty="0"/>
-          </a:p>
-          <a:p>
-            <a:pPr indent="0" marL="0">
-              <a:lnSpc>
-                <a:spcPct val="104000"/>
-              </a:lnSpc>
-              <a:spcAft>
-                <a:spcPts val="400"/>
-              </a:spcAft>
-              <a:buNone/>
-            </a:pPr>
-            <a:r>
-              <a:rPr lang="en-US" sz="1500" b="1" dirty="0">
-                <a:solidFill>
-                  <a:srgbClr val="24313A"/>
-                </a:solidFill>
-                <a:latin typeface="Calibri" pitchFamily="34" charset="0"/>
-                <a:ea typeface="Calibri" pitchFamily="34" charset="-122"/>
-                <a:cs typeface="Calibri" pitchFamily="34" charset="-120"/>
-              </a:rPr>
-              <a:t>Means: </a:t>
-            </a:r>
-            <a:pPr indent="0" marL="0">
-              <a:lnSpc>
-                <a:spcPct val="104000"/>
-              </a:lnSpc>
-              <a:spcAft>
-                <a:spcPts val="400"/>
-              </a:spcAft>
-              <a:buNone/>
-            </a:pPr>
-            <a:r>
-              <a:rPr lang="en-US" sz="1500" dirty="0">
-                <a:solidFill>
-                  <a:srgbClr val="24313A"/>
-                </a:solidFill>
-                <a:latin typeface="Calibri" pitchFamily="34" charset="0"/>
-                <a:ea typeface="Calibri" pitchFamily="34" charset="-122"/>
-                <a:cs typeface="Calibri" pitchFamily="34" charset="-120"/>
-              </a:rPr>
-              <a:t>Information only (mailing, guide, contact points); the money comes from the earnings-ceiling rule on the previous slide.</a:t>
-            </a:r>
-            <a:endParaRPr lang="en-US" sz="1500" dirty="0"/>
-          </a:p>
-          <a:p>
-            <a:pPr indent="0" marL="0">
-              <a:lnSpc>
-                <a:spcPct val="104000"/>
-              </a:lnSpc>
-              <a:spcAft>
-                <a:spcPts val="400"/>
-              </a:spcAft>
-              <a:buNone/>
-            </a:pPr>
-            <a:r>
-              <a:rPr lang="en-US" sz="1500" b="1" dirty="0">
-                <a:solidFill>
-                  <a:srgbClr val="24313A"/>
-                </a:solidFill>
-                <a:latin typeface="Calibri" pitchFamily="34" charset="0"/>
-                <a:ea typeface="Calibri" pitchFamily="34" charset="-122"/>
-                <a:cs typeface="Calibri" pitchFamily="34" charset="-120"/>
-              </a:rPr>
-              <a:t>Since: </a:t>
-            </a:r>
-            <a:pPr indent="0" marL="0">
-              <a:lnSpc>
-                <a:spcPct val="104000"/>
-              </a:lnSpc>
-              <a:spcAft>
-                <a:spcPts val="400"/>
-              </a:spcAft>
-              <a:buNone/>
-            </a:pPr>
-            <a:r>
-              <a:rPr lang="en-US" sz="1500" dirty="0">
-                <a:solidFill>
-                  <a:srgbClr val="24313A"/>
-                </a:solidFill>
-                <a:latin typeface="Calibri" pitchFamily="34" charset="0"/>
-                <a:ea typeface="Calibri" pitchFamily="34" charset="-122"/>
-                <a:cs typeface="Calibri" pitchFamily="34" charset="-120"/>
-              </a:rPr>
-              <a:t>November 2023.</a:t>
+              <a:t>In November 2023 the Minister of Education of Lower Saxony, Julia Willie Hamburg, wrote a personal letter to every teacher who was about to retire. The letter thanks them for their years of service and asks them to keep helping the schools, which face rising pupil numbers, and it comes with an information sheet and a registration guide that explain the two ways of doing so: civil-servant teachers can ask to postpone their retirement by up to three years, and any teacher can retire and immediately be re-hired on a fixed-term contract while keeping the pension, thanks to the relaxed earnings rules described on the previous slide. The letter itself carries no money; it simply makes sure that every teacher knows the options before signing the retirement paperwork.</a:t>
             </a:r>
             <a:endParaRPr lang="en-US" sz="1500" dirty="0"/>
           </a:p>
@@ -19781,15 +17669,12 @@
           <a:p>
             <a:pPr indent="0" marL="0">
               <a:lnSpc>
-                <a:spcPct val="104000"/>
+                <a:spcPct val="106000"/>
               </a:lnSpc>
-              <a:spcAft>
-                <a:spcPts val="400"/>
-              </a:spcAft>
-              <a:buNone/>
-            </a:pPr>
-            <a:r>
-              <a:rPr lang="en-US" sz="1500" b="1" dirty="0">
+              <a:buNone/>
+            </a:pPr>
+            <a:r>
+              <a:rPr lang="en-US" sz="1500" dirty="0">
                 <a:solidFill>
                   <a:srgbClr val="24313A"/>
                 </a:solidFill>
@@ -19797,156 +17682,7 @@
                 <a:ea typeface="Calibri" pitchFamily="34" charset="-122"/>
                 <a:cs typeface="Calibri" pitchFamily="34" charset="-120"/>
               </a:rPr>
-              <a:t>What it is: </a:t>
-            </a:r>
-            <a:pPr indent="0" marL="0">
-              <a:lnSpc>
-                <a:spcPct val="104000"/>
-              </a:lnSpc>
-              <a:spcAft>
-                <a:spcPts val="400"/>
-              </a:spcAft>
-              <a:buNone/>
-            </a:pPr>
-            <a:r>
-              <a:rPr lang="en-US" sz="1500" dirty="0">
-                <a:solidFill>
-                  <a:srgbClr val="24313A"/>
-                </a:solidFill>
-                <a:latin typeface="Calibri" pitchFamily="34" charset="0"/>
-                <a:ea typeface="Calibri" pitchFamily="34" charset="-122"/>
-                <a:cs typeface="Calibri" pitchFamily="34" charset="-120"/>
-              </a:rPr>
-              <a:t>A rule that lets retired teachers work up to 50 days a year without any cut to their pension, issued by the Department of Education.</a:t>
-            </a:r>
-            <a:endParaRPr lang="en-US" sz="1500" dirty="0"/>
-          </a:p>
-          <a:p>
-            <a:pPr indent="0" marL="0">
-              <a:lnSpc>
-                <a:spcPct val="104000"/>
-              </a:lnSpc>
-              <a:spcAft>
-                <a:spcPts val="400"/>
-              </a:spcAft>
-              <a:buNone/>
-            </a:pPr>
-            <a:r>
-              <a:rPr lang="en-US" sz="1500" b="1" dirty="0">
-                <a:solidFill>
-                  <a:srgbClr val="24313A"/>
-                </a:solidFill>
-                <a:latin typeface="Calibri" pitchFamily="34" charset="0"/>
-                <a:ea typeface="Calibri" pitchFamily="34" charset="-122"/>
-                <a:cs typeface="Calibri" pitchFamily="34" charset="-120"/>
-              </a:rPr>
-              <a:t>How it works: </a:t>
-            </a:r>
-            <a:pPr indent="0" marL="0">
-              <a:lnSpc>
-                <a:spcPct val="104000"/>
-              </a:lnSpc>
-              <a:spcAft>
-                <a:spcPts val="400"/>
-              </a:spcAft>
-              <a:buNone/>
-            </a:pPr>
-            <a:r>
-              <a:rPr lang="en-US" sz="1500" dirty="0">
-                <a:solidFill>
-                  <a:srgbClr val="24313A"/>
-                </a:solidFill>
-                <a:latin typeface="Calibri" pitchFamily="34" charset="0"/>
-                <a:ea typeface="Calibri" pitchFamily="34" charset="-122"/>
-                <a:cs typeface="Calibri" pitchFamily="34" charset="-120"/>
-              </a:rPr>
-              <a:t>Normally ‘abatement’ reduces the pension when pension plus new salary exceed the pay the teacher had at retirement. Under the waiver the first 50 days worked in a calendar year, as a substitute or on a fixed-term contract, are exempt; each day counts as one whatever the hours. Beyond day 50 abatement is assessed as usual.</a:t>
-            </a:r>
-            <a:endParaRPr lang="en-US" sz="1500" dirty="0"/>
-          </a:p>
-          <a:p>
-            <a:pPr indent="0" marL="0">
-              <a:lnSpc>
-                <a:spcPct val="104000"/>
-              </a:lnSpc>
-              <a:spcAft>
-                <a:spcPts val="400"/>
-              </a:spcAft>
-              <a:buNone/>
-            </a:pPr>
-            <a:r>
-              <a:rPr lang="en-US" sz="1500" b="1" dirty="0">
-                <a:solidFill>
-                  <a:srgbClr val="24313A"/>
-                </a:solidFill>
-                <a:latin typeface="Calibri" pitchFamily="34" charset="0"/>
-                <a:ea typeface="Calibri" pitchFamily="34" charset="-122"/>
-                <a:cs typeface="Calibri" pitchFamily="34" charset="-120"/>
-              </a:rPr>
-              <a:t>Means: </a:t>
-            </a:r>
-            <a:pPr indent="0" marL="0">
-              <a:lnSpc>
-                <a:spcPct val="104000"/>
-              </a:lnSpc>
-              <a:spcAft>
-                <a:spcPts val="400"/>
-              </a:spcAft>
-              <a:buNone/>
-            </a:pPr>
-            <a:r>
-              <a:rPr lang="en-US" sz="1500" dirty="0">
-                <a:solidFill>
-                  <a:srgbClr val="24313A"/>
-                </a:solidFill>
-                <a:latin typeface="Calibri" pitchFamily="34" charset="0"/>
-                <a:ea typeface="Calibri" pitchFamily="34" charset="-122"/>
-                <a:cs typeface="Calibri" pitchFamily="34" charset="-120"/>
-              </a:rPr>
-              <a:t>Department circulars (0003/2021, 04/2024, 17/2026); no extra budget, only the pension rule.</a:t>
-            </a:r>
-            <a:endParaRPr lang="en-US" sz="1500" dirty="0"/>
-          </a:p>
-          <a:p>
-            <a:pPr indent="0" marL="0">
-              <a:lnSpc>
-                <a:spcPct val="104000"/>
-              </a:lnSpc>
-              <a:spcAft>
-                <a:spcPts val="400"/>
-              </a:spcAft>
-              <a:buNone/>
-            </a:pPr>
-            <a:r>
-              <a:rPr lang="en-US" sz="1500" b="1" dirty="0">
-                <a:solidFill>
-                  <a:srgbClr val="24313A"/>
-                </a:solidFill>
-                <a:latin typeface="Calibri" pitchFamily="34" charset="0"/>
-                <a:ea typeface="Calibri" pitchFamily="34" charset="-122"/>
-                <a:cs typeface="Calibri" pitchFamily="34" charset="-120"/>
-              </a:rPr>
-              <a:t>Since: </a:t>
-            </a:r>
-            <a:pPr indent="0" marL="0">
-              <a:lnSpc>
-                <a:spcPct val="104000"/>
-              </a:lnSpc>
-              <a:spcAft>
-                <a:spcPts val="400"/>
-              </a:spcAft>
-              <a:buNone/>
-            </a:pPr>
-            <a:r>
-              <a:rPr lang="en-US" sz="1500" dirty="0">
-                <a:solidFill>
-                  <a:srgbClr val="24313A"/>
-                </a:solidFill>
-                <a:latin typeface="Calibri" pitchFamily="34" charset="0"/>
-                <a:ea typeface="Calibri" pitchFamily="34" charset="-122"/>
-                <a:cs typeface="Calibri" pitchFamily="34" charset="-120"/>
-              </a:rPr>
-              <a:t>2021, renewed for 2024–25 and 2026–27.</a:t>
+              <a:t>In Ireland a retired teacher who goes back to work normally sees the pension reduced whenever pension and new salary together exceed the pay they had when they retired, a rule known as abatement. To ease the shortage of substitutes, the Department of Education introduced a waiver in 2021: the first fifty days a retired teacher works in a calendar year, as a substitute or on a fixed-term contract, do not count for abatement, so the pension is paid in full. Every day worked counts as one day, however many hours it lasts, and only from the fifty-first day is the usual rule applied. The waiver was set out in a departmental circular in 2021 and has since been renewed twice, for 2024 and 2025 and again for 2026 and 2027.</a:t>
             </a:r>
             <a:endParaRPr lang="en-US" sz="1500" dirty="0"/>
           </a:p>
@@ -20469,15 +18205,12 @@
           <a:p>
             <a:pPr indent="0" marL="0">
               <a:lnSpc>
-                <a:spcPct val="104000"/>
+                <a:spcPct val="106000"/>
               </a:lnSpc>
-              <a:spcAft>
-                <a:spcPts val="400"/>
-              </a:spcAft>
-              <a:buNone/>
-            </a:pPr>
-            <a:r>
-              <a:rPr lang="en-US" sz="1500" b="1" dirty="0">
+              <a:buNone/>
+            </a:pPr>
+            <a:r>
+              <a:rPr lang="en-US" sz="1500" dirty="0">
                 <a:solidFill>
                   <a:srgbClr val="24313A"/>
                 </a:solidFill>
@@ -20485,156 +18218,7 @@
                 <a:ea typeface="Calibri" pitchFamily="34" charset="-122"/>
                 <a:cs typeface="Calibri" pitchFamily="34" charset="-120"/>
               </a:rPr>
-              <a:t>What it is: </a:t>
-            </a:r>
-            <a:pPr indent="0" marL="0">
-              <a:lnSpc>
-                <a:spcPct val="104000"/>
-              </a:lnSpc>
-              <a:spcAft>
-                <a:spcPts val="400"/>
-              </a:spcAft>
-              <a:buNone/>
-            </a:pPr>
-            <a:r>
-              <a:rPr lang="en-US" sz="1500" dirty="0">
-                <a:solidFill>
-                  <a:srgbClr val="24313A"/>
-                </a:solidFill>
-                <a:latin typeface="Calibri" pitchFamily="34" charset="0"/>
-                <a:ea typeface="Calibri" pitchFamily="34" charset="-122"/>
-                <a:cs typeface="Calibri" pitchFamily="34" charset="-120"/>
-              </a:rPr>
-              <a:t>A legal change that made expired teaching licences valid again, so former teachers can apply for jobs without re-certifying, enacted by the Diet and implemented by MEXT.</a:t>
-            </a:r>
-            <a:endParaRPr lang="en-US" sz="1500" dirty="0"/>
-          </a:p>
-          <a:p>
-            <a:pPr indent="0" marL="0">
-              <a:lnSpc>
-                <a:spcPct val="104000"/>
-              </a:lnSpc>
-              <a:spcAft>
-                <a:spcPts val="400"/>
-              </a:spcAft>
-              <a:buNone/>
-            </a:pPr>
-            <a:r>
-              <a:rPr lang="en-US" sz="1500" b="1" dirty="0">
-                <a:solidFill>
-                  <a:srgbClr val="24313A"/>
-                </a:solidFill>
-                <a:latin typeface="Calibri" pitchFamily="34" charset="0"/>
-                <a:ea typeface="Calibri" pitchFamily="34" charset="-122"/>
-                <a:cs typeface="Calibri" pitchFamily="34" charset="-120"/>
-              </a:rPr>
-              <a:t>How it works: </a:t>
-            </a:r>
-            <a:pPr indent="0" marL="0">
-              <a:lnSpc>
-                <a:spcPct val="104000"/>
-              </a:lnSpc>
-              <a:spcAft>
-                <a:spcPts val="400"/>
-              </a:spcAft>
-              <a:buNone/>
-            </a:pPr>
-            <a:r>
-              <a:rPr lang="en-US" sz="1500" dirty="0">
-                <a:solidFill>
-                  <a:srgbClr val="24313A"/>
-                </a:solidFill>
-                <a:latin typeface="Calibri" pitchFamily="34" charset="0"/>
-                <a:ea typeface="Calibri" pitchFamily="34" charset="-122"/>
-                <a:cs typeface="Calibri" pitchFamily="34" charset="-120"/>
-              </a:rPr>
-              <a:t>From 2009 licences expired every 10 years unless the holder took a 30-hour renewal course, so people who had left teaching lost their licence. The renewal system was abolished on 1 July 2022; every licence valid at that date, including dormant ones, became permanent with no procedure or fee.</a:t>
-            </a:r>
-            <a:endParaRPr lang="en-US" sz="1500" dirty="0"/>
-          </a:p>
-          <a:p>
-            <a:pPr indent="0" marL="0">
-              <a:lnSpc>
-                <a:spcPct val="104000"/>
-              </a:lnSpc>
-              <a:spcAft>
-                <a:spcPts val="400"/>
-              </a:spcAft>
-              <a:buNone/>
-            </a:pPr>
-            <a:r>
-              <a:rPr lang="en-US" sz="1500" b="1" dirty="0">
-                <a:solidFill>
-                  <a:srgbClr val="24313A"/>
-                </a:solidFill>
-                <a:latin typeface="Calibri" pitchFamily="34" charset="0"/>
-                <a:ea typeface="Calibri" pitchFamily="34" charset="-122"/>
-                <a:cs typeface="Calibri" pitchFamily="34" charset="-120"/>
-              </a:rPr>
-              <a:t>Means: </a:t>
-            </a:r>
-            <a:pPr indent="0" marL="0">
-              <a:lnSpc>
-                <a:spcPct val="104000"/>
-              </a:lnSpc>
-              <a:spcAft>
-                <a:spcPts val="400"/>
-              </a:spcAft>
-              <a:buNone/>
-            </a:pPr>
-            <a:r>
-              <a:rPr lang="en-US" sz="1500" dirty="0">
-                <a:solidFill>
-                  <a:srgbClr val="24313A"/>
-                </a:solidFill>
-                <a:latin typeface="Calibri" pitchFamily="34" charset="0"/>
-                <a:ea typeface="Calibri" pitchFamily="34" charset="-122"/>
-                <a:cs typeface="Calibri" pitchFamily="34" charset="-120"/>
-              </a:rPr>
-              <a:t>Amendment to the Educational Personnel Certification Act (May 2022); boards of education add ‘paper-teacher’ seminars for licence holders who left teaching.</a:t>
-            </a:r>
-            <a:endParaRPr lang="en-US" sz="1500" dirty="0"/>
-          </a:p>
-          <a:p>
-            <a:pPr indent="0" marL="0">
-              <a:lnSpc>
-                <a:spcPct val="104000"/>
-              </a:lnSpc>
-              <a:spcAft>
-                <a:spcPts val="400"/>
-              </a:spcAft>
-              <a:buNone/>
-            </a:pPr>
-            <a:r>
-              <a:rPr lang="en-US" sz="1500" b="1" dirty="0">
-                <a:solidFill>
-                  <a:srgbClr val="24313A"/>
-                </a:solidFill>
-                <a:latin typeface="Calibri" pitchFamily="34" charset="0"/>
-                <a:ea typeface="Calibri" pitchFamily="34" charset="-122"/>
-                <a:cs typeface="Calibri" pitchFamily="34" charset="-120"/>
-              </a:rPr>
-              <a:t>Since: </a:t>
-            </a:r>
-            <a:pPr indent="0" marL="0">
-              <a:lnSpc>
-                <a:spcPct val="104000"/>
-              </a:lnSpc>
-              <a:spcAft>
-                <a:spcPts val="400"/>
-              </a:spcAft>
-              <a:buNone/>
-            </a:pPr>
-            <a:r>
-              <a:rPr lang="en-US" sz="1500" dirty="0">
-                <a:solidFill>
-                  <a:srgbClr val="24313A"/>
-                </a:solidFill>
-                <a:latin typeface="Calibri" pitchFamily="34" charset="0"/>
-                <a:ea typeface="Calibri" pitchFamily="34" charset="-122"/>
-                <a:cs typeface="Calibri" pitchFamily="34" charset="-120"/>
-              </a:rPr>
-              <a:t>1 July 2022.</a:t>
+              <a:t>Between 2009 and 2022 a Japanese teaching licence expired every ten years unless the holder completed a thirty-hour renewal course, so teachers who had left the profession usually lost their licence and became what is known as ‘paper teachers’. In May 2022 the Diet amended the Educational Personnel Certification Act and the renewal system was abolished on 1 July 2022. Every licence that was valid on that date, including the dormant licences of people no longer teaching, became valid for life, with no procedure and no fee, which removed the main administrative barrier to returning. Boards of education have since built on this with seminars and consultation days for licence holders who left or never entered teaching, for example in Saitama, Chiba and Nagoya.</a:t>
             </a:r>
             <a:endParaRPr lang="en-US" sz="1500" dirty="0"/>
           </a:p>

</xml_diff>

<commit_message>
Policy deck: calmer type on intro slides, scale as a solid pill inside the card, English-only Sweden title
Co-Authored-By: Claude Opus 5 <noreply@anthropic.com>
Claude-Session: https://claude.ai/code/session_01REVwghctKjYh8VQ919ThdA
</commit_message>
<xml_diff>
--- a/policies/Re-attracting_Former_Teachers.pptx
+++ b/policies/Re-attracting_Former_Teachers.pptx
@@ -4911,7 +4911,7 @@
         <p:spPr>
           <a:xfrm>
             <a:off x="1783080" y="4864608"/>
-            <a:ext cx="9738360" cy="274320"/>
+            <a:ext cx="8183880" cy="274320"/>
           </a:xfrm>
           <a:prstGeom prst="rect">
             <a:avLst/>
@@ -5071,11 +5071,13 @@
         </p:nvSpPr>
         <p:spPr>
           <a:xfrm>
-            <a:off x="9402775" y="6382512"/>
-            <a:ext cx="219456" cy="219456"/>
-          </a:xfrm>
-          <a:prstGeom prst="ellipse">
-            <a:avLst/>
+            <a:off x="10241280" y="4791456"/>
+            <a:ext cx="1280160" cy="365760"/>
+          </a:xfrm>
+          <a:prstGeom prst="roundRect">
+            <a:avLst>
+              <a:gd name="adj" fmla="val 50000"/>
+            </a:avLst>
           </a:prstGeom>
           <a:solidFill>
             <a:srgbClr val="C8892B"/>
@@ -5096,8 +5098,8 @@
         </p:nvSpPr>
         <p:spPr>
           <a:xfrm>
-            <a:off x="9704527" y="6327648"/>
-            <a:ext cx="1554480" cy="329184"/>
+            <a:off x="10241280" y="4791456"/>
+            <a:ext cx="1280160" cy="365760"/>
           </a:xfrm>
           <a:prstGeom prst="rect">
             <a:avLst/>
@@ -5109,13 +5111,13 @@
           <a:bodyPr wrap="square" lIns="0" tIns="0" rIns="0" bIns="0" rtlCol="0" anchor="ctr"/>
           <a:lstStyle/>
           <a:p>
-            <a:pPr indent="0" marL="0">
-              <a:buNone/>
-            </a:pPr>
-            <a:r>
-              <a:rPr lang="en-US" sz="1400" b="1" dirty="0">
-                <a:solidFill>
-                  <a:srgbClr val="C8892B"/>
+            <a:pPr algn="ctr" indent="0" marL="0">
+              <a:buNone/>
+            </a:pPr>
+            <a:r>
+              <a:rPr lang="en-US" sz="1250" b="1" dirty="0">
+                <a:solidFill>
+                  <a:srgbClr val="FFFFFF"/>
                 </a:solidFill>
                 <a:latin typeface="Calibri" pitchFamily="34" charset="0"/>
                 <a:ea typeface="Calibri" pitchFamily="34" charset="-122"/>
@@ -5123,7 +5125,7 @@
               </a:rPr>
               <a:t>Medium</a:t>
             </a:r>
-            <a:endParaRPr lang="en-US" sz="1400" dirty="0"/>
+            <a:endParaRPr lang="en-US" sz="1250" dirty="0"/>
           </a:p>
         </p:txBody>
       </p:sp>
@@ -5554,7 +5556,7 @@
         <p:spPr>
           <a:xfrm>
             <a:off x="1783080" y="4864608"/>
-            <a:ext cx="9738360" cy="274320"/>
+            <a:ext cx="8183880" cy="274320"/>
           </a:xfrm>
           <a:prstGeom prst="rect">
             <a:avLst/>
@@ -5714,11 +5716,13 @@
         </p:nvSpPr>
         <p:spPr>
           <a:xfrm>
-            <a:off x="9402775" y="6382512"/>
-            <a:ext cx="219456" cy="219456"/>
-          </a:xfrm>
-          <a:prstGeom prst="ellipse">
-            <a:avLst/>
+            <a:off x="10241280" y="4791456"/>
+            <a:ext cx="1280160" cy="365760"/>
+          </a:xfrm>
+          <a:prstGeom prst="roundRect">
+            <a:avLst>
+              <a:gd name="adj" fmla="val 50000"/>
+            </a:avLst>
           </a:prstGeom>
           <a:solidFill>
             <a:srgbClr val="1F4E46"/>
@@ -5739,8 +5743,8 @@
         </p:nvSpPr>
         <p:spPr>
           <a:xfrm>
-            <a:off x="9704527" y="6327648"/>
-            <a:ext cx="1554480" cy="329184"/>
+            <a:off x="10241280" y="4791456"/>
+            <a:ext cx="1280160" cy="365760"/>
           </a:xfrm>
           <a:prstGeom prst="rect">
             <a:avLst/>
@@ -5752,13 +5756,13 @@
           <a:bodyPr wrap="square" lIns="0" tIns="0" rIns="0" bIns="0" rtlCol="0" anchor="ctr"/>
           <a:lstStyle/>
           <a:p>
-            <a:pPr indent="0" marL="0">
-              <a:buNone/>
-            </a:pPr>
-            <a:r>
-              <a:rPr lang="en-US" sz="1400" b="1" dirty="0">
-                <a:solidFill>
-                  <a:srgbClr val="1F4E46"/>
+            <a:pPr algn="ctr" indent="0" marL="0">
+              <a:buNone/>
+            </a:pPr>
+            <a:r>
+              <a:rPr lang="en-US" sz="1250" b="1" dirty="0">
+                <a:solidFill>
+                  <a:srgbClr val="FFFFFF"/>
                 </a:solidFill>
                 <a:latin typeface="Calibri" pitchFamily="34" charset="0"/>
                 <a:ea typeface="Calibri" pitchFamily="34" charset="-122"/>
@@ -5766,7 +5770,7 @@
               </a:rPr>
               <a:t>Large</a:t>
             </a:r>
-            <a:endParaRPr lang="en-US" sz="1400" dirty="0"/>
+            <a:endParaRPr lang="en-US" sz="1250" dirty="0"/>
           </a:p>
         </p:txBody>
       </p:sp>
@@ -6197,7 +6201,7 @@
         <p:spPr>
           <a:xfrm>
             <a:off x="1783080" y="4864608"/>
-            <a:ext cx="9738360" cy="274320"/>
+            <a:ext cx="8183880" cy="274320"/>
           </a:xfrm>
           <a:prstGeom prst="rect">
             <a:avLst/>
@@ -6357,11 +6361,13 @@
         </p:nvSpPr>
         <p:spPr>
           <a:xfrm>
-            <a:off x="9402775" y="6382512"/>
-            <a:ext cx="219456" cy="219456"/>
-          </a:xfrm>
-          <a:prstGeom prst="ellipse">
-            <a:avLst/>
+            <a:off x="10241280" y="4791456"/>
+            <a:ext cx="1280160" cy="365760"/>
+          </a:xfrm>
+          <a:prstGeom prst="roundRect">
+            <a:avLst>
+              <a:gd name="adj" fmla="val 50000"/>
+            </a:avLst>
           </a:prstGeom>
           <a:solidFill>
             <a:srgbClr val="1F4E46"/>
@@ -6382,8 +6388,8 @@
         </p:nvSpPr>
         <p:spPr>
           <a:xfrm>
-            <a:off x="9704527" y="6327648"/>
-            <a:ext cx="1554480" cy="329184"/>
+            <a:off x="10241280" y="4791456"/>
+            <a:ext cx="1280160" cy="365760"/>
           </a:xfrm>
           <a:prstGeom prst="rect">
             <a:avLst/>
@@ -6395,13 +6401,13 @@
           <a:bodyPr wrap="square" lIns="0" tIns="0" rIns="0" bIns="0" rtlCol="0" anchor="ctr"/>
           <a:lstStyle/>
           <a:p>
-            <a:pPr indent="0" marL="0">
-              <a:buNone/>
-            </a:pPr>
-            <a:r>
-              <a:rPr lang="en-US" sz="1400" b="1" dirty="0">
-                <a:solidFill>
-                  <a:srgbClr val="1F4E46"/>
+            <a:pPr algn="ctr" indent="0" marL="0">
+              <a:buNone/>
+            </a:pPr>
+            <a:r>
+              <a:rPr lang="en-US" sz="1250" b="1" dirty="0">
+                <a:solidFill>
+                  <a:srgbClr val="FFFFFF"/>
                 </a:solidFill>
                 <a:latin typeface="Calibri" pitchFamily="34" charset="0"/>
                 <a:ea typeface="Calibri" pitchFamily="34" charset="-122"/>
@@ -6409,7 +6415,7 @@
               </a:rPr>
               <a:t>Large</a:t>
             </a:r>
-            <a:endParaRPr lang="en-US" sz="1400" dirty="0"/>
+            <a:endParaRPr lang="en-US" sz="1250" dirty="0"/>
           </a:p>
         </p:txBody>
       </p:sp>
@@ -6879,7 +6885,7 @@
         <p:spPr>
           <a:xfrm>
             <a:off x="1783080" y="4864608"/>
-            <a:ext cx="9738360" cy="274320"/>
+            <a:ext cx="8183880" cy="274320"/>
           </a:xfrm>
           <a:prstGeom prst="rect">
             <a:avLst/>
@@ -7039,11 +7045,13 @@
         </p:nvSpPr>
         <p:spPr>
           <a:xfrm>
-            <a:off x="9402775" y="6382512"/>
-            <a:ext cx="219456" cy="219456"/>
-          </a:xfrm>
-          <a:prstGeom prst="ellipse">
-            <a:avLst/>
+            <a:off x="10241280" y="4791456"/>
+            <a:ext cx="1280160" cy="365760"/>
+          </a:xfrm>
+          <a:prstGeom prst="roundRect">
+            <a:avLst>
+              <a:gd name="adj" fmla="val 50000"/>
+            </a:avLst>
           </a:prstGeom>
           <a:solidFill>
             <a:srgbClr val="C8892B"/>
@@ -7064,8 +7072,8 @@
         </p:nvSpPr>
         <p:spPr>
           <a:xfrm>
-            <a:off x="9704527" y="6327648"/>
-            <a:ext cx="1554480" cy="329184"/>
+            <a:off x="10241280" y="4791456"/>
+            <a:ext cx="1280160" cy="365760"/>
           </a:xfrm>
           <a:prstGeom prst="rect">
             <a:avLst/>
@@ -7077,13 +7085,13 @@
           <a:bodyPr wrap="square" lIns="0" tIns="0" rIns="0" bIns="0" rtlCol="0" anchor="ctr"/>
           <a:lstStyle/>
           <a:p>
-            <a:pPr indent="0" marL="0">
-              <a:buNone/>
-            </a:pPr>
-            <a:r>
-              <a:rPr lang="en-US" sz="1400" b="1" dirty="0">
-                <a:solidFill>
-                  <a:srgbClr val="C8892B"/>
+            <a:pPr algn="ctr" indent="0" marL="0">
+              <a:buNone/>
+            </a:pPr>
+            <a:r>
+              <a:rPr lang="en-US" sz="1250" b="1" dirty="0">
+                <a:solidFill>
+                  <a:srgbClr val="FFFFFF"/>
                 </a:solidFill>
                 <a:latin typeface="Calibri" pitchFamily="34" charset="0"/>
                 <a:ea typeface="Calibri" pitchFamily="34" charset="-122"/>
@@ -7091,7 +7099,7 @@
               </a:rPr>
               <a:t>Medium</a:t>
             </a:r>
-            <a:endParaRPr lang="en-US" sz="1400" dirty="0"/>
+            <a:endParaRPr lang="en-US" sz="1250" dirty="0"/>
           </a:p>
         </p:txBody>
       </p:sp>
@@ -7561,7 +7569,7 @@
         <p:spPr>
           <a:xfrm>
             <a:off x="1783080" y="4864608"/>
-            <a:ext cx="9738360" cy="274320"/>
+            <a:ext cx="8183880" cy="274320"/>
           </a:xfrm>
           <a:prstGeom prst="rect">
             <a:avLst/>
@@ -7721,11 +7729,13 @@
         </p:nvSpPr>
         <p:spPr>
           <a:xfrm>
-            <a:off x="9402775" y="6382512"/>
-            <a:ext cx="219456" cy="219456"/>
-          </a:xfrm>
-          <a:prstGeom prst="ellipse">
-            <a:avLst/>
+            <a:off x="10241280" y="4791456"/>
+            <a:ext cx="1280160" cy="365760"/>
+          </a:xfrm>
+          <a:prstGeom prst="roundRect">
+            <a:avLst>
+              <a:gd name="adj" fmla="val 50000"/>
+            </a:avLst>
           </a:prstGeom>
           <a:solidFill>
             <a:srgbClr val="C8892B"/>
@@ -7746,8 +7756,8 @@
         </p:nvSpPr>
         <p:spPr>
           <a:xfrm>
-            <a:off x="9704527" y="6327648"/>
-            <a:ext cx="1554480" cy="329184"/>
+            <a:off x="10241280" y="4791456"/>
+            <a:ext cx="1280160" cy="365760"/>
           </a:xfrm>
           <a:prstGeom prst="rect">
             <a:avLst/>
@@ -7759,13 +7769,13 @@
           <a:bodyPr wrap="square" lIns="0" tIns="0" rIns="0" bIns="0" rtlCol="0" anchor="ctr"/>
           <a:lstStyle/>
           <a:p>
-            <a:pPr indent="0" marL="0">
-              <a:buNone/>
-            </a:pPr>
-            <a:r>
-              <a:rPr lang="en-US" sz="1400" b="1" dirty="0">
-                <a:solidFill>
-                  <a:srgbClr val="C8892B"/>
+            <a:pPr algn="ctr" indent="0" marL="0">
+              <a:buNone/>
+            </a:pPr>
+            <a:r>
+              <a:rPr lang="en-US" sz="1250" b="1" dirty="0">
+                <a:solidFill>
+                  <a:srgbClr val="FFFFFF"/>
                 </a:solidFill>
                 <a:latin typeface="Calibri" pitchFamily="34" charset="0"/>
                 <a:ea typeface="Calibri" pitchFamily="34" charset="-122"/>
@@ -7773,7 +7783,7 @@
               </a:rPr>
               <a:t>Medium</a:t>
             </a:r>
-            <a:endParaRPr lang="en-US" sz="1400" dirty="0"/>
+            <a:endParaRPr lang="en-US" sz="1250" dirty="0"/>
           </a:p>
         </p:txBody>
       </p:sp>
@@ -8204,7 +8214,7 @@
         <p:spPr>
           <a:xfrm>
             <a:off x="1783080" y="4864608"/>
-            <a:ext cx="9738360" cy="274320"/>
+            <a:ext cx="8183880" cy="274320"/>
           </a:xfrm>
           <a:prstGeom prst="rect">
             <a:avLst/>
@@ -8321,11 +8331,13 @@
         </p:nvSpPr>
         <p:spPr>
           <a:xfrm>
-            <a:off x="9402775" y="6382512"/>
-            <a:ext cx="219456" cy="219456"/>
-          </a:xfrm>
-          <a:prstGeom prst="ellipse">
-            <a:avLst/>
+            <a:off x="10241280" y="4791456"/>
+            <a:ext cx="1280160" cy="365760"/>
+          </a:xfrm>
+          <a:prstGeom prst="roundRect">
+            <a:avLst>
+              <a:gd name="adj" fmla="val 50000"/>
+            </a:avLst>
           </a:prstGeom>
           <a:solidFill>
             <a:srgbClr val="1F4E46"/>
@@ -8346,8 +8358,8 @@
         </p:nvSpPr>
         <p:spPr>
           <a:xfrm>
-            <a:off x="9704527" y="6327648"/>
-            <a:ext cx="1554480" cy="329184"/>
+            <a:off x="10241280" y="4791456"/>
+            <a:ext cx="1280160" cy="365760"/>
           </a:xfrm>
           <a:prstGeom prst="rect">
             <a:avLst/>
@@ -8359,13 +8371,13 @@
           <a:bodyPr wrap="square" lIns="0" tIns="0" rIns="0" bIns="0" rtlCol="0" anchor="ctr"/>
           <a:lstStyle/>
           <a:p>
-            <a:pPr indent="0" marL="0">
-              <a:buNone/>
-            </a:pPr>
-            <a:r>
-              <a:rPr lang="en-US" sz="1400" b="1" dirty="0">
-                <a:solidFill>
-                  <a:srgbClr val="1F4E46"/>
+            <a:pPr algn="ctr" indent="0" marL="0">
+              <a:buNone/>
+            </a:pPr>
+            <a:r>
+              <a:rPr lang="en-US" sz="1250" b="1" dirty="0">
+                <a:solidFill>
+                  <a:srgbClr val="FFFFFF"/>
                 </a:solidFill>
                 <a:latin typeface="Calibri" pitchFamily="34" charset="0"/>
                 <a:ea typeface="Calibri" pitchFamily="34" charset="-122"/>
@@ -8373,7 +8385,7 @@
               </a:rPr>
               <a:t>Large</a:t>
             </a:r>
-            <a:endParaRPr lang="en-US" sz="1400" dirty="0"/>
+            <a:endParaRPr lang="en-US" sz="1250" dirty="0"/>
           </a:p>
         </p:txBody>
       </p:sp>
@@ -8804,7 +8816,7 @@
         <p:spPr>
           <a:xfrm>
             <a:off x="1783080" y="4864608"/>
-            <a:ext cx="9738360" cy="274320"/>
+            <a:ext cx="8183880" cy="274320"/>
           </a:xfrm>
           <a:prstGeom prst="rect">
             <a:avLst/>
@@ -8964,11 +8976,13 @@
         </p:nvSpPr>
         <p:spPr>
           <a:xfrm>
-            <a:off x="9402775" y="6382512"/>
-            <a:ext cx="219456" cy="219456"/>
-          </a:xfrm>
-          <a:prstGeom prst="ellipse">
-            <a:avLst/>
+            <a:off x="10241280" y="4791456"/>
+            <a:ext cx="1280160" cy="365760"/>
+          </a:xfrm>
+          <a:prstGeom prst="roundRect">
+            <a:avLst>
+              <a:gd name="adj" fmla="val 50000"/>
+            </a:avLst>
           </a:prstGeom>
           <a:solidFill>
             <a:srgbClr val="1F4E46"/>
@@ -8989,8 +9003,8 @@
         </p:nvSpPr>
         <p:spPr>
           <a:xfrm>
-            <a:off x="9704527" y="6327648"/>
-            <a:ext cx="1554480" cy="329184"/>
+            <a:off x="10241280" y="4791456"/>
+            <a:ext cx="1280160" cy="365760"/>
           </a:xfrm>
           <a:prstGeom prst="rect">
             <a:avLst/>
@@ -9002,13 +9016,13 @@
           <a:bodyPr wrap="square" lIns="0" tIns="0" rIns="0" bIns="0" rtlCol="0" anchor="ctr"/>
           <a:lstStyle/>
           <a:p>
-            <a:pPr indent="0" marL="0">
-              <a:buNone/>
-            </a:pPr>
-            <a:r>
-              <a:rPr lang="en-US" sz="1400" b="1" dirty="0">
-                <a:solidFill>
-                  <a:srgbClr val="1F4E46"/>
+            <a:pPr algn="ctr" indent="0" marL="0">
+              <a:buNone/>
+            </a:pPr>
+            <a:r>
+              <a:rPr lang="en-US" sz="1250" b="1" dirty="0">
+                <a:solidFill>
+                  <a:srgbClr val="FFFFFF"/>
                 </a:solidFill>
                 <a:latin typeface="Calibri" pitchFamily="34" charset="0"/>
                 <a:ea typeface="Calibri" pitchFamily="34" charset="-122"/>
@@ -9016,7 +9030,7 @@
               </a:rPr>
               <a:t>Large</a:t>
             </a:r>
-            <a:endParaRPr lang="en-US" sz="1400" dirty="0"/>
+            <a:endParaRPr lang="en-US" sz="1250" dirty="0"/>
           </a:p>
         </p:txBody>
       </p:sp>
@@ -9447,7 +9461,7 @@
         <p:spPr>
           <a:xfrm>
             <a:off x="1783080" y="4864608"/>
-            <a:ext cx="9738360" cy="274320"/>
+            <a:ext cx="8183880" cy="274320"/>
           </a:xfrm>
           <a:prstGeom prst="rect">
             <a:avLst/>
@@ -9607,11 +9621,13 @@
         </p:nvSpPr>
         <p:spPr>
           <a:xfrm>
-            <a:off x="9402775" y="6382512"/>
-            <a:ext cx="219456" cy="219456"/>
-          </a:xfrm>
-          <a:prstGeom prst="ellipse">
-            <a:avLst/>
+            <a:off x="10241280" y="4791456"/>
+            <a:ext cx="1280160" cy="365760"/>
+          </a:xfrm>
+          <a:prstGeom prst="roundRect">
+            <a:avLst>
+              <a:gd name="adj" fmla="val 50000"/>
+            </a:avLst>
           </a:prstGeom>
           <a:solidFill>
             <a:srgbClr val="1F4E46"/>
@@ -9632,8 +9648,8 @@
         </p:nvSpPr>
         <p:spPr>
           <a:xfrm>
-            <a:off x="9704527" y="6327648"/>
-            <a:ext cx="1554480" cy="329184"/>
+            <a:off x="10241280" y="4791456"/>
+            <a:ext cx="1280160" cy="365760"/>
           </a:xfrm>
           <a:prstGeom prst="rect">
             <a:avLst/>
@@ -9645,13 +9661,13 @@
           <a:bodyPr wrap="square" lIns="0" tIns="0" rIns="0" bIns="0" rtlCol="0" anchor="ctr"/>
           <a:lstStyle/>
           <a:p>
-            <a:pPr indent="0" marL="0">
-              <a:buNone/>
-            </a:pPr>
-            <a:r>
-              <a:rPr lang="en-US" sz="1400" b="1" dirty="0">
-                <a:solidFill>
-                  <a:srgbClr val="1F4E46"/>
+            <a:pPr algn="ctr" indent="0" marL="0">
+              <a:buNone/>
+            </a:pPr>
+            <a:r>
+              <a:rPr lang="en-US" sz="1250" b="1" dirty="0">
+                <a:solidFill>
+                  <a:srgbClr val="FFFFFF"/>
                 </a:solidFill>
                 <a:latin typeface="Calibri" pitchFamily="34" charset="0"/>
                 <a:ea typeface="Calibri" pitchFamily="34" charset="-122"/>
@@ -9659,7 +9675,7 @@
               </a:rPr>
               <a:t>Large</a:t>
             </a:r>
-            <a:endParaRPr lang="en-US" sz="1400" dirty="0"/>
+            <a:endParaRPr lang="en-US" sz="1250" dirty="0"/>
           </a:p>
         </p:txBody>
       </p:sp>
@@ -10090,7 +10106,7 @@
         <p:spPr>
           <a:xfrm>
             <a:off x="1783080" y="4864608"/>
-            <a:ext cx="9738360" cy="274320"/>
+            <a:ext cx="8183880" cy="274320"/>
           </a:xfrm>
           <a:prstGeom prst="rect">
             <a:avLst/>
@@ -10250,11 +10266,13 @@
         </p:nvSpPr>
         <p:spPr>
           <a:xfrm>
-            <a:off x="9402775" y="6382512"/>
-            <a:ext cx="219456" cy="219456"/>
-          </a:xfrm>
-          <a:prstGeom prst="ellipse">
-            <a:avLst/>
+            <a:off x="10241280" y="4791456"/>
+            <a:ext cx="1280160" cy="365760"/>
+          </a:xfrm>
+          <a:prstGeom prst="roundRect">
+            <a:avLst>
+              <a:gd name="adj" fmla="val 50000"/>
+            </a:avLst>
           </a:prstGeom>
           <a:solidFill>
             <a:srgbClr val="1F4E46"/>
@@ -10275,8 +10293,8 @@
         </p:nvSpPr>
         <p:spPr>
           <a:xfrm>
-            <a:off x="9704527" y="6327648"/>
-            <a:ext cx="1554480" cy="329184"/>
+            <a:off x="10241280" y="4791456"/>
+            <a:ext cx="1280160" cy="365760"/>
           </a:xfrm>
           <a:prstGeom prst="rect">
             <a:avLst/>
@@ -10288,13 +10306,13 @@
           <a:bodyPr wrap="square" lIns="0" tIns="0" rIns="0" bIns="0" rtlCol="0" anchor="ctr"/>
           <a:lstStyle/>
           <a:p>
-            <a:pPr indent="0" marL="0">
-              <a:buNone/>
-            </a:pPr>
-            <a:r>
-              <a:rPr lang="en-US" sz="1400" b="1" dirty="0">
-                <a:solidFill>
-                  <a:srgbClr val="1F4E46"/>
+            <a:pPr algn="ctr" indent="0" marL="0">
+              <a:buNone/>
+            </a:pPr>
+            <a:r>
+              <a:rPr lang="en-US" sz="1250" b="1" dirty="0">
+                <a:solidFill>
+                  <a:srgbClr val="FFFFFF"/>
                 </a:solidFill>
                 <a:latin typeface="Calibri" pitchFamily="34" charset="0"/>
                 <a:ea typeface="Calibri" pitchFamily="34" charset="-122"/>
@@ -10302,7 +10320,7 @@
               </a:rPr>
               <a:t>Large</a:t>
             </a:r>
-            <a:endParaRPr lang="en-US" sz="1400" dirty="0"/>
+            <a:endParaRPr lang="en-US" sz="1250" dirty="0"/>
           </a:p>
         </p:txBody>
       </p:sp>
@@ -10733,7 +10751,7 @@
         <p:spPr>
           <a:xfrm>
             <a:off x="1783080" y="4864608"/>
-            <a:ext cx="9738360" cy="274320"/>
+            <a:ext cx="8183880" cy="274320"/>
           </a:xfrm>
           <a:prstGeom prst="rect">
             <a:avLst/>
@@ -10893,11 +10911,13 @@
         </p:nvSpPr>
         <p:spPr>
           <a:xfrm>
-            <a:off x="9402775" y="6382512"/>
-            <a:ext cx="219456" cy="219456"/>
-          </a:xfrm>
-          <a:prstGeom prst="ellipse">
-            <a:avLst/>
+            <a:off x="10241280" y="4791456"/>
+            <a:ext cx="1280160" cy="365760"/>
+          </a:xfrm>
+          <a:prstGeom prst="roundRect">
+            <a:avLst>
+              <a:gd name="adj" fmla="val 50000"/>
+            </a:avLst>
           </a:prstGeom>
           <a:solidFill>
             <a:srgbClr val="1F4E46"/>
@@ -10918,8 +10938,8 @@
         </p:nvSpPr>
         <p:spPr>
           <a:xfrm>
-            <a:off x="9704527" y="6327648"/>
-            <a:ext cx="1554480" cy="329184"/>
+            <a:off x="10241280" y="4791456"/>
+            <a:ext cx="1280160" cy="365760"/>
           </a:xfrm>
           <a:prstGeom prst="rect">
             <a:avLst/>
@@ -10931,13 +10951,13 @@
           <a:bodyPr wrap="square" lIns="0" tIns="0" rIns="0" bIns="0" rtlCol="0" anchor="ctr"/>
           <a:lstStyle/>
           <a:p>
-            <a:pPr indent="0" marL="0">
-              <a:buNone/>
-            </a:pPr>
-            <a:r>
-              <a:rPr lang="en-US" sz="1400" b="1" dirty="0">
-                <a:solidFill>
-                  <a:srgbClr val="1F4E46"/>
+            <a:pPr algn="ctr" indent="0" marL="0">
+              <a:buNone/>
+            </a:pPr>
+            <a:r>
+              <a:rPr lang="en-US" sz="1250" b="1" dirty="0">
+                <a:solidFill>
+                  <a:srgbClr val="FFFFFF"/>
                 </a:solidFill>
                 <a:latin typeface="Calibri" pitchFamily="34" charset="0"/>
                 <a:ea typeface="Calibri" pitchFamily="34" charset="-122"/>
@@ -10945,7 +10965,7 @@
               </a:rPr>
               <a:t>Large</a:t>
             </a:r>
-            <a:endParaRPr lang="en-US" sz="1400" dirty="0"/>
+            <a:endParaRPr lang="en-US" sz="1250" dirty="0"/>
           </a:p>
         </p:txBody>
       </p:sp>
@@ -11028,8 +11048,8 @@
         </p:nvSpPr>
         <p:spPr>
           <a:xfrm>
-            <a:off x="685800" y="640080"/>
-            <a:ext cx="10789920" cy="731520"/>
+            <a:off x="640080" y="548640"/>
+            <a:ext cx="10789920" cy="640080"/>
           </a:xfrm>
           <a:prstGeom prst="rect">
             <a:avLst/>
@@ -11045,7 +11065,7 @@
               <a:buNone/>
             </a:pPr>
             <a:r>
-              <a:rPr lang="en-US" sz="3600" b="1" dirty="0">
+              <a:rPr lang="en-US" sz="3000" b="1" dirty="0">
                 <a:solidFill>
                   <a:srgbClr val="24313A"/>
                 </a:solidFill>
@@ -11055,7 +11075,7 @@
               </a:rPr>
               <a:t>Who we mean by former teachers</a:t>
             </a:r>
-            <a:endParaRPr lang="en-US" sz="3600" dirty="0"/>
+            <a:endParaRPr lang="en-US" sz="3000" dirty="0"/>
           </a:p>
         </p:txBody>
       </p:sp>
@@ -11067,8 +11087,8 @@
         </p:nvSpPr>
         <p:spPr>
           <a:xfrm>
-            <a:off x="822960" y="1965960"/>
-            <a:ext cx="1051560" cy="1051560"/>
+            <a:off x="822960" y="1874520"/>
+            <a:ext cx="731520" cy="731520"/>
           </a:xfrm>
           <a:prstGeom prst="ellipse">
             <a:avLst/>
@@ -11100,8 +11120,8 @@
         </p:blipFill>
         <p:spPr>
           <a:xfrm>
-            <a:off x="1075334" y="2218334"/>
-            <a:ext cx="546811" cy="546811"/>
+            <a:off x="998525" y="2050085"/>
+            <a:ext cx="380390" cy="380390"/>
           </a:xfrm>
           <a:prstGeom prst="rect">
             <a:avLst/>
@@ -11116,8 +11136,8 @@
         </p:nvSpPr>
         <p:spPr>
           <a:xfrm>
-            <a:off x="2240280" y="1947672"/>
-            <a:ext cx="8961120" cy="475488"/>
+            <a:off x="1828800" y="1837944"/>
+            <a:ext cx="9326880" cy="384048"/>
           </a:xfrm>
           <a:prstGeom prst="rect">
             <a:avLst/>
@@ -11133,7 +11153,7 @@
               <a:buNone/>
             </a:pPr>
             <a:r>
-              <a:rPr lang="en-US" sz="2600" b="1" dirty="0">
+              <a:rPr lang="en-US" sz="1900" b="1" dirty="0">
                 <a:solidFill>
                   <a:srgbClr val="24313A"/>
                 </a:solidFill>
@@ -11143,7 +11163,7 @@
               </a:rPr>
               <a:t>(a) Switchers</a:t>
             </a:r>
-            <a:endParaRPr lang="en-US" sz="2600" dirty="0"/>
+            <a:endParaRPr lang="en-US" sz="1900" dirty="0"/>
           </a:p>
         </p:txBody>
       </p:sp>
@@ -11155,8 +11175,8 @@
         </p:nvSpPr>
         <p:spPr>
           <a:xfrm>
-            <a:off x="2240280" y="2423160"/>
-            <a:ext cx="8961120" cy="548640"/>
+            <a:off x="1828800" y="2221992"/>
+            <a:ext cx="9326880" cy="502920"/>
           </a:xfrm>
           <a:prstGeom prst="rect">
             <a:avLst/>
@@ -11172,7 +11192,7 @@
               <a:buNone/>
             </a:pPr>
             <a:r>
-              <a:rPr lang="en-US" sz="1700" dirty="0">
+              <a:rPr lang="en-US" sz="1400" dirty="0">
                 <a:solidFill>
                   <a:srgbClr val="24313A"/>
                 </a:solidFill>
@@ -11182,7 +11202,7 @@
               </a:rPr>
               <a:t>Left the teaching profession to work in another sector.</a:t>
             </a:r>
-            <a:endParaRPr lang="en-US" sz="1700" dirty="0"/>
+            <a:endParaRPr lang="en-US" sz="1400" dirty="0"/>
           </a:p>
         </p:txBody>
       </p:sp>
@@ -11194,8 +11214,8 @@
         </p:nvSpPr>
         <p:spPr>
           <a:xfrm>
-            <a:off x="822960" y="3447288"/>
-            <a:ext cx="1051560" cy="1051560"/>
+            <a:off x="822960" y="3081528"/>
+            <a:ext cx="731520" cy="731520"/>
           </a:xfrm>
           <a:prstGeom prst="ellipse">
             <a:avLst/>
@@ -11227,8 +11247,8 @@
         </p:blipFill>
         <p:spPr>
           <a:xfrm>
-            <a:off x="1075334" y="3699662"/>
-            <a:ext cx="546811" cy="546811"/>
+            <a:off x="998525" y="3257093"/>
+            <a:ext cx="380390" cy="380390"/>
           </a:xfrm>
           <a:prstGeom prst="rect">
             <a:avLst/>
@@ -11243,8 +11263,8 @@
         </p:nvSpPr>
         <p:spPr>
           <a:xfrm>
-            <a:off x="2240280" y="3429000"/>
-            <a:ext cx="8961120" cy="475488"/>
+            <a:off x="1828800" y="3044952"/>
+            <a:ext cx="9326880" cy="384048"/>
           </a:xfrm>
           <a:prstGeom prst="rect">
             <a:avLst/>
@@ -11260,7 +11280,7 @@
               <a:buNone/>
             </a:pPr>
             <a:r>
-              <a:rPr lang="en-US" sz="2600" b="1" dirty="0">
+              <a:rPr lang="en-US" sz="1900" b="1" dirty="0">
                 <a:solidFill>
                   <a:srgbClr val="24313A"/>
                 </a:solidFill>
@@ -11270,7 +11290,7 @@
               </a:rPr>
               <a:t>(b) Leavers</a:t>
             </a:r>
-            <a:endParaRPr lang="en-US" sz="2600" dirty="0"/>
+            <a:endParaRPr lang="en-US" sz="1900" dirty="0"/>
           </a:p>
         </p:txBody>
       </p:sp>
@@ -11282,8 +11302,8 @@
         </p:nvSpPr>
         <p:spPr>
           <a:xfrm>
-            <a:off x="2240280" y="3904488"/>
-            <a:ext cx="8961120" cy="548640"/>
+            <a:off x="1828800" y="3429000"/>
+            <a:ext cx="9326880" cy="502920"/>
           </a:xfrm>
           <a:prstGeom prst="rect">
             <a:avLst/>
@@ -11299,7 +11319,7 @@
               <a:buNone/>
             </a:pPr>
             <a:r>
-              <a:rPr lang="en-US" sz="1700" dirty="0">
+              <a:rPr lang="en-US" sz="1400" dirty="0">
                 <a:solidFill>
                   <a:srgbClr val="24313A"/>
                 </a:solidFill>
@@ -11309,7 +11329,7 @@
               </a:rPr>
               <a:t>Left the teaching profession and the labour market altogether (not employed).</a:t>
             </a:r>
-            <a:endParaRPr lang="en-US" sz="1700" dirty="0"/>
+            <a:endParaRPr lang="en-US" sz="1400" dirty="0"/>
           </a:p>
         </p:txBody>
       </p:sp>
@@ -11321,8 +11341,8 @@
         </p:nvSpPr>
         <p:spPr>
           <a:xfrm>
-            <a:off x="822960" y="4928616"/>
-            <a:ext cx="1051560" cy="1051560"/>
+            <a:off x="822960" y="4288536"/>
+            <a:ext cx="731520" cy="731520"/>
           </a:xfrm>
           <a:prstGeom prst="ellipse">
             <a:avLst/>
@@ -11354,8 +11374,8 @@
         </p:blipFill>
         <p:spPr>
           <a:xfrm>
-            <a:off x="1075334" y="5180990"/>
-            <a:ext cx="546811" cy="546811"/>
+            <a:off x="998525" y="4464101"/>
+            <a:ext cx="380390" cy="380390"/>
           </a:xfrm>
           <a:prstGeom prst="rect">
             <a:avLst/>
@@ -11370,8 +11390,8 @@
         </p:nvSpPr>
         <p:spPr>
           <a:xfrm>
-            <a:off x="2240280" y="4910328"/>
-            <a:ext cx="8961120" cy="475488"/>
+            <a:off x="1828800" y="4251960"/>
+            <a:ext cx="9326880" cy="384048"/>
           </a:xfrm>
           <a:prstGeom prst="rect">
             <a:avLst/>
@@ -11387,7 +11407,7 @@
               <a:buNone/>
             </a:pPr>
             <a:r>
-              <a:rPr lang="en-US" sz="2600" b="1" dirty="0">
+              <a:rPr lang="en-US" sz="1900" b="1" dirty="0">
                 <a:solidFill>
                   <a:srgbClr val="24313A"/>
                 </a:solidFill>
@@ -11397,7 +11417,7 @@
               </a:rPr>
               <a:t>(c) Retired</a:t>
             </a:r>
-            <a:endParaRPr lang="en-US" sz="2600" dirty="0"/>
+            <a:endParaRPr lang="en-US" sz="1900" dirty="0"/>
           </a:p>
         </p:txBody>
       </p:sp>
@@ -11409,8 +11429,8 @@
         </p:nvSpPr>
         <p:spPr>
           <a:xfrm>
-            <a:off x="2240280" y="5385816"/>
-            <a:ext cx="8961120" cy="548640"/>
+            <a:off x="1828800" y="4636008"/>
+            <a:ext cx="9326880" cy="502920"/>
           </a:xfrm>
           <a:prstGeom prst="rect">
             <a:avLst/>
@@ -11426,7 +11446,7 @@
               <a:buNone/>
             </a:pPr>
             <a:r>
-              <a:rPr lang="en-US" sz="1700" dirty="0">
+              <a:rPr lang="en-US" sz="1400" dirty="0">
                 <a:solidFill>
                   <a:srgbClr val="24313A"/>
                 </a:solidFill>
@@ -11436,7 +11456,7 @@
               </a:rPr>
               <a:t>Retired from teaching.</a:t>
             </a:r>
-            <a:endParaRPr lang="en-US" sz="1700" dirty="0"/>
+            <a:endParaRPr lang="en-US" sz="1400" dirty="0"/>
           </a:p>
         </p:txBody>
       </p:sp>
@@ -11906,7 +11926,7 @@
         <p:spPr>
           <a:xfrm>
             <a:off x="1783080" y="4864608"/>
-            <a:ext cx="9738360" cy="274320"/>
+            <a:ext cx="8183880" cy="274320"/>
           </a:xfrm>
           <a:prstGeom prst="rect">
             <a:avLst/>
@@ -12066,11 +12086,13 @@
         </p:nvSpPr>
         <p:spPr>
           <a:xfrm>
-            <a:off x="9402775" y="6382512"/>
-            <a:ext cx="219456" cy="219456"/>
-          </a:xfrm>
-          <a:prstGeom prst="ellipse">
-            <a:avLst/>
+            <a:off x="10241280" y="4791456"/>
+            <a:ext cx="1280160" cy="365760"/>
+          </a:xfrm>
+          <a:prstGeom prst="roundRect">
+            <a:avLst>
+              <a:gd name="adj" fmla="val 50000"/>
+            </a:avLst>
           </a:prstGeom>
           <a:solidFill>
             <a:srgbClr val="B3542E"/>
@@ -12091,8 +12113,8 @@
         </p:nvSpPr>
         <p:spPr>
           <a:xfrm>
-            <a:off x="9704527" y="6327648"/>
-            <a:ext cx="1554480" cy="329184"/>
+            <a:off x="10241280" y="4791456"/>
+            <a:ext cx="1280160" cy="365760"/>
           </a:xfrm>
           <a:prstGeom prst="rect">
             <a:avLst/>
@@ -12104,13 +12126,13 @@
           <a:bodyPr wrap="square" lIns="0" tIns="0" rIns="0" bIns="0" rtlCol="0" anchor="ctr"/>
           <a:lstStyle/>
           <a:p>
-            <a:pPr indent="0" marL="0">
-              <a:buNone/>
-            </a:pPr>
-            <a:r>
-              <a:rPr lang="en-US" sz="1400" b="1" dirty="0">
-                <a:solidFill>
-                  <a:srgbClr val="B3542E"/>
+            <a:pPr algn="ctr" indent="0" marL="0">
+              <a:buNone/>
+            </a:pPr>
+            <a:r>
+              <a:rPr lang="en-US" sz="1250" b="1" dirty="0">
+                <a:solidFill>
+                  <a:srgbClr val="FFFFFF"/>
                 </a:solidFill>
                 <a:latin typeface="Calibri" pitchFamily="34" charset="0"/>
                 <a:ea typeface="Calibri" pitchFamily="34" charset="-122"/>
@@ -12118,7 +12140,7 @@
               </a:rPr>
               <a:t>Small</a:t>
             </a:r>
-            <a:endParaRPr lang="en-US" sz="1400" dirty="0"/>
+            <a:endParaRPr lang="en-US" sz="1250" dirty="0"/>
           </a:p>
         </p:txBody>
       </p:sp>
@@ -12492,7 +12514,7 @@
                 <a:ea typeface="Cambria" pitchFamily="34" charset="-122"/>
                 <a:cs typeface="Cambria" pitchFamily="34" charset="-120"/>
               </a:rPr>
-              <a:t>Skolverket web-based training for returning teachers and preschool teachers (since 2018)</a:t>
+              <a:t>Online refresher course for returning teachers (National Agency for Education, since 2018)</a:t>
             </a:r>
             <a:endParaRPr lang="en-US" sz="2100" dirty="0"/>
           </a:p>
@@ -12549,7 +12571,7 @@
         <p:spPr>
           <a:xfrm>
             <a:off x="1783080" y="4864608"/>
-            <a:ext cx="9738360" cy="274320"/>
+            <a:ext cx="8183880" cy="274320"/>
           </a:xfrm>
           <a:prstGeom prst="rect">
             <a:avLst/>
@@ -12709,11 +12731,13 @@
         </p:nvSpPr>
         <p:spPr>
           <a:xfrm>
-            <a:off x="9402775" y="6382512"/>
-            <a:ext cx="219456" cy="219456"/>
-          </a:xfrm>
-          <a:prstGeom prst="ellipse">
-            <a:avLst/>
+            <a:off x="10241280" y="4791456"/>
+            <a:ext cx="1280160" cy="365760"/>
+          </a:xfrm>
+          <a:prstGeom prst="roundRect">
+            <a:avLst>
+              <a:gd name="adj" fmla="val 50000"/>
+            </a:avLst>
           </a:prstGeom>
           <a:solidFill>
             <a:srgbClr val="1F4E46"/>
@@ -12734,8 +12758,8 @@
         </p:nvSpPr>
         <p:spPr>
           <a:xfrm>
-            <a:off x="9704527" y="6327648"/>
-            <a:ext cx="1554480" cy="329184"/>
+            <a:off x="10241280" y="4791456"/>
+            <a:ext cx="1280160" cy="365760"/>
           </a:xfrm>
           <a:prstGeom prst="rect">
             <a:avLst/>
@@ -12747,13 +12771,13 @@
           <a:bodyPr wrap="square" lIns="0" tIns="0" rIns="0" bIns="0" rtlCol="0" anchor="ctr"/>
           <a:lstStyle/>
           <a:p>
-            <a:pPr indent="0" marL="0">
-              <a:buNone/>
-            </a:pPr>
-            <a:r>
-              <a:rPr lang="en-US" sz="1400" b="1" dirty="0">
-                <a:solidFill>
-                  <a:srgbClr val="1F4E46"/>
+            <a:pPr algn="ctr" indent="0" marL="0">
+              <a:buNone/>
+            </a:pPr>
+            <a:r>
+              <a:rPr lang="en-US" sz="1250" b="1" dirty="0">
+                <a:solidFill>
+                  <a:srgbClr val="FFFFFF"/>
                 </a:solidFill>
                 <a:latin typeface="Calibri" pitchFamily="34" charset="0"/>
                 <a:ea typeface="Calibri" pitchFamily="34" charset="-122"/>
@@ -12761,7 +12785,7 @@
               </a:rPr>
               <a:t>Large</a:t>
             </a:r>
-            <a:endParaRPr lang="en-US" sz="1400" dirty="0"/>
+            <a:endParaRPr lang="en-US" sz="1250" dirty="0"/>
           </a:p>
         </p:txBody>
       </p:sp>
@@ -13231,7 +13255,7 @@
         <p:spPr>
           <a:xfrm>
             <a:off x="1783080" y="4864608"/>
-            <a:ext cx="9738360" cy="274320"/>
+            <a:ext cx="8183880" cy="274320"/>
           </a:xfrm>
           <a:prstGeom prst="rect">
             <a:avLst/>
@@ -13348,11 +13372,13 @@
         </p:nvSpPr>
         <p:spPr>
           <a:xfrm>
-            <a:off x="9402775" y="6382512"/>
-            <a:ext cx="219456" cy="219456"/>
-          </a:xfrm>
-          <a:prstGeom prst="ellipse">
-            <a:avLst/>
+            <a:off x="10241280" y="4791456"/>
+            <a:ext cx="1280160" cy="365760"/>
+          </a:xfrm>
+          <a:prstGeom prst="roundRect">
+            <a:avLst>
+              <a:gd name="adj" fmla="val 50000"/>
+            </a:avLst>
           </a:prstGeom>
           <a:solidFill>
             <a:srgbClr val="C8892B"/>
@@ -13373,8 +13399,8 @@
         </p:nvSpPr>
         <p:spPr>
           <a:xfrm>
-            <a:off x="9704527" y="6327648"/>
-            <a:ext cx="1554480" cy="329184"/>
+            <a:off x="10241280" y="4791456"/>
+            <a:ext cx="1280160" cy="365760"/>
           </a:xfrm>
           <a:prstGeom prst="rect">
             <a:avLst/>
@@ -13386,13 +13412,13 @@
           <a:bodyPr wrap="square" lIns="0" tIns="0" rIns="0" bIns="0" rtlCol="0" anchor="ctr"/>
           <a:lstStyle/>
           <a:p>
-            <a:pPr indent="0" marL="0">
-              <a:buNone/>
-            </a:pPr>
-            <a:r>
-              <a:rPr lang="en-US" sz="1400" b="1" dirty="0">
-                <a:solidFill>
-                  <a:srgbClr val="C8892B"/>
+            <a:pPr algn="ctr" indent="0" marL="0">
+              <a:buNone/>
+            </a:pPr>
+            <a:r>
+              <a:rPr lang="en-US" sz="1250" b="1" dirty="0">
+                <a:solidFill>
+                  <a:srgbClr val="FFFFFF"/>
                 </a:solidFill>
                 <a:latin typeface="Calibri" pitchFamily="34" charset="0"/>
                 <a:ea typeface="Calibri" pitchFamily="34" charset="-122"/>
@@ -13400,7 +13426,7 @@
               </a:rPr>
               <a:t>Medium</a:t>
             </a:r>
-            <a:endParaRPr lang="en-US" sz="1400" dirty="0"/>
+            <a:endParaRPr lang="en-US" sz="1250" dirty="0"/>
           </a:p>
         </p:txBody>
       </p:sp>
@@ -13870,7 +13896,7 @@
         <p:spPr>
           <a:xfrm>
             <a:off x="1783080" y="4864608"/>
-            <a:ext cx="9738360" cy="274320"/>
+            <a:ext cx="8183880" cy="274320"/>
           </a:xfrm>
           <a:prstGeom prst="rect">
             <a:avLst/>
@@ -14030,11 +14056,13 @@
         </p:nvSpPr>
         <p:spPr>
           <a:xfrm>
-            <a:off x="9402775" y="6382512"/>
-            <a:ext cx="219456" cy="219456"/>
-          </a:xfrm>
-          <a:prstGeom prst="ellipse">
-            <a:avLst/>
+            <a:off x="10241280" y="4791456"/>
+            <a:ext cx="1280160" cy="365760"/>
+          </a:xfrm>
+          <a:prstGeom prst="roundRect">
+            <a:avLst>
+              <a:gd name="adj" fmla="val 50000"/>
+            </a:avLst>
           </a:prstGeom>
           <a:solidFill>
             <a:srgbClr val="1F4E46"/>
@@ -14055,8 +14083,8 @@
         </p:nvSpPr>
         <p:spPr>
           <a:xfrm>
-            <a:off x="9704527" y="6327648"/>
-            <a:ext cx="1554480" cy="329184"/>
+            <a:off x="10241280" y="4791456"/>
+            <a:ext cx="1280160" cy="365760"/>
           </a:xfrm>
           <a:prstGeom prst="rect">
             <a:avLst/>
@@ -14068,13 +14096,13 @@
           <a:bodyPr wrap="square" lIns="0" tIns="0" rIns="0" bIns="0" rtlCol="0" anchor="ctr"/>
           <a:lstStyle/>
           <a:p>
-            <a:pPr indent="0" marL="0">
-              <a:buNone/>
-            </a:pPr>
-            <a:r>
-              <a:rPr lang="en-US" sz="1400" b="1" dirty="0">
-                <a:solidFill>
-                  <a:srgbClr val="1F4E46"/>
+            <a:pPr algn="ctr" indent="0" marL="0">
+              <a:buNone/>
+            </a:pPr>
+            <a:r>
+              <a:rPr lang="en-US" sz="1250" b="1" dirty="0">
+                <a:solidFill>
+                  <a:srgbClr val="FFFFFF"/>
                 </a:solidFill>
                 <a:latin typeface="Calibri" pitchFamily="34" charset="0"/>
                 <a:ea typeface="Calibri" pitchFamily="34" charset="-122"/>
@@ -14082,7 +14110,7 @@
               </a:rPr>
               <a:t>Large</a:t>
             </a:r>
-            <a:endParaRPr lang="en-US" sz="1400" dirty="0"/>
+            <a:endParaRPr lang="en-US" sz="1250" dirty="0"/>
           </a:p>
         </p:txBody>
       </p:sp>
@@ -14552,7 +14580,7 @@
         <p:spPr>
           <a:xfrm>
             <a:off x="1783080" y="4864608"/>
-            <a:ext cx="9738360" cy="274320"/>
+            <a:ext cx="8183880" cy="274320"/>
           </a:xfrm>
           <a:prstGeom prst="rect">
             <a:avLst/>
@@ -14712,11 +14740,13 @@
         </p:nvSpPr>
         <p:spPr>
           <a:xfrm>
-            <a:off x="9402775" y="6382512"/>
-            <a:ext cx="219456" cy="219456"/>
-          </a:xfrm>
-          <a:prstGeom prst="ellipse">
-            <a:avLst/>
+            <a:off x="10241280" y="4791456"/>
+            <a:ext cx="1280160" cy="365760"/>
+          </a:xfrm>
+          <a:prstGeom prst="roundRect">
+            <a:avLst>
+              <a:gd name="adj" fmla="val 50000"/>
+            </a:avLst>
           </a:prstGeom>
           <a:solidFill>
             <a:srgbClr val="1F4E46"/>
@@ -14737,8 +14767,8 @@
         </p:nvSpPr>
         <p:spPr>
           <a:xfrm>
-            <a:off x="9704527" y="6327648"/>
-            <a:ext cx="1554480" cy="329184"/>
+            <a:off x="10241280" y="4791456"/>
+            <a:ext cx="1280160" cy="365760"/>
           </a:xfrm>
           <a:prstGeom prst="rect">
             <a:avLst/>
@@ -14750,13 +14780,13 @@
           <a:bodyPr wrap="square" lIns="0" tIns="0" rIns="0" bIns="0" rtlCol="0" anchor="ctr"/>
           <a:lstStyle/>
           <a:p>
-            <a:pPr indent="0" marL="0">
-              <a:buNone/>
-            </a:pPr>
-            <a:r>
-              <a:rPr lang="en-US" sz="1400" b="1" dirty="0">
-                <a:solidFill>
-                  <a:srgbClr val="1F4E46"/>
+            <a:pPr algn="ctr" indent="0" marL="0">
+              <a:buNone/>
+            </a:pPr>
+            <a:r>
+              <a:rPr lang="en-US" sz="1250" b="1" dirty="0">
+                <a:solidFill>
+                  <a:srgbClr val="FFFFFF"/>
                 </a:solidFill>
                 <a:latin typeface="Calibri" pitchFamily="34" charset="0"/>
                 <a:ea typeface="Calibri" pitchFamily="34" charset="-122"/>
@@ -14764,7 +14794,7 @@
               </a:rPr>
               <a:t>Large</a:t>
             </a:r>
-            <a:endParaRPr lang="en-US" sz="1400" dirty="0"/>
+            <a:endParaRPr lang="en-US" sz="1250" dirty="0"/>
           </a:p>
         </p:txBody>
       </p:sp>
@@ -15234,7 +15264,7 @@
         <p:spPr>
           <a:xfrm>
             <a:off x="1783080" y="4864608"/>
-            <a:ext cx="9738360" cy="274320"/>
+            <a:ext cx="8183880" cy="274320"/>
           </a:xfrm>
           <a:prstGeom prst="rect">
             <a:avLst/>
@@ -15351,11 +15381,13 @@
         </p:nvSpPr>
         <p:spPr>
           <a:xfrm>
-            <a:off x="9402775" y="6382512"/>
-            <a:ext cx="219456" cy="219456"/>
-          </a:xfrm>
-          <a:prstGeom prst="ellipse">
-            <a:avLst/>
+            <a:off x="10241280" y="4791456"/>
+            <a:ext cx="1280160" cy="365760"/>
+          </a:xfrm>
+          <a:prstGeom prst="roundRect">
+            <a:avLst>
+              <a:gd name="adj" fmla="val 50000"/>
+            </a:avLst>
           </a:prstGeom>
           <a:solidFill>
             <a:srgbClr val="B3542E"/>
@@ -15376,8 +15408,8 @@
         </p:nvSpPr>
         <p:spPr>
           <a:xfrm>
-            <a:off x="9704527" y="6327648"/>
-            <a:ext cx="1554480" cy="329184"/>
+            <a:off x="10241280" y="4791456"/>
+            <a:ext cx="1280160" cy="365760"/>
           </a:xfrm>
           <a:prstGeom prst="rect">
             <a:avLst/>
@@ -15389,13 +15421,13 @@
           <a:bodyPr wrap="square" lIns="0" tIns="0" rIns="0" bIns="0" rtlCol="0" anchor="ctr"/>
           <a:lstStyle/>
           <a:p>
-            <a:pPr indent="0" marL="0">
-              <a:buNone/>
-            </a:pPr>
-            <a:r>
-              <a:rPr lang="en-US" sz="1400" b="1" dirty="0">
-                <a:solidFill>
-                  <a:srgbClr val="B3542E"/>
+            <a:pPr algn="ctr" indent="0" marL="0">
+              <a:buNone/>
+            </a:pPr>
+            <a:r>
+              <a:rPr lang="en-US" sz="1250" b="1" dirty="0">
+                <a:solidFill>
+                  <a:srgbClr val="FFFFFF"/>
                 </a:solidFill>
                 <a:latin typeface="Calibri" pitchFamily="34" charset="0"/>
                 <a:ea typeface="Calibri" pitchFamily="34" charset="-122"/>
@@ -15403,7 +15435,7 @@
               </a:rPr>
               <a:t>Small</a:t>
             </a:r>
-            <a:endParaRPr lang="en-US" sz="1400" dirty="0"/>
+            <a:endParaRPr lang="en-US" sz="1250" dirty="0"/>
           </a:p>
         </p:txBody>
       </p:sp>
@@ -15873,7 +15905,7 @@
         <p:spPr>
           <a:xfrm>
             <a:off x="1783080" y="4864608"/>
-            <a:ext cx="9738360" cy="274320"/>
+            <a:ext cx="8183880" cy="274320"/>
           </a:xfrm>
           <a:prstGeom prst="rect">
             <a:avLst/>
@@ -16033,11 +16065,13 @@
         </p:nvSpPr>
         <p:spPr>
           <a:xfrm>
-            <a:off x="9402775" y="6382512"/>
-            <a:ext cx="219456" cy="219456"/>
-          </a:xfrm>
-          <a:prstGeom prst="ellipse">
-            <a:avLst/>
+            <a:off x="10241280" y="4791456"/>
+            <a:ext cx="1280160" cy="365760"/>
+          </a:xfrm>
+          <a:prstGeom prst="roundRect">
+            <a:avLst>
+              <a:gd name="adj" fmla="val 50000"/>
+            </a:avLst>
           </a:prstGeom>
           <a:solidFill>
             <a:srgbClr val="1F4E46"/>
@@ -16058,8 +16092,8 @@
         </p:nvSpPr>
         <p:spPr>
           <a:xfrm>
-            <a:off x="9704527" y="6327648"/>
-            <a:ext cx="1554480" cy="329184"/>
+            <a:off x="10241280" y="4791456"/>
+            <a:ext cx="1280160" cy="365760"/>
           </a:xfrm>
           <a:prstGeom prst="rect">
             <a:avLst/>
@@ -16071,13 +16105,13 @@
           <a:bodyPr wrap="square" lIns="0" tIns="0" rIns="0" bIns="0" rtlCol="0" anchor="ctr"/>
           <a:lstStyle/>
           <a:p>
-            <a:pPr indent="0" marL="0">
-              <a:buNone/>
-            </a:pPr>
-            <a:r>
-              <a:rPr lang="en-US" sz="1400" b="1" dirty="0">
-                <a:solidFill>
-                  <a:srgbClr val="1F4E46"/>
+            <a:pPr algn="ctr" indent="0" marL="0">
+              <a:buNone/>
+            </a:pPr>
+            <a:r>
+              <a:rPr lang="en-US" sz="1250" b="1" dirty="0">
+                <a:solidFill>
+                  <a:srgbClr val="FFFFFF"/>
                 </a:solidFill>
                 <a:latin typeface="Calibri" pitchFamily="34" charset="0"/>
                 <a:ea typeface="Calibri" pitchFamily="34" charset="-122"/>
@@ -16085,7 +16119,7 @@
               </a:rPr>
               <a:t>Large</a:t>
             </a:r>
-            <a:endParaRPr lang="en-US" sz="1400" dirty="0"/>
+            <a:endParaRPr lang="en-US" sz="1250" dirty="0"/>
           </a:p>
         </p:txBody>
       </p:sp>
@@ -16555,7 +16589,7 @@
         <p:spPr>
           <a:xfrm>
             <a:off x="1783080" y="4864608"/>
-            <a:ext cx="9738360" cy="274320"/>
+            <a:ext cx="8183880" cy="274320"/>
           </a:xfrm>
           <a:prstGeom prst="rect">
             <a:avLst/>
@@ -16715,11 +16749,13 @@
         </p:nvSpPr>
         <p:spPr>
           <a:xfrm>
-            <a:off x="9402775" y="6382512"/>
-            <a:ext cx="219456" cy="219456"/>
-          </a:xfrm>
-          <a:prstGeom prst="ellipse">
-            <a:avLst/>
+            <a:off x="10241280" y="4791456"/>
+            <a:ext cx="1280160" cy="365760"/>
+          </a:xfrm>
+          <a:prstGeom prst="roundRect">
+            <a:avLst>
+              <a:gd name="adj" fmla="val 50000"/>
+            </a:avLst>
           </a:prstGeom>
           <a:solidFill>
             <a:srgbClr val="C8892B"/>
@@ -16740,8 +16776,8 @@
         </p:nvSpPr>
         <p:spPr>
           <a:xfrm>
-            <a:off x="9704527" y="6327648"/>
-            <a:ext cx="1554480" cy="329184"/>
+            <a:off x="10241280" y="4791456"/>
+            <a:ext cx="1280160" cy="365760"/>
           </a:xfrm>
           <a:prstGeom prst="rect">
             <a:avLst/>
@@ -16753,13 +16789,13 @@
           <a:bodyPr wrap="square" lIns="0" tIns="0" rIns="0" bIns="0" rtlCol="0" anchor="ctr"/>
           <a:lstStyle/>
           <a:p>
-            <a:pPr indent="0" marL="0">
-              <a:buNone/>
-            </a:pPr>
-            <a:r>
-              <a:rPr lang="en-US" sz="1400" b="1" dirty="0">
-                <a:solidFill>
-                  <a:srgbClr val="C8892B"/>
+            <a:pPr algn="ctr" indent="0" marL="0">
+              <a:buNone/>
+            </a:pPr>
+            <a:r>
+              <a:rPr lang="en-US" sz="1250" b="1" dirty="0">
+                <a:solidFill>
+                  <a:srgbClr val="FFFFFF"/>
                 </a:solidFill>
                 <a:latin typeface="Calibri" pitchFamily="34" charset="0"/>
                 <a:ea typeface="Calibri" pitchFamily="34" charset="-122"/>
@@ -16767,7 +16803,7 @@
               </a:rPr>
               <a:t>Medium</a:t>
             </a:r>
-            <a:endParaRPr lang="en-US" sz="1400" dirty="0"/>
+            <a:endParaRPr lang="en-US" sz="1250" dirty="0"/>
           </a:p>
         </p:txBody>
       </p:sp>
@@ -17237,7 +17273,7 @@
         <p:spPr>
           <a:xfrm>
             <a:off x="1783080" y="4864608"/>
-            <a:ext cx="9738360" cy="274320"/>
+            <a:ext cx="8183880" cy="274320"/>
           </a:xfrm>
           <a:prstGeom prst="rect">
             <a:avLst/>
@@ -17397,11 +17433,13 @@
         </p:nvSpPr>
         <p:spPr>
           <a:xfrm>
-            <a:off x="9402775" y="6382512"/>
-            <a:ext cx="219456" cy="219456"/>
-          </a:xfrm>
-          <a:prstGeom prst="ellipse">
-            <a:avLst/>
+            <a:off x="10241280" y="4791456"/>
+            <a:ext cx="1280160" cy="365760"/>
+          </a:xfrm>
+          <a:prstGeom prst="roundRect">
+            <a:avLst>
+              <a:gd name="adj" fmla="val 50000"/>
+            </a:avLst>
           </a:prstGeom>
           <a:solidFill>
             <a:srgbClr val="C8892B"/>
@@ -17422,8 +17460,8 @@
         </p:nvSpPr>
         <p:spPr>
           <a:xfrm>
-            <a:off x="9704527" y="6327648"/>
-            <a:ext cx="1554480" cy="329184"/>
+            <a:off x="10241280" y="4791456"/>
+            <a:ext cx="1280160" cy="365760"/>
           </a:xfrm>
           <a:prstGeom prst="rect">
             <a:avLst/>
@@ -17435,13 +17473,13 @@
           <a:bodyPr wrap="square" lIns="0" tIns="0" rIns="0" bIns="0" rtlCol="0" anchor="ctr"/>
           <a:lstStyle/>
           <a:p>
-            <a:pPr indent="0" marL="0">
-              <a:buNone/>
-            </a:pPr>
-            <a:r>
-              <a:rPr lang="en-US" sz="1400" b="1" dirty="0">
-                <a:solidFill>
-                  <a:srgbClr val="C8892B"/>
+            <a:pPr algn="ctr" indent="0" marL="0">
+              <a:buNone/>
+            </a:pPr>
+            <a:r>
+              <a:rPr lang="en-US" sz="1250" b="1" dirty="0">
+                <a:solidFill>
+                  <a:srgbClr val="FFFFFF"/>
                 </a:solidFill>
                 <a:latin typeface="Calibri" pitchFamily="34" charset="0"/>
                 <a:ea typeface="Calibri" pitchFamily="34" charset="-122"/>
@@ -17449,7 +17487,7 @@
               </a:rPr>
               <a:t>Medium</a:t>
             </a:r>
-            <a:endParaRPr lang="en-US" sz="1400" dirty="0"/>
+            <a:endParaRPr lang="en-US" sz="1250" dirty="0"/>
           </a:p>
         </p:txBody>
       </p:sp>
@@ -17919,7 +17957,7 @@
         <p:spPr>
           <a:xfrm>
             <a:off x="1783080" y="4864608"/>
-            <a:ext cx="9738360" cy="274320"/>
+            <a:ext cx="8183880" cy="274320"/>
           </a:xfrm>
           <a:prstGeom prst="rect">
             <a:avLst/>
@@ -18079,11 +18117,13 @@
         </p:nvSpPr>
         <p:spPr>
           <a:xfrm>
-            <a:off x="9402775" y="6382512"/>
-            <a:ext cx="219456" cy="219456"/>
-          </a:xfrm>
-          <a:prstGeom prst="ellipse">
-            <a:avLst/>
+            <a:off x="10241280" y="4791456"/>
+            <a:ext cx="1280160" cy="365760"/>
+          </a:xfrm>
+          <a:prstGeom prst="roundRect">
+            <a:avLst>
+              <a:gd name="adj" fmla="val 50000"/>
+            </a:avLst>
           </a:prstGeom>
           <a:solidFill>
             <a:srgbClr val="C8892B"/>
@@ -18104,8 +18144,8 @@
         </p:nvSpPr>
         <p:spPr>
           <a:xfrm>
-            <a:off x="9704527" y="6327648"/>
-            <a:ext cx="1554480" cy="329184"/>
+            <a:off x="10241280" y="4791456"/>
+            <a:ext cx="1280160" cy="365760"/>
           </a:xfrm>
           <a:prstGeom prst="rect">
             <a:avLst/>
@@ -18117,13 +18157,13 @@
           <a:bodyPr wrap="square" lIns="0" tIns="0" rIns="0" bIns="0" rtlCol="0" anchor="ctr"/>
           <a:lstStyle/>
           <a:p>
-            <a:pPr indent="0" marL="0">
-              <a:buNone/>
-            </a:pPr>
-            <a:r>
-              <a:rPr lang="en-US" sz="1400" b="1" dirty="0">
-                <a:solidFill>
-                  <a:srgbClr val="C8892B"/>
+            <a:pPr algn="ctr" indent="0" marL="0">
+              <a:buNone/>
+            </a:pPr>
+            <a:r>
+              <a:rPr lang="en-US" sz="1250" b="1" dirty="0">
+                <a:solidFill>
+                  <a:srgbClr val="FFFFFF"/>
                 </a:solidFill>
                 <a:latin typeface="Calibri" pitchFamily="34" charset="0"/>
                 <a:ea typeface="Calibri" pitchFamily="34" charset="-122"/>
@@ -18131,7 +18171,7 @@
               </a:rPr>
               <a:t>Medium</a:t>
             </a:r>
-            <a:endParaRPr lang="en-US" sz="1400" dirty="0"/>
+            <a:endParaRPr lang="en-US" sz="1250" dirty="0"/>
           </a:p>
         </p:txBody>
       </p:sp>
@@ -18214,8 +18254,8 @@
         </p:nvSpPr>
         <p:spPr>
           <a:xfrm>
-            <a:off x="685800" y="457200"/>
-            <a:ext cx="10789920" cy="685800"/>
+            <a:off x="640080" y="411480"/>
+            <a:ext cx="10789920" cy="640080"/>
           </a:xfrm>
           <a:prstGeom prst="rect">
             <a:avLst/>
@@ -18231,7 +18271,7 @@
               <a:buNone/>
             </a:pPr>
             <a:r>
-              <a:rPr lang="en-US" sz="3600" b="1" dirty="0">
+              <a:rPr lang="en-US" sz="3000" b="1" dirty="0">
                 <a:solidFill>
                   <a:srgbClr val="24313A"/>
                 </a:solidFill>
@@ -18241,7 +18281,7 @@
               </a:rPr>
               <a:t>Five policy instruments</a:t>
             </a:r>
-            <a:endParaRPr lang="en-US" sz="3600" dirty="0"/>
+            <a:endParaRPr lang="en-US" sz="3000" dirty="0"/>
           </a:p>
         </p:txBody>
       </p:sp>
@@ -18253,8 +18293,8 @@
         </p:nvSpPr>
         <p:spPr>
           <a:xfrm>
-            <a:off x="713232" y="1115568"/>
-            <a:ext cx="10789920" cy="365760"/>
+            <a:off x="667512" y="1024128"/>
+            <a:ext cx="10789920" cy="320040"/>
           </a:xfrm>
           <a:prstGeom prst="rect">
             <a:avLst/>
@@ -18270,7 +18310,7 @@
               <a:buNone/>
             </a:pPr>
             <a:r>
-              <a:rPr lang="en-US" sz="1600" dirty="0">
+              <a:rPr lang="en-US" sz="1400" dirty="0">
                 <a:solidFill>
                   <a:srgbClr val="B3542E"/>
                 </a:solidFill>
@@ -18280,7 +18320,7 @@
               </a:rPr>
               <a:t>Each policy is classified by the instrument it uses</a:t>
             </a:r>
-            <a:endParaRPr lang="en-US" sz="1600" dirty="0"/>
+            <a:endParaRPr lang="en-US" sz="1400" dirty="0"/>
           </a:p>
         </p:txBody>
       </p:sp>
@@ -18292,8 +18332,8 @@
         </p:nvSpPr>
         <p:spPr>
           <a:xfrm>
-            <a:off x="822960" y="1737360"/>
-            <a:ext cx="822960" cy="822960"/>
+            <a:off x="822960" y="1691640"/>
+            <a:ext cx="621792" cy="621792"/>
           </a:xfrm>
           <a:prstGeom prst="ellipse">
             <a:avLst/>
@@ -18325,8 +18365,8 @@
         </p:blipFill>
         <p:spPr>
           <a:xfrm>
-            <a:off x="1020470" y="1934870"/>
-            <a:ext cx="427939" cy="427939"/>
+            <a:off x="972190" y="1840870"/>
+            <a:ext cx="323332" cy="323332"/>
           </a:xfrm>
           <a:prstGeom prst="rect">
             <a:avLst/>
@@ -18341,8 +18381,8 @@
         </p:nvSpPr>
         <p:spPr>
           <a:xfrm>
-            <a:off x="2011680" y="1700784"/>
-            <a:ext cx="9326880" cy="384048"/>
+            <a:off x="1691640" y="1645920"/>
+            <a:ext cx="9692640" cy="329184"/>
           </a:xfrm>
           <a:prstGeom prst="rect">
             <a:avLst/>
@@ -18358,7 +18398,7 @@
               <a:buNone/>
             </a:pPr>
             <a:r>
-              <a:rPr lang="en-US" sz="2100" b="1" dirty="0">
+              <a:rPr lang="en-US" sz="1650" b="1" dirty="0">
                 <a:solidFill>
                   <a:srgbClr val="24313A"/>
                 </a:solidFill>
@@ -18368,7 +18408,7 @@
               </a:rPr>
               <a:t>Financial incentives</a:t>
             </a:r>
-            <a:endParaRPr lang="en-US" sz="2100" dirty="0"/>
+            <a:endParaRPr lang="en-US" sz="1650" dirty="0"/>
           </a:p>
         </p:txBody>
       </p:sp>
@@ -18380,8 +18420,8 @@
         </p:nvSpPr>
         <p:spPr>
           <a:xfrm>
-            <a:off x="2011680" y="2084832"/>
-            <a:ext cx="9326880" cy="548640"/>
+            <a:off x="1691640" y="1965960"/>
+            <a:ext cx="9692640" cy="548640"/>
           </a:xfrm>
           <a:prstGeom prst="rect">
             <a:avLst/>
@@ -18397,7 +18437,7 @@
               <a:buNone/>
             </a:pPr>
             <a:r>
-              <a:rPr lang="en-US" sz="1450" dirty="0">
+              <a:rPr lang="en-US" sz="1300" dirty="0">
                 <a:solidFill>
                   <a:srgbClr val="24313A"/>
                 </a:solidFill>
@@ -18407,7 +18447,7 @@
               </a:rPr>
               <a:t>Direct payments or legal changes with an economic effect: rules letting retirees draw salary plus pension, return bonuses for switchers or leavers, bonuses for schools that re-hire them.</a:t>
             </a:r>
-            <a:endParaRPr lang="en-US" sz="1450" dirty="0"/>
+            <a:endParaRPr lang="en-US" sz="1300" dirty="0"/>
           </a:p>
         </p:txBody>
       </p:sp>
@@ -18419,8 +18459,8 @@
         </p:nvSpPr>
         <p:spPr>
           <a:xfrm>
-            <a:off x="822960" y="2724912"/>
-            <a:ext cx="822960" cy="822960"/>
+            <a:off x="822960" y="2606040"/>
+            <a:ext cx="621792" cy="621792"/>
           </a:xfrm>
           <a:prstGeom prst="ellipse">
             <a:avLst/>
@@ -18452,8 +18492,8 @@
         </p:blipFill>
         <p:spPr>
           <a:xfrm>
-            <a:off x="1020470" y="2922422"/>
-            <a:ext cx="427939" cy="427939"/>
+            <a:off x="972190" y="2755270"/>
+            <a:ext cx="323332" cy="323332"/>
           </a:xfrm>
           <a:prstGeom prst="rect">
             <a:avLst/>
@@ -18468,8 +18508,8 @@
         </p:nvSpPr>
         <p:spPr>
           <a:xfrm>
-            <a:off x="2011680" y="2688336"/>
-            <a:ext cx="9326880" cy="384048"/>
+            <a:off x="1691640" y="2560320"/>
+            <a:ext cx="9692640" cy="329184"/>
           </a:xfrm>
           <a:prstGeom prst="rect">
             <a:avLst/>
@@ -18485,7 +18525,7 @@
               <a:buNone/>
             </a:pPr>
             <a:r>
-              <a:rPr lang="en-US" sz="2100" b="1" dirty="0">
+              <a:rPr lang="en-US" sz="1650" b="1" dirty="0">
                 <a:solidFill>
                   <a:srgbClr val="24313A"/>
                 </a:solidFill>
@@ -18495,7 +18535,7 @@
               </a:rPr>
               <a:t>Information &amp; nudges</a:t>
             </a:r>
-            <a:endParaRPr lang="en-US" sz="2100" dirty="0"/>
+            <a:endParaRPr lang="en-US" sz="1650" dirty="0"/>
           </a:p>
         </p:txBody>
       </p:sp>
@@ -18507,8 +18547,8 @@
         </p:nvSpPr>
         <p:spPr>
           <a:xfrm>
-            <a:off x="2011680" y="3072384"/>
-            <a:ext cx="9326880" cy="548640"/>
+            <a:off x="1691640" y="2880360"/>
+            <a:ext cx="9692640" cy="548640"/>
           </a:xfrm>
           <a:prstGeom prst="rect">
             <a:avLst/>
@@ -18524,7 +18564,7 @@
               <a:buNone/>
             </a:pPr>
             <a:r>
-              <a:rPr lang="en-US" sz="1450" dirty="0">
+              <a:rPr lang="en-US" sz="1300" dirty="0">
                 <a:solidFill>
                   <a:srgbClr val="24313A"/>
                 </a:solidFill>
@@ -18534,7 +18574,7 @@
               </a:rPr>
               <a:t>Informing, reminding or prompting the decision to return without changing economic incentives: information sessions, career guidance or peer mentoring, a leaflet with the retirement form, personalised letters, calls or e-mails.</a:t>
             </a:r>
-            <a:endParaRPr lang="en-US" sz="1450" dirty="0"/>
+            <a:endParaRPr lang="en-US" sz="1300" dirty="0"/>
           </a:p>
         </p:txBody>
       </p:sp>
@@ -18546,8 +18586,8 @@
         </p:nvSpPr>
         <p:spPr>
           <a:xfrm>
-            <a:off x="822960" y="3712464"/>
-            <a:ext cx="822960" cy="822960"/>
+            <a:off x="822960" y="3520440"/>
+            <a:ext cx="621792" cy="621792"/>
           </a:xfrm>
           <a:prstGeom prst="ellipse">
             <a:avLst/>
@@ -18579,8 +18619,8 @@
         </p:blipFill>
         <p:spPr>
           <a:xfrm>
-            <a:off x="1020470" y="3909974"/>
-            <a:ext cx="427939" cy="427939"/>
+            <a:off x="972190" y="3669670"/>
+            <a:ext cx="323332" cy="323332"/>
           </a:xfrm>
           <a:prstGeom prst="rect">
             <a:avLst/>
@@ -18595,8 +18635,8 @@
         </p:nvSpPr>
         <p:spPr>
           <a:xfrm>
-            <a:off x="2011680" y="3675888"/>
-            <a:ext cx="9326880" cy="384048"/>
+            <a:off x="1691640" y="3474720"/>
+            <a:ext cx="9692640" cy="329184"/>
           </a:xfrm>
           <a:prstGeom prst="rect">
             <a:avLst/>
@@ -18612,7 +18652,7 @@
               <a:buNone/>
             </a:pPr>
             <a:r>
-              <a:rPr lang="en-US" sz="2100" b="1" dirty="0">
+              <a:rPr lang="en-US" sz="1650" b="1" dirty="0">
                 <a:solidFill>
                   <a:srgbClr val="24313A"/>
                 </a:solidFill>
@@ -18622,7 +18662,7 @@
               </a:rPr>
               <a:t>Support &amp; training</a:t>
             </a:r>
-            <a:endParaRPr lang="en-US" sz="2100" dirty="0"/>
+            <a:endParaRPr lang="en-US" sz="1650" dirty="0"/>
           </a:p>
         </p:txBody>
       </p:sp>
@@ -18634,8 +18674,8 @@
         </p:nvSpPr>
         <p:spPr>
           <a:xfrm>
-            <a:off x="2011680" y="4059936"/>
-            <a:ext cx="9326880" cy="548640"/>
+            <a:off x="1691640" y="3794760"/>
+            <a:ext cx="9692640" cy="548640"/>
           </a:xfrm>
           <a:prstGeom prst="rect">
             <a:avLst/>
@@ -18651,7 +18691,7 @@
               <a:buNone/>
             </a:pPr>
             <a:r>
-              <a:rPr lang="en-US" sz="1450" dirty="0">
+              <a:rPr lang="en-US" sz="1300" dirty="0">
                 <a:solidFill>
                   <a:srgbClr val="24313A"/>
                 </a:solidFill>
@@ -18661,7 +18701,7 @@
               </a:rPr>
               <a:t>Refresher courses, return-to-teaching programmes, induction and coaching that make re-entry easier.</a:t>
             </a:r>
-            <a:endParaRPr lang="en-US" sz="1450" dirty="0"/>
+            <a:endParaRPr lang="en-US" sz="1300" dirty="0"/>
           </a:p>
         </p:txBody>
       </p:sp>
@@ -18673,8 +18713,8 @@
         </p:nvSpPr>
         <p:spPr>
           <a:xfrm>
-            <a:off x="822960" y="4700016"/>
-            <a:ext cx="822960" cy="822960"/>
+            <a:off x="822960" y="4434840"/>
+            <a:ext cx="621792" cy="621792"/>
           </a:xfrm>
           <a:prstGeom prst="ellipse">
             <a:avLst/>
@@ -18706,8 +18746,8 @@
         </p:blipFill>
         <p:spPr>
           <a:xfrm>
-            <a:off x="1020470" y="4897526"/>
-            <a:ext cx="427939" cy="427939"/>
+            <a:off x="972190" y="4584070"/>
+            <a:ext cx="323332" cy="323332"/>
           </a:xfrm>
           <a:prstGeom prst="rect">
             <a:avLst/>
@@ -18722,8 +18762,8 @@
         </p:nvSpPr>
         <p:spPr>
           <a:xfrm>
-            <a:off x="2011680" y="4663440"/>
-            <a:ext cx="9326880" cy="384048"/>
+            <a:off x="1691640" y="4389120"/>
+            <a:ext cx="9692640" cy="329184"/>
           </a:xfrm>
           <a:prstGeom prst="rect">
             <a:avLst/>
@@ -18739,7 +18779,7 @@
               <a:buNone/>
             </a:pPr>
             <a:r>
-              <a:rPr lang="en-US" sz="2100" b="1" dirty="0">
+              <a:rPr lang="en-US" sz="1650" b="1" dirty="0">
                 <a:solidFill>
                   <a:srgbClr val="24313A"/>
                 </a:solidFill>
@@ -18749,7 +18789,7 @@
               </a:rPr>
               <a:t>Flexible positions</a:t>
             </a:r>
-            <a:endParaRPr lang="en-US" sz="2100" dirty="0"/>
+            <a:endParaRPr lang="en-US" sz="1650" dirty="0"/>
           </a:p>
         </p:txBody>
       </p:sp>
@@ -18761,8 +18801,8 @@
         </p:nvSpPr>
         <p:spPr>
           <a:xfrm>
-            <a:off x="2011680" y="5047488"/>
-            <a:ext cx="9326880" cy="548640"/>
+            <a:off x="1691640" y="4709160"/>
+            <a:ext cx="9692640" cy="548640"/>
           </a:xfrm>
           <a:prstGeom prst="rect">
             <a:avLst/>
@@ -18778,7 +18818,7 @@
               <a:buNone/>
             </a:pPr>
             <a:r>
-              <a:rPr lang="en-US" sz="1450" dirty="0">
+              <a:rPr lang="en-US" sz="1300" dirty="0">
                 <a:solidFill>
                   <a:srgbClr val="24313A"/>
                 </a:solidFill>
@@ -18788,7 +18828,7 @@
               </a:rPr>
               <a:t>Roles other than a full-time teaching post: tutoring pupils, mentoring future or novice teachers, part-time or flexible substitute work.</a:t>
             </a:r>
-            <a:endParaRPr lang="en-US" sz="1450" dirty="0"/>
+            <a:endParaRPr lang="en-US" sz="1300" dirty="0"/>
           </a:p>
         </p:txBody>
       </p:sp>
@@ -18800,8 +18840,8 @@
         </p:nvSpPr>
         <p:spPr>
           <a:xfrm>
-            <a:off x="822960" y="5687568"/>
-            <a:ext cx="822960" cy="822960"/>
+            <a:off x="822960" y="5349240"/>
+            <a:ext cx="621792" cy="621792"/>
           </a:xfrm>
           <a:prstGeom prst="ellipse">
             <a:avLst/>
@@ -18833,8 +18873,8 @@
         </p:blipFill>
         <p:spPr>
           <a:xfrm>
-            <a:off x="1020470" y="5885078"/>
-            <a:ext cx="427939" cy="427939"/>
+            <a:off x="972190" y="5498470"/>
+            <a:ext cx="323332" cy="323332"/>
           </a:xfrm>
           <a:prstGeom prst="rect">
             <a:avLst/>
@@ -18849,8 +18889,8 @@
         </p:nvSpPr>
         <p:spPr>
           <a:xfrm>
-            <a:off x="2011680" y="5650992"/>
-            <a:ext cx="9326880" cy="384048"/>
+            <a:off x="1691640" y="5303520"/>
+            <a:ext cx="9692640" cy="329184"/>
           </a:xfrm>
           <a:prstGeom prst="rect">
             <a:avLst/>
@@ -18866,7 +18906,7 @@
               <a:buNone/>
             </a:pPr>
             <a:r>
-              <a:rPr lang="en-US" sz="2100" b="1" dirty="0">
+              <a:rPr lang="en-US" sz="1650" b="1" dirty="0">
                 <a:solidFill>
                   <a:srgbClr val="24313A"/>
                 </a:solidFill>
@@ -18876,7 +18916,7 @@
               </a:rPr>
               <a:t>Flexible re-certification</a:t>
             </a:r>
-            <a:endParaRPr lang="en-US" sz="2100" dirty="0"/>
+            <a:endParaRPr lang="en-US" sz="1650" dirty="0"/>
           </a:p>
         </p:txBody>
       </p:sp>
@@ -18888,8 +18928,8 @@
         </p:nvSpPr>
         <p:spPr>
           <a:xfrm>
-            <a:off x="2011680" y="6035040"/>
-            <a:ext cx="9326880" cy="548640"/>
+            <a:off x="1691640" y="5623560"/>
+            <a:ext cx="9692640" cy="548640"/>
           </a:xfrm>
           <a:prstGeom prst="rect">
             <a:avLst/>
@@ -18905,7 +18945,7 @@
               <a:buNone/>
             </a:pPr>
             <a:r>
-              <a:rPr lang="en-US" sz="1450" dirty="0">
+              <a:rPr lang="en-US" sz="1300" dirty="0">
                 <a:solidFill>
                   <a:srgbClr val="24313A"/>
                 </a:solidFill>
@@ -18915,7 +18955,7 @@
               </a:rPr>
               <a:t>Lowering administrative or training barriers where former teachers must re-certify: fewer compulsory course days, simplified procedures, limited teaching hours while re-certifying.</a:t>
             </a:r>
-            <a:endParaRPr lang="en-US" sz="1450" dirty="0"/>
+            <a:endParaRPr lang="en-US" sz="1300" dirty="0"/>
           </a:p>
         </p:txBody>
       </p:sp>
@@ -19385,7 +19425,7 @@
         <p:spPr>
           <a:xfrm>
             <a:off x="1783080" y="4864608"/>
-            <a:ext cx="9738360" cy="274320"/>
+            <a:ext cx="8183880" cy="274320"/>
           </a:xfrm>
           <a:prstGeom prst="rect">
             <a:avLst/>
@@ -19545,11 +19585,13 @@
         </p:nvSpPr>
         <p:spPr>
           <a:xfrm>
-            <a:off x="9402775" y="6382512"/>
-            <a:ext cx="219456" cy="219456"/>
-          </a:xfrm>
-          <a:prstGeom prst="ellipse">
-            <a:avLst/>
+            <a:off x="10241280" y="4791456"/>
+            <a:ext cx="1280160" cy="365760"/>
+          </a:xfrm>
+          <a:prstGeom prst="roundRect">
+            <a:avLst>
+              <a:gd name="adj" fmla="val 50000"/>
+            </a:avLst>
           </a:prstGeom>
           <a:solidFill>
             <a:srgbClr val="1F4E46"/>
@@ -19570,8 +19612,8 @@
         </p:nvSpPr>
         <p:spPr>
           <a:xfrm>
-            <a:off x="9704527" y="6327648"/>
-            <a:ext cx="1554480" cy="329184"/>
+            <a:off x="10241280" y="4791456"/>
+            <a:ext cx="1280160" cy="365760"/>
           </a:xfrm>
           <a:prstGeom prst="rect">
             <a:avLst/>
@@ -19583,13 +19625,13 @@
           <a:bodyPr wrap="square" lIns="0" tIns="0" rIns="0" bIns="0" rtlCol="0" anchor="ctr"/>
           <a:lstStyle/>
           <a:p>
-            <a:pPr indent="0" marL="0">
-              <a:buNone/>
-            </a:pPr>
-            <a:r>
-              <a:rPr lang="en-US" sz="1400" b="1" dirty="0">
-                <a:solidFill>
-                  <a:srgbClr val="1F4E46"/>
+            <a:pPr algn="ctr" indent="0" marL="0">
+              <a:buNone/>
+            </a:pPr>
+            <a:r>
+              <a:rPr lang="en-US" sz="1250" b="1" dirty="0">
+                <a:solidFill>
+                  <a:srgbClr val="FFFFFF"/>
                 </a:solidFill>
                 <a:latin typeface="Calibri" pitchFamily="34" charset="0"/>
                 <a:ea typeface="Calibri" pitchFamily="34" charset="-122"/>
@@ -19597,7 +19639,7 @@
               </a:rPr>
               <a:t>Large</a:t>
             </a:r>
-            <a:endParaRPr lang="en-US" sz="1400" dirty="0"/>
+            <a:endParaRPr lang="en-US" sz="1250" dirty="0"/>
           </a:p>
         </p:txBody>
       </p:sp>
@@ -20067,7 +20109,7 @@
         <p:spPr>
           <a:xfrm>
             <a:off x="1783080" y="4864608"/>
-            <a:ext cx="9738360" cy="274320"/>
+            <a:ext cx="8183880" cy="274320"/>
           </a:xfrm>
           <a:prstGeom prst="rect">
             <a:avLst/>
@@ -20227,11 +20269,13 @@
         </p:nvSpPr>
         <p:spPr>
           <a:xfrm>
-            <a:off x="9402775" y="6382512"/>
-            <a:ext cx="219456" cy="219456"/>
-          </a:xfrm>
-          <a:prstGeom prst="ellipse">
-            <a:avLst/>
+            <a:off x="10241280" y="4791456"/>
+            <a:ext cx="1280160" cy="365760"/>
+          </a:xfrm>
+          <a:prstGeom prst="roundRect">
+            <a:avLst>
+              <a:gd name="adj" fmla="val 50000"/>
+            </a:avLst>
           </a:prstGeom>
           <a:solidFill>
             <a:srgbClr val="C8892B"/>
@@ -20252,8 +20296,8 @@
         </p:nvSpPr>
         <p:spPr>
           <a:xfrm>
-            <a:off x="9704527" y="6327648"/>
-            <a:ext cx="1554480" cy="329184"/>
+            <a:off x="10241280" y="4791456"/>
+            <a:ext cx="1280160" cy="365760"/>
           </a:xfrm>
           <a:prstGeom prst="rect">
             <a:avLst/>
@@ -20265,13 +20309,13 @@
           <a:bodyPr wrap="square" lIns="0" tIns="0" rIns="0" bIns="0" rtlCol="0" anchor="ctr"/>
           <a:lstStyle/>
           <a:p>
-            <a:pPr indent="0" marL="0">
-              <a:buNone/>
-            </a:pPr>
-            <a:r>
-              <a:rPr lang="en-US" sz="1400" b="1" dirty="0">
-                <a:solidFill>
-                  <a:srgbClr val="C8892B"/>
+            <a:pPr algn="ctr" indent="0" marL="0">
+              <a:buNone/>
+            </a:pPr>
+            <a:r>
+              <a:rPr lang="en-US" sz="1250" b="1" dirty="0">
+                <a:solidFill>
+                  <a:srgbClr val="FFFFFF"/>
                 </a:solidFill>
                 <a:latin typeface="Calibri" pitchFamily="34" charset="0"/>
                 <a:ea typeface="Calibri" pitchFamily="34" charset="-122"/>
@@ -20279,7 +20323,7 @@
               </a:rPr>
               <a:t>Medium</a:t>
             </a:r>
-            <a:endParaRPr lang="en-US" sz="1400" dirty="0"/>
+            <a:endParaRPr lang="en-US" sz="1250" dirty="0"/>
           </a:p>
         </p:txBody>
       </p:sp>
@@ -20749,7 +20793,7 @@
         <p:spPr>
           <a:xfrm>
             <a:off x="1783080" y="4864608"/>
-            <a:ext cx="9738360" cy="274320"/>
+            <a:ext cx="8183880" cy="274320"/>
           </a:xfrm>
           <a:prstGeom prst="rect">
             <a:avLst/>
@@ -20909,11 +20953,13 @@
         </p:nvSpPr>
         <p:spPr>
           <a:xfrm>
-            <a:off x="9402775" y="6382512"/>
-            <a:ext cx="219456" cy="219456"/>
-          </a:xfrm>
-          <a:prstGeom prst="ellipse">
-            <a:avLst/>
+            <a:off x="10241280" y="4791456"/>
+            <a:ext cx="1280160" cy="365760"/>
+          </a:xfrm>
+          <a:prstGeom prst="roundRect">
+            <a:avLst>
+              <a:gd name="adj" fmla="val 50000"/>
+            </a:avLst>
           </a:prstGeom>
           <a:solidFill>
             <a:srgbClr val="C8892B"/>
@@ -20934,8 +20980,8 @@
         </p:nvSpPr>
         <p:spPr>
           <a:xfrm>
-            <a:off x="9704527" y="6327648"/>
-            <a:ext cx="1554480" cy="329184"/>
+            <a:off x="10241280" y="4791456"/>
+            <a:ext cx="1280160" cy="365760"/>
           </a:xfrm>
           <a:prstGeom prst="rect">
             <a:avLst/>
@@ -20947,13 +20993,13 @@
           <a:bodyPr wrap="square" lIns="0" tIns="0" rIns="0" bIns="0" rtlCol="0" anchor="ctr"/>
           <a:lstStyle/>
           <a:p>
-            <a:pPr indent="0" marL="0">
-              <a:buNone/>
-            </a:pPr>
-            <a:r>
-              <a:rPr lang="en-US" sz="1400" b="1" dirty="0">
-                <a:solidFill>
-                  <a:srgbClr val="C8892B"/>
+            <a:pPr algn="ctr" indent="0" marL="0">
+              <a:buNone/>
+            </a:pPr>
+            <a:r>
+              <a:rPr lang="en-US" sz="1250" b="1" dirty="0">
+                <a:solidFill>
+                  <a:srgbClr val="FFFFFF"/>
                 </a:solidFill>
                 <a:latin typeface="Calibri" pitchFamily="34" charset="0"/>
                 <a:ea typeface="Calibri" pitchFamily="34" charset="-122"/>
@@ -20961,7 +21007,7 @@
               </a:rPr>
               <a:t>Medium</a:t>
             </a:r>
-            <a:endParaRPr lang="en-US" sz="1400" dirty="0"/>
+            <a:endParaRPr lang="en-US" sz="1250" dirty="0"/>
           </a:p>
         </p:txBody>
       </p:sp>
@@ -21431,7 +21477,7 @@
         <p:spPr>
           <a:xfrm>
             <a:off x="1783080" y="4864608"/>
-            <a:ext cx="9738360" cy="274320"/>
+            <a:ext cx="8183880" cy="274320"/>
           </a:xfrm>
           <a:prstGeom prst="rect">
             <a:avLst/>
@@ -21591,11 +21637,13 @@
         </p:nvSpPr>
         <p:spPr>
           <a:xfrm>
-            <a:off x="9402775" y="6382512"/>
-            <a:ext cx="219456" cy="219456"/>
-          </a:xfrm>
-          <a:prstGeom prst="ellipse">
-            <a:avLst/>
+            <a:off x="10241280" y="4791456"/>
+            <a:ext cx="1280160" cy="365760"/>
+          </a:xfrm>
+          <a:prstGeom prst="roundRect">
+            <a:avLst>
+              <a:gd name="adj" fmla="val 50000"/>
+            </a:avLst>
           </a:prstGeom>
           <a:solidFill>
             <a:srgbClr val="C8892B"/>
@@ -21616,8 +21664,8 @@
         </p:nvSpPr>
         <p:spPr>
           <a:xfrm>
-            <a:off x="9704527" y="6327648"/>
-            <a:ext cx="1554480" cy="329184"/>
+            <a:off x="10241280" y="4791456"/>
+            <a:ext cx="1280160" cy="365760"/>
           </a:xfrm>
           <a:prstGeom prst="rect">
             <a:avLst/>
@@ -21629,13 +21677,13 @@
           <a:bodyPr wrap="square" lIns="0" tIns="0" rIns="0" bIns="0" rtlCol="0" anchor="ctr"/>
           <a:lstStyle/>
           <a:p>
-            <a:pPr indent="0" marL="0">
-              <a:buNone/>
-            </a:pPr>
-            <a:r>
-              <a:rPr lang="en-US" sz="1400" b="1" dirty="0">
-                <a:solidFill>
-                  <a:srgbClr val="C8892B"/>
+            <a:pPr algn="ctr" indent="0" marL="0">
+              <a:buNone/>
+            </a:pPr>
+            <a:r>
+              <a:rPr lang="en-US" sz="1250" b="1" dirty="0">
+                <a:solidFill>
+                  <a:srgbClr val="FFFFFF"/>
                 </a:solidFill>
                 <a:latin typeface="Calibri" pitchFamily="34" charset="0"/>
                 <a:ea typeface="Calibri" pitchFamily="34" charset="-122"/>
@@ -21643,7 +21691,7 @@
               </a:rPr>
               <a:t>Medium</a:t>
             </a:r>
-            <a:endParaRPr lang="en-US" sz="1400" dirty="0"/>
+            <a:endParaRPr lang="en-US" sz="1250" dirty="0"/>
           </a:p>
         </p:txBody>
       </p:sp>
@@ -28171,7 +28219,7 @@
                           <a:ea typeface="Calibri" pitchFamily="34" charset="-122"/>
                           <a:cs typeface="Calibri" pitchFamily="34" charset="-120"/>
                         </a:rPr>
-                        <a:t>Skolverket web-based training for returning teachers and preschool teachers (since 2018)</a:t>
+                        <a:t>Online refresher course for returning teachers (National Agency for Education, since 2018)</a:t>
                       </a:r>
                       <a:endParaRPr lang="en-US" sz="950" dirty="0">
                         <a:latin typeface="Calibri" charset="0"/>
@@ -32614,8 +32662,8 @@
         </p:nvSpPr>
         <p:spPr>
           <a:xfrm>
-            <a:off x="685800" y="640080"/>
-            <a:ext cx="10789920" cy="731520"/>
+            <a:off x="640080" y="548640"/>
+            <a:ext cx="10789920" cy="640080"/>
           </a:xfrm>
           <a:prstGeom prst="rect">
             <a:avLst/>
@@ -32631,7 +32679,7 @@
               <a:buNone/>
             </a:pPr>
             <a:r>
-              <a:rPr lang="en-US" sz="3600" b="1" dirty="0">
+              <a:rPr lang="en-US" sz="3000" b="1" dirty="0">
                 <a:solidFill>
                   <a:srgbClr val="24313A"/>
                 </a:solidFill>
@@ -32641,7 +32689,7 @@
               </a:rPr>
               <a:t>Scale</a:t>
             </a:r>
-            <a:endParaRPr lang="en-US" sz="3600" dirty="0"/>
+            <a:endParaRPr lang="en-US" sz="3000" dirty="0"/>
           </a:p>
         </p:txBody>
       </p:sp>
@@ -32653,8 +32701,8 @@
         </p:nvSpPr>
         <p:spPr>
           <a:xfrm>
-            <a:off x="713232" y="1325880"/>
-            <a:ext cx="10789920" cy="365760"/>
+            <a:off x="667512" y="1161288"/>
+            <a:ext cx="10789920" cy="320040"/>
           </a:xfrm>
           <a:prstGeom prst="rect">
             <a:avLst/>
@@ -32670,7 +32718,7 @@
               <a:buNone/>
             </a:pPr>
             <a:r>
-              <a:rPr lang="en-US" sz="1600" dirty="0">
+              <a:rPr lang="en-US" sz="1400" dirty="0">
                 <a:solidFill>
                   <a:srgbClr val="B3542E"/>
                 </a:solidFill>
@@ -32678,9 +32726,9 @@
                 <a:ea typeface="Calibri" pitchFamily="34" charset="-122"/>
                 <a:cs typeface="Calibri" pitchFamily="34" charset="-120"/>
               </a:rPr>
-              <a:t>Every policy slide carries one of these labels in the bottom-right corner</a:t>
-            </a:r>
-            <a:endParaRPr lang="en-US" sz="1600" dirty="0"/>
+              <a:t>Every policy slide carries one of these labels at the bottom right of its card</a:t>
+            </a:r>
+            <a:endParaRPr lang="en-US" sz="1400" dirty="0"/>
           </a:p>
         </p:txBody>
       </p:sp>
@@ -32692,8 +32740,8 @@
         </p:nvSpPr>
         <p:spPr>
           <a:xfrm>
-            <a:off x="914400" y="2542032"/>
-            <a:ext cx="384048" cy="384048"/>
+            <a:off x="868680" y="2231136"/>
+            <a:ext cx="256032" cy="256032"/>
           </a:xfrm>
           <a:prstGeom prst="ellipse">
             <a:avLst/>
@@ -32717,8 +32765,8 @@
         </p:nvSpPr>
         <p:spPr>
           <a:xfrm>
-            <a:off x="1600200" y="2468880"/>
-            <a:ext cx="2377440" cy="530352"/>
+            <a:off x="1325880" y="2148840"/>
+            <a:ext cx="2011680" cy="420624"/>
           </a:xfrm>
           <a:prstGeom prst="rect">
             <a:avLst/>
@@ -32734,7 +32782,7 @@
               <a:buNone/>
             </a:pPr>
             <a:r>
-              <a:rPr lang="en-US" sz="3000" b="1" dirty="0">
+              <a:rPr lang="en-US" sz="2000" b="1" dirty="0">
                 <a:solidFill>
                   <a:srgbClr val="1F4E46"/>
                 </a:solidFill>
@@ -32744,7 +32792,7 @@
               </a:rPr>
               <a:t>Large</a:t>
             </a:r>
-            <a:endParaRPr lang="en-US" sz="3000" dirty="0"/>
+            <a:endParaRPr lang="en-US" sz="2000" dirty="0"/>
           </a:p>
         </p:txBody>
       </p:sp>
@@ -32756,8 +32804,8 @@
         </p:nvSpPr>
         <p:spPr>
           <a:xfrm>
-            <a:off x="4023360" y="2468880"/>
-            <a:ext cx="7498080" cy="530352"/>
+            <a:off x="3291840" y="2148840"/>
+            <a:ext cx="8229600" cy="420624"/>
           </a:xfrm>
           <a:prstGeom prst="rect">
             <a:avLst/>
@@ -32773,7 +32821,7 @@
               <a:buNone/>
             </a:pPr>
             <a:r>
-              <a:rPr lang="en-US" sz="1900" dirty="0">
+              <a:rPr lang="en-US" sz="1500" dirty="0">
                 <a:solidFill>
                   <a:srgbClr val="24313A"/>
                 </a:solidFill>
@@ -32783,7 +32831,7 @@
               </a:rPr>
               <a:t>National policy</a:t>
             </a:r>
-            <a:endParaRPr lang="en-US" sz="1900" dirty="0"/>
+            <a:endParaRPr lang="en-US" sz="1500" dirty="0"/>
           </a:p>
         </p:txBody>
       </p:sp>
@@ -32795,8 +32843,8 @@
         </p:nvSpPr>
         <p:spPr>
           <a:xfrm>
-            <a:off x="914400" y="3593592"/>
-            <a:ext cx="384048" cy="384048"/>
+            <a:off x="868680" y="3099816"/>
+            <a:ext cx="256032" cy="256032"/>
           </a:xfrm>
           <a:prstGeom prst="ellipse">
             <a:avLst/>
@@ -32820,8 +32868,8 @@
         </p:nvSpPr>
         <p:spPr>
           <a:xfrm>
-            <a:off x="1600200" y="3520440"/>
-            <a:ext cx="2377440" cy="530352"/>
+            <a:off x="1325880" y="3017520"/>
+            <a:ext cx="2011680" cy="420624"/>
           </a:xfrm>
           <a:prstGeom prst="rect">
             <a:avLst/>
@@ -32837,7 +32885,7 @@
               <a:buNone/>
             </a:pPr>
             <a:r>
-              <a:rPr lang="en-US" sz="3000" b="1" dirty="0">
+              <a:rPr lang="en-US" sz="2000" b="1" dirty="0">
                 <a:solidFill>
                   <a:srgbClr val="C8892B"/>
                 </a:solidFill>
@@ -32847,7 +32895,7 @@
               </a:rPr>
               <a:t>Medium</a:t>
             </a:r>
-            <a:endParaRPr lang="en-US" sz="3000" dirty="0"/>
+            <a:endParaRPr lang="en-US" sz="2000" dirty="0"/>
           </a:p>
         </p:txBody>
       </p:sp>
@@ -32859,8 +32907,8 @@
         </p:nvSpPr>
         <p:spPr>
           <a:xfrm>
-            <a:off x="4023360" y="3520440"/>
-            <a:ext cx="7498080" cy="530352"/>
+            <a:off x="3291840" y="3017520"/>
+            <a:ext cx="8229600" cy="420624"/>
           </a:xfrm>
           <a:prstGeom prst="rect">
             <a:avLst/>
@@ -32876,7 +32924,7 @@
               <a:buNone/>
             </a:pPr>
             <a:r>
-              <a:rPr lang="en-US" sz="1900" dirty="0">
+              <a:rPr lang="en-US" sz="1500" dirty="0">
                 <a:solidFill>
                   <a:srgbClr val="24313A"/>
                 </a:solidFill>
@@ -32886,7 +32934,7 @@
               </a:rPr>
               <a:t>State, region, province or canton</a:t>
             </a:r>
-            <a:endParaRPr lang="en-US" sz="1900" dirty="0"/>
+            <a:endParaRPr lang="en-US" sz="1500" dirty="0"/>
           </a:p>
         </p:txBody>
       </p:sp>
@@ -32898,8 +32946,8 @@
         </p:nvSpPr>
         <p:spPr>
           <a:xfrm>
-            <a:off x="914400" y="4645152"/>
-            <a:ext cx="384048" cy="384048"/>
+            <a:off x="868680" y="3968496"/>
+            <a:ext cx="256032" cy="256032"/>
           </a:xfrm>
           <a:prstGeom prst="ellipse">
             <a:avLst/>
@@ -32923,8 +32971,8 @@
         </p:nvSpPr>
         <p:spPr>
           <a:xfrm>
-            <a:off x="1600200" y="4572000"/>
-            <a:ext cx="2377440" cy="530352"/>
+            <a:off x="1325880" y="3886200"/>
+            <a:ext cx="2011680" cy="420624"/>
           </a:xfrm>
           <a:prstGeom prst="rect">
             <a:avLst/>
@@ -32940,7 +32988,7 @@
               <a:buNone/>
             </a:pPr>
             <a:r>
-              <a:rPr lang="en-US" sz="3000" b="1" dirty="0">
+              <a:rPr lang="en-US" sz="2000" b="1" dirty="0">
                 <a:solidFill>
                   <a:srgbClr val="B3542E"/>
                 </a:solidFill>
@@ -32950,7 +32998,7 @@
               </a:rPr>
               <a:t>Small</a:t>
             </a:r>
-            <a:endParaRPr lang="en-US" sz="3000" dirty="0"/>
+            <a:endParaRPr lang="en-US" sz="2000" dirty="0"/>
           </a:p>
         </p:txBody>
       </p:sp>
@@ -32962,8 +33010,8 @@
         </p:nvSpPr>
         <p:spPr>
           <a:xfrm>
-            <a:off x="4023360" y="4572000"/>
-            <a:ext cx="7498080" cy="530352"/>
+            <a:off x="3291840" y="3886200"/>
+            <a:ext cx="8229600" cy="420624"/>
           </a:xfrm>
           <a:prstGeom prst="rect">
             <a:avLst/>
@@ -32979,7 +33027,7 @@
               <a:buNone/>
             </a:pPr>
             <a:r>
-              <a:rPr lang="en-US" sz="1900" dirty="0">
+              <a:rPr lang="en-US" sz="1500" dirty="0">
                 <a:solidFill>
                   <a:srgbClr val="24313A"/>
                 </a:solidFill>
@@ -32989,7 +33037,7 @@
               </a:rPr>
               <a:t>District, city or a single institution</a:t>
             </a:r>
-            <a:endParaRPr lang="en-US" sz="1900" dirty="0"/>
+            <a:endParaRPr lang="en-US" sz="1500" dirty="0"/>
           </a:p>
         </p:txBody>
       </p:sp>
@@ -33459,7 +33507,7 @@
         <p:spPr>
           <a:xfrm>
             <a:off x="1783080" y="4864608"/>
-            <a:ext cx="9738360" cy="274320"/>
+            <a:ext cx="8183880" cy="274320"/>
           </a:xfrm>
           <a:prstGeom prst="rect">
             <a:avLst/>
@@ -33619,11 +33667,13 @@
         </p:nvSpPr>
         <p:spPr>
           <a:xfrm>
-            <a:off x="9402775" y="6382512"/>
-            <a:ext cx="219456" cy="219456"/>
-          </a:xfrm>
-          <a:prstGeom prst="ellipse">
-            <a:avLst/>
+            <a:off x="10241280" y="4791456"/>
+            <a:ext cx="1280160" cy="365760"/>
+          </a:xfrm>
+          <a:prstGeom prst="roundRect">
+            <a:avLst>
+              <a:gd name="adj" fmla="val 50000"/>
+            </a:avLst>
           </a:prstGeom>
           <a:solidFill>
             <a:srgbClr val="C8892B"/>
@@ -33644,8 +33694,8 @@
         </p:nvSpPr>
         <p:spPr>
           <a:xfrm>
-            <a:off x="9704527" y="6327648"/>
-            <a:ext cx="1554480" cy="329184"/>
+            <a:off x="10241280" y="4791456"/>
+            <a:ext cx="1280160" cy="365760"/>
           </a:xfrm>
           <a:prstGeom prst="rect">
             <a:avLst/>
@@ -33657,13 +33707,13 @@
           <a:bodyPr wrap="square" lIns="0" tIns="0" rIns="0" bIns="0" rtlCol="0" anchor="ctr"/>
           <a:lstStyle/>
           <a:p>
-            <a:pPr indent="0" marL="0">
-              <a:buNone/>
-            </a:pPr>
-            <a:r>
-              <a:rPr lang="en-US" sz="1400" b="1" dirty="0">
-                <a:solidFill>
-                  <a:srgbClr val="C8892B"/>
+            <a:pPr algn="ctr" indent="0" marL="0">
+              <a:buNone/>
+            </a:pPr>
+            <a:r>
+              <a:rPr lang="en-US" sz="1250" b="1" dirty="0">
+                <a:solidFill>
+                  <a:srgbClr val="FFFFFF"/>
                 </a:solidFill>
                 <a:latin typeface="Calibri" pitchFamily="34" charset="0"/>
                 <a:ea typeface="Calibri" pitchFamily="34" charset="-122"/>
@@ -33671,7 +33721,7 @@
               </a:rPr>
               <a:t>Medium</a:t>
             </a:r>
-            <a:endParaRPr lang="en-US" sz="1400" dirty="0"/>
+            <a:endParaRPr lang="en-US" sz="1250" dirty="0"/>
           </a:p>
         </p:txBody>
       </p:sp>
@@ -34141,7 +34191,7 @@
         <p:spPr>
           <a:xfrm>
             <a:off x="1783080" y="4864608"/>
-            <a:ext cx="9738360" cy="274320"/>
+            <a:ext cx="8183880" cy="274320"/>
           </a:xfrm>
           <a:prstGeom prst="rect">
             <a:avLst/>
@@ -34258,11 +34308,13 @@
         </p:nvSpPr>
         <p:spPr>
           <a:xfrm>
-            <a:off x="9402775" y="6382512"/>
-            <a:ext cx="219456" cy="219456"/>
-          </a:xfrm>
-          <a:prstGeom prst="ellipse">
-            <a:avLst/>
+            <a:off x="10241280" y="4791456"/>
+            <a:ext cx="1280160" cy="365760"/>
+          </a:xfrm>
+          <a:prstGeom prst="roundRect">
+            <a:avLst>
+              <a:gd name="adj" fmla="val 50000"/>
+            </a:avLst>
           </a:prstGeom>
           <a:solidFill>
             <a:srgbClr val="C8892B"/>
@@ -34283,8 +34335,8 @@
         </p:nvSpPr>
         <p:spPr>
           <a:xfrm>
-            <a:off x="9704527" y="6327648"/>
-            <a:ext cx="1554480" cy="329184"/>
+            <a:off x="10241280" y="4791456"/>
+            <a:ext cx="1280160" cy="365760"/>
           </a:xfrm>
           <a:prstGeom prst="rect">
             <a:avLst/>
@@ -34296,13 +34348,13 @@
           <a:bodyPr wrap="square" lIns="0" tIns="0" rIns="0" bIns="0" rtlCol="0" anchor="ctr"/>
           <a:lstStyle/>
           <a:p>
-            <a:pPr indent="0" marL="0">
-              <a:buNone/>
-            </a:pPr>
-            <a:r>
-              <a:rPr lang="en-US" sz="1400" b="1" dirty="0">
-                <a:solidFill>
-                  <a:srgbClr val="C8892B"/>
+            <a:pPr algn="ctr" indent="0" marL="0">
+              <a:buNone/>
+            </a:pPr>
+            <a:r>
+              <a:rPr lang="en-US" sz="1250" b="1" dirty="0">
+                <a:solidFill>
+                  <a:srgbClr val="FFFFFF"/>
                 </a:solidFill>
                 <a:latin typeface="Calibri" pitchFamily="34" charset="0"/>
                 <a:ea typeface="Calibri" pitchFamily="34" charset="-122"/>
@@ -34310,7 +34362,7 @@
               </a:rPr>
               <a:t>Medium</a:t>
             </a:r>
-            <a:endParaRPr lang="en-US" sz="1400" dirty="0"/>
+            <a:endParaRPr lang="en-US" sz="1250" dirty="0"/>
           </a:p>
         </p:txBody>
       </p:sp>
@@ -34741,7 +34793,7 @@
         <p:spPr>
           <a:xfrm>
             <a:off x="1783080" y="4864608"/>
-            <a:ext cx="9738360" cy="274320"/>
+            <a:ext cx="8183880" cy="274320"/>
           </a:xfrm>
           <a:prstGeom prst="rect">
             <a:avLst/>
@@ -34901,11 +34953,13 @@
         </p:nvSpPr>
         <p:spPr>
           <a:xfrm>
-            <a:off x="9402775" y="6382512"/>
-            <a:ext cx="219456" cy="219456"/>
-          </a:xfrm>
-          <a:prstGeom prst="ellipse">
-            <a:avLst/>
+            <a:off x="10241280" y="4791456"/>
+            <a:ext cx="1280160" cy="365760"/>
+          </a:xfrm>
+          <a:prstGeom prst="roundRect">
+            <a:avLst>
+              <a:gd name="adj" fmla="val 50000"/>
+            </a:avLst>
           </a:prstGeom>
           <a:solidFill>
             <a:srgbClr val="C8892B"/>
@@ -34926,8 +34980,8 @@
         </p:nvSpPr>
         <p:spPr>
           <a:xfrm>
-            <a:off x="9704527" y="6327648"/>
-            <a:ext cx="1554480" cy="329184"/>
+            <a:off x="10241280" y="4791456"/>
+            <a:ext cx="1280160" cy="365760"/>
           </a:xfrm>
           <a:prstGeom prst="rect">
             <a:avLst/>
@@ -34939,13 +34993,13 @@
           <a:bodyPr wrap="square" lIns="0" tIns="0" rIns="0" bIns="0" rtlCol="0" anchor="ctr"/>
           <a:lstStyle/>
           <a:p>
-            <a:pPr indent="0" marL="0">
-              <a:buNone/>
-            </a:pPr>
-            <a:r>
-              <a:rPr lang="en-US" sz="1400" b="1" dirty="0">
-                <a:solidFill>
-                  <a:srgbClr val="C8892B"/>
+            <a:pPr algn="ctr" indent="0" marL="0">
+              <a:buNone/>
+            </a:pPr>
+            <a:r>
+              <a:rPr lang="en-US" sz="1250" b="1" dirty="0">
+                <a:solidFill>
+                  <a:srgbClr val="FFFFFF"/>
                 </a:solidFill>
                 <a:latin typeface="Calibri" pitchFamily="34" charset="0"/>
                 <a:ea typeface="Calibri" pitchFamily="34" charset="-122"/>
@@ -34953,7 +35007,7 @@
               </a:rPr>
               <a:t>Medium</a:t>
             </a:r>
-            <a:endParaRPr lang="en-US" sz="1400" dirty="0"/>
+            <a:endParaRPr lang="en-US" sz="1250" dirty="0"/>
           </a:p>
         </p:txBody>
       </p:sp>
@@ -35384,7 +35438,7 @@
         <p:spPr>
           <a:xfrm>
             <a:off x="1783080" y="4864608"/>
-            <a:ext cx="9738360" cy="274320"/>
+            <a:ext cx="8183880" cy="274320"/>
           </a:xfrm>
           <a:prstGeom prst="rect">
             <a:avLst/>
@@ -35544,11 +35598,13 @@
         </p:nvSpPr>
         <p:spPr>
           <a:xfrm>
-            <a:off x="9402775" y="6382512"/>
-            <a:ext cx="219456" cy="219456"/>
-          </a:xfrm>
-          <a:prstGeom prst="ellipse">
-            <a:avLst/>
+            <a:off x="10241280" y="4791456"/>
+            <a:ext cx="1280160" cy="365760"/>
+          </a:xfrm>
+          <a:prstGeom prst="roundRect">
+            <a:avLst>
+              <a:gd name="adj" fmla="val 50000"/>
+            </a:avLst>
           </a:prstGeom>
           <a:solidFill>
             <a:srgbClr val="1F4E46"/>
@@ -35569,8 +35625,8 @@
         </p:nvSpPr>
         <p:spPr>
           <a:xfrm>
-            <a:off x="9704527" y="6327648"/>
-            <a:ext cx="1554480" cy="329184"/>
+            <a:off x="10241280" y="4791456"/>
+            <a:ext cx="1280160" cy="365760"/>
           </a:xfrm>
           <a:prstGeom prst="rect">
             <a:avLst/>
@@ -35582,13 +35638,13 @@
           <a:bodyPr wrap="square" lIns="0" tIns="0" rIns="0" bIns="0" rtlCol="0" anchor="ctr"/>
           <a:lstStyle/>
           <a:p>
-            <a:pPr indent="0" marL="0">
-              <a:buNone/>
-            </a:pPr>
-            <a:r>
-              <a:rPr lang="en-US" sz="1400" b="1" dirty="0">
-                <a:solidFill>
-                  <a:srgbClr val="1F4E46"/>
+            <a:pPr algn="ctr" indent="0" marL="0">
+              <a:buNone/>
+            </a:pPr>
+            <a:r>
+              <a:rPr lang="en-US" sz="1250" b="1" dirty="0">
+                <a:solidFill>
+                  <a:srgbClr val="FFFFFF"/>
                 </a:solidFill>
                 <a:latin typeface="Calibri" pitchFamily="34" charset="0"/>
                 <a:ea typeface="Calibri" pitchFamily="34" charset="-122"/>
@@ -35596,7 +35652,7 @@
               </a:rPr>
               <a:t>Large</a:t>
             </a:r>
-            <a:endParaRPr lang="en-US" sz="1400" dirty="0"/>
+            <a:endParaRPr lang="en-US" sz="1250" dirty="0"/>
           </a:p>
         </p:txBody>
       </p:sp>
@@ -36066,7 +36122,7 @@
         <p:spPr>
           <a:xfrm>
             <a:off x="1783080" y="4864608"/>
-            <a:ext cx="9738360" cy="274320"/>
+            <a:ext cx="8183880" cy="274320"/>
           </a:xfrm>
           <a:prstGeom prst="rect">
             <a:avLst/>
@@ -36226,11 +36282,13 @@
         </p:nvSpPr>
         <p:spPr>
           <a:xfrm>
-            <a:off x="9402775" y="6382512"/>
-            <a:ext cx="219456" cy="219456"/>
-          </a:xfrm>
-          <a:prstGeom prst="ellipse">
-            <a:avLst/>
+            <a:off x="10241280" y="4791456"/>
+            <a:ext cx="1280160" cy="365760"/>
+          </a:xfrm>
+          <a:prstGeom prst="roundRect">
+            <a:avLst>
+              <a:gd name="adj" fmla="val 50000"/>
+            </a:avLst>
           </a:prstGeom>
           <a:solidFill>
             <a:srgbClr val="C8892B"/>
@@ -36251,8 +36309,8 @@
         </p:nvSpPr>
         <p:spPr>
           <a:xfrm>
-            <a:off x="9704527" y="6327648"/>
-            <a:ext cx="1554480" cy="329184"/>
+            <a:off x="10241280" y="4791456"/>
+            <a:ext cx="1280160" cy="365760"/>
           </a:xfrm>
           <a:prstGeom prst="rect">
             <a:avLst/>
@@ -36264,13 +36322,13 @@
           <a:bodyPr wrap="square" lIns="0" tIns="0" rIns="0" bIns="0" rtlCol="0" anchor="ctr"/>
           <a:lstStyle/>
           <a:p>
-            <a:pPr indent="0" marL="0">
-              <a:buNone/>
-            </a:pPr>
-            <a:r>
-              <a:rPr lang="en-US" sz="1400" b="1" dirty="0">
-                <a:solidFill>
-                  <a:srgbClr val="C8892B"/>
+            <a:pPr algn="ctr" indent="0" marL="0">
+              <a:buNone/>
+            </a:pPr>
+            <a:r>
+              <a:rPr lang="en-US" sz="1250" b="1" dirty="0">
+                <a:solidFill>
+                  <a:srgbClr val="FFFFFF"/>
                 </a:solidFill>
                 <a:latin typeface="Calibri" pitchFamily="34" charset="0"/>
                 <a:ea typeface="Calibri" pitchFamily="34" charset="-122"/>
@@ -36278,7 +36336,7 @@
               </a:rPr>
               <a:t>Medium</a:t>
             </a:r>
-            <a:endParaRPr lang="en-US" sz="1400" dirty="0"/>
+            <a:endParaRPr lang="en-US" sz="1250" dirty="0"/>
           </a:p>
         </p:txBody>
       </p:sp>

</xml_diff>

<commit_message>
Austria: name the authority and the channel, attribute both take-up figures, add the two press sources
Co-Authored-By: Claude Opus 5 <noreply@anthropic.com>
Claude-Session: https://claude.ai/code/session_01REVwghctKjYh8VQ919ThdA
</commit_message>
<xml_diff>
--- a/policies/Re-attracting_Former_Teachers.pptx
+++ b/policies/Re-attracting_Former_Teachers.pptx
@@ -3405,7 +3405,13 @@
             <a:r>
               <a:rPr lang="en-US" dirty="0"/>
               <a:t>Austria — Information &amp; nudges — Target: Retired.
-Sources: ORF national report 'Lehrkräftemangel: Pensionisten umworben' and ORF Vienna 'Pensionisten kehren kaum in Job zurück' (300 letters in December 2022, three positive replies; principals instructed in February 2023), Wiener Zeitung ('Nur 42 Pflichtschullehrer kamen aus Pension zurück'), and the 2025 European Journal of Teacher Education article on retired teachers as a reserve. Press-based; no official statistics.
+Austria — Information &amp; nudges — Target: Retired.
+Who runs it: the Bildungsdirektionen, the education directorates that administer schools in each province; the Vienna directorate ran the letter campaign.
+Channel: letters, sent in December 2022 to about 300 retired teachers, extended to all retired teachers up to age 67 (ORF Vienna).
+Response: ORF Vienna reports that three accepted. From February 2023 the directorate instructed school principals to hold the conversation in person with staff approaching retirement age, about staying on rather than returning.
+Take-up: Wiener Zeitung reports 42 teachers returning from retirement across Austria's compulsory schools in 2022/23, against a workforce of more than 70,000.
+Barriers: 2025 article in the European Journal of Teacher Education on pension and service-crediting rules.
+Both take-up figures come from press reporting of directorate statements, not from published statistics; ORF national coverage at https://oesterreich.orf.at/stories/3198263/ and the Vorarlberg post at https://vorarlberg.orf.at/stories/3198241/.
 Euro amounts in brackets are approximate conversions, rounded, for orientation only.</a:t>
             </a:r>
             <a:endParaRPr lang="en-US" dirty="0"/>
@@ -34739,7 +34745,7 @@
                 <a:ea typeface="Calibri" pitchFamily="34" charset="-122"/>
                 <a:cs typeface="Calibri" pitchFamily="34" charset="-120"/>
               </a:rPr>
-              <a:t>Austria's regional education directorates write to teachers who have recently retired, and have school principals raise the question in person with staff approaching retirement age, offering them a return with reduced teaching hours. Vienna sent the letters first and almost nobody answered, so from February 2023 the directorate asked every principal to hold the conversation face to face instead; Vorarlberg created a post to promote the option. A teacher who comes back keeps the full pension and signs a separate contract paid on the beginner's salary scale, which the directorates themselves name as part of the problem. Take-up has stayed at a few dozen teachers nationwide, and a 2025 academic study points to pension and service-crediting rules as the main barrier.</a:t>
+              <a:t>Austria's regional education directorates, the authorities that administer schools in each province, wrote to teachers who had already retired and asked them to come back to the classroom. The Vienna directorate posted letters in December 2022 to some 300 retired teachers, and extended the offer to every retired teacher up to the age of 67; according to ORF, three accepted. From February 2023 the directorate passed the task to school principals, who were asked to put the question in person, this time to staff approaching retirement age, usually proposing that they stay on with reduced hours; Vorarlberg created a post to promote the option. A returning teacher keeps the full pension and signs a separate contract paid on the beginner's salary scale. The Wiener Zeitung reported 42 returns from retirement across Austria's compulsory schools in 2022/23, out of more than 70,000 teachers, and a 2025 study in the European Journal of Teacher Education points to pension and service-crediting rules as the main barrier.</a:t>
             </a:r>
             <a:endParaRPr lang="en-US" sz="1500" dirty="0"/>
           </a:p>
@@ -34849,7 +34855,7 @@
                 <a:latin typeface="Calibri" pitchFamily="34" charset="0"/>
                 <a:ea typeface="Calibri" pitchFamily="34" charset="-122"/>
                 <a:cs typeface="Calibri" pitchFamily="34" charset="-120"/>
-                <a:hlinkClick r:id="rId3" invalidUrl="" action="" tgtFrame="" tooltip="https://oesterreich.orf.at/stories/3198263/" history="1" highlightClick="0" endSnd="0">
+                <a:hlinkClick r:id="rId3" invalidUrl="" action="" tgtFrame="" tooltip="https://wien.orf.at/stories/3200562/" history="1" highlightClick="0" endSnd="0">
                   <a:extLst>
                     <a:ext uri="{A12FA001-AC4F-418D-AE19-62706E023703}">
                       <ahyp:hlinkClr xmlns:ahyp="http://schemas.microsoft.com/office/drawing/2018/hyperlinkcolor" val="tx"/>
@@ -34857,7 +34863,7 @@
                   </a:extLst>
                 </a:hlinkClick>
               </a:rPr>
-              <a:t>https://oesterreich.orf.at/stories/3198263/</a:t>
+              <a:t>https://wien.orf.at/stories/3200562/</a:t>
             </a:r>
             <a:endParaRPr lang="en-US" sz="1000" dirty="0"/>
           </a:p>
@@ -34892,7 +34898,50 @@
                 <a:latin typeface="Calibri" pitchFamily="34" charset="0"/>
                 <a:ea typeface="Calibri" pitchFamily="34" charset="-122"/>
                 <a:cs typeface="Calibri" pitchFamily="34" charset="-120"/>
-                <a:hlinkClick r:id="rId4" invalidUrl="" action="" tgtFrame="" tooltip="https://www.tandfonline.com/doi/full/10.1080/02619768.2025.2531930" history="1" highlightClick="0" endSnd="0">
+                <a:hlinkClick r:id="rId4" invalidUrl="" action="" tgtFrame="" tooltip="https://www.wienerzeitung.at/nachrichten/politik/oesterreich/2175563-Nur-42-Pflichtschullehrer-kamen-aus-Pension-zurueck.html" history="1" highlightClick="0" endSnd="0">
+                  <a:extLst>
+                    <a:ext uri="{A12FA001-AC4F-418D-AE19-62706E023703}">
+                      <ahyp:hlinkClr xmlns:ahyp="http://schemas.microsoft.com/office/drawing/2018/hyperlinkcolor" val="tx"/>
+                    </a:ext>
+                  </a:extLst>
+                </a:hlinkClick>
+              </a:rPr>
+              <a:t>https://www.wienerzeitung.at/nachrichten/politik/oesterreich/2175563-Nur-42-Pflichtschullehrer-kamen-aus-Pension-zurueck.html</a:t>
+            </a:r>
+            <a:endParaRPr lang="en-US" sz="1000" dirty="0"/>
+          </a:p>
+          <a:p>
+            <a:pPr indent="0" marL="0">
+              <a:buNone/>
+            </a:pPr>
+            <a:r>
+              <a:rPr lang="en-US" sz="1000" b="1" dirty="0">
+                <a:solidFill>
+                  <a:srgbClr val="24313A"/>
+                </a:solidFill>
+                <a:latin typeface="Calibri" pitchFamily="34" charset="0"/>
+                <a:ea typeface="Calibri" pitchFamily="34" charset="-122"/>
+                <a:cs typeface="Calibri" pitchFamily="34" charset="-120"/>
+              </a:rPr>
+              <a:t>Source (see also): </a:t>
+            </a:r>
+            <a:pPr indent="0" marL="0">
+              <a:buNone/>
+            </a:pPr>
+            <a:r>
+              <a:rPr lang="en-US" sz="1000" u="sng" dirty="0">
+                <a:solidFill>
+                  <a:srgbClr val="B3542E"/>
+                </a:solidFill>
+                <a:uFill>
+                  <a:solidFill>
+                    <a:srgbClr val="B3542E"/>
+                  </a:solidFill>
+                </a:uFill>
+                <a:latin typeface="Calibri" pitchFamily="34" charset="0"/>
+                <a:ea typeface="Calibri" pitchFamily="34" charset="-122"/>
+                <a:cs typeface="Calibri" pitchFamily="34" charset="-120"/>
+                <a:hlinkClick r:id="rId5" invalidUrl="" action="" tgtFrame="" tooltip="https://www.tandfonline.com/doi/full/10.1080/02619768.2025.2531930" history="1" highlightClick="0" endSnd="0">
                   <a:extLst>
                     <a:ext uri="{A12FA001-AC4F-418D-AE19-62706E023703}">
                       <ahyp:hlinkClr xmlns:ahyp="http://schemas.microsoft.com/office/drawing/2018/hyperlinkcolor" val="tx"/>

</xml_diff>

<commit_message>
Drop country, region and programme-name repetition from every opening; name institutions by what they are
Descriptions now start with the mechanism. Media and journals are described
first and named in brackets.

Co-Authored-By: Claude Opus 5 <noreply@anthropic.com>
Claude-Session: https://claude.ai/code/session_01REVwghctKjYh8VQ919ThdA
</commit_message>
<xml_diff>
--- a/policies/Re-attracting_Former_Teachers.pptx
+++ b/policies/Re-attracting_Former_Teachers.pptx
@@ -4902,7 +4902,7 @@
                 <a:ea typeface="Calibri" pitchFamily="34" charset="-122"/>
                 <a:cs typeface="Calibri" pitchFamily="34" charset="-120"/>
               </a:rPr>
-              <a:t>Quebec pays a retired teacher who goes back to the classroom at the salary step they had reached when they retired, from the first day of substitute work, rather than the flat substitute rate, and the pension keeps running in full. The measure was introduced during the pandemic and later made permanent, and the ministry followed it with a personal letter from the minister to every retired teacher. A returning retiree earns about 412 Canadian dollars a day (about 275 euros) instead of 212 dollars (about 140 euros), and up to 578 dollars (about 385 euros) on longer contracts. Seven hundred retirees came back in the first year and more than 5,000 worked in schools in 2022-23.</a:t>
+              <a:t>A retired teacher who goes back to the classroom is paid at the salary step they had reached when they retired, from the first day of substitute work, rather than the flat substitute rate, and the pension keeps running in full. The measure was introduced during the pandemic and later made permanent, and the ministry followed it with a personal letter from the minister to every retired teacher. A returning retiree earns about 412 Canadian dollars a day (about 275 euros) instead of 212 dollars (about 140 euros), and up to 578 dollars (about 385 euros) on longer contracts. Seven hundred retirees came back in the first year and more than 5,000 worked in schools in 2022-23.</a:t>
             </a:r>
             <a:endParaRPr lang="en-US" sz="1500" dirty="0"/>
           </a:p>
@@ -5547,7 +5547,7 @@
                 <a:ea typeface="Calibri" pitchFamily="34" charset="-122"/>
                 <a:cs typeface="Calibri" pitchFamily="34" charset="-120"/>
               </a:rPr>
-              <a:t>The Silver-Age Lecturing Plan posts retired principals, senior teachers and ‘special-grade’ teachers aged 65 or under to rural primary and lower-secondary schools in poor and remote counties, for at least one school year, where they teach classes, coach the school's young teachers and advise the head on running the school. They apply to a call issued by their province, keep their pension and receive an allowance from the central government of 20,000 yuan a year (about 2,500 euros) that covers a stipend, travel and insurance. The Ministries of Education and Finance have run the plan since 2018, aiming at 10,000 posts in its first three years, and recruited 7,000 teachers in the 2024 round alone.</a:t>
+              <a:t>Retired principals, senior teachers and ‘special-grade’ teachers aged 65 or under are posted to rural primary and lower-secondary schools in poor and remote counties, for at least one school year, where they teach classes, coach the school's young teachers and advise the head on running the school. They apply to a call issued by their province, keep their pension and receive an allowance from the central government of 20,000 yuan a year (about 2,500 euros) that covers a stipend, travel and insurance. The Ministries of Education and Finance have run the plan since 2018, aiming at 10,000 posts in its first three years, and recruited 7,000 teachers in the 2024 round alone.</a:t>
             </a:r>
             <a:endParaRPr lang="en-US" sz="1500" dirty="0"/>
           </a:p>
@@ -6192,7 +6192,7 @@
                 <a:ea typeface="Calibri" pitchFamily="34" charset="-122"/>
                 <a:cs typeface="Calibri" pitchFamily="34" charset="-120"/>
               </a:rPr>
-              <a:t>French rules on drawing a pension while working let a retired public-school teacher take a contract or substitute post and receive both the salary and the pension, once six months have passed since the pension took effect. A written answer from the Ministry of Education to the National Assembly confirmed that this applies to retired civil servants and contract teachers alike, including at the last school where they served. School authorities use it to cover posts in shortage subjects, and deputies have pressed the government to make it easier to call retired teachers in for replacements. It is a rule that removes an obstacle rather than a programme that recruits, and no figures on how many teachers come back are published.</a:t>
+              <a:t>The general rules on drawing a pension while working let a retired public-school teacher take a contract or substitute post and receive both the salary and the pension, once six months have passed since the pension took effect. A written answer from the Ministry of Education to the National Assembly confirmed that this applies to retired civil servants and contract teachers alike, including at the last school where they served. School authorities use it to cover posts in shortage subjects, and deputies have pressed the government to make it easier to call retired teachers in for replacements. It is a rule that removes an obstacle rather than a programme that recruits, and no figures on how many teachers come back are published.</a:t>
             </a:r>
             <a:endParaRPr lang="en-US" sz="1500" dirty="0"/>
           </a:p>
@@ -6876,7 +6876,7 @@
                 <a:ea typeface="Calibri" pitchFamily="34" charset="-122"/>
                 <a:cs typeface="Calibri" pitchFamily="34" charset="-120"/>
               </a:rPr>
-              <a:t>Lower Saxony raised, and then removed altogether, the ceiling that cut a retired teacher's pension once pay and pension together passed a set share of their former salary. The state parliament lifted it in 2022, which let a pensioner teach around nine or ten hours a week with nothing deducted, and raised overtime pay for serving teachers at the same time. In 2024 the ceiling for retired teachers was dropped completely, so a pensioner can now teach as many hours as a school needs and still draw the full pension. Before the change, teaching after retirement cost a pensioner part of the pension, which is why few did it.</a:t>
+              <a:t>A retired teacher used to lose part of the pension once pay and pension together passed a set share of their former salary, which is why few of them taught after retiring. The state parliament raised that ceiling in 2022, enough for a pensioner to teach around nine or ten hours a week with nothing deducted, and increased overtime pay for serving teachers at the same time. In 2024 the ceiling for retired teachers was dropped completely, so a pensioner can now teach as many hours as a school needs and still draw the full pension.</a:t>
             </a:r>
             <a:endParaRPr lang="en-US" sz="1500" dirty="0"/>
           </a:p>
@@ -7560,7 +7560,7 @@
                 <a:ea typeface="Calibri" pitchFamily="34" charset="-122"/>
                 <a:cs typeface="Calibri" pitchFamily="34" charset="-120"/>
               </a:rPr>
-              <a:t>The Minister of Education of Lower Saxony wrote personally to every teacher about to retire, with an information sheet and a registration guide setting out two ways to stay in the classroom: a civil-servant teacher can ask to put off retirement by up to three years, or any teacher can retire and be re-hired at once on a fixed-term contract while drawing the pension, under the relaxed earnings rules. The letter thanks them for their service and asks for their help with schools facing rising pupil numbers. It carries no money of its own; its purpose is that nobody signs the retirement paperwork without knowing the options. It was sent in November 2023.</a:t>
+              <a:t>The Minister of Education wrote personally to every teacher about to retire, with an information sheet and a registration guide setting out two ways to stay in the classroom: a civil-servant teacher can ask to put off retirement by up to three years, or any teacher can retire and be re-hired at once on a fixed-term contract while drawing the pension, under the relaxed earnings rules. The letter thanks them for their service and asks for their help with schools facing rising pupil numbers. It carries no money of its own; its purpose is that nobody signs the retirement paperwork without knowing the options. It was sent in November 2023.</a:t>
             </a:r>
             <a:endParaRPr lang="en-US" sz="1500" dirty="0"/>
           </a:p>
@@ -8205,7 +8205,7 @@
                 <a:ea typeface="Calibri" pitchFamily="34" charset="-122"/>
                 <a:cs typeface="Calibri" pitchFamily="34" charset="-120"/>
               </a:rPr>
-              <a:t>Ireland exempts the first fifty days a retired teacher works in a calendar year from abatement, the rule that cuts a public-service pension when pension and new salary together pass the pay the person had when they retired. Within those fifty days a retiree can cover absences as a substitute, or take a fixed-term contract, and keep the pension in full; every working day counts as one whatever the hours, and abatement is assessed only from the fifty-first. The Department of Education introduced the waiver by circular in 2021 to ease the shortage of substitutes, and has renewed it twice, most recently for 2026 and 2027.</a:t>
+              <a:t>The first fifty days a retired teacher works in a calendar year are exempt from abatement, the rule that cuts a public-service pension when pension and new salary together pass the pay the person had when they retired. Within those fifty days a retiree can cover absences as a substitute, or take a fixed-term contract, and keep the pension in full; every working day counts as one whatever the hours, and abatement is assessed only from the fifty-first. The Department of Education introduced the waiver by circular in 2021 to ease the shortage of substitutes, and has renewed it twice, most recently for 2026 and 2027.</a:t>
             </a:r>
             <a:endParaRPr lang="en-US" sz="1500" dirty="0"/>
           </a:p>
@@ -8807,7 +8807,7 @@
                 <a:ea typeface="Calibri" pitchFamily="34" charset="-122"/>
                 <a:cs typeface="Calibri" pitchFamily="34" charset="-120"/>
               </a:rPr>
-              <a:t>The Dutch Ministry of Education paid a primary school up to 2,500 euros for every qualified teacher it re-hired who had been out of primary teaching for at least a year, on a contract of six months or more. The money went to the school board, not the teacher, and had to be spent on the returner's first months back: coaching, refresher training, time alongside a colleague. It was aimed at the cost and effort that make a school hesitate to take on someone who has been away. The scheme ran from November 2017 to January 2020, with a first budget covering up to 500 returners and a further round of applications in 2019.</a:t>
+              <a:t>The Ministry of Education paid a primary school up to 2,500 euros for every qualified teacher it re-hired who had been out of primary teaching for at least a year, on a contract of six months or more. The money went to the school board, not the teacher, and had to be spent on the returner's first months back: coaching, refresher training, time alongside a colleague. It was aimed at the cost and effort that make a school hesitate to take on someone who has been away. The scheme ran from November 2017 to January 2020, with a first budget covering up to 500 returners and a further round of applications in 2019.</a:t>
             </a:r>
             <a:endParaRPr lang="en-US" sz="1500" dirty="0"/>
           </a:p>
@@ -9452,7 +9452,7 @@
                 <a:ea typeface="Calibri" pitchFamily="34" charset="-122"/>
                 <a:cs typeface="Calibri" pitchFamily="34" charset="-120"/>
               </a:rPr>
-              <a:t>New Zealand dropped the refresher course that a registered teacher who had not taught for five years or more used to need before getting a practising certificate back. With a job offer in hand, a returner now renews the certificate directly, can do substitute teaching for up to twenty half-days while the renewal is processed, and agrees a short teaching plan with the school principal in place of the course. The government also pays the registration fees, so coming back costs the teacher nothing. Fees have been covered since October 2024 and are funded until June 2028; 352 teachers had returned by April 2025.</a:t>
+              <a:t>A registered teacher who had not taught for five years or more used to need a refresher course before getting a practising certificate back, and that requirement has gone. With a job offer in hand, a returner now renews the certificate directly, can do substitute teaching for up to twenty half-days while the renewal is processed, and agrees a short teaching plan with the school principal in place of the course. The government also pays the registration fees, so coming back costs the teacher nothing. Fees have been covered since October 2024 and are funded until June 2028; 352 teachers had returned by April 2025.</a:t>
             </a:r>
             <a:endParaRPr lang="en-US" sz="1500" dirty="0"/>
           </a:p>
@@ -10097,7 +10097,7 @@
                 <a:ea typeface="Calibri" pitchFamily="34" charset="-122"/>
                 <a:cs typeface="Calibri" pitchFamily="34" charset="-120"/>
               </a:rPr>
-              <a:t>Portugal lets a school with an unfilled post in a shortage subject, or a school officially classed as under-staffed, sign a fixed-term contract with a teacher who retired five years ago or less. The school applies through an online form of the schools' administration directorate and the ministry authorises the contract within a yearly quota agreed with the finance ministry. The returning teacher keeps the full pension and receives an extra payment tied to the first step of the teacher salary scale, in proportion to the hours taught each week. The decree-law creating it was published in August 2024, and about 63 of some 200 posts were filled in the first round.</a:t>
+              <a:t>A school with an unfilled post in a shortage subject, or a school officially classed as under-staffed, may sign a fixed-term contract with a teacher who retired five years ago or less. The school applies through an online form of the schools' administration directorate and the ministry authorises the contract within a yearly quota agreed with the finance ministry. The returning teacher keeps the full pension and receives an extra payment tied to the first step of the teacher salary scale, in proportion to the hours taught each week. The decree-law creating it was published in August 2024, and about 63 of some 200 posts were filled in the first round.</a:t>
             </a:r>
             <a:endParaRPr lang="en-US" sz="1500" dirty="0"/>
           </a:p>
@@ -10742,7 +10742,7 @@
                 <a:ea typeface="Calibri" pitchFamily="34" charset="-122"/>
                 <a:cs typeface="Calibri" pitchFamily="34" charset="-120"/>
               </a:rPr>
-              <a:t>Singapore registers trained ex-teachers, retirees among them, on a Ministry of Education portal from which schools hire them directly for spells lasting anywhere from a single day to ten weeks, for teaching alone or for a mix of teaching and other duties agreed case by case. They are paid a daily rate and begin to earn leave after ninety days of cumulative service. A companion scheme signs former ministry teachers to longer contracts, of one year to eighteen months. Between 2022 and 2024 about 220 teachers a year joined the flexible scheme within twelve months of leaving the service.</a:t>
+              <a:t>Trained ex-teachers, retirees among them, register on a Ministry of Education portal from which schools hire them directly for spells lasting anywhere from a single day to ten weeks, for teaching alone or for a mix of teaching and other duties agreed case by case. They are paid a daily rate and begin to earn leave after ninety days of cumulative service. A companion scheme signs former ministry teachers to longer contracts, of one year to eighteen months. Between 2022 and 2024 about 220 teachers a year joined the flexible scheme within twelve months of leaving the service.</a:t>
             </a:r>
             <a:endParaRPr lang="en-US" sz="1500" dirty="0"/>
           </a:p>
@@ -11917,7 +11917,7 @@
                 <a:ea typeface="Calibri" pitchFamily="34" charset="-122"/>
                 <a:cs typeface="Calibri" pitchFamily="34" charset="-120"/>
               </a:rPr>
-              <a:t>Ten retired teachers from early-childhood and primary education mentored 57 students in the final years of their teaching degrees at the University of Zaragoza, as part of the faculty's student guidance plan. Each group met three times, on the teaching profession and its vocation, on further training and employability, and on the teaching career, with personal contact between mentor and students in between. The mentors were teachers with a recognised professional record, and the role brought them back into teacher education without a contract or a classroom. The experience was documented in a 2019 publication of the university.</a:t>
+              <a:t>Ten retired teachers from early-childhood and primary education mentored 57 students in the final years of their teaching degrees, as part of the Faculty of Education's student guidance plan. Each group met three times, on the teaching profession and its vocation, on further training and employability, and on the teaching career, with personal contact between mentor and students in between. The mentors were teachers with a recognised professional record, and the role brought them back into teacher education without a contract or a classroom. The experience was documented in a 2019 publication of the university.</a:t>
             </a:r>
             <a:endParaRPr lang="en-US" sz="1500" dirty="0"/>
           </a:p>
@@ -12562,7 +12562,7 @@
                 <a:ea typeface="Calibri" pitchFamily="34" charset="-122"/>
                 <a:cs typeface="Calibri" pitchFamily="34" charset="-120"/>
               </a:rPr>
-              <a:t>Sweden's National Agency for Education put a free online course on its learning platform for qualified teachers and preschool teachers coming back after working elsewhere. The returner logs in, picks the school or the preschool track and takes only the modules they need, in any order, with a certificate for each one. The modules cover the curricula, laws and official guidelines that changed while they were away, which is what a teacher who has been out for years is least sure about. It was built at the government's request, has been available since October 2018, and is open to anyone with a Swedish teaching licence or a qualifying degree.</a:t>
+              <a:t>The National Agency for Education put a free online course on its learning platform for qualified teachers and preschool teachers coming back after working elsewhere. The returner logs in, picks the school or the preschool track and takes only the modules they need, in any order, with a certificate for each one. The modules cover the curricula, laws and official guidelines that changed while they were away, which is what a teacher who has been out for years is least sure about. It was built at the government's request, has been available since October 2018, and is open to anyone with a Swedish teaching licence or a qualifying degree.</a:t>
             </a:r>
             <a:endParaRPr lang="en-US" sz="1500" dirty="0"/>
           </a:p>
@@ -13246,7 +13246,7 @@
                 <a:ea typeface="Calibri" pitchFamily="34" charset="-122"/>
                 <a:cs typeface="Calibri" pitchFamily="34" charset="-120"/>
               </a:rPr>
-              <a:t>The Zurich University of Teacher Education gives a teacher coming back to the classroom a counselling session and an assessment interview that set out what preparation the return needs, with the first hour free and the rest paid by the canton. In the first school year back, a teacher who has been away for eight years or more uses the university's induction programme free of charge: up to twenty-five hours of mentoring by an experienced colleague in their own school, individual and group supervision, coaching in their subject, and optional courses on grading, classroom management and working with parents. Returners are also encouraged to sit in on lessons before they start.</a:t>
+              <a:t>A teacher coming back to the classroom starts with a counselling session and an assessment interview that set out what preparation the return needs, with the first hour free and the rest paid by the canton. In the first school year back, a teacher who has been away for eight years or more uses the university's induction programme free of charge: up to twenty-five hours of mentoring by an experienced colleague in their own school, individual and group supervision, coaching in their subject, and optional courses on grading, classroom management and working with parents. Returners are also encouraged to sit in on lessons before they start.</a:t>
             </a:r>
             <a:endParaRPr lang="en-US" sz="1500" dirty="0"/>
           </a:p>
@@ -13887,7 +13887,7 @@
                 <a:ea typeface="Calibri" pitchFamily="34" charset="-122"/>
                 <a:cs typeface="Calibri" pitchFamily="34" charset="-120"/>
               </a:rPr>
-              <a:t>The Department for Education gives any former teacher who asks a named adviser, who then works with them one to one, by phone, text or e-mail and for as long as they need. The adviser goes through the skills they gained while away, helps with applications and interviews, points them to refresher courses and professional qualifications, and passes on vacancies and webinars. It runs through the department's ‘Get Into Teaching’ service and was the channel for its ‘Come back to teaching’ campaign in January 2022. Returners are a large part of teacher supply in England: about 17,500 came back in 2023, some 38 percent of all qualified entrants.</a:t>
+              <a:t>Any former teacher who asks is given a named adviser, who then works with them one to one, by phone, text or e-mail and for as long as they need. The adviser goes through the skills they gained while away, helps with applications and interviews, points them to refresher courses and professional qualifications, and passes on vacancies and webinars. It runs through the ‘Get Into Teaching’ service and was the channel for the ‘Come back to teaching’ campaign in January 2022. Returners are a large part of teacher supply: about 17,500 came back in 2023, some 38 percent of all qualified entrants.</a:t>
             </a:r>
             <a:endParaRPr lang="en-US" sz="1500" dirty="0"/>
           </a:p>
@@ -14571,7 +14571,7 @@
                 <a:ea typeface="Calibri" pitchFamily="34" charset="-122"/>
                 <a:cs typeface="Calibri" pitchFamily="34" charset="-120"/>
               </a:rPr>
-              <a:t>England paid for refresher courses, time in classrooms and help with applications for qualified teachers returning to secondary maths, science and languages, first through a central pilot in 2015 and then, in 2016, by funding schools to run the support themselves, with a course of two to four weeks, a bursary for the returner and a payment to the school once the returner was hired. The first pilot drew heavy interest but converted little of it: of 5,729 registrations and 354 people supported, 27 were in permanent posts months later, and the independent evaluation judged it poor value for money. Its lessons went into the adviser service on the previous slide.</a:t>
+              <a:t>The Department for Education paid for refresher courses, time in classrooms and help with applications for qualified teachers returning to secondary maths, science and languages, first through a central pilot in 2015 and then, in 2016, by funding schools to run the support themselves, with a course of two to four weeks, a bursary for the returner and a payment to the school once the returner was hired. The first pilot drew heavy interest but converted little of it: of 5,729 registrations and 354 people supported, 27 were in permanent posts months later, and the independent evaluation judged it poor value for money. Its lessons went into the adviser service on the previous slide.</a:t>
             </a:r>
             <a:endParaRPr lang="en-US" sz="1500" dirty="0"/>
           </a:p>
@@ -15255,7 +15255,7 @@
                 <a:ea typeface="Calibri" pitchFamily="34" charset="-122"/>
                 <a:cs typeface="Calibri" pitchFamily="34" charset="-120"/>
               </a:rPr>
-              <a:t>Aurora Public Schools hired recently retired teachers part-time to mentor first- and second-year teachers in high-poverty elementary schools, meeting them weekly and sitting in on their lessons for two years. The district's ordinary support for new teachers was a one-year pairing with a colleague, with no training for the mentor and no release time. The retirees were chosen among teachers with a strong record in the district, and the role gave them paid, part-time work back inside the school system. A randomised trial published in 2017 followed 77 new teachers in 11 schools and found a small gain in mathematics after the first year that did not hold, no effect on reading and no effect on whether the new teachers stayed.</a:t>
+              <a:t>The district hired recently retired teachers part-time to mentor first- and second-year teachers in high-poverty elementary schools, meeting them weekly and sitting in on their lessons for two years. Its ordinary support for new teachers was a one-year pairing with a colleague, with no training for the mentor and no release time. The retirees were chosen among teachers with a strong record in the district, and the role gave them paid, part-time work back inside the school system. A randomised trial published in 2017 followed 77 new teachers in 11 schools and found a small gain in mathematics after the first year that did not hold, no effect on reading and no effect on whether the new teachers stayed.</a:t>
             </a:r>
             <a:endParaRPr lang="en-US" sz="1500" dirty="0"/>
           </a:p>
@@ -16580,7 +16580,7 @@
                 <a:ea typeface="Calibri" pitchFamily="34" charset="-122"/>
                 <a:cs typeface="Calibri" pitchFamily="34" charset="-120"/>
               </a:rPr>
-              <a:t>House Bill 385 let a Georgia teacher who had retired with thirty or more years of service, and had been retired at least a year, take a full-time classroom post in one of the three subjects of greatest need in their region and draw a full salary on top of the full pension. The regional education agency decided which subjects counted, usually special education, mathematics, science, English or elementary teaching. The district paid the pension contributions and the retiree earned no further pension rights. The narrow conditions kept numbers low: a state audit found about 350 retirees a year, under one percent of Georgia's teachers. The law expired on 30 June 2026 and was replaced by Senate Bill 150.</a:t>
+              <a:t>A teacher who had retired with thirty or more years of service, and had been retired at least a year, could take a full-time classroom post in one of the three subjects of greatest need in their region and draw a full salary on top of the full pension. The regional education agency decided which subjects counted, usually special education, mathematics, science, English or elementary teaching. The district paid the pension contributions and the retiree earned no further pension rights. The narrow conditions kept numbers low: a state audit found about 350 retirees a year, under one percent of the state's teachers. The law expired on 30 June 2026 and was replaced by Senate Bill 150.</a:t>
             </a:r>
             <a:endParaRPr lang="en-US" sz="1500" dirty="0"/>
           </a:p>
@@ -17264,7 +17264,7 @@
                 <a:ea typeface="Calibri" pitchFamily="34" charset="-122"/>
                 <a:cs typeface="Calibri" pitchFamily="34" charset="-120"/>
               </a:rPr>
-              <a:t>Louisiana lets a retired teacher take a post that has been declared a critical shortage, full-time or half-time, without the pension being suspended or reduced. The posts covered are classroom teachers, speech therapists and school counsellors. The retiree and the employer keep paying into the retirement system while the re-employment lasts, but the retiree earns no extra service credit or benefit from it. The state education department issued guidance for principals on how to use the rule. It is the most recent of several return-to-work laws the state has passed since 2022, signed in May 2024.</a:t>
+              <a:t>A retired teacher may take a post that has been declared a critical shortage, full-time or half-time, without the pension being suspended or reduced. The posts covered are classroom teachers, speech therapists and school counsellors. The retiree and the employer keep paying into the retirement system while the re-employment lasts, but the retiree earns no extra service credit or benefit from it. The state education department issued guidance for principals on how to use the rule. It is the most recent of several return-to-work laws passed since 2022, signed in May 2024.</a:t>
             </a:r>
             <a:endParaRPr lang="en-US" sz="1500" dirty="0"/>
           </a:p>
@@ -17948,7 +17948,7 @@
                 <a:ea typeface="Calibri" pitchFamily="34" charset="-122"/>
                 <a:cs typeface="Calibri" pitchFamily="34" charset="-120"/>
               </a:rPr>
-              <a:t>Michigan cut from nine months to six the wait before a school can re-hire a retired school employee, and removed the cap on what they may earn once the six months have passed, so the pension keeps running whatever the salary. During the waiting period a retiree may already work, as long as earnings stay under a set ceiling, and may not return as superintendent. The law was passed in response to post-pandemic shortages and signed in October 2023. It is temporary and expires in October 2028, so the state will have to decide whether to keep it.</a:t>
+              <a:t>The wait before a school can re-hire a retired school employee fell from nine months to six, and the cap on what they may earn once those six months have passed was removed, so the pension keeps running whatever the salary. During the waiting period a retiree may already work, as long as earnings stay under a set ceiling, and may not return as superintendent. The law was passed in response to post-pandemic shortages and signed in October 2023. It is temporary and expires in October 2028, so the state will have to decide whether to keep it.</a:t>
             </a:r>
             <a:endParaRPr lang="en-US" sz="1500" dirty="0"/>
           </a:p>
@@ -19416,7 +19416,7 @@
                 <a:ea typeface="Calibri" pitchFamily="34" charset="-122"/>
                 <a:cs typeface="Calibri" pitchFamily="34" charset="-120"/>
               </a:rPr>
-              <a:t>The AARP Foundation trains people over fifty, many of them retired teachers, and places them in high-poverty public schools to tutor children who are behind in reading, in short weekly sessions with small groups. Volunteers commit for a school year and get training and continuing support from the programme. It has run since 1996 and now reaches several thousand children in 18 communities across the country. A randomised study found substantially greater gains in sounding out words and in reading comprehension among the children tutored, and a separate trial found the tutoring also protects the volunteers' own physical and cognitive health.</a:t>
+              <a:t>Volunteers over fifty, many of them retired teachers, are trained and placed in high-poverty public schools to tutor children who are behind in reading, in short weekly sessions with small groups. They commit for a school year and get training and continuing support from the programme. It has run since 1996 and now reaches several thousand children in 18 communities across the country. A randomised study found substantially greater gains in sounding out words and in reading comprehension among the children tutored, and a separate trial found the tutoring also protects the volunteers' own physical and cognitive health.</a:t>
             </a:r>
             <a:endParaRPr lang="en-US" sz="1500" dirty="0"/>
           </a:p>
@@ -20100,7 +20100,7 @@
                 <a:ea typeface="Calibri" pitchFamily="34" charset="-122"/>
                 <a:cs typeface="Calibri" pitchFamily="34" charset="-120"/>
               </a:rPr>
-              <a:t>New Mexico lets a retired teacher or college lecturer go back to work in a public school, college or university for up to three years with no limit on salary or hours and no loss of pension. The retiree applies to the state's Educational Retirement Board and must be approved before starting, so every return is on record. The law was signed in March 2022 and announced to retirees that June, opening the classroom to the state's roughly 48,000 retired educators at a time of severe shortages.</a:t>
+              <a:t>A retired teacher or college lecturer may go back to work in a public school, college or university for up to three years with no limit on salary or hours and no loss of pension. The retiree applies to the state's Educational Retirement Board and must be approved before starting, so every return is on record. The law was signed in March 2022 and announced to retirees that June, opening the classroom to the state's roughly 48,000 retired educators at a time of severe shortages.</a:t>
             </a:r>
             <a:endParaRPr lang="en-US" sz="1500" dirty="0"/>
           </a:p>
@@ -20784,7 +20784,7 @@
                 <a:ea typeface="Calibri" pitchFamily="34" charset="-122"/>
                 <a:cs typeface="Calibri" pitchFamily="34" charset="-120"/>
               </a:rPr>
-              <a:t>North Carolina let a retired teacher take a full-time classroom post and draw the state pension alongside the salary, which put a returning teacher about half as much again as a comparable colleague. Any district could hire a retired teacher back without penalty; it was a pension rule open to all rather than a programme with places. A 2024 study using state administrative data found that schools with many economically disadvantaged or Black pupils, the ones that struggle most to fill vacancies, hired a disproportionate share of these teachers. The provision ran from 1999 to 2009.</a:t>
+              <a:t>A retired teacher could take a full-time classroom post and draw the state pension alongside the salary, which put a returning teacher about half as much again as a comparable colleague. Any district could hire a retired teacher back without penalty; it was a pension rule open to all rather than a programme with places. A 2024 study using state administrative data found that schools with many economically disadvantaged or Black pupils, the ones that struggle most to fill vacancies, hired a disproportionate share of these teachers. The provision ran from 1999 to 2009.</a:t>
             </a:r>
             <a:endParaRPr lang="en-US" sz="1500" dirty="0"/>
           </a:p>
@@ -21468,7 +21468,7 @@
                 <a:ea typeface="Calibri" pitchFamily="34" charset="-122"/>
                 <a:cs typeface="Calibri" pitchFamily="34" charset="-120"/>
               </a:rPr>
-              <a:t>Virginia told its state superintendent to issue or renew teaching licences for retired and out-of-state teachers whose licences had lapsed, and its education department to work with the state retirement system so that retirees could fill any vacant school post. It built on a rule in force since 2001 under which a retiree who returns to a critical-shortage area draws a new salary on top of the pension. The same directive launched an online licensing system and a wider plan on the educator shortage, under which the department reports adding more than 17,000 endorsements to teacher licences between 2022 and 2025.</a:t>
+              <a:t>The governor's directive told the state superintendent to issue or renew teaching licences for retired and out-of-state teachers whose licences had lapsed, and the education department to work with the state retirement system so that retirees could fill any vacant school post. It built on a rule in force since 2001 under which a retiree who returns to a critical-shortage area draws a new salary on top of the pension. The same directive launched an online licensing system and a wider plan on the educator shortage, under which the department reports adding more than 17,000 endorsements to teacher licences between 2022 and 2025.</a:t>
             </a:r>
             <a:endParaRPr lang="en-US" sz="1500" dirty="0"/>
           </a:p>
@@ -33459,7 +33459,7 @@
                 <a:ea typeface="Calibri" pitchFamily="34" charset="-122"/>
                 <a:cs typeface="Calibri" pitchFamily="34" charset="-120"/>
               </a:rPr>
-              <a:t>The Department of Education of New South Wales directly contacted teachers who had resigned in the previous five years and asked them to consider coming back. Those interested were offered assistance to renew their accreditation and a placement in casual or temporary work, with the possibility of moving to a permanent post later. The initiative was launched shortly after teachers received one of the largest pay rises in decades and a significant cut in administrative work, and the department credits both with helping the returns. More than 1,500 former teachers were contacted from November 2023; by May 2024, 260 had expressed interest and 145 were placed across more than 600 schools, about sixty percent of them coming out of retirement. The pathway is still open, but nothing has been published since.</a:t>
+              <a:t>The Department of Education directly contacted teachers who had resigned in the previous five years and asked them to consider coming back. Those interested were offered assistance to renew their accreditation and a placement in casual or temporary work, with the possibility of moving to a permanent post later. The initiative was launched shortly after teachers received one of the largest pay rises in decades and a significant cut in administrative work, and the department credits both with helping the returns. More than 1,500 former teachers were contacted from November 2023; by May 2024, 260 had expressed interest and 145 were placed across more than 600 schools, about sixty percent of them coming out of retirement. The pathway is still open, but nothing has been published since.</a:t>
             </a:r>
             <a:endParaRPr lang="en-US" sz="1500" dirty="0"/>
           </a:p>
@@ -34143,7 +34143,7 @@
                 <a:ea typeface="Calibri" pitchFamily="34" charset="-122"/>
                 <a:cs typeface="Calibri" pitchFamily="34" charset="-120"/>
               </a:rPr>
-              <a:t>The Teacher Re-Engagement Initiative is a scheme of the Department of Education of the state of Victoria for qualified teachers who stopped teaching at least a year ago, whether they retired or moved to another job. It lets them spend up to forty paid days in a public school to get used to the classroom again before they apply for a real post. After a teacher registers, a team from the department calls them, offers free coaching on writing a CV, preparing for interviews and the current curriculum, and finds them a school; during the forty days they observe lessons, teach and are guided by serving teachers. Those returning from retirement or a career break are paid up to 12,000 Australian dollars (about 7,200 euros) for the forty days. The initiative began in late 2022, received more than 1,100 expressions of interest in its first months and was given 12 million Australian dollars (about 7.2 million euros) in the 2023/24 state budget, which funded placements up to June 2025.</a:t>
+              <a:t>Qualified teachers who stopped teaching at least a year ago, whether they retired or moved to another job, are offered up to forty paid days in a public school to get used to the classroom again before they apply for a real post. After a teacher registers, a team from the Department of Education calls them, offers free coaching on writing a CV, preparing for interviews and the current curriculum, and finds them a school; during the forty days they observe lessons, teach and are guided by serving teachers. Those returning from retirement or a career break are paid up to 12,000 Australian dollars (about 7,200 euros) for the forty days. It began in late 2022, drew more than 1,100 expressions of interest in its first months and was given 12 million Australian dollars (about 7.2 million euros) in the 2023/24 state budget, which funded placements up to June 2025.</a:t>
             </a:r>
             <a:endParaRPr lang="en-US" sz="1500" dirty="0"/>
           </a:p>
@@ -34745,7 +34745,7 @@
                 <a:ea typeface="Calibri" pitchFamily="34" charset="-122"/>
                 <a:cs typeface="Calibri" pitchFamily="34" charset="-120"/>
               </a:rPr>
-              <a:t>The regional education directorates, the authorities that administer schools in each province, wrote to teachers who had already retired and asked them to come back to the classroom. The Vienna directorate posted letters in December 2022 to some 300 retired teachers, and extended the offer to every retired teacher up to the age of 67; according to ORF, three accepted. From February 2023 the directorate passed the task to school principals, who were asked to put the question in person, this time to staff approaching retirement age, usually proposing that they stay on with reduced hours; Vorarlberg created a post to promote the option. A returning teacher keeps the full pension and signs a separate contract paid on the beginner's salary scale. The Wiener Zeitung reported 42 returns from retirement across the country's compulsory schools in 2022/23, out of more than 70,000 teachers, and a 2025 study in the European Journal of Teacher Education points to pension and service-crediting rules as the main barrier.</a:t>
+              <a:t>The regional education directorates, which run the schools in each province, wrote to teachers who had already retired and asked them to come back. Vienna posted letters in December 2022 to some 300 of them, and to every retired teacher up to the age of 67; the public broadcaster (ORF) reports that three accepted. From February 2023 the directorate passed the job to school principals, who put the question in person to staff approaching retirement age, usually offering reduced hours to stay on. A teacher who returns keeps the full pension and signs a separate contract paid on the beginner's salary scale. A national newspaper (Wiener Zeitung) counted 42 returns from retirement in the country's compulsory schools in 2022/23, out of more than 70,000 teachers, and a 2025 academic study points to pension and seniority rules as the main barrier.</a:t>
             </a:r>
             <a:endParaRPr lang="en-US" sz="1500" dirty="0"/>
           </a:p>
@@ -35433,7 +35433,7 @@
                 <a:ea typeface="Calibri" pitchFamily="34" charset="-122"/>
                 <a:cs typeface="Calibri" pitchFamily="34" charset="-120"/>
               </a:rPr>
-              <a:t>The Bahamian Ministry of Education is turning its supply-teacher platform into a permanent register where retired teachers, former teachers now working in other careers and recent graduates sign up in advance, so that a school can call one of them in when a post falls vacant or a teacher is absent. A task force drawn from several agencies checks records and accreditation quickly, so a reservist can start without the usual delay. The point of the design is that the pool exists before the gap appears, rather than being assembled each time. It was announced in July 2026, when the country was short of about 300 teachers across 162 schools spread over 24 islands, and no regulations, enrolment figures or results have been published yet.</a:t>
+              <a:t>The Ministry of Education is turning its supply-teacher platform into a permanent register where retired teachers, former teachers now working in other careers and recent graduates sign up in advance, so that a school can call one of them in when a post falls vacant or a teacher is absent. A task force drawn from several agencies checks records and accreditation quickly, so a reservist can start without the usual delay. The point of the design is that the pool exists before the gap appears, rather than being assembled each time. It was announced in July 2026, when the country was short of about 300 teachers across 162 schools spread over 24 islands, and no regulations, enrolment figures or results have been published yet.</a:t>
             </a:r>
             <a:endParaRPr lang="en-US" sz="1500" dirty="0"/>
           </a:p>
@@ -36117,7 +36117,7 @@
                 <a:ea typeface="Calibri" pitchFamily="34" charset="-122"/>
                 <a:cs typeface="Calibri" pitchFamily="34" charset="-120"/>
               </a:rPr>
-              <a:t>Ontario's teachers' pension plan caps at fifty the number of days a retired teacher may work for a school board in a school year while still drawing the full pension; past that limit the pension stops for the rest of the year. The provincial government and the teachers' federation, which sponsor the plan together, have lifted the cap to ninety-five days when schools ran short of staff, as they did during and after the pandemic. Boards then had to report how they used retirees, so that the extra days did not take work from occasional teachers at the start of their careers. Teacher unions have argued that leaning on retirees is not a lasting answer to shortages.</a:t>
+              <a:t>A retired teacher may work for a school board for up to fifty days in a school year and still draw the full pension; past that limit the pension stops for the rest of the year. The provincial government and the teachers' federation, which sponsor the pension plan together, have lifted the cap to ninety-five days when schools ran short of staff, as they did during and after the pandemic. Boards then had to report how they used retirees, so that the extra days did not take work from occasional teachers at the start of their careers. Teacher unions have argued that leaning on retirees is not a lasting answer to shortages.</a:t>
             </a:r>
             <a:endParaRPr lang="en-US" sz="1500" dirty="0"/>
           </a:p>

</xml_diff>

<commit_message>
Plural subjects instead of 'a teacher who returns' across the deck
Co-Authored-By: Claude Opus 5 <noreply@anthropic.com>
Claude-Session: https://claude.ai/code/session_01REVwghctKjYh8VQ919ThdA
</commit_message>
<xml_diff>
--- a/policies/Re-attracting_Former_Teachers.pptx
+++ b/policies/Re-attracting_Former_Teachers.pptx
@@ -4902,7 +4902,7 @@
                 <a:ea typeface="Calibri" pitchFamily="34" charset="-122"/>
                 <a:cs typeface="Calibri" pitchFamily="34" charset="-120"/>
               </a:rPr>
-              <a:t>A retired teacher who goes back to the classroom is paid at the salary step they had reached when they retired, from the first day of substitute work, rather than the flat substitute rate, and the pension keeps running in full. The measure was introduced during the pandemic and later made permanent, and the ministry followed it with a personal letter from the minister to every retired teacher. A returning retiree earns about 412 Canadian dollars a day (about 275 euros) instead of 212 dollars (about 140 euros), and up to 578 dollars (about 385 euros) on longer contracts. Seven hundred retirees came back in the first year and more than 5,000 worked in schools in 2022-23.</a:t>
+              <a:t>Retired teachers who go back to the classroom are paid at the salary step they had reached when they retired, from the first day of substitute work, rather than the flat substitute rate, and the pension keeps running in full. The measure was introduced during the pandemic and later made permanent, and the ministry followed it with a personal letter from the minister to every retired teacher. A returning retiree earns about 412 Canadian dollars a day (about 275 euros) instead of 212 dollars (about 140 euros), and up to 578 dollars (about 385 euros) on longer contracts. Seven hundred retirees came back in the first year and more than 5,000 worked in schools in 2022-23.</a:t>
             </a:r>
             <a:endParaRPr lang="en-US" sz="1500" dirty="0"/>
           </a:p>
@@ -6192,7 +6192,7 @@
                 <a:ea typeface="Calibri" pitchFamily="34" charset="-122"/>
                 <a:cs typeface="Calibri" pitchFamily="34" charset="-120"/>
               </a:rPr>
-              <a:t>The general rules on drawing a pension while working let a retired public-school teacher take a contract or substitute post and receive both the salary and the pension, once six months have passed since the pension took effect. A written answer from the Ministry of Education to the National Assembly confirmed that this applies to retired civil servants and contract teachers alike, including at the last school where they served. School authorities use it to cover posts in shortage subjects, and deputies have pressed the government to make it easier to call retired teachers in for replacements. It is a rule that removes an obstacle rather than a programme that recruits, and no figures on how many teachers come back are published.</a:t>
+              <a:t>The general rules on drawing a pension while working let retired public-school teachers take a contract or substitute post and receive both the salary and the pension, once six months have passed since the pension took effect. A written answer from the Ministry of Education to the National Assembly confirmed that this applies to retired civil servants and contract teachers alike, including at the last school where they served. School authorities use it to cover posts in shortage subjects, and deputies have pressed the government to make it easier to call retired teachers in for replacements. It is a rule that removes an obstacle rather than a programme that recruits, and no figures on how many teachers come back are published.</a:t>
             </a:r>
             <a:endParaRPr lang="en-US" sz="1500" dirty="0"/>
           </a:p>
@@ -6876,7 +6876,7 @@
                 <a:ea typeface="Calibri" pitchFamily="34" charset="-122"/>
                 <a:cs typeface="Calibri" pitchFamily="34" charset="-120"/>
               </a:rPr>
-              <a:t>A retired teacher used to lose part of the pension once pay and pension together passed a set share of their former salary, which is why few of them taught after retiring. The state parliament raised that ceiling in 2022, enough for a pensioner to teach around nine or ten hours a week with nothing deducted, and increased overtime pay for serving teachers at the same time. In 2024 the ceiling for retired teachers was dropped completely, so a pensioner can now teach as many hours as a school needs and still draw the full pension.</a:t>
+              <a:t>Retired teachers used to lose part of the pension once pay and pension together passed a set share of their former salary, which is why few of them taught after retiring. The state parliament raised that ceiling in 2022, enough for a pensioner to teach around nine or ten hours a week with nothing deducted, and increased overtime pay for serving teachers at the same time. In 2024 the ceiling for retired teachers was dropped completely, so a pensioner can now teach as many hours as a school needs and still draw the full pension.</a:t>
             </a:r>
             <a:endParaRPr lang="en-US" sz="1500" dirty="0"/>
           </a:p>
@@ -9452,7 +9452,7 @@
                 <a:ea typeface="Calibri" pitchFamily="34" charset="-122"/>
                 <a:cs typeface="Calibri" pitchFamily="34" charset="-120"/>
               </a:rPr>
-              <a:t>A registered teacher who had not taught for five years or more used to need a refresher course before getting a practising certificate back, and that requirement has gone. With a job offer in hand, a returner now renews the certificate directly, can do substitute teaching for up to twenty half-days while the renewal is processed, and agrees a short teaching plan with the school principal in place of the course. The government also pays the registration fees, so coming back costs the teacher nothing. Fees have been covered since October 2024 and are funded until June 2028; 352 teachers had returned by April 2025.</a:t>
+              <a:t>Registered teachers who had not taught for five years or more used to need a refresher course before getting a practising certificate back, and that requirement has gone. With a job offer in hand, a returner now renews the certificate directly, can do substitute teaching for up to twenty half-days while the renewal is processed, and agrees a short teaching plan with the school principal in place of the course. The government also pays the registration fees, so coming back costs the teacher nothing. Fees have been covered since October 2024 and are funded until June 2028; 352 teachers had returned by April 2025.</a:t>
             </a:r>
             <a:endParaRPr lang="en-US" sz="1500" dirty="0"/>
           </a:p>
@@ -10097,7 +10097,7 @@
                 <a:ea typeface="Calibri" pitchFamily="34" charset="-122"/>
                 <a:cs typeface="Calibri" pitchFamily="34" charset="-120"/>
               </a:rPr>
-              <a:t>A school with an unfilled post in a shortage subject, or a school officially classed as under-staffed, may sign a fixed-term contract with a teacher who retired five years ago or less. The school applies through an online form of the schools' administration directorate and the ministry authorises the contract within a yearly quota agreed with the finance ministry. The returning teacher keeps the full pension and receives an extra payment tied to the first step of the teacher salary scale, in proportion to the hours taught each week. The decree-law creating it was published in August 2024, and about 63 of some 200 posts were filled in the first round.</a:t>
+              <a:t>Schools with an unfilled post in a shortage subject, or officially classed as under-staffed, may sign a fixed-term contract with a teacher who retired five years ago or less. The school applies through an online form of the schools' administration directorate and the ministry authorises the contract within a yearly quota agreed with the finance ministry. Returners keep the full pension and receive an extra payment tied to the first step of the teacher salary scale, in proportion to the hours taught each week. The decree-law creating it was published in August 2024, and about 63 of some 200 posts were filled in the first round.</a:t>
             </a:r>
             <a:endParaRPr lang="en-US" sz="1500" dirty="0"/>
           </a:p>
@@ -13246,7 +13246,7 @@
                 <a:ea typeface="Calibri" pitchFamily="34" charset="-122"/>
                 <a:cs typeface="Calibri" pitchFamily="34" charset="-120"/>
               </a:rPr>
-              <a:t>A teacher coming back to the classroom starts with a counselling session and an assessment interview that set out what preparation the return needs, with the first hour free and the rest paid by the canton. In the first school year back, a teacher who has been away for eight years or more uses the university's induction programme free of charge: up to twenty-five hours of mentoring by an experienced colleague in their own school, individual and group supervision, coaching in their subject, and optional courses on grading, classroom management and working with parents. Returners are also encouraged to sit in on lessons before they start.</a:t>
+              <a:t>Returners start with a counselling session and an assessment interview that set out what preparation the return needs, with the first hour free and the rest paid by the canton. In the first school year back, a teacher who has been away for eight years or more uses the university's induction programme free of charge: up to twenty-five hours of mentoring by an experienced colleague in their own school, individual and group supervision, coaching in their subject, and optional courses on grading, classroom management and working with parents. Returners are also encouraged to sit in on lessons before they start.</a:t>
             </a:r>
             <a:endParaRPr lang="en-US" sz="1500" dirty="0"/>
           </a:p>
@@ -13887,7 +13887,7 @@
                 <a:ea typeface="Calibri" pitchFamily="34" charset="-122"/>
                 <a:cs typeface="Calibri" pitchFamily="34" charset="-120"/>
               </a:rPr>
-              <a:t>Any former teacher who asks is given a named adviser, who then works with them one to one, by phone, text or e-mail and for as long as they need. The adviser goes through the skills they gained while away, helps with applications and interviews, points them to refresher courses and professional qualifications, and passes on vacancies and webinars. It runs through the ‘Get Into Teaching’ service and was the channel for the ‘Come back to teaching’ campaign in January 2022. Returners are a large part of teacher supply: about 17,500 came back in 2023, some 38 percent of all qualified entrants.</a:t>
+              <a:t>Former teachers who ask are given a named adviser, who works with them one to one, by phone, text or e-mail and for as long as they need. The adviser goes through the skills they gained while away, helps with applications and interviews, points them to refresher courses and professional qualifications, and passes on vacancies and webinars. It runs through the ‘Get Into Teaching’ service and was the channel for the ‘Come back to teaching’ campaign in January 2022. Returners are a large part of teacher supply: about 17,500 came back in 2023, some 38 percent of all qualified entrants.</a:t>
             </a:r>
             <a:endParaRPr lang="en-US" sz="1500" dirty="0"/>
           </a:p>
@@ -16580,7 +16580,7 @@
                 <a:ea typeface="Calibri" pitchFamily="34" charset="-122"/>
                 <a:cs typeface="Calibri" pitchFamily="34" charset="-120"/>
               </a:rPr>
-              <a:t>A teacher who had retired with thirty or more years of service, and had been retired at least a year, could take a full-time classroom post in one of the three subjects of greatest need in their region and draw a full salary on top of the full pension. The regional education agency decided which subjects counted, usually special education, mathematics, science, English or elementary teaching. The district paid the pension contributions and the retiree earned no further pension rights. The narrow conditions kept numbers low: a state audit found about 350 retirees a year, under one percent of the state's teachers. The law expired on 30 June 2026 and was replaced by Senate Bill 150.</a:t>
+              <a:t>Teachers who had retired with thirty or more years of service, and had been retired at least a year, could take a full-time classroom post in one of the three subjects of greatest need in their region and draw a full salary on top of the full pension. The regional education agency decided which subjects counted, usually special education, mathematics, science, English or elementary teaching. The district paid the pension contributions and the retiree earned no further pension rights. The narrow conditions kept numbers low: a state audit found about 350 retirees a year, under one percent of the state's teachers. The law expired on 30 June 2026 and was replaced by Senate Bill 150.</a:t>
             </a:r>
             <a:endParaRPr lang="en-US" sz="1500" dirty="0"/>
           </a:p>
@@ -17264,7 +17264,7 @@
                 <a:ea typeface="Calibri" pitchFamily="34" charset="-122"/>
                 <a:cs typeface="Calibri" pitchFamily="34" charset="-120"/>
               </a:rPr>
-              <a:t>A retired teacher may take a post that has been declared a critical shortage, full-time or half-time, without the pension being suspended or reduced. The posts covered are classroom teachers, speech therapists and school counsellors. The retiree and the employer keep paying into the retirement system while the re-employment lasts, but the retiree earns no extra service credit or benefit from it. The state education department issued guidance for principals on how to use the rule. It is the most recent of several return-to-work laws passed since 2022, signed in May 2024.</a:t>
+              <a:t>Retired teachers may take a post that has been declared a critical shortage, full-time or half-time, without the pension being suspended or reduced. The posts covered are classroom teachers, speech therapists and school counsellors. The retiree and the employer keep paying into the retirement system while the re-employment lasts, but the retiree earns no extra service credit or benefit from it. The state education department issued guidance for principals on how to use the rule. It is the most recent of several return-to-work laws passed since 2022, signed in May 2024.</a:t>
             </a:r>
             <a:endParaRPr lang="en-US" sz="1500" dirty="0"/>
           </a:p>
@@ -20100,7 +20100,7 @@
                 <a:ea typeface="Calibri" pitchFamily="34" charset="-122"/>
                 <a:cs typeface="Calibri" pitchFamily="34" charset="-120"/>
               </a:rPr>
-              <a:t>A retired teacher or college lecturer may go back to work in a public school, college or university for up to three years with no limit on salary or hours and no loss of pension. The retiree applies to the state's Educational Retirement Board and must be approved before starting, so every return is on record. The law was signed in March 2022 and announced to retirees that June, opening the classroom to the state's roughly 48,000 retired educators at a time of severe shortages.</a:t>
+              <a:t>Retired teachers and college lecturers may go back to work in a public school, college or university for up to three years with no limit on salary or hours and no loss of pension. They apply to the state's Educational Retirement Board and must be approved before starting, so every return is on record. The law was signed in March 2022 and announced to retirees that June, opening the classroom to the state's roughly 48,000 retired educators at a time of severe shortages.</a:t>
             </a:r>
             <a:endParaRPr lang="en-US" sz="1500" dirty="0"/>
           </a:p>
@@ -20784,7 +20784,7 @@
                 <a:ea typeface="Calibri" pitchFamily="34" charset="-122"/>
                 <a:cs typeface="Calibri" pitchFamily="34" charset="-120"/>
               </a:rPr>
-              <a:t>A retired teacher could take a full-time classroom post and draw the state pension alongside the salary, which put a returning teacher about half as much again as a comparable colleague. Any district could hire a retired teacher back without penalty; it was a pension rule open to all rather than a programme with places. A 2024 study using state administrative data found that schools with many economically disadvantaged or Black pupils, the ones that struggle most to fill vacancies, hired a disproportionate share of these teachers. The provision ran from 1999 to 2009.</a:t>
+              <a:t>Retired teachers could take a full-time classroom post and draw the state pension alongside the salary, which put returners about half as much again as a comparable colleague. Any district could hire a retired teacher back without penalty; it was a pension rule open to all rather than a programme with places. A 2024 study using state administrative data found that schools with many economically disadvantaged or Black pupils, the ones that struggle most to fill vacancies, hired a disproportionate share of these teachers. The provision ran from 1999 to 2009.</a:t>
             </a:r>
             <a:endParaRPr lang="en-US" sz="1500" dirty="0"/>
           </a:p>
@@ -34745,7 +34745,7 @@
                 <a:ea typeface="Calibri" pitchFamily="34" charset="-122"/>
                 <a:cs typeface="Calibri" pitchFamily="34" charset="-120"/>
               </a:rPr>
-              <a:t>The regional education directorates, which run the schools in each province, wrote to teachers who had already retired and asked them to come back. In Vienna about 300 letters went out and, according to the public broadcaster (ORF), three teachers accepted. The directorate then passed the job to school principals, who put the question in person to staff approaching retirement age, usually offering reduced hours to stay on. A teacher who returns keeps the full pension and signs a separate contract paid on the beginner's salary scale. Take-up has stayed very low across the country, and an academic study points to pension and seniority rules as the main barrier.</a:t>
+              <a:t>The regional education directorates, which run the schools in each province, wrote to teachers who had already retired and asked them to come back. In Vienna about 300 letters went out and, according to the public broadcaster (ORF), three teachers accepted. The directorate then passed the job to school principals, who put the question in person to staff approaching retirement age, usually offering reduced hours to stay on. Returners keep the full pension and sign a separate contract paid on the beginner's salary scale. Take-up has stayed very low across the country, and an academic study points to pension and seniority rules as the main barrier.</a:t>
             </a:r>
             <a:endParaRPr lang="en-US" sz="1500" dirty="0"/>
           </a:p>
@@ -36117,7 +36117,7 @@
                 <a:ea typeface="Calibri" pitchFamily="34" charset="-122"/>
                 <a:cs typeface="Calibri" pitchFamily="34" charset="-120"/>
               </a:rPr>
-              <a:t>A retired teacher may work for a school board for up to fifty days in a school year and still draw the full pension; past that limit the pension stops for the rest of the year. The provincial government and the teachers' federation, which sponsor the pension plan together, have lifted the cap to ninety-five days when schools ran short of staff, as they did during and after the pandemic. Boards then had to report how they used retirees, so that the extra days did not take work from occasional teachers at the start of their careers. Teacher unions have argued that leaning on retirees is not a lasting answer to shortages.</a:t>
+              <a:t>Retired teachers may work for a school board for up to fifty days in a school year and still draw the full pension; past that limit the pension stops for the rest of the year. The provincial government and the teachers' federation, which sponsor the pension plan together, have lifted the cap to ninety-five days when schools ran short of staff, as they did during and after the pandemic. Boards then had to report how they used retirees, so that the extra days did not take work from occasional teachers at the start of their careers. Teacher unions have argued that leaning on retirees is not a lasting answer to shortages.</a:t>
             </a:r>
             <a:endParaRPr lang="en-US" sz="1500" dirty="0"/>
           </a:p>

</xml_diff>

<commit_message>
Deck: bigger instrument dots, and the definition circles back to the first version's green
The five dots grow again, to 0.62 inches, and the source block narrows so it
stays clear of them. The circles on the definition slides return to the dark
green on the pale card used in the first version of the deck.

Co-Authored-By: Claude Opus 5 <noreply@anthropic.com>
Claude-Session: https://claude.ai/code/session_01REVwghctKjYh8VQ919ThdA
</commit_message>
<xml_diff>
--- a/policies/Re-attracting_Former_Teachers.pptx
+++ b/policies/Re-attracting_Former_Teachers.pptx
@@ -4554,7 +4554,7 @@
         <p:spPr>
           <a:xfrm>
             <a:off x="457200" y="5303520"/>
-            <a:ext cx="8138160" cy="822960"/>
+            <a:ext cx="7589520" cy="822960"/>
           </a:xfrm>
           <a:prstGeom prst="rect">
             <a:avLst/>
@@ -4661,8 +4661,8 @@
         </p:nvSpPr>
         <p:spPr>
           <a:xfrm>
-            <a:off x="8695944" y="5815584"/>
-            <a:ext cx="475488" cy="475488"/>
+            <a:off x="8165592" y="5724144"/>
+            <a:ext cx="566928" cy="566928"/>
           </a:xfrm>
           <a:prstGeom prst="ellipse">
             <a:avLst/>
@@ -4694,8 +4694,8 @@
         </p:blipFill>
         <p:spPr>
           <a:xfrm>
-            <a:off x="8810061" y="5929701"/>
-            <a:ext cx="247254" cy="247254"/>
+            <a:off x="8301655" y="5860207"/>
+            <a:ext cx="294803" cy="294803"/>
           </a:xfrm>
           <a:prstGeom prst="rect">
             <a:avLst/>
@@ -4710,8 +4710,8 @@
         </p:nvSpPr>
         <p:spPr>
           <a:xfrm>
-            <a:off x="9336024" y="5815584"/>
-            <a:ext cx="475488" cy="475488"/>
+            <a:off x="8915400" y="5724144"/>
+            <a:ext cx="566928" cy="566928"/>
           </a:xfrm>
           <a:prstGeom prst="ellipse">
             <a:avLst/>
@@ -4743,8 +4743,8 @@
         </p:blipFill>
         <p:spPr>
           <a:xfrm>
-            <a:off x="9450141" y="5929701"/>
-            <a:ext cx="247254" cy="247254"/>
+            <a:off x="9051463" y="5860207"/>
+            <a:ext cx="294803" cy="294803"/>
           </a:xfrm>
           <a:prstGeom prst="rect">
             <a:avLst/>
@@ -4759,8 +4759,8 @@
         </p:nvSpPr>
         <p:spPr>
           <a:xfrm>
-            <a:off x="9976104" y="5815584"/>
-            <a:ext cx="475488" cy="475488"/>
+            <a:off x="9665208" y="5724144"/>
+            <a:ext cx="566928" cy="566928"/>
           </a:xfrm>
           <a:prstGeom prst="ellipse">
             <a:avLst/>
@@ -4792,8 +4792,8 @@
         </p:blipFill>
         <p:spPr>
           <a:xfrm>
-            <a:off x="10090221" y="5929701"/>
-            <a:ext cx="247254" cy="247254"/>
+            <a:off x="9801271" y="5860207"/>
+            <a:ext cx="294803" cy="294803"/>
           </a:xfrm>
           <a:prstGeom prst="rect">
             <a:avLst/>
@@ -4808,8 +4808,8 @@
         </p:nvSpPr>
         <p:spPr>
           <a:xfrm>
-            <a:off x="10616184" y="5815584"/>
-            <a:ext cx="475488" cy="475488"/>
+            <a:off x="10415016" y="5724144"/>
+            <a:ext cx="566928" cy="566928"/>
           </a:xfrm>
           <a:prstGeom prst="ellipse">
             <a:avLst/>
@@ -4841,8 +4841,8 @@
         </p:blipFill>
         <p:spPr>
           <a:xfrm>
-            <a:off x="10730301" y="5929701"/>
-            <a:ext cx="247254" cy="247254"/>
+            <a:off x="10551079" y="5860207"/>
+            <a:ext cx="294803" cy="294803"/>
           </a:xfrm>
           <a:prstGeom prst="rect">
             <a:avLst/>
@@ -4857,8 +4857,8 @@
         </p:nvSpPr>
         <p:spPr>
           <a:xfrm>
-            <a:off x="11256264" y="5815584"/>
-            <a:ext cx="475488" cy="475488"/>
+            <a:off x="11164824" y="5724144"/>
+            <a:ext cx="566928" cy="566928"/>
           </a:xfrm>
           <a:prstGeom prst="ellipse">
             <a:avLst/>
@@ -4890,8 +4890,8 @@
         </p:blipFill>
         <p:spPr>
           <a:xfrm>
-            <a:off x="11370381" y="5929701"/>
-            <a:ext cx="247254" cy="247254"/>
+            <a:off x="11300887" y="5860207"/>
+            <a:ext cx="294803" cy="294803"/>
           </a:xfrm>
           <a:prstGeom prst="rect">
             <a:avLst/>
@@ -4906,7 +4906,7 @@
         </p:nvSpPr>
         <p:spPr>
           <a:xfrm>
-            <a:off x="7132320" y="6355080"/>
+            <a:off x="7132320" y="6373368"/>
             <a:ext cx="4599432" cy="256032"/>
           </a:xfrm>
           <a:prstGeom prst="rect">
@@ -5276,7 +5276,7 @@
         <p:spPr>
           <a:xfrm>
             <a:off x="457200" y="5303520"/>
-            <a:ext cx="8138160" cy="822960"/>
+            <a:ext cx="7589520" cy="822960"/>
           </a:xfrm>
           <a:prstGeom prst="rect">
             <a:avLst/>
@@ -5383,8 +5383,8 @@
         </p:nvSpPr>
         <p:spPr>
           <a:xfrm>
-            <a:off x="8695944" y="5815584"/>
-            <a:ext cx="475488" cy="475488"/>
+            <a:off x="8165592" y="5724144"/>
+            <a:ext cx="566928" cy="566928"/>
           </a:xfrm>
           <a:prstGeom prst="ellipse">
             <a:avLst/>
@@ -5416,8 +5416,8 @@
         </p:blipFill>
         <p:spPr>
           <a:xfrm>
-            <a:off x="8810061" y="5929701"/>
-            <a:ext cx="247254" cy="247254"/>
+            <a:off x="8301655" y="5860207"/>
+            <a:ext cx="294803" cy="294803"/>
           </a:xfrm>
           <a:prstGeom prst="rect">
             <a:avLst/>
@@ -5432,8 +5432,8 @@
         </p:nvSpPr>
         <p:spPr>
           <a:xfrm>
-            <a:off x="9336024" y="5815584"/>
-            <a:ext cx="475488" cy="475488"/>
+            <a:off x="8915400" y="5724144"/>
+            <a:ext cx="566928" cy="566928"/>
           </a:xfrm>
           <a:prstGeom prst="ellipse">
             <a:avLst/>
@@ -5465,8 +5465,8 @@
         </p:blipFill>
         <p:spPr>
           <a:xfrm>
-            <a:off x="9450141" y="5929701"/>
-            <a:ext cx="247254" cy="247254"/>
+            <a:off x="9051463" y="5860207"/>
+            <a:ext cx="294803" cy="294803"/>
           </a:xfrm>
           <a:prstGeom prst="rect">
             <a:avLst/>
@@ -5481,8 +5481,8 @@
         </p:nvSpPr>
         <p:spPr>
           <a:xfrm>
-            <a:off x="9976104" y="5815584"/>
-            <a:ext cx="475488" cy="475488"/>
+            <a:off x="9665208" y="5724144"/>
+            <a:ext cx="566928" cy="566928"/>
           </a:xfrm>
           <a:prstGeom prst="ellipse">
             <a:avLst/>
@@ -5514,8 +5514,8 @@
         </p:blipFill>
         <p:spPr>
           <a:xfrm>
-            <a:off x="10090221" y="5929701"/>
-            <a:ext cx="247254" cy="247254"/>
+            <a:off x="9801271" y="5860207"/>
+            <a:ext cx="294803" cy="294803"/>
           </a:xfrm>
           <a:prstGeom prst="rect">
             <a:avLst/>
@@ -5530,8 +5530,8 @@
         </p:nvSpPr>
         <p:spPr>
           <a:xfrm>
-            <a:off x="10616184" y="5815584"/>
-            <a:ext cx="475488" cy="475488"/>
+            <a:off x="10415016" y="5724144"/>
+            <a:ext cx="566928" cy="566928"/>
           </a:xfrm>
           <a:prstGeom prst="ellipse">
             <a:avLst/>
@@ -5563,8 +5563,8 @@
         </p:blipFill>
         <p:spPr>
           <a:xfrm>
-            <a:off x="10730301" y="5929701"/>
-            <a:ext cx="247254" cy="247254"/>
+            <a:off x="10551079" y="5860207"/>
+            <a:ext cx="294803" cy="294803"/>
           </a:xfrm>
           <a:prstGeom prst="rect">
             <a:avLst/>
@@ -5579,8 +5579,8 @@
         </p:nvSpPr>
         <p:spPr>
           <a:xfrm>
-            <a:off x="11256264" y="5815584"/>
-            <a:ext cx="475488" cy="475488"/>
+            <a:off x="11164824" y="5724144"/>
+            <a:ext cx="566928" cy="566928"/>
           </a:xfrm>
           <a:prstGeom prst="ellipse">
             <a:avLst/>
@@ -5612,8 +5612,8 @@
         </p:blipFill>
         <p:spPr>
           <a:xfrm>
-            <a:off x="11370381" y="5929701"/>
-            <a:ext cx="247254" cy="247254"/>
+            <a:off x="11300887" y="5860207"/>
+            <a:ext cx="294803" cy="294803"/>
           </a:xfrm>
           <a:prstGeom prst="rect">
             <a:avLst/>
@@ -5628,7 +5628,7 @@
         </p:nvSpPr>
         <p:spPr>
           <a:xfrm>
-            <a:off x="7132320" y="6355080"/>
+            <a:off x="7132320" y="6373368"/>
             <a:ext cx="4599432" cy="256032"/>
           </a:xfrm>
           <a:prstGeom prst="rect">
@@ -5998,7 +5998,7 @@
         <p:spPr>
           <a:xfrm>
             <a:off x="457200" y="5303520"/>
-            <a:ext cx="8138160" cy="822960"/>
+            <a:ext cx="7589520" cy="822960"/>
           </a:xfrm>
           <a:prstGeom prst="rect">
             <a:avLst/>
@@ -6105,8 +6105,8 @@
         </p:nvSpPr>
         <p:spPr>
           <a:xfrm>
-            <a:off x="8695944" y="5815584"/>
-            <a:ext cx="475488" cy="475488"/>
+            <a:off x="8165592" y="5724144"/>
+            <a:ext cx="566928" cy="566928"/>
           </a:xfrm>
           <a:prstGeom prst="ellipse">
             <a:avLst/>
@@ -6138,8 +6138,8 @@
         </p:blipFill>
         <p:spPr>
           <a:xfrm>
-            <a:off x="8810061" y="5929701"/>
-            <a:ext cx="247254" cy="247254"/>
+            <a:off x="8301655" y="5860207"/>
+            <a:ext cx="294803" cy="294803"/>
           </a:xfrm>
           <a:prstGeom prst="rect">
             <a:avLst/>
@@ -6154,8 +6154,8 @@
         </p:nvSpPr>
         <p:spPr>
           <a:xfrm>
-            <a:off x="9336024" y="5815584"/>
-            <a:ext cx="475488" cy="475488"/>
+            <a:off x="8915400" y="5724144"/>
+            <a:ext cx="566928" cy="566928"/>
           </a:xfrm>
           <a:prstGeom prst="ellipse">
             <a:avLst/>
@@ -6187,8 +6187,8 @@
         </p:blipFill>
         <p:spPr>
           <a:xfrm>
-            <a:off x="9450141" y="5929701"/>
-            <a:ext cx="247254" cy="247254"/>
+            <a:off x="9051463" y="5860207"/>
+            <a:ext cx="294803" cy="294803"/>
           </a:xfrm>
           <a:prstGeom prst="rect">
             <a:avLst/>
@@ -6203,8 +6203,8 @@
         </p:nvSpPr>
         <p:spPr>
           <a:xfrm>
-            <a:off x="9976104" y="5815584"/>
-            <a:ext cx="475488" cy="475488"/>
+            <a:off x="9665208" y="5724144"/>
+            <a:ext cx="566928" cy="566928"/>
           </a:xfrm>
           <a:prstGeom prst="ellipse">
             <a:avLst/>
@@ -6236,8 +6236,8 @@
         </p:blipFill>
         <p:spPr>
           <a:xfrm>
-            <a:off x="10090221" y="5929701"/>
-            <a:ext cx="247254" cy="247254"/>
+            <a:off x="9801271" y="5860207"/>
+            <a:ext cx="294803" cy="294803"/>
           </a:xfrm>
           <a:prstGeom prst="rect">
             <a:avLst/>
@@ -6252,8 +6252,8 @@
         </p:nvSpPr>
         <p:spPr>
           <a:xfrm>
-            <a:off x="10616184" y="5815584"/>
-            <a:ext cx="475488" cy="475488"/>
+            <a:off x="10415016" y="5724144"/>
+            <a:ext cx="566928" cy="566928"/>
           </a:xfrm>
           <a:prstGeom prst="ellipse">
             <a:avLst/>
@@ -6285,8 +6285,8 @@
         </p:blipFill>
         <p:spPr>
           <a:xfrm>
-            <a:off x="10730301" y="5929701"/>
-            <a:ext cx="247254" cy="247254"/>
+            <a:off x="10551079" y="5860207"/>
+            <a:ext cx="294803" cy="294803"/>
           </a:xfrm>
           <a:prstGeom prst="rect">
             <a:avLst/>
@@ -6301,8 +6301,8 @@
         </p:nvSpPr>
         <p:spPr>
           <a:xfrm>
-            <a:off x="11256264" y="5815584"/>
-            <a:ext cx="475488" cy="475488"/>
+            <a:off x="11164824" y="5724144"/>
+            <a:ext cx="566928" cy="566928"/>
           </a:xfrm>
           <a:prstGeom prst="ellipse">
             <a:avLst/>
@@ -6334,8 +6334,8 @@
         </p:blipFill>
         <p:spPr>
           <a:xfrm>
-            <a:off x="11370381" y="5929701"/>
-            <a:ext cx="247254" cy="247254"/>
+            <a:off x="11300887" y="5860207"/>
+            <a:ext cx="294803" cy="294803"/>
           </a:xfrm>
           <a:prstGeom prst="rect">
             <a:avLst/>
@@ -6350,7 +6350,7 @@
         </p:nvSpPr>
         <p:spPr>
           <a:xfrm>
-            <a:off x="7132320" y="6355080"/>
+            <a:off x="7132320" y="6373368"/>
             <a:ext cx="4599432" cy="256032"/>
           </a:xfrm>
           <a:prstGeom prst="rect">
@@ -6759,7 +6759,7 @@
         <p:spPr>
           <a:xfrm>
             <a:off x="457200" y="5303520"/>
-            <a:ext cx="8138160" cy="822960"/>
+            <a:ext cx="7589520" cy="822960"/>
           </a:xfrm>
           <a:prstGeom prst="rect">
             <a:avLst/>
@@ -6866,8 +6866,8 @@
         </p:nvSpPr>
         <p:spPr>
           <a:xfrm>
-            <a:off x="8695944" y="5815584"/>
-            <a:ext cx="475488" cy="475488"/>
+            <a:off x="8165592" y="5724144"/>
+            <a:ext cx="566928" cy="566928"/>
           </a:xfrm>
           <a:prstGeom prst="ellipse">
             <a:avLst/>
@@ -6899,8 +6899,8 @@
         </p:blipFill>
         <p:spPr>
           <a:xfrm>
-            <a:off x="8810061" y="5929701"/>
-            <a:ext cx="247254" cy="247254"/>
+            <a:off x="8301655" y="5860207"/>
+            <a:ext cx="294803" cy="294803"/>
           </a:xfrm>
           <a:prstGeom prst="rect">
             <a:avLst/>
@@ -6915,8 +6915,8 @@
         </p:nvSpPr>
         <p:spPr>
           <a:xfrm>
-            <a:off x="9336024" y="5815584"/>
-            <a:ext cx="475488" cy="475488"/>
+            <a:off x="8915400" y="5724144"/>
+            <a:ext cx="566928" cy="566928"/>
           </a:xfrm>
           <a:prstGeom prst="ellipse">
             <a:avLst/>
@@ -6948,8 +6948,8 @@
         </p:blipFill>
         <p:spPr>
           <a:xfrm>
-            <a:off x="9450141" y="5929701"/>
-            <a:ext cx="247254" cy="247254"/>
+            <a:off x="9051463" y="5860207"/>
+            <a:ext cx="294803" cy="294803"/>
           </a:xfrm>
           <a:prstGeom prst="rect">
             <a:avLst/>
@@ -6964,8 +6964,8 @@
         </p:nvSpPr>
         <p:spPr>
           <a:xfrm>
-            <a:off x="9976104" y="5815584"/>
-            <a:ext cx="475488" cy="475488"/>
+            <a:off x="9665208" y="5724144"/>
+            <a:ext cx="566928" cy="566928"/>
           </a:xfrm>
           <a:prstGeom prst="ellipse">
             <a:avLst/>
@@ -6997,8 +6997,8 @@
         </p:blipFill>
         <p:spPr>
           <a:xfrm>
-            <a:off x="10090221" y="5929701"/>
-            <a:ext cx="247254" cy="247254"/>
+            <a:off x="9801271" y="5860207"/>
+            <a:ext cx="294803" cy="294803"/>
           </a:xfrm>
           <a:prstGeom prst="rect">
             <a:avLst/>
@@ -7013,8 +7013,8 @@
         </p:nvSpPr>
         <p:spPr>
           <a:xfrm>
-            <a:off x="10616184" y="5815584"/>
-            <a:ext cx="475488" cy="475488"/>
+            <a:off x="10415016" y="5724144"/>
+            <a:ext cx="566928" cy="566928"/>
           </a:xfrm>
           <a:prstGeom prst="ellipse">
             <a:avLst/>
@@ -7046,8 +7046,8 @@
         </p:blipFill>
         <p:spPr>
           <a:xfrm>
-            <a:off x="10730301" y="5929701"/>
-            <a:ext cx="247254" cy="247254"/>
+            <a:off x="10551079" y="5860207"/>
+            <a:ext cx="294803" cy="294803"/>
           </a:xfrm>
           <a:prstGeom prst="rect">
             <a:avLst/>
@@ -7062,8 +7062,8 @@
         </p:nvSpPr>
         <p:spPr>
           <a:xfrm>
-            <a:off x="11256264" y="5815584"/>
-            <a:ext cx="475488" cy="475488"/>
+            <a:off x="11164824" y="5724144"/>
+            <a:ext cx="566928" cy="566928"/>
           </a:xfrm>
           <a:prstGeom prst="ellipse">
             <a:avLst/>
@@ -7095,8 +7095,8 @@
         </p:blipFill>
         <p:spPr>
           <a:xfrm>
-            <a:off x="11370381" y="5929701"/>
-            <a:ext cx="247254" cy="247254"/>
+            <a:off x="11300887" y="5860207"/>
+            <a:ext cx="294803" cy="294803"/>
           </a:xfrm>
           <a:prstGeom prst="rect">
             <a:avLst/>
@@ -7111,7 +7111,7 @@
         </p:nvSpPr>
         <p:spPr>
           <a:xfrm>
-            <a:off x="7132320" y="6355080"/>
+            <a:off x="7132320" y="6373368"/>
             <a:ext cx="4599432" cy="256032"/>
           </a:xfrm>
           <a:prstGeom prst="rect">
@@ -7520,7 +7520,7 @@
         <p:spPr>
           <a:xfrm>
             <a:off x="457200" y="5303520"/>
-            <a:ext cx="8138160" cy="822960"/>
+            <a:ext cx="7589520" cy="822960"/>
           </a:xfrm>
           <a:prstGeom prst="rect">
             <a:avLst/>
@@ -7627,8 +7627,8 @@
         </p:nvSpPr>
         <p:spPr>
           <a:xfrm>
-            <a:off x="8695944" y="5815584"/>
-            <a:ext cx="475488" cy="475488"/>
+            <a:off x="8165592" y="5724144"/>
+            <a:ext cx="566928" cy="566928"/>
           </a:xfrm>
           <a:prstGeom prst="ellipse">
             <a:avLst/>
@@ -7660,8 +7660,8 @@
         </p:blipFill>
         <p:spPr>
           <a:xfrm>
-            <a:off x="8810061" y="5929701"/>
-            <a:ext cx="247254" cy="247254"/>
+            <a:off x="8301655" y="5860207"/>
+            <a:ext cx="294803" cy="294803"/>
           </a:xfrm>
           <a:prstGeom prst="rect">
             <a:avLst/>
@@ -7676,8 +7676,8 @@
         </p:nvSpPr>
         <p:spPr>
           <a:xfrm>
-            <a:off x="9336024" y="5815584"/>
-            <a:ext cx="475488" cy="475488"/>
+            <a:off x="8915400" y="5724144"/>
+            <a:ext cx="566928" cy="566928"/>
           </a:xfrm>
           <a:prstGeom prst="ellipse">
             <a:avLst/>
@@ -7709,8 +7709,8 @@
         </p:blipFill>
         <p:spPr>
           <a:xfrm>
-            <a:off x="9450141" y="5929701"/>
-            <a:ext cx="247254" cy="247254"/>
+            <a:off x="9051463" y="5860207"/>
+            <a:ext cx="294803" cy="294803"/>
           </a:xfrm>
           <a:prstGeom prst="rect">
             <a:avLst/>
@@ -7725,8 +7725,8 @@
         </p:nvSpPr>
         <p:spPr>
           <a:xfrm>
-            <a:off x="9976104" y="5815584"/>
-            <a:ext cx="475488" cy="475488"/>
+            <a:off x="9665208" y="5724144"/>
+            <a:ext cx="566928" cy="566928"/>
           </a:xfrm>
           <a:prstGeom prst="ellipse">
             <a:avLst/>
@@ -7758,8 +7758,8 @@
         </p:blipFill>
         <p:spPr>
           <a:xfrm>
-            <a:off x="10090221" y="5929701"/>
-            <a:ext cx="247254" cy="247254"/>
+            <a:off x="9801271" y="5860207"/>
+            <a:ext cx="294803" cy="294803"/>
           </a:xfrm>
           <a:prstGeom prst="rect">
             <a:avLst/>
@@ -7774,8 +7774,8 @@
         </p:nvSpPr>
         <p:spPr>
           <a:xfrm>
-            <a:off x="10616184" y="5815584"/>
-            <a:ext cx="475488" cy="475488"/>
+            <a:off x="10415016" y="5724144"/>
+            <a:ext cx="566928" cy="566928"/>
           </a:xfrm>
           <a:prstGeom prst="ellipse">
             <a:avLst/>
@@ -7807,8 +7807,8 @@
         </p:blipFill>
         <p:spPr>
           <a:xfrm>
-            <a:off x="10730301" y="5929701"/>
-            <a:ext cx="247254" cy="247254"/>
+            <a:off x="10551079" y="5860207"/>
+            <a:ext cx="294803" cy="294803"/>
           </a:xfrm>
           <a:prstGeom prst="rect">
             <a:avLst/>
@@ -7823,8 +7823,8 @@
         </p:nvSpPr>
         <p:spPr>
           <a:xfrm>
-            <a:off x="11256264" y="5815584"/>
-            <a:ext cx="475488" cy="475488"/>
+            <a:off x="11164824" y="5724144"/>
+            <a:ext cx="566928" cy="566928"/>
           </a:xfrm>
           <a:prstGeom prst="ellipse">
             <a:avLst/>
@@ -7856,8 +7856,8 @@
         </p:blipFill>
         <p:spPr>
           <a:xfrm>
-            <a:off x="11370381" y="5929701"/>
-            <a:ext cx="247254" cy="247254"/>
+            <a:off x="11300887" y="5860207"/>
+            <a:ext cx="294803" cy="294803"/>
           </a:xfrm>
           <a:prstGeom prst="rect">
             <a:avLst/>
@@ -7872,7 +7872,7 @@
         </p:nvSpPr>
         <p:spPr>
           <a:xfrm>
-            <a:off x="7132320" y="6355080"/>
+            <a:off x="7132320" y="6373368"/>
             <a:ext cx="4599432" cy="256032"/>
           </a:xfrm>
           <a:prstGeom prst="rect">
@@ -8242,7 +8242,7 @@
         <p:spPr>
           <a:xfrm>
             <a:off x="457200" y="5303520"/>
-            <a:ext cx="8138160" cy="822960"/>
+            <a:ext cx="7589520" cy="822960"/>
           </a:xfrm>
           <a:prstGeom prst="rect">
             <a:avLst/>
@@ -8306,8 +8306,8 @@
         </p:nvSpPr>
         <p:spPr>
           <a:xfrm>
-            <a:off x="8695944" y="5815584"/>
-            <a:ext cx="475488" cy="475488"/>
+            <a:off x="8165592" y="5724144"/>
+            <a:ext cx="566928" cy="566928"/>
           </a:xfrm>
           <a:prstGeom prst="ellipse">
             <a:avLst/>
@@ -8339,8 +8339,8 @@
         </p:blipFill>
         <p:spPr>
           <a:xfrm>
-            <a:off x="8810061" y="5929701"/>
-            <a:ext cx="247254" cy="247254"/>
+            <a:off x="8301655" y="5860207"/>
+            <a:ext cx="294803" cy="294803"/>
           </a:xfrm>
           <a:prstGeom prst="rect">
             <a:avLst/>
@@ -8355,8 +8355,8 @@
         </p:nvSpPr>
         <p:spPr>
           <a:xfrm>
-            <a:off x="9336024" y="5815584"/>
-            <a:ext cx="475488" cy="475488"/>
+            <a:off x="8915400" y="5724144"/>
+            <a:ext cx="566928" cy="566928"/>
           </a:xfrm>
           <a:prstGeom prst="ellipse">
             <a:avLst/>
@@ -8388,8 +8388,8 @@
         </p:blipFill>
         <p:spPr>
           <a:xfrm>
-            <a:off x="9450141" y="5929701"/>
-            <a:ext cx="247254" cy="247254"/>
+            <a:off x="9051463" y="5860207"/>
+            <a:ext cx="294803" cy="294803"/>
           </a:xfrm>
           <a:prstGeom prst="rect">
             <a:avLst/>
@@ -8404,8 +8404,8 @@
         </p:nvSpPr>
         <p:spPr>
           <a:xfrm>
-            <a:off x="9976104" y="5815584"/>
-            <a:ext cx="475488" cy="475488"/>
+            <a:off x="9665208" y="5724144"/>
+            <a:ext cx="566928" cy="566928"/>
           </a:xfrm>
           <a:prstGeom prst="ellipse">
             <a:avLst/>
@@ -8437,8 +8437,8 @@
         </p:blipFill>
         <p:spPr>
           <a:xfrm>
-            <a:off x="10090221" y="5929701"/>
-            <a:ext cx="247254" cy="247254"/>
+            <a:off x="9801271" y="5860207"/>
+            <a:ext cx="294803" cy="294803"/>
           </a:xfrm>
           <a:prstGeom prst="rect">
             <a:avLst/>
@@ -8453,8 +8453,8 @@
         </p:nvSpPr>
         <p:spPr>
           <a:xfrm>
-            <a:off x="10616184" y="5815584"/>
-            <a:ext cx="475488" cy="475488"/>
+            <a:off x="10415016" y="5724144"/>
+            <a:ext cx="566928" cy="566928"/>
           </a:xfrm>
           <a:prstGeom prst="ellipse">
             <a:avLst/>
@@ -8486,8 +8486,8 @@
         </p:blipFill>
         <p:spPr>
           <a:xfrm>
-            <a:off x="10730301" y="5929701"/>
-            <a:ext cx="247254" cy="247254"/>
+            <a:off x="10551079" y="5860207"/>
+            <a:ext cx="294803" cy="294803"/>
           </a:xfrm>
           <a:prstGeom prst="rect">
             <a:avLst/>
@@ -8502,8 +8502,8 @@
         </p:nvSpPr>
         <p:spPr>
           <a:xfrm>
-            <a:off x="11256264" y="5815584"/>
-            <a:ext cx="475488" cy="475488"/>
+            <a:off x="11164824" y="5724144"/>
+            <a:ext cx="566928" cy="566928"/>
           </a:xfrm>
           <a:prstGeom prst="ellipse">
             <a:avLst/>
@@ -8535,8 +8535,8 @@
         </p:blipFill>
         <p:spPr>
           <a:xfrm>
-            <a:off x="11370381" y="5929701"/>
-            <a:ext cx="247254" cy="247254"/>
+            <a:off x="11300887" y="5860207"/>
+            <a:ext cx="294803" cy="294803"/>
           </a:xfrm>
           <a:prstGeom prst="rect">
             <a:avLst/>
@@ -8551,7 +8551,7 @@
         </p:nvSpPr>
         <p:spPr>
           <a:xfrm>
-            <a:off x="7132320" y="6355080"/>
+            <a:off x="7132320" y="6373368"/>
             <a:ext cx="4599432" cy="256032"/>
           </a:xfrm>
           <a:prstGeom prst="rect">
@@ -8921,7 +8921,7 @@
         <p:spPr>
           <a:xfrm>
             <a:off x="457200" y="5303520"/>
-            <a:ext cx="8138160" cy="822960"/>
+            <a:ext cx="7589520" cy="822960"/>
           </a:xfrm>
           <a:prstGeom prst="rect">
             <a:avLst/>
@@ -9028,8 +9028,8 @@
         </p:nvSpPr>
         <p:spPr>
           <a:xfrm>
-            <a:off x="8695944" y="5815584"/>
-            <a:ext cx="475488" cy="475488"/>
+            <a:off x="8165592" y="5724144"/>
+            <a:ext cx="566928" cy="566928"/>
           </a:xfrm>
           <a:prstGeom prst="ellipse">
             <a:avLst/>
@@ -9061,8 +9061,8 @@
         </p:blipFill>
         <p:spPr>
           <a:xfrm>
-            <a:off x="8810061" y="5929701"/>
-            <a:ext cx="247254" cy="247254"/>
+            <a:off x="8301655" y="5860207"/>
+            <a:ext cx="294803" cy="294803"/>
           </a:xfrm>
           <a:prstGeom prst="rect">
             <a:avLst/>
@@ -9077,8 +9077,8 @@
         </p:nvSpPr>
         <p:spPr>
           <a:xfrm>
-            <a:off x="9336024" y="5815584"/>
-            <a:ext cx="475488" cy="475488"/>
+            <a:off x="8915400" y="5724144"/>
+            <a:ext cx="566928" cy="566928"/>
           </a:xfrm>
           <a:prstGeom prst="ellipse">
             <a:avLst/>
@@ -9110,8 +9110,8 @@
         </p:blipFill>
         <p:spPr>
           <a:xfrm>
-            <a:off x="9450141" y="5929701"/>
-            <a:ext cx="247254" cy="247254"/>
+            <a:off x="9051463" y="5860207"/>
+            <a:ext cx="294803" cy="294803"/>
           </a:xfrm>
           <a:prstGeom prst="rect">
             <a:avLst/>
@@ -9126,8 +9126,8 @@
         </p:nvSpPr>
         <p:spPr>
           <a:xfrm>
-            <a:off x="9976104" y="5815584"/>
-            <a:ext cx="475488" cy="475488"/>
+            <a:off x="9665208" y="5724144"/>
+            <a:ext cx="566928" cy="566928"/>
           </a:xfrm>
           <a:prstGeom prst="ellipse">
             <a:avLst/>
@@ -9159,8 +9159,8 @@
         </p:blipFill>
         <p:spPr>
           <a:xfrm>
-            <a:off x="10090221" y="5929701"/>
-            <a:ext cx="247254" cy="247254"/>
+            <a:off x="9801271" y="5860207"/>
+            <a:ext cx="294803" cy="294803"/>
           </a:xfrm>
           <a:prstGeom prst="rect">
             <a:avLst/>
@@ -9175,8 +9175,8 @@
         </p:nvSpPr>
         <p:spPr>
           <a:xfrm>
-            <a:off x="10616184" y="5815584"/>
-            <a:ext cx="475488" cy="475488"/>
+            <a:off x="10415016" y="5724144"/>
+            <a:ext cx="566928" cy="566928"/>
           </a:xfrm>
           <a:prstGeom prst="ellipse">
             <a:avLst/>
@@ -9208,8 +9208,8 @@
         </p:blipFill>
         <p:spPr>
           <a:xfrm>
-            <a:off x="10730301" y="5929701"/>
-            <a:ext cx="247254" cy="247254"/>
+            <a:off x="10551079" y="5860207"/>
+            <a:ext cx="294803" cy="294803"/>
           </a:xfrm>
           <a:prstGeom prst="rect">
             <a:avLst/>
@@ -9224,8 +9224,8 @@
         </p:nvSpPr>
         <p:spPr>
           <a:xfrm>
-            <a:off x="11256264" y="5815584"/>
-            <a:ext cx="475488" cy="475488"/>
+            <a:off x="11164824" y="5724144"/>
+            <a:ext cx="566928" cy="566928"/>
           </a:xfrm>
           <a:prstGeom prst="ellipse">
             <a:avLst/>
@@ -9257,8 +9257,8 @@
         </p:blipFill>
         <p:spPr>
           <a:xfrm>
-            <a:off x="11370381" y="5929701"/>
-            <a:ext cx="247254" cy="247254"/>
+            <a:off x="11300887" y="5860207"/>
+            <a:ext cx="294803" cy="294803"/>
           </a:xfrm>
           <a:prstGeom prst="rect">
             <a:avLst/>
@@ -9273,7 +9273,7 @@
         </p:nvSpPr>
         <p:spPr>
           <a:xfrm>
-            <a:off x="7132320" y="6355080"/>
+            <a:off x="7132320" y="6373368"/>
             <a:ext cx="4599432" cy="256032"/>
           </a:xfrm>
           <a:prstGeom prst="rect">
@@ -9643,7 +9643,7 @@
         <p:spPr>
           <a:xfrm>
             <a:off x="457200" y="5303520"/>
-            <a:ext cx="8138160" cy="822960"/>
+            <a:ext cx="7589520" cy="822960"/>
           </a:xfrm>
           <a:prstGeom prst="rect">
             <a:avLst/>
@@ -9750,8 +9750,8 @@
         </p:nvSpPr>
         <p:spPr>
           <a:xfrm>
-            <a:off x="8695944" y="5815584"/>
-            <a:ext cx="475488" cy="475488"/>
+            <a:off x="8165592" y="5724144"/>
+            <a:ext cx="566928" cy="566928"/>
           </a:xfrm>
           <a:prstGeom prst="ellipse">
             <a:avLst/>
@@ -9783,8 +9783,8 @@
         </p:blipFill>
         <p:spPr>
           <a:xfrm>
-            <a:off x="8810061" y="5929701"/>
-            <a:ext cx="247254" cy="247254"/>
+            <a:off x="8301655" y="5860207"/>
+            <a:ext cx="294803" cy="294803"/>
           </a:xfrm>
           <a:prstGeom prst="rect">
             <a:avLst/>
@@ -9799,8 +9799,8 @@
         </p:nvSpPr>
         <p:spPr>
           <a:xfrm>
-            <a:off x="9336024" y="5815584"/>
-            <a:ext cx="475488" cy="475488"/>
+            <a:off x="8915400" y="5724144"/>
+            <a:ext cx="566928" cy="566928"/>
           </a:xfrm>
           <a:prstGeom prst="ellipse">
             <a:avLst/>
@@ -9832,8 +9832,8 @@
         </p:blipFill>
         <p:spPr>
           <a:xfrm>
-            <a:off x="9450141" y="5929701"/>
-            <a:ext cx="247254" cy="247254"/>
+            <a:off x="9051463" y="5860207"/>
+            <a:ext cx="294803" cy="294803"/>
           </a:xfrm>
           <a:prstGeom prst="rect">
             <a:avLst/>
@@ -9848,8 +9848,8 @@
         </p:nvSpPr>
         <p:spPr>
           <a:xfrm>
-            <a:off x="9976104" y="5815584"/>
-            <a:ext cx="475488" cy="475488"/>
+            <a:off x="9665208" y="5724144"/>
+            <a:ext cx="566928" cy="566928"/>
           </a:xfrm>
           <a:prstGeom prst="ellipse">
             <a:avLst/>
@@ -9881,8 +9881,8 @@
         </p:blipFill>
         <p:spPr>
           <a:xfrm>
-            <a:off x="10090221" y="5929701"/>
-            <a:ext cx="247254" cy="247254"/>
+            <a:off x="9801271" y="5860207"/>
+            <a:ext cx="294803" cy="294803"/>
           </a:xfrm>
           <a:prstGeom prst="rect">
             <a:avLst/>
@@ -9897,8 +9897,8 @@
         </p:nvSpPr>
         <p:spPr>
           <a:xfrm>
-            <a:off x="10616184" y="5815584"/>
-            <a:ext cx="475488" cy="475488"/>
+            <a:off x="10415016" y="5724144"/>
+            <a:ext cx="566928" cy="566928"/>
           </a:xfrm>
           <a:prstGeom prst="ellipse">
             <a:avLst/>
@@ -9930,8 +9930,8 @@
         </p:blipFill>
         <p:spPr>
           <a:xfrm>
-            <a:off x="10730301" y="5929701"/>
-            <a:ext cx="247254" cy="247254"/>
+            <a:off x="10551079" y="5860207"/>
+            <a:ext cx="294803" cy="294803"/>
           </a:xfrm>
           <a:prstGeom prst="rect">
             <a:avLst/>
@@ -9946,8 +9946,8 @@
         </p:nvSpPr>
         <p:spPr>
           <a:xfrm>
-            <a:off x="11256264" y="5815584"/>
-            <a:ext cx="475488" cy="475488"/>
+            <a:off x="11164824" y="5724144"/>
+            <a:ext cx="566928" cy="566928"/>
           </a:xfrm>
           <a:prstGeom prst="ellipse">
             <a:avLst/>
@@ -9979,8 +9979,8 @@
         </p:blipFill>
         <p:spPr>
           <a:xfrm>
-            <a:off x="11370381" y="5929701"/>
-            <a:ext cx="247254" cy="247254"/>
+            <a:off x="11300887" y="5860207"/>
+            <a:ext cx="294803" cy="294803"/>
           </a:xfrm>
           <a:prstGeom prst="rect">
             <a:avLst/>
@@ -9995,7 +9995,7 @@
         </p:nvSpPr>
         <p:spPr>
           <a:xfrm>
-            <a:off x="7132320" y="6355080"/>
+            <a:off x="7132320" y="6373368"/>
             <a:ext cx="4599432" cy="256032"/>
           </a:xfrm>
           <a:prstGeom prst="rect">
@@ -10365,7 +10365,7 @@
         <p:spPr>
           <a:xfrm>
             <a:off x="457200" y="5303520"/>
-            <a:ext cx="8138160" cy="822960"/>
+            <a:ext cx="7589520" cy="822960"/>
           </a:xfrm>
           <a:prstGeom prst="rect">
             <a:avLst/>
@@ -10472,8 +10472,8 @@
         </p:nvSpPr>
         <p:spPr>
           <a:xfrm>
-            <a:off x="8695944" y="5815584"/>
-            <a:ext cx="475488" cy="475488"/>
+            <a:off x="8165592" y="5724144"/>
+            <a:ext cx="566928" cy="566928"/>
           </a:xfrm>
           <a:prstGeom prst="ellipse">
             <a:avLst/>
@@ -10505,8 +10505,8 @@
         </p:blipFill>
         <p:spPr>
           <a:xfrm>
-            <a:off x="8810061" y="5929701"/>
-            <a:ext cx="247254" cy="247254"/>
+            <a:off x="8301655" y="5860207"/>
+            <a:ext cx="294803" cy="294803"/>
           </a:xfrm>
           <a:prstGeom prst="rect">
             <a:avLst/>
@@ -10521,8 +10521,8 @@
         </p:nvSpPr>
         <p:spPr>
           <a:xfrm>
-            <a:off x="9336024" y="5815584"/>
-            <a:ext cx="475488" cy="475488"/>
+            <a:off x="8915400" y="5724144"/>
+            <a:ext cx="566928" cy="566928"/>
           </a:xfrm>
           <a:prstGeom prst="ellipse">
             <a:avLst/>
@@ -10554,8 +10554,8 @@
         </p:blipFill>
         <p:spPr>
           <a:xfrm>
-            <a:off x="9450141" y="5929701"/>
-            <a:ext cx="247254" cy="247254"/>
+            <a:off x="9051463" y="5860207"/>
+            <a:ext cx="294803" cy="294803"/>
           </a:xfrm>
           <a:prstGeom prst="rect">
             <a:avLst/>
@@ -10570,8 +10570,8 @@
         </p:nvSpPr>
         <p:spPr>
           <a:xfrm>
-            <a:off x="9976104" y="5815584"/>
-            <a:ext cx="475488" cy="475488"/>
+            <a:off x="9665208" y="5724144"/>
+            <a:ext cx="566928" cy="566928"/>
           </a:xfrm>
           <a:prstGeom prst="ellipse">
             <a:avLst/>
@@ -10603,8 +10603,8 @@
         </p:blipFill>
         <p:spPr>
           <a:xfrm>
-            <a:off x="10090221" y="5929701"/>
-            <a:ext cx="247254" cy="247254"/>
+            <a:off x="9801271" y="5860207"/>
+            <a:ext cx="294803" cy="294803"/>
           </a:xfrm>
           <a:prstGeom prst="rect">
             <a:avLst/>
@@ -10619,8 +10619,8 @@
         </p:nvSpPr>
         <p:spPr>
           <a:xfrm>
-            <a:off x="10616184" y="5815584"/>
-            <a:ext cx="475488" cy="475488"/>
+            <a:off x="10415016" y="5724144"/>
+            <a:ext cx="566928" cy="566928"/>
           </a:xfrm>
           <a:prstGeom prst="ellipse">
             <a:avLst/>
@@ -10652,8 +10652,8 @@
         </p:blipFill>
         <p:spPr>
           <a:xfrm>
-            <a:off x="10730301" y="5929701"/>
-            <a:ext cx="247254" cy="247254"/>
+            <a:off x="10551079" y="5860207"/>
+            <a:ext cx="294803" cy="294803"/>
           </a:xfrm>
           <a:prstGeom prst="rect">
             <a:avLst/>
@@ -10668,8 +10668,8 @@
         </p:nvSpPr>
         <p:spPr>
           <a:xfrm>
-            <a:off x="11256264" y="5815584"/>
-            <a:ext cx="475488" cy="475488"/>
+            <a:off x="11164824" y="5724144"/>
+            <a:ext cx="566928" cy="566928"/>
           </a:xfrm>
           <a:prstGeom prst="ellipse">
             <a:avLst/>
@@ -10701,8 +10701,8 @@
         </p:blipFill>
         <p:spPr>
           <a:xfrm>
-            <a:off x="11370381" y="5929701"/>
-            <a:ext cx="247254" cy="247254"/>
+            <a:off x="11300887" y="5860207"/>
+            <a:ext cx="294803" cy="294803"/>
           </a:xfrm>
           <a:prstGeom prst="rect">
             <a:avLst/>
@@ -10717,7 +10717,7 @@
         </p:nvSpPr>
         <p:spPr>
           <a:xfrm>
-            <a:off x="7132320" y="6355080"/>
+            <a:off x="7132320" y="6373368"/>
             <a:ext cx="4599432" cy="256032"/>
           </a:xfrm>
           <a:prstGeom prst="rect">
@@ -11087,7 +11087,7 @@
         <p:spPr>
           <a:xfrm>
             <a:off x="457200" y="5303520"/>
-            <a:ext cx="8138160" cy="822960"/>
+            <a:ext cx="7589520" cy="822960"/>
           </a:xfrm>
           <a:prstGeom prst="rect">
             <a:avLst/>
@@ -11194,8 +11194,8 @@
         </p:nvSpPr>
         <p:spPr>
           <a:xfrm>
-            <a:off x="8695944" y="5815584"/>
-            <a:ext cx="475488" cy="475488"/>
+            <a:off x="8165592" y="5724144"/>
+            <a:ext cx="566928" cy="566928"/>
           </a:xfrm>
           <a:prstGeom prst="ellipse">
             <a:avLst/>
@@ -11227,8 +11227,8 @@
         </p:blipFill>
         <p:spPr>
           <a:xfrm>
-            <a:off x="8810061" y="5929701"/>
-            <a:ext cx="247254" cy="247254"/>
+            <a:off x="8301655" y="5860207"/>
+            <a:ext cx="294803" cy="294803"/>
           </a:xfrm>
           <a:prstGeom prst="rect">
             <a:avLst/>
@@ -11243,8 +11243,8 @@
         </p:nvSpPr>
         <p:spPr>
           <a:xfrm>
-            <a:off x="9336024" y="5815584"/>
-            <a:ext cx="475488" cy="475488"/>
+            <a:off x="8915400" y="5724144"/>
+            <a:ext cx="566928" cy="566928"/>
           </a:xfrm>
           <a:prstGeom prst="ellipse">
             <a:avLst/>
@@ -11276,8 +11276,8 @@
         </p:blipFill>
         <p:spPr>
           <a:xfrm>
-            <a:off x="9450141" y="5929701"/>
-            <a:ext cx="247254" cy="247254"/>
+            <a:off x="9051463" y="5860207"/>
+            <a:ext cx="294803" cy="294803"/>
           </a:xfrm>
           <a:prstGeom prst="rect">
             <a:avLst/>
@@ -11292,8 +11292,8 @@
         </p:nvSpPr>
         <p:spPr>
           <a:xfrm>
-            <a:off x="9976104" y="5815584"/>
-            <a:ext cx="475488" cy="475488"/>
+            <a:off x="9665208" y="5724144"/>
+            <a:ext cx="566928" cy="566928"/>
           </a:xfrm>
           <a:prstGeom prst="ellipse">
             <a:avLst/>
@@ -11325,8 +11325,8 @@
         </p:blipFill>
         <p:spPr>
           <a:xfrm>
-            <a:off x="10090221" y="5929701"/>
-            <a:ext cx="247254" cy="247254"/>
+            <a:off x="9801271" y="5860207"/>
+            <a:ext cx="294803" cy="294803"/>
           </a:xfrm>
           <a:prstGeom prst="rect">
             <a:avLst/>
@@ -11341,8 +11341,8 @@
         </p:nvSpPr>
         <p:spPr>
           <a:xfrm>
-            <a:off x="10616184" y="5815584"/>
-            <a:ext cx="475488" cy="475488"/>
+            <a:off x="10415016" y="5724144"/>
+            <a:ext cx="566928" cy="566928"/>
           </a:xfrm>
           <a:prstGeom prst="ellipse">
             <a:avLst/>
@@ -11374,8 +11374,8 @@
         </p:blipFill>
         <p:spPr>
           <a:xfrm>
-            <a:off x="10730301" y="5929701"/>
-            <a:ext cx="247254" cy="247254"/>
+            <a:off x="10551079" y="5860207"/>
+            <a:ext cx="294803" cy="294803"/>
           </a:xfrm>
           <a:prstGeom prst="rect">
             <a:avLst/>
@@ -11390,8 +11390,8 @@
         </p:nvSpPr>
         <p:spPr>
           <a:xfrm>
-            <a:off x="11256264" y="5815584"/>
-            <a:ext cx="475488" cy="475488"/>
+            <a:off x="11164824" y="5724144"/>
+            <a:ext cx="566928" cy="566928"/>
           </a:xfrm>
           <a:prstGeom prst="ellipse">
             <a:avLst/>
@@ -11423,8 +11423,8 @@
         </p:blipFill>
         <p:spPr>
           <a:xfrm>
-            <a:off x="11370381" y="5929701"/>
-            <a:ext cx="247254" cy="247254"/>
+            <a:off x="11300887" y="5860207"/>
+            <a:ext cx="294803" cy="294803"/>
           </a:xfrm>
           <a:prstGeom prst="rect">
             <a:avLst/>
@@ -11439,7 +11439,7 @@
         </p:nvSpPr>
         <p:spPr>
           <a:xfrm>
-            <a:off x="7132320" y="6355080"/>
+            <a:off x="7132320" y="6373368"/>
             <a:ext cx="4599432" cy="256032"/>
           </a:xfrm>
           <a:prstGeom prst="rect">
@@ -11661,11 +11661,11 @@
             <a:avLst/>
           </a:prstGeom>
           <a:solidFill>
-            <a:srgbClr val="F79646"/>
+            <a:srgbClr val="1F4E46"/>
           </a:solidFill>
           <a:ln w="12700">
             <a:solidFill>
-              <a:srgbClr val="F79646"/>
+              <a:srgbClr val="1F4E46"/>
             </a:solidFill>
             <a:prstDash val="solid"/>
           </a:ln>
@@ -11788,11 +11788,11 @@
             <a:avLst/>
           </a:prstGeom>
           <a:solidFill>
-            <a:srgbClr val="F79646"/>
+            <a:srgbClr val="1F4E46"/>
           </a:solidFill>
           <a:ln w="12700">
             <a:solidFill>
-              <a:srgbClr val="F79646"/>
+              <a:srgbClr val="1F4E46"/>
             </a:solidFill>
             <a:prstDash val="solid"/>
           </a:ln>
@@ -11915,11 +11915,11 @@
             <a:avLst/>
           </a:prstGeom>
           <a:solidFill>
-            <a:srgbClr val="F79646"/>
+            <a:srgbClr val="1F4E46"/>
           </a:solidFill>
           <a:ln w="12700">
             <a:solidFill>
-              <a:srgbClr val="F79646"/>
+              <a:srgbClr val="1F4E46"/>
             </a:solidFill>
             <a:prstDash val="solid"/>
           </a:ln>
@@ -12339,7 +12339,7 @@
         <p:spPr>
           <a:xfrm>
             <a:off x="457200" y="5303520"/>
-            <a:ext cx="8138160" cy="822960"/>
+            <a:ext cx="7589520" cy="822960"/>
           </a:xfrm>
           <a:prstGeom prst="rect">
             <a:avLst/>
@@ -12446,8 +12446,8 @@
         </p:nvSpPr>
         <p:spPr>
           <a:xfrm>
-            <a:off x="8695944" y="5815584"/>
-            <a:ext cx="475488" cy="475488"/>
+            <a:off x="8165592" y="5724144"/>
+            <a:ext cx="566928" cy="566928"/>
           </a:xfrm>
           <a:prstGeom prst="ellipse">
             <a:avLst/>
@@ -12479,8 +12479,8 @@
         </p:blipFill>
         <p:spPr>
           <a:xfrm>
-            <a:off x="8810061" y="5929701"/>
-            <a:ext cx="247254" cy="247254"/>
+            <a:off x="8301655" y="5860207"/>
+            <a:ext cx="294803" cy="294803"/>
           </a:xfrm>
           <a:prstGeom prst="rect">
             <a:avLst/>
@@ -12495,8 +12495,8 @@
         </p:nvSpPr>
         <p:spPr>
           <a:xfrm>
-            <a:off x="9336024" y="5815584"/>
-            <a:ext cx="475488" cy="475488"/>
+            <a:off x="8915400" y="5724144"/>
+            <a:ext cx="566928" cy="566928"/>
           </a:xfrm>
           <a:prstGeom prst="ellipse">
             <a:avLst/>
@@ -12528,8 +12528,8 @@
         </p:blipFill>
         <p:spPr>
           <a:xfrm>
-            <a:off x="9450141" y="5929701"/>
-            <a:ext cx="247254" cy="247254"/>
+            <a:off x="9051463" y="5860207"/>
+            <a:ext cx="294803" cy="294803"/>
           </a:xfrm>
           <a:prstGeom prst="rect">
             <a:avLst/>
@@ -12544,8 +12544,8 @@
         </p:nvSpPr>
         <p:spPr>
           <a:xfrm>
-            <a:off x="9976104" y="5815584"/>
-            <a:ext cx="475488" cy="475488"/>
+            <a:off x="9665208" y="5724144"/>
+            <a:ext cx="566928" cy="566928"/>
           </a:xfrm>
           <a:prstGeom prst="ellipse">
             <a:avLst/>
@@ -12577,8 +12577,8 @@
         </p:blipFill>
         <p:spPr>
           <a:xfrm>
-            <a:off x="10090221" y="5929701"/>
-            <a:ext cx="247254" cy="247254"/>
+            <a:off x="9801271" y="5860207"/>
+            <a:ext cx="294803" cy="294803"/>
           </a:xfrm>
           <a:prstGeom prst="rect">
             <a:avLst/>
@@ -12593,8 +12593,8 @@
         </p:nvSpPr>
         <p:spPr>
           <a:xfrm>
-            <a:off x="10616184" y="5815584"/>
-            <a:ext cx="475488" cy="475488"/>
+            <a:off x="10415016" y="5724144"/>
+            <a:ext cx="566928" cy="566928"/>
           </a:xfrm>
           <a:prstGeom prst="ellipse">
             <a:avLst/>
@@ -12626,8 +12626,8 @@
         </p:blipFill>
         <p:spPr>
           <a:xfrm>
-            <a:off x="10730301" y="5929701"/>
-            <a:ext cx="247254" cy="247254"/>
+            <a:off x="10551079" y="5860207"/>
+            <a:ext cx="294803" cy="294803"/>
           </a:xfrm>
           <a:prstGeom prst="rect">
             <a:avLst/>
@@ -12642,8 +12642,8 @@
         </p:nvSpPr>
         <p:spPr>
           <a:xfrm>
-            <a:off x="11256264" y="5815584"/>
-            <a:ext cx="475488" cy="475488"/>
+            <a:off x="11164824" y="5724144"/>
+            <a:ext cx="566928" cy="566928"/>
           </a:xfrm>
           <a:prstGeom prst="ellipse">
             <a:avLst/>
@@ -12675,8 +12675,8 @@
         </p:blipFill>
         <p:spPr>
           <a:xfrm>
-            <a:off x="11370381" y="5929701"/>
-            <a:ext cx="247254" cy="247254"/>
+            <a:off x="11300887" y="5860207"/>
+            <a:ext cx="294803" cy="294803"/>
           </a:xfrm>
           <a:prstGeom prst="rect">
             <a:avLst/>
@@ -12691,7 +12691,7 @@
         </p:nvSpPr>
         <p:spPr>
           <a:xfrm>
-            <a:off x="7132320" y="6355080"/>
+            <a:off x="7132320" y="6373368"/>
             <a:ext cx="4599432" cy="256032"/>
           </a:xfrm>
           <a:prstGeom prst="rect">
@@ -13061,7 +13061,7 @@
         <p:spPr>
           <a:xfrm>
             <a:off x="457200" y="5303520"/>
-            <a:ext cx="8138160" cy="822960"/>
+            <a:ext cx="7589520" cy="822960"/>
           </a:xfrm>
           <a:prstGeom prst="rect">
             <a:avLst/>
@@ -13168,8 +13168,8 @@
         </p:nvSpPr>
         <p:spPr>
           <a:xfrm>
-            <a:off x="8695944" y="5815584"/>
-            <a:ext cx="475488" cy="475488"/>
+            <a:off x="8165592" y="5724144"/>
+            <a:ext cx="566928" cy="566928"/>
           </a:xfrm>
           <a:prstGeom prst="ellipse">
             <a:avLst/>
@@ -13201,8 +13201,8 @@
         </p:blipFill>
         <p:spPr>
           <a:xfrm>
-            <a:off x="8810061" y="5929701"/>
-            <a:ext cx="247254" cy="247254"/>
+            <a:off x="8301655" y="5860207"/>
+            <a:ext cx="294803" cy="294803"/>
           </a:xfrm>
           <a:prstGeom prst="rect">
             <a:avLst/>
@@ -13217,8 +13217,8 @@
         </p:nvSpPr>
         <p:spPr>
           <a:xfrm>
-            <a:off x="9336024" y="5815584"/>
-            <a:ext cx="475488" cy="475488"/>
+            <a:off x="8915400" y="5724144"/>
+            <a:ext cx="566928" cy="566928"/>
           </a:xfrm>
           <a:prstGeom prst="ellipse">
             <a:avLst/>
@@ -13250,8 +13250,8 @@
         </p:blipFill>
         <p:spPr>
           <a:xfrm>
-            <a:off x="9450141" y="5929701"/>
-            <a:ext cx="247254" cy="247254"/>
+            <a:off x="9051463" y="5860207"/>
+            <a:ext cx="294803" cy="294803"/>
           </a:xfrm>
           <a:prstGeom prst="rect">
             <a:avLst/>
@@ -13266,8 +13266,8 @@
         </p:nvSpPr>
         <p:spPr>
           <a:xfrm>
-            <a:off x="9976104" y="5815584"/>
-            <a:ext cx="475488" cy="475488"/>
+            <a:off x="9665208" y="5724144"/>
+            <a:ext cx="566928" cy="566928"/>
           </a:xfrm>
           <a:prstGeom prst="ellipse">
             <a:avLst/>
@@ -13299,8 +13299,8 @@
         </p:blipFill>
         <p:spPr>
           <a:xfrm>
-            <a:off x="10090221" y="5929701"/>
-            <a:ext cx="247254" cy="247254"/>
+            <a:off x="9801271" y="5860207"/>
+            <a:ext cx="294803" cy="294803"/>
           </a:xfrm>
           <a:prstGeom prst="rect">
             <a:avLst/>
@@ -13315,8 +13315,8 @@
         </p:nvSpPr>
         <p:spPr>
           <a:xfrm>
-            <a:off x="10616184" y="5815584"/>
-            <a:ext cx="475488" cy="475488"/>
+            <a:off x="10415016" y="5724144"/>
+            <a:ext cx="566928" cy="566928"/>
           </a:xfrm>
           <a:prstGeom prst="ellipse">
             <a:avLst/>
@@ -13348,8 +13348,8 @@
         </p:blipFill>
         <p:spPr>
           <a:xfrm>
-            <a:off x="10730301" y="5929701"/>
-            <a:ext cx="247254" cy="247254"/>
+            <a:off x="10551079" y="5860207"/>
+            <a:ext cx="294803" cy="294803"/>
           </a:xfrm>
           <a:prstGeom prst="rect">
             <a:avLst/>
@@ -13364,8 +13364,8 @@
         </p:nvSpPr>
         <p:spPr>
           <a:xfrm>
-            <a:off x="11256264" y="5815584"/>
-            <a:ext cx="475488" cy="475488"/>
+            <a:off x="11164824" y="5724144"/>
+            <a:ext cx="566928" cy="566928"/>
           </a:xfrm>
           <a:prstGeom prst="ellipse">
             <a:avLst/>
@@ -13397,8 +13397,8 @@
         </p:blipFill>
         <p:spPr>
           <a:xfrm>
-            <a:off x="11370381" y="5929701"/>
-            <a:ext cx="247254" cy="247254"/>
+            <a:off x="11300887" y="5860207"/>
+            <a:ext cx="294803" cy="294803"/>
           </a:xfrm>
           <a:prstGeom prst="rect">
             <a:avLst/>
@@ -13413,7 +13413,7 @@
         </p:nvSpPr>
         <p:spPr>
           <a:xfrm>
-            <a:off x="7132320" y="6355080"/>
+            <a:off x="7132320" y="6373368"/>
             <a:ext cx="4599432" cy="256032"/>
           </a:xfrm>
           <a:prstGeom prst="rect">
@@ -13822,7 +13822,7 @@
         <p:spPr>
           <a:xfrm>
             <a:off x="457200" y="5303520"/>
-            <a:ext cx="8138160" cy="822960"/>
+            <a:ext cx="7589520" cy="822960"/>
           </a:xfrm>
           <a:prstGeom prst="rect">
             <a:avLst/>
@@ -13886,8 +13886,8 @@
         </p:nvSpPr>
         <p:spPr>
           <a:xfrm>
-            <a:off x="8695944" y="5815584"/>
-            <a:ext cx="475488" cy="475488"/>
+            <a:off x="8165592" y="5724144"/>
+            <a:ext cx="566928" cy="566928"/>
           </a:xfrm>
           <a:prstGeom prst="ellipse">
             <a:avLst/>
@@ -13919,8 +13919,8 @@
         </p:blipFill>
         <p:spPr>
           <a:xfrm>
-            <a:off x="8810061" y="5929701"/>
-            <a:ext cx="247254" cy="247254"/>
+            <a:off x="8301655" y="5860207"/>
+            <a:ext cx="294803" cy="294803"/>
           </a:xfrm>
           <a:prstGeom prst="rect">
             <a:avLst/>
@@ -13935,8 +13935,8 @@
         </p:nvSpPr>
         <p:spPr>
           <a:xfrm>
-            <a:off x="9336024" y="5815584"/>
-            <a:ext cx="475488" cy="475488"/>
+            <a:off x="8915400" y="5724144"/>
+            <a:ext cx="566928" cy="566928"/>
           </a:xfrm>
           <a:prstGeom prst="ellipse">
             <a:avLst/>
@@ -13968,8 +13968,8 @@
         </p:blipFill>
         <p:spPr>
           <a:xfrm>
-            <a:off x="9450141" y="5929701"/>
-            <a:ext cx="247254" cy="247254"/>
+            <a:off x="9051463" y="5860207"/>
+            <a:ext cx="294803" cy="294803"/>
           </a:xfrm>
           <a:prstGeom prst="rect">
             <a:avLst/>
@@ -13984,8 +13984,8 @@
         </p:nvSpPr>
         <p:spPr>
           <a:xfrm>
-            <a:off x="9976104" y="5815584"/>
-            <a:ext cx="475488" cy="475488"/>
+            <a:off x="9665208" y="5724144"/>
+            <a:ext cx="566928" cy="566928"/>
           </a:xfrm>
           <a:prstGeom prst="ellipse">
             <a:avLst/>
@@ -14017,8 +14017,8 @@
         </p:blipFill>
         <p:spPr>
           <a:xfrm>
-            <a:off x="10090221" y="5929701"/>
-            <a:ext cx="247254" cy="247254"/>
+            <a:off x="9801271" y="5860207"/>
+            <a:ext cx="294803" cy="294803"/>
           </a:xfrm>
           <a:prstGeom prst="rect">
             <a:avLst/>
@@ -14033,8 +14033,8 @@
         </p:nvSpPr>
         <p:spPr>
           <a:xfrm>
-            <a:off x="10616184" y="5815584"/>
-            <a:ext cx="475488" cy="475488"/>
+            <a:off x="10415016" y="5724144"/>
+            <a:ext cx="566928" cy="566928"/>
           </a:xfrm>
           <a:prstGeom prst="ellipse">
             <a:avLst/>
@@ -14066,8 +14066,8 @@
         </p:blipFill>
         <p:spPr>
           <a:xfrm>
-            <a:off x="10730301" y="5929701"/>
-            <a:ext cx="247254" cy="247254"/>
+            <a:off x="10551079" y="5860207"/>
+            <a:ext cx="294803" cy="294803"/>
           </a:xfrm>
           <a:prstGeom prst="rect">
             <a:avLst/>
@@ -14082,8 +14082,8 @@
         </p:nvSpPr>
         <p:spPr>
           <a:xfrm>
-            <a:off x="11256264" y="5815584"/>
-            <a:ext cx="475488" cy="475488"/>
+            <a:off x="11164824" y="5724144"/>
+            <a:ext cx="566928" cy="566928"/>
           </a:xfrm>
           <a:prstGeom prst="ellipse">
             <a:avLst/>
@@ -14115,8 +14115,8 @@
         </p:blipFill>
         <p:spPr>
           <a:xfrm>
-            <a:off x="11370381" y="5929701"/>
-            <a:ext cx="247254" cy="247254"/>
+            <a:off x="11300887" y="5860207"/>
+            <a:ext cx="294803" cy="294803"/>
           </a:xfrm>
           <a:prstGeom prst="rect">
             <a:avLst/>
@@ -14131,7 +14131,7 @@
         </p:nvSpPr>
         <p:spPr>
           <a:xfrm>
-            <a:off x="7132320" y="6355080"/>
+            <a:off x="7132320" y="6373368"/>
             <a:ext cx="4599432" cy="256032"/>
           </a:xfrm>
           <a:prstGeom prst="rect">
@@ -14540,7 +14540,7 @@
         <p:spPr>
           <a:xfrm>
             <a:off x="457200" y="5303520"/>
-            <a:ext cx="8138160" cy="822960"/>
+            <a:ext cx="7589520" cy="822960"/>
           </a:xfrm>
           <a:prstGeom prst="rect">
             <a:avLst/>
@@ -14647,8 +14647,8 @@
         </p:nvSpPr>
         <p:spPr>
           <a:xfrm>
-            <a:off x="8695944" y="5815584"/>
-            <a:ext cx="475488" cy="475488"/>
+            <a:off x="8165592" y="5724144"/>
+            <a:ext cx="566928" cy="566928"/>
           </a:xfrm>
           <a:prstGeom prst="ellipse">
             <a:avLst/>
@@ -14680,8 +14680,8 @@
         </p:blipFill>
         <p:spPr>
           <a:xfrm>
-            <a:off x="8810061" y="5929701"/>
-            <a:ext cx="247254" cy="247254"/>
+            <a:off x="8301655" y="5860207"/>
+            <a:ext cx="294803" cy="294803"/>
           </a:xfrm>
           <a:prstGeom prst="rect">
             <a:avLst/>
@@ -14696,8 +14696,8 @@
         </p:nvSpPr>
         <p:spPr>
           <a:xfrm>
-            <a:off x="9336024" y="5815584"/>
-            <a:ext cx="475488" cy="475488"/>
+            <a:off x="8915400" y="5724144"/>
+            <a:ext cx="566928" cy="566928"/>
           </a:xfrm>
           <a:prstGeom prst="ellipse">
             <a:avLst/>
@@ -14729,8 +14729,8 @@
         </p:blipFill>
         <p:spPr>
           <a:xfrm>
-            <a:off x="9450141" y="5929701"/>
-            <a:ext cx="247254" cy="247254"/>
+            <a:off x="9051463" y="5860207"/>
+            <a:ext cx="294803" cy="294803"/>
           </a:xfrm>
           <a:prstGeom prst="rect">
             <a:avLst/>
@@ -14745,8 +14745,8 @@
         </p:nvSpPr>
         <p:spPr>
           <a:xfrm>
-            <a:off x="9976104" y="5815584"/>
-            <a:ext cx="475488" cy="475488"/>
+            <a:off x="9665208" y="5724144"/>
+            <a:ext cx="566928" cy="566928"/>
           </a:xfrm>
           <a:prstGeom prst="ellipse">
             <a:avLst/>
@@ -14778,8 +14778,8 @@
         </p:blipFill>
         <p:spPr>
           <a:xfrm>
-            <a:off x="10090221" y="5929701"/>
-            <a:ext cx="247254" cy="247254"/>
+            <a:off x="9801271" y="5860207"/>
+            <a:ext cx="294803" cy="294803"/>
           </a:xfrm>
           <a:prstGeom prst="rect">
             <a:avLst/>
@@ -14794,8 +14794,8 @@
         </p:nvSpPr>
         <p:spPr>
           <a:xfrm>
-            <a:off x="10616184" y="5815584"/>
-            <a:ext cx="475488" cy="475488"/>
+            <a:off x="10415016" y="5724144"/>
+            <a:ext cx="566928" cy="566928"/>
           </a:xfrm>
           <a:prstGeom prst="ellipse">
             <a:avLst/>
@@ -14827,8 +14827,8 @@
         </p:blipFill>
         <p:spPr>
           <a:xfrm>
-            <a:off x="10730301" y="5929701"/>
-            <a:ext cx="247254" cy="247254"/>
+            <a:off x="10551079" y="5860207"/>
+            <a:ext cx="294803" cy="294803"/>
           </a:xfrm>
           <a:prstGeom prst="rect">
             <a:avLst/>
@@ -14843,8 +14843,8 @@
         </p:nvSpPr>
         <p:spPr>
           <a:xfrm>
-            <a:off x="11256264" y="5815584"/>
-            <a:ext cx="475488" cy="475488"/>
+            <a:off x="11164824" y="5724144"/>
+            <a:ext cx="566928" cy="566928"/>
           </a:xfrm>
           <a:prstGeom prst="ellipse">
             <a:avLst/>
@@ -14876,8 +14876,8 @@
         </p:blipFill>
         <p:spPr>
           <a:xfrm>
-            <a:off x="11370381" y="5929701"/>
-            <a:ext cx="247254" cy="247254"/>
+            <a:off x="11300887" y="5860207"/>
+            <a:ext cx="294803" cy="294803"/>
           </a:xfrm>
           <a:prstGeom prst="rect">
             <a:avLst/>
@@ -14892,7 +14892,7 @@
         </p:nvSpPr>
         <p:spPr>
           <a:xfrm>
-            <a:off x="7132320" y="6355080"/>
+            <a:off x="7132320" y="6373368"/>
             <a:ext cx="4599432" cy="256032"/>
           </a:xfrm>
           <a:prstGeom prst="rect">
@@ -15301,7 +15301,7 @@
         <p:spPr>
           <a:xfrm>
             <a:off x="457200" y="5303520"/>
-            <a:ext cx="8138160" cy="822960"/>
+            <a:ext cx="7589520" cy="822960"/>
           </a:xfrm>
           <a:prstGeom prst="rect">
             <a:avLst/>
@@ -15408,8 +15408,8 @@
         </p:nvSpPr>
         <p:spPr>
           <a:xfrm>
-            <a:off x="8695944" y="5815584"/>
-            <a:ext cx="475488" cy="475488"/>
+            <a:off x="8165592" y="5724144"/>
+            <a:ext cx="566928" cy="566928"/>
           </a:xfrm>
           <a:prstGeom prst="ellipse">
             <a:avLst/>
@@ -15441,8 +15441,8 @@
         </p:blipFill>
         <p:spPr>
           <a:xfrm>
-            <a:off x="8810061" y="5929701"/>
-            <a:ext cx="247254" cy="247254"/>
+            <a:off x="8301655" y="5860207"/>
+            <a:ext cx="294803" cy="294803"/>
           </a:xfrm>
           <a:prstGeom prst="rect">
             <a:avLst/>
@@ -15457,8 +15457,8 @@
         </p:nvSpPr>
         <p:spPr>
           <a:xfrm>
-            <a:off x="9336024" y="5815584"/>
-            <a:ext cx="475488" cy="475488"/>
+            <a:off x="8915400" y="5724144"/>
+            <a:ext cx="566928" cy="566928"/>
           </a:xfrm>
           <a:prstGeom prst="ellipse">
             <a:avLst/>
@@ -15490,8 +15490,8 @@
         </p:blipFill>
         <p:spPr>
           <a:xfrm>
-            <a:off x="9450141" y="5929701"/>
-            <a:ext cx="247254" cy="247254"/>
+            <a:off x="9051463" y="5860207"/>
+            <a:ext cx="294803" cy="294803"/>
           </a:xfrm>
           <a:prstGeom prst="rect">
             <a:avLst/>
@@ -15506,8 +15506,8 @@
         </p:nvSpPr>
         <p:spPr>
           <a:xfrm>
-            <a:off x="9976104" y="5815584"/>
-            <a:ext cx="475488" cy="475488"/>
+            <a:off x="9665208" y="5724144"/>
+            <a:ext cx="566928" cy="566928"/>
           </a:xfrm>
           <a:prstGeom prst="ellipse">
             <a:avLst/>
@@ -15539,8 +15539,8 @@
         </p:blipFill>
         <p:spPr>
           <a:xfrm>
-            <a:off x="10090221" y="5929701"/>
-            <a:ext cx="247254" cy="247254"/>
+            <a:off x="9801271" y="5860207"/>
+            <a:ext cx="294803" cy="294803"/>
           </a:xfrm>
           <a:prstGeom prst="rect">
             <a:avLst/>
@@ -15555,8 +15555,8 @@
         </p:nvSpPr>
         <p:spPr>
           <a:xfrm>
-            <a:off x="10616184" y="5815584"/>
-            <a:ext cx="475488" cy="475488"/>
+            <a:off x="10415016" y="5724144"/>
+            <a:ext cx="566928" cy="566928"/>
           </a:xfrm>
           <a:prstGeom prst="ellipse">
             <a:avLst/>
@@ -15588,8 +15588,8 @@
         </p:blipFill>
         <p:spPr>
           <a:xfrm>
-            <a:off x="10730301" y="5929701"/>
-            <a:ext cx="247254" cy="247254"/>
+            <a:off x="10551079" y="5860207"/>
+            <a:ext cx="294803" cy="294803"/>
           </a:xfrm>
           <a:prstGeom prst="rect">
             <a:avLst/>
@@ -15604,8 +15604,8 @@
         </p:nvSpPr>
         <p:spPr>
           <a:xfrm>
-            <a:off x="11256264" y="5815584"/>
-            <a:ext cx="475488" cy="475488"/>
+            <a:off x="11164824" y="5724144"/>
+            <a:ext cx="566928" cy="566928"/>
           </a:xfrm>
           <a:prstGeom prst="ellipse">
             <a:avLst/>
@@ -15637,8 +15637,8 @@
         </p:blipFill>
         <p:spPr>
           <a:xfrm>
-            <a:off x="11370381" y="5929701"/>
-            <a:ext cx="247254" cy="247254"/>
+            <a:off x="11300887" y="5860207"/>
+            <a:ext cx="294803" cy="294803"/>
           </a:xfrm>
           <a:prstGeom prst="rect">
             <a:avLst/>
@@ -15653,7 +15653,7 @@
         </p:nvSpPr>
         <p:spPr>
           <a:xfrm>
-            <a:off x="7132320" y="6355080"/>
+            <a:off x="7132320" y="6373368"/>
             <a:ext cx="4599432" cy="256032"/>
           </a:xfrm>
           <a:prstGeom prst="rect">
@@ -16062,7 +16062,7 @@
         <p:spPr>
           <a:xfrm>
             <a:off x="457200" y="5303520"/>
-            <a:ext cx="8138160" cy="822960"/>
+            <a:ext cx="7589520" cy="822960"/>
           </a:xfrm>
           <a:prstGeom prst="rect">
             <a:avLst/>
@@ -16126,8 +16126,8 @@
         </p:nvSpPr>
         <p:spPr>
           <a:xfrm>
-            <a:off x="8695944" y="5815584"/>
-            <a:ext cx="475488" cy="475488"/>
+            <a:off x="8165592" y="5724144"/>
+            <a:ext cx="566928" cy="566928"/>
           </a:xfrm>
           <a:prstGeom prst="ellipse">
             <a:avLst/>
@@ -16159,8 +16159,8 @@
         </p:blipFill>
         <p:spPr>
           <a:xfrm>
-            <a:off x="8810061" y="5929701"/>
-            <a:ext cx="247254" cy="247254"/>
+            <a:off x="8301655" y="5860207"/>
+            <a:ext cx="294803" cy="294803"/>
           </a:xfrm>
           <a:prstGeom prst="rect">
             <a:avLst/>
@@ -16175,8 +16175,8 @@
         </p:nvSpPr>
         <p:spPr>
           <a:xfrm>
-            <a:off x="9336024" y="5815584"/>
-            <a:ext cx="475488" cy="475488"/>
+            <a:off x="8915400" y="5724144"/>
+            <a:ext cx="566928" cy="566928"/>
           </a:xfrm>
           <a:prstGeom prst="ellipse">
             <a:avLst/>
@@ -16208,8 +16208,8 @@
         </p:blipFill>
         <p:spPr>
           <a:xfrm>
-            <a:off x="9450141" y="5929701"/>
-            <a:ext cx="247254" cy="247254"/>
+            <a:off x="9051463" y="5860207"/>
+            <a:ext cx="294803" cy="294803"/>
           </a:xfrm>
           <a:prstGeom prst="rect">
             <a:avLst/>
@@ -16224,8 +16224,8 @@
         </p:nvSpPr>
         <p:spPr>
           <a:xfrm>
-            <a:off x="9976104" y="5815584"/>
-            <a:ext cx="475488" cy="475488"/>
+            <a:off x="9665208" y="5724144"/>
+            <a:ext cx="566928" cy="566928"/>
           </a:xfrm>
           <a:prstGeom prst="ellipse">
             <a:avLst/>
@@ -16257,8 +16257,8 @@
         </p:blipFill>
         <p:spPr>
           <a:xfrm>
-            <a:off x="10090221" y="5929701"/>
-            <a:ext cx="247254" cy="247254"/>
+            <a:off x="9801271" y="5860207"/>
+            <a:ext cx="294803" cy="294803"/>
           </a:xfrm>
           <a:prstGeom prst="rect">
             <a:avLst/>
@@ -16273,8 +16273,8 @@
         </p:nvSpPr>
         <p:spPr>
           <a:xfrm>
-            <a:off x="10616184" y="5815584"/>
-            <a:ext cx="475488" cy="475488"/>
+            <a:off x="10415016" y="5724144"/>
+            <a:ext cx="566928" cy="566928"/>
           </a:xfrm>
           <a:prstGeom prst="ellipse">
             <a:avLst/>
@@ -16306,8 +16306,8 @@
         </p:blipFill>
         <p:spPr>
           <a:xfrm>
-            <a:off x="10730301" y="5929701"/>
-            <a:ext cx="247254" cy="247254"/>
+            <a:off x="10551079" y="5860207"/>
+            <a:ext cx="294803" cy="294803"/>
           </a:xfrm>
           <a:prstGeom prst="rect">
             <a:avLst/>
@@ -16322,8 +16322,8 @@
         </p:nvSpPr>
         <p:spPr>
           <a:xfrm>
-            <a:off x="11256264" y="5815584"/>
-            <a:ext cx="475488" cy="475488"/>
+            <a:off x="11164824" y="5724144"/>
+            <a:ext cx="566928" cy="566928"/>
           </a:xfrm>
           <a:prstGeom prst="ellipse">
             <a:avLst/>
@@ -16355,8 +16355,8 @@
         </p:blipFill>
         <p:spPr>
           <a:xfrm>
-            <a:off x="11370381" y="5929701"/>
-            <a:ext cx="247254" cy="247254"/>
+            <a:off x="11300887" y="5860207"/>
+            <a:ext cx="294803" cy="294803"/>
           </a:xfrm>
           <a:prstGeom prst="rect">
             <a:avLst/>
@@ -16371,7 +16371,7 @@
         </p:nvSpPr>
         <p:spPr>
           <a:xfrm>
-            <a:off x="7132320" y="6355080"/>
+            <a:off x="7132320" y="6373368"/>
             <a:ext cx="4599432" cy="256032"/>
           </a:xfrm>
           <a:prstGeom prst="rect">
@@ -16780,7 +16780,7 @@
         <p:spPr>
           <a:xfrm>
             <a:off x="457200" y="5303520"/>
-            <a:ext cx="8138160" cy="822960"/>
+            <a:ext cx="7589520" cy="822960"/>
           </a:xfrm>
           <a:prstGeom prst="rect">
             <a:avLst/>
@@ -16887,8 +16887,8 @@
         </p:nvSpPr>
         <p:spPr>
           <a:xfrm>
-            <a:off x="8695944" y="5815584"/>
-            <a:ext cx="475488" cy="475488"/>
+            <a:off x="8165592" y="5724144"/>
+            <a:ext cx="566928" cy="566928"/>
           </a:xfrm>
           <a:prstGeom prst="ellipse">
             <a:avLst/>
@@ -16920,8 +16920,8 @@
         </p:blipFill>
         <p:spPr>
           <a:xfrm>
-            <a:off x="8810061" y="5929701"/>
-            <a:ext cx="247254" cy="247254"/>
+            <a:off x="8301655" y="5860207"/>
+            <a:ext cx="294803" cy="294803"/>
           </a:xfrm>
           <a:prstGeom prst="rect">
             <a:avLst/>
@@ -16936,8 +16936,8 @@
         </p:nvSpPr>
         <p:spPr>
           <a:xfrm>
-            <a:off x="9336024" y="5815584"/>
-            <a:ext cx="475488" cy="475488"/>
+            <a:off x="8915400" y="5724144"/>
+            <a:ext cx="566928" cy="566928"/>
           </a:xfrm>
           <a:prstGeom prst="ellipse">
             <a:avLst/>
@@ -16969,8 +16969,8 @@
         </p:blipFill>
         <p:spPr>
           <a:xfrm>
-            <a:off x="9450141" y="5929701"/>
-            <a:ext cx="247254" cy="247254"/>
+            <a:off x="9051463" y="5860207"/>
+            <a:ext cx="294803" cy="294803"/>
           </a:xfrm>
           <a:prstGeom prst="rect">
             <a:avLst/>
@@ -16985,8 +16985,8 @@
         </p:nvSpPr>
         <p:spPr>
           <a:xfrm>
-            <a:off x="9976104" y="5815584"/>
-            <a:ext cx="475488" cy="475488"/>
+            <a:off x="9665208" y="5724144"/>
+            <a:ext cx="566928" cy="566928"/>
           </a:xfrm>
           <a:prstGeom prst="ellipse">
             <a:avLst/>
@@ -17018,8 +17018,8 @@
         </p:blipFill>
         <p:spPr>
           <a:xfrm>
-            <a:off x="10090221" y="5929701"/>
-            <a:ext cx="247254" cy="247254"/>
+            <a:off x="9801271" y="5860207"/>
+            <a:ext cx="294803" cy="294803"/>
           </a:xfrm>
           <a:prstGeom prst="rect">
             <a:avLst/>
@@ -17034,8 +17034,8 @@
         </p:nvSpPr>
         <p:spPr>
           <a:xfrm>
-            <a:off x="10616184" y="5815584"/>
-            <a:ext cx="475488" cy="475488"/>
+            <a:off x="10415016" y="5724144"/>
+            <a:ext cx="566928" cy="566928"/>
           </a:xfrm>
           <a:prstGeom prst="ellipse">
             <a:avLst/>
@@ -17067,8 +17067,8 @@
         </p:blipFill>
         <p:spPr>
           <a:xfrm>
-            <a:off x="10730301" y="5929701"/>
-            <a:ext cx="247254" cy="247254"/>
+            <a:off x="10551079" y="5860207"/>
+            <a:ext cx="294803" cy="294803"/>
           </a:xfrm>
           <a:prstGeom prst="rect">
             <a:avLst/>
@@ -17083,8 +17083,8 @@
         </p:nvSpPr>
         <p:spPr>
           <a:xfrm>
-            <a:off x="11256264" y="5815584"/>
-            <a:ext cx="475488" cy="475488"/>
+            <a:off x="11164824" y="5724144"/>
+            <a:ext cx="566928" cy="566928"/>
           </a:xfrm>
           <a:prstGeom prst="ellipse">
             <a:avLst/>
@@ -17116,8 +17116,8 @@
         </p:blipFill>
         <p:spPr>
           <a:xfrm>
-            <a:off x="11370381" y="5929701"/>
-            <a:ext cx="247254" cy="247254"/>
+            <a:off x="11300887" y="5860207"/>
+            <a:ext cx="294803" cy="294803"/>
           </a:xfrm>
           <a:prstGeom prst="rect">
             <a:avLst/>
@@ -17132,7 +17132,7 @@
         </p:nvSpPr>
         <p:spPr>
           <a:xfrm>
-            <a:off x="7132320" y="6355080"/>
+            <a:off x="7132320" y="6373368"/>
             <a:ext cx="4599432" cy="256032"/>
           </a:xfrm>
           <a:prstGeom prst="rect">
@@ -17541,7 +17541,7 @@
         <p:spPr>
           <a:xfrm>
             <a:off x="457200" y="5303520"/>
-            <a:ext cx="8138160" cy="822960"/>
+            <a:ext cx="7589520" cy="822960"/>
           </a:xfrm>
           <a:prstGeom prst="rect">
             <a:avLst/>
@@ -17648,8 +17648,8 @@
         </p:nvSpPr>
         <p:spPr>
           <a:xfrm>
-            <a:off x="8695944" y="5815584"/>
-            <a:ext cx="475488" cy="475488"/>
+            <a:off x="8165592" y="5724144"/>
+            <a:ext cx="566928" cy="566928"/>
           </a:xfrm>
           <a:prstGeom prst="ellipse">
             <a:avLst/>
@@ -17681,8 +17681,8 @@
         </p:blipFill>
         <p:spPr>
           <a:xfrm>
-            <a:off x="8810061" y="5929701"/>
-            <a:ext cx="247254" cy="247254"/>
+            <a:off x="8301655" y="5860207"/>
+            <a:ext cx="294803" cy="294803"/>
           </a:xfrm>
           <a:prstGeom prst="rect">
             <a:avLst/>
@@ -17697,8 +17697,8 @@
         </p:nvSpPr>
         <p:spPr>
           <a:xfrm>
-            <a:off x="9336024" y="5815584"/>
-            <a:ext cx="475488" cy="475488"/>
+            <a:off x="8915400" y="5724144"/>
+            <a:ext cx="566928" cy="566928"/>
           </a:xfrm>
           <a:prstGeom prst="ellipse">
             <a:avLst/>
@@ -17730,8 +17730,8 @@
         </p:blipFill>
         <p:spPr>
           <a:xfrm>
-            <a:off x="9450141" y="5929701"/>
-            <a:ext cx="247254" cy="247254"/>
+            <a:off x="9051463" y="5860207"/>
+            <a:ext cx="294803" cy="294803"/>
           </a:xfrm>
           <a:prstGeom prst="rect">
             <a:avLst/>
@@ -17746,8 +17746,8 @@
         </p:nvSpPr>
         <p:spPr>
           <a:xfrm>
-            <a:off x="9976104" y="5815584"/>
-            <a:ext cx="475488" cy="475488"/>
+            <a:off x="9665208" y="5724144"/>
+            <a:ext cx="566928" cy="566928"/>
           </a:xfrm>
           <a:prstGeom prst="ellipse">
             <a:avLst/>
@@ -17779,8 +17779,8 @@
         </p:blipFill>
         <p:spPr>
           <a:xfrm>
-            <a:off x="10090221" y="5929701"/>
-            <a:ext cx="247254" cy="247254"/>
+            <a:off x="9801271" y="5860207"/>
+            <a:ext cx="294803" cy="294803"/>
           </a:xfrm>
           <a:prstGeom prst="rect">
             <a:avLst/>
@@ -17795,8 +17795,8 @@
         </p:nvSpPr>
         <p:spPr>
           <a:xfrm>
-            <a:off x="10616184" y="5815584"/>
-            <a:ext cx="475488" cy="475488"/>
+            <a:off x="10415016" y="5724144"/>
+            <a:ext cx="566928" cy="566928"/>
           </a:xfrm>
           <a:prstGeom prst="ellipse">
             <a:avLst/>
@@ -17828,8 +17828,8 @@
         </p:blipFill>
         <p:spPr>
           <a:xfrm>
-            <a:off x="10730301" y="5929701"/>
-            <a:ext cx="247254" cy="247254"/>
+            <a:off x="10551079" y="5860207"/>
+            <a:ext cx="294803" cy="294803"/>
           </a:xfrm>
           <a:prstGeom prst="rect">
             <a:avLst/>
@@ -17844,8 +17844,8 @@
         </p:nvSpPr>
         <p:spPr>
           <a:xfrm>
-            <a:off x="11256264" y="5815584"/>
-            <a:ext cx="475488" cy="475488"/>
+            <a:off x="11164824" y="5724144"/>
+            <a:ext cx="566928" cy="566928"/>
           </a:xfrm>
           <a:prstGeom prst="ellipse">
             <a:avLst/>
@@ -17877,8 +17877,8 @@
         </p:blipFill>
         <p:spPr>
           <a:xfrm>
-            <a:off x="11370381" y="5929701"/>
-            <a:ext cx="247254" cy="247254"/>
+            <a:off x="11300887" y="5860207"/>
+            <a:ext cx="294803" cy="294803"/>
           </a:xfrm>
           <a:prstGeom prst="rect">
             <a:avLst/>
@@ -17893,7 +17893,7 @@
         </p:nvSpPr>
         <p:spPr>
           <a:xfrm>
-            <a:off x="7132320" y="6355080"/>
+            <a:off x="7132320" y="6373368"/>
             <a:ext cx="4599432" cy="256032"/>
           </a:xfrm>
           <a:prstGeom prst="rect">
@@ -18302,7 +18302,7 @@
         <p:spPr>
           <a:xfrm>
             <a:off x="457200" y="5303520"/>
-            <a:ext cx="8138160" cy="822960"/>
+            <a:ext cx="7589520" cy="822960"/>
           </a:xfrm>
           <a:prstGeom prst="rect">
             <a:avLst/>
@@ -18409,8 +18409,8 @@
         </p:nvSpPr>
         <p:spPr>
           <a:xfrm>
-            <a:off x="8695944" y="5815584"/>
-            <a:ext cx="475488" cy="475488"/>
+            <a:off x="8165592" y="5724144"/>
+            <a:ext cx="566928" cy="566928"/>
           </a:xfrm>
           <a:prstGeom prst="ellipse">
             <a:avLst/>
@@ -18442,8 +18442,8 @@
         </p:blipFill>
         <p:spPr>
           <a:xfrm>
-            <a:off x="8810061" y="5929701"/>
-            <a:ext cx="247254" cy="247254"/>
+            <a:off x="8301655" y="5860207"/>
+            <a:ext cx="294803" cy="294803"/>
           </a:xfrm>
           <a:prstGeom prst="rect">
             <a:avLst/>
@@ -18458,8 +18458,8 @@
         </p:nvSpPr>
         <p:spPr>
           <a:xfrm>
-            <a:off x="9336024" y="5815584"/>
-            <a:ext cx="475488" cy="475488"/>
+            <a:off x="8915400" y="5724144"/>
+            <a:ext cx="566928" cy="566928"/>
           </a:xfrm>
           <a:prstGeom prst="ellipse">
             <a:avLst/>
@@ -18491,8 +18491,8 @@
         </p:blipFill>
         <p:spPr>
           <a:xfrm>
-            <a:off x="9450141" y="5929701"/>
-            <a:ext cx="247254" cy="247254"/>
+            <a:off x="9051463" y="5860207"/>
+            <a:ext cx="294803" cy="294803"/>
           </a:xfrm>
           <a:prstGeom prst="rect">
             <a:avLst/>
@@ -18507,8 +18507,8 @@
         </p:nvSpPr>
         <p:spPr>
           <a:xfrm>
-            <a:off x="9976104" y="5815584"/>
-            <a:ext cx="475488" cy="475488"/>
+            <a:off x="9665208" y="5724144"/>
+            <a:ext cx="566928" cy="566928"/>
           </a:xfrm>
           <a:prstGeom prst="ellipse">
             <a:avLst/>
@@ -18540,8 +18540,8 @@
         </p:blipFill>
         <p:spPr>
           <a:xfrm>
-            <a:off x="10090221" y="5929701"/>
-            <a:ext cx="247254" cy="247254"/>
+            <a:off x="9801271" y="5860207"/>
+            <a:ext cx="294803" cy="294803"/>
           </a:xfrm>
           <a:prstGeom prst="rect">
             <a:avLst/>
@@ -18556,8 +18556,8 @@
         </p:nvSpPr>
         <p:spPr>
           <a:xfrm>
-            <a:off x="10616184" y="5815584"/>
-            <a:ext cx="475488" cy="475488"/>
+            <a:off x="10415016" y="5724144"/>
+            <a:ext cx="566928" cy="566928"/>
           </a:xfrm>
           <a:prstGeom prst="ellipse">
             <a:avLst/>
@@ -18589,8 +18589,8 @@
         </p:blipFill>
         <p:spPr>
           <a:xfrm>
-            <a:off x="10730301" y="5929701"/>
-            <a:ext cx="247254" cy="247254"/>
+            <a:off x="10551079" y="5860207"/>
+            <a:ext cx="294803" cy="294803"/>
           </a:xfrm>
           <a:prstGeom prst="rect">
             <a:avLst/>
@@ -18605,8 +18605,8 @@
         </p:nvSpPr>
         <p:spPr>
           <a:xfrm>
-            <a:off x="11256264" y="5815584"/>
-            <a:ext cx="475488" cy="475488"/>
+            <a:off x="11164824" y="5724144"/>
+            <a:ext cx="566928" cy="566928"/>
           </a:xfrm>
           <a:prstGeom prst="ellipse">
             <a:avLst/>
@@ -18638,8 +18638,8 @@
         </p:blipFill>
         <p:spPr>
           <a:xfrm>
-            <a:off x="11370381" y="5929701"/>
-            <a:ext cx="247254" cy="247254"/>
+            <a:off x="11300887" y="5860207"/>
+            <a:ext cx="294803" cy="294803"/>
           </a:xfrm>
           <a:prstGeom prst="rect">
             <a:avLst/>
@@ -18654,7 +18654,7 @@
         </p:nvSpPr>
         <p:spPr>
           <a:xfrm>
-            <a:off x="7132320" y="6355080"/>
+            <a:off x="7132320" y="6373368"/>
             <a:ext cx="4599432" cy="256032"/>
           </a:xfrm>
           <a:prstGeom prst="rect">
@@ -19063,7 +19063,7 @@
         <p:spPr>
           <a:xfrm>
             <a:off x="457200" y="5303520"/>
-            <a:ext cx="8138160" cy="822960"/>
+            <a:ext cx="7589520" cy="822960"/>
           </a:xfrm>
           <a:prstGeom prst="rect">
             <a:avLst/>
@@ -19170,8 +19170,8 @@
         </p:nvSpPr>
         <p:spPr>
           <a:xfrm>
-            <a:off x="8695944" y="5815584"/>
-            <a:ext cx="475488" cy="475488"/>
+            <a:off x="8165592" y="5724144"/>
+            <a:ext cx="566928" cy="566928"/>
           </a:xfrm>
           <a:prstGeom prst="ellipse">
             <a:avLst/>
@@ -19203,8 +19203,8 @@
         </p:blipFill>
         <p:spPr>
           <a:xfrm>
-            <a:off x="8810061" y="5929701"/>
-            <a:ext cx="247254" cy="247254"/>
+            <a:off x="8301655" y="5860207"/>
+            <a:ext cx="294803" cy="294803"/>
           </a:xfrm>
           <a:prstGeom prst="rect">
             <a:avLst/>
@@ -19219,8 +19219,8 @@
         </p:nvSpPr>
         <p:spPr>
           <a:xfrm>
-            <a:off x="9336024" y="5815584"/>
-            <a:ext cx="475488" cy="475488"/>
+            <a:off x="8915400" y="5724144"/>
+            <a:ext cx="566928" cy="566928"/>
           </a:xfrm>
           <a:prstGeom prst="ellipse">
             <a:avLst/>
@@ -19252,8 +19252,8 @@
         </p:blipFill>
         <p:spPr>
           <a:xfrm>
-            <a:off x="9450141" y="5929701"/>
-            <a:ext cx="247254" cy="247254"/>
+            <a:off x="9051463" y="5860207"/>
+            <a:ext cx="294803" cy="294803"/>
           </a:xfrm>
           <a:prstGeom prst="rect">
             <a:avLst/>
@@ -19268,8 +19268,8 @@
         </p:nvSpPr>
         <p:spPr>
           <a:xfrm>
-            <a:off x="9976104" y="5815584"/>
-            <a:ext cx="475488" cy="475488"/>
+            <a:off x="9665208" y="5724144"/>
+            <a:ext cx="566928" cy="566928"/>
           </a:xfrm>
           <a:prstGeom prst="ellipse">
             <a:avLst/>
@@ -19301,8 +19301,8 @@
         </p:blipFill>
         <p:spPr>
           <a:xfrm>
-            <a:off x="10090221" y="5929701"/>
-            <a:ext cx="247254" cy="247254"/>
+            <a:off x="9801271" y="5860207"/>
+            <a:ext cx="294803" cy="294803"/>
           </a:xfrm>
           <a:prstGeom prst="rect">
             <a:avLst/>
@@ -19317,8 +19317,8 @@
         </p:nvSpPr>
         <p:spPr>
           <a:xfrm>
-            <a:off x="10616184" y="5815584"/>
-            <a:ext cx="475488" cy="475488"/>
+            <a:off x="10415016" y="5724144"/>
+            <a:ext cx="566928" cy="566928"/>
           </a:xfrm>
           <a:prstGeom prst="ellipse">
             <a:avLst/>
@@ -19350,8 +19350,8 @@
         </p:blipFill>
         <p:spPr>
           <a:xfrm>
-            <a:off x="10730301" y="5929701"/>
-            <a:ext cx="247254" cy="247254"/>
+            <a:off x="10551079" y="5860207"/>
+            <a:ext cx="294803" cy="294803"/>
           </a:xfrm>
           <a:prstGeom prst="rect">
             <a:avLst/>
@@ -19366,8 +19366,8 @@
         </p:nvSpPr>
         <p:spPr>
           <a:xfrm>
-            <a:off x="11256264" y="5815584"/>
-            <a:ext cx="475488" cy="475488"/>
+            <a:off x="11164824" y="5724144"/>
+            <a:ext cx="566928" cy="566928"/>
           </a:xfrm>
           <a:prstGeom prst="ellipse">
             <a:avLst/>
@@ -19399,8 +19399,8 @@
         </p:blipFill>
         <p:spPr>
           <a:xfrm>
-            <a:off x="11370381" y="5929701"/>
-            <a:ext cx="247254" cy="247254"/>
+            <a:off x="11300887" y="5860207"/>
+            <a:ext cx="294803" cy="294803"/>
           </a:xfrm>
           <a:prstGeom prst="rect">
             <a:avLst/>
@@ -19415,7 +19415,7 @@
         </p:nvSpPr>
         <p:spPr>
           <a:xfrm>
-            <a:off x="7132320" y="6355080"/>
+            <a:off x="7132320" y="6373368"/>
             <a:ext cx="4599432" cy="256032"/>
           </a:xfrm>
           <a:prstGeom prst="rect">
@@ -19676,11 +19676,11 @@
             <a:avLst/>
           </a:prstGeom>
           <a:solidFill>
-            <a:srgbClr val="F79646"/>
+            <a:srgbClr val="1F4E46"/>
           </a:solidFill>
           <a:ln w="12700">
             <a:solidFill>
-              <a:srgbClr val="F79646"/>
+              <a:srgbClr val="1F4E46"/>
             </a:solidFill>
             <a:prstDash val="solid"/>
           </a:ln>
@@ -19803,11 +19803,11 @@
             <a:avLst/>
           </a:prstGeom>
           <a:solidFill>
-            <a:srgbClr val="F79646"/>
+            <a:srgbClr val="1F4E46"/>
           </a:solidFill>
           <a:ln w="12700">
             <a:solidFill>
-              <a:srgbClr val="F79646"/>
+              <a:srgbClr val="1F4E46"/>
             </a:solidFill>
             <a:prstDash val="solid"/>
           </a:ln>
@@ -19930,11 +19930,11 @@
             <a:avLst/>
           </a:prstGeom>
           <a:solidFill>
-            <a:srgbClr val="F79646"/>
+            <a:srgbClr val="1F4E46"/>
           </a:solidFill>
           <a:ln w="12700">
             <a:solidFill>
-              <a:srgbClr val="F79646"/>
+              <a:srgbClr val="1F4E46"/>
             </a:solidFill>
             <a:prstDash val="solid"/>
           </a:ln>
@@ -20057,11 +20057,11 @@
             <a:avLst/>
           </a:prstGeom>
           <a:solidFill>
-            <a:srgbClr val="F79646"/>
+            <a:srgbClr val="1F4E46"/>
           </a:solidFill>
           <a:ln w="12700">
             <a:solidFill>
-              <a:srgbClr val="F79646"/>
+              <a:srgbClr val="1F4E46"/>
             </a:solidFill>
             <a:prstDash val="solid"/>
           </a:ln>
@@ -20184,11 +20184,11 @@
             <a:avLst/>
           </a:prstGeom>
           <a:solidFill>
-            <a:srgbClr val="F79646"/>
+            <a:srgbClr val="1F4E46"/>
           </a:solidFill>
           <a:ln w="12700">
             <a:solidFill>
-              <a:srgbClr val="F79646"/>
+              <a:srgbClr val="1F4E46"/>
             </a:solidFill>
             <a:prstDash val="solid"/>
           </a:ln>
@@ -20608,7 +20608,7 @@
         <p:spPr>
           <a:xfrm>
             <a:off x="457200" y="5303520"/>
-            <a:ext cx="8138160" cy="822960"/>
+            <a:ext cx="7589520" cy="822960"/>
           </a:xfrm>
           <a:prstGeom prst="rect">
             <a:avLst/>
@@ -20715,8 +20715,8 @@
         </p:nvSpPr>
         <p:spPr>
           <a:xfrm>
-            <a:off x="8695944" y="5815584"/>
-            <a:ext cx="475488" cy="475488"/>
+            <a:off x="8165592" y="5724144"/>
+            <a:ext cx="566928" cy="566928"/>
           </a:xfrm>
           <a:prstGeom prst="ellipse">
             <a:avLst/>
@@ -20748,8 +20748,8 @@
         </p:blipFill>
         <p:spPr>
           <a:xfrm>
-            <a:off x="8810061" y="5929701"/>
-            <a:ext cx="247254" cy="247254"/>
+            <a:off x="8301655" y="5860207"/>
+            <a:ext cx="294803" cy="294803"/>
           </a:xfrm>
           <a:prstGeom prst="rect">
             <a:avLst/>
@@ -20764,8 +20764,8 @@
         </p:nvSpPr>
         <p:spPr>
           <a:xfrm>
-            <a:off x="9336024" y="5815584"/>
-            <a:ext cx="475488" cy="475488"/>
+            <a:off x="8915400" y="5724144"/>
+            <a:ext cx="566928" cy="566928"/>
           </a:xfrm>
           <a:prstGeom prst="ellipse">
             <a:avLst/>
@@ -20797,8 +20797,8 @@
         </p:blipFill>
         <p:spPr>
           <a:xfrm>
-            <a:off x="9450141" y="5929701"/>
-            <a:ext cx="247254" cy="247254"/>
+            <a:off x="9051463" y="5860207"/>
+            <a:ext cx="294803" cy="294803"/>
           </a:xfrm>
           <a:prstGeom prst="rect">
             <a:avLst/>
@@ -20813,8 +20813,8 @@
         </p:nvSpPr>
         <p:spPr>
           <a:xfrm>
-            <a:off x="9976104" y="5815584"/>
-            <a:ext cx="475488" cy="475488"/>
+            <a:off x="9665208" y="5724144"/>
+            <a:ext cx="566928" cy="566928"/>
           </a:xfrm>
           <a:prstGeom prst="ellipse">
             <a:avLst/>
@@ -20846,8 +20846,8 @@
         </p:blipFill>
         <p:spPr>
           <a:xfrm>
-            <a:off x="10090221" y="5929701"/>
-            <a:ext cx="247254" cy="247254"/>
+            <a:off x="9801271" y="5860207"/>
+            <a:ext cx="294803" cy="294803"/>
           </a:xfrm>
           <a:prstGeom prst="rect">
             <a:avLst/>
@@ -20862,8 +20862,8 @@
         </p:nvSpPr>
         <p:spPr>
           <a:xfrm>
-            <a:off x="10616184" y="5815584"/>
-            <a:ext cx="475488" cy="475488"/>
+            <a:off x="10415016" y="5724144"/>
+            <a:ext cx="566928" cy="566928"/>
           </a:xfrm>
           <a:prstGeom prst="ellipse">
             <a:avLst/>
@@ -20895,8 +20895,8 @@
         </p:blipFill>
         <p:spPr>
           <a:xfrm>
-            <a:off x="10730301" y="5929701"/>
-            <a:ext cx="247254" cy="247254"/>
+            <a:off x="10551079" y="5860207"/>
+            <a:ext cx="294803" cy="294803"/>
           </a:xfrm>
           <a:prstGeom prst="rect">
             <a:avLst/>
@@ -20911,8 +20911,8 @@
         </p:nvSpPr>
         <p:spPr>
           <a:xfrm>
-            <a:off x="11256264" y="5815584"/>
-            <a:ext cx="475488" cy="475488"/>
+            <a:off x="11164824" y="5724144"/>
+            <a:ext cx="566928" cy="566928"/>
           </a:xfrm>
           <a:prstGeom prst="ellipse">
             <a:avLst/>
@@ -20944,8 +20944,8 @@
         </p:blipFill>
         <p:spPr>
           <a:xfrm>
-            <a:off x="11370381" y="5929701"/>
-            <a:ext cx="247254" cy="247254"/>
+            <a:off x="11300887" y="5860207"/>
+            <a:ext cx="294803" cy="294803"/>
           </a:xfrm>
           <a:prstGeom prst="rect">
             <a:avLst/>
@@ -20960,7 +20960,7 @@
         </p:nvSpPr>
         <p:spPr>
           <a:xfrm>
-            <a:off x="7132320" y="6355080"/>
+            <a:off x="7132320" y="6373368"/>
             <a:ext cx="4599432" cy="256032"/>
           </a:xfrm>
           <a:prstGeom prst="rect">
@@ -21369,7 +21369,7 @@
         <p:spPr>
           <a:xfrm>
             <a:off x="457200" y="5303520"/>
-            <a:ext cx="8138160" cy="822960"/>
+            <a:ext cx="7589520" cy="822960"/>
           </a:xfrm>
           <a:prstGeom prst="rect">
             <a:avLst/>
@@ -21476,8 +21476,8 @@
         </p:nvSpPr>
         <p:spPr>
           <a:xfrm>
-            <a:off x="8695944" y="5815584"/>
-            <a:ext cx="475488" cy="475488"/>
+            <a:off x="8165592" y="5724144"/>
+            <a:ext cx="566928" cy="566928"/>
           </a:xfrm>
           <a:prstGeom prst="ellipse">
             <a:avLst/>
@@ -21509,8 +21509,8 @@
         </p:blipFill>
         <p:spPr>
           <a:xfrm>
-            <a:off x="8810061" y="5929701"/>
-            <a:ext cx="247254" cy="247254"/>
+            <a:off x="8301655" y="5860207"/>
+            <a:ext cx="294803" cy="294803"/>
           </a:xfrm>
           <a:prstGeom prst="rect">
             <a:avLst/>
@@ -21525,8 +21525,8 @@
         </p:nvSpPr>
         <p:spPr>
           <a:xfrm>
-            <a:off x="9336024" y="5815584"/>
-            <a:ext cx="475488" cy="475488"/>
+            <a:off x="8915400" y="5724144"/>
+            <a:ext cx="566928" cy="566928"/>
           </a:xfrm>
           <a:prstGeom prst="ellipse">
             <a:avLst/>
@@ -21558,8 +21558,8 @@
         </p:blipFill>
         <p:spPr>
           <a:xfrm>
-            <a:off x="9450141" y="5929701"/>
-            <a:ext cx="247254" cy="247254"/>
+            <a:off x="9051463" y="5860207"/>
+            <a:ext cx="294803" cy="294803"/>
           </a:xfrm>
           <a:prstGeom prst="rect">
             <a:avLst/>
@@ -21574,8 +21574,8 @@
         </p:nvSpPr>
         <p:spPr>
           <a:xfrm>
-            <a:off x="9976104" y="5815584"/>
-            <a:ext cx="475488" cy="475488"/>
+            <a:off x="9665208" y="5724144"/>
+            <a:ext cx="566928" cy="566928"/>
           </a:xfrm>
           <a:prstGeom prst="ellipse">
             <a:avLst/>
@@ -21607,8 +21607,8 @@
         </p:blipFill>
         <p:spPr>
           <a:xfrm>
-            <a:off x="10090221" y="5929701"/>
-            <a:ext cx="247254" cy="247254"/>
+            <a:off x="9801271" y="5860207"/>
+            <a:ext cx="294803" cy="294803"/>
           </a:xfrm>
           <a:prstGeom prst="rect">
             <a:avLst/>
@@ -21623,8 +21623,8 @@
         </p:nvSpPr>
         <p:spPr>
           <a:xfrm>
-            <a:off x="10616184" y="5815584"/>
-            <a:ext cx="475488" cy="475488"/>
+            <a:off x="10415016" y="5724144"/>
+            <a:ext cx="566928" cy="566928"/>
           </a:xfrm>
           <a:prstGeom prst="ellipse">
             <a:avLst/>
@@ -21656,8 +21656,8 @@
         </p:blipFill>
         <p:spPr>
           <a:xfrm>
-            <a:off x="10730301" y="5929701"/>
-            <a:ext cx="247254" cy="247254"/>
+            <a:off x="10551079" y="5860207"/>
+            <a:ext cx="294803" cy="294803"/>
           </a:xfrm>
           <a:prstGeom prst="rect">
             <a:avLst/>
@@ -21672,8 +21672,8 @@
         </p:nvSpPr>
         <p:spPr>
           <a:xfrm>
-            <a:off x="11256264" y="5815584"/>
-            <a:ext cx="475488" cy="475488"/>
+            <a:off x="11164824" y="5724144"/>
+            <a:ext cx="566928" cy="566928"/>
           </a:xfrm>
           <a:prstGeom prst="ellipse">
             <a:avLst/>
@@ -21705,8 +21705,8 @@
         </p:blipFill>
         <p:spPr>
           <a:xfrm>
-            <a:off x="11370381" y="5929701"/>
-            <a:ext cx="247254" cy="247254"/>
+            <a:off x="11300887" y="5860207"/>
+            <a:ext cx="294803" cy="294803"/>
           </a:xfrm>
           <a:prstGeom prst="rect">
             <a:avLst/>
@@ -21721,7 +21721,7 @@
         </p:nvSpPr>
         <p:spPr>
           <a:xfrm>
-            <a:off x="7132320" y="6355080"/>
+            <a:off x="7132320" y="6373368"/>
             <a:ext cx="4599432" cy="256032"/>
           </a:xfrm>
           <a:prstGeom prst="rect">
@@ -22130,7 +22130,7 @@
         <p:spPr>
           <a:xfrm>
             <a:off x="457200" y="5303520"/>
-            <a:ext cx="8138160" cy="822960"/>
+            <a:ext cx="7589520" cy="822960"/>
           </a:xfrm>
           <a:prstGeom prst="rect">
             <a:avLst/>
@@ -22237,8 +22237,8 @@
         </p:nvSpPr>
         <p:spPr>
           <a:xfrm>
-            <a:off x="8695944" y="5815584"/>
-            <a:ext cx="475488" cy="475488"/>
+            <a:off x="8165592" y="5724144"/>
+            <a:ext cx="566928" cy="566928"/>
           </a:xfrm>
           <a:prstGeom prst="ellipse">
             <a:avLst/>
@@ -22270,8 +22270,8 @@
         </p:blipFill>
         <p:spPr>
           <a:xfrm>
-            <a:off x="8810061" y="5929701"/>
-            <a:ext cx="247254" cy="247254"/>
+            <a:off x="8301655" y="5860207"/>
+            <a:ext cx="294803" cy="294803"/>
           </a:xfrm>
           <a:prstGeom prst="rect">
             <a:avLst/>
@@ -22286,8 +22286,8 @@
         </p:nvSpPr>
         <p:spPr>
           <a:xfrm>
-            <a:off x="9336024" y="5815584"/>
-            <a:ext cx="475488" cy="475488"/>
+            <a:off x="8915400" y="5724144"/>
+            <a:ext cx="566928" cy="566928"/>
           </a:xfrm>
           <a:prstGeom prst="ellipse">
             <a:avLst/>
@@ -22319,8 +22319,8 @@
         </p:blipFill>
         <p:spPr>
           <a:xfrm>
-            <a:off x="9450141" y="5929701"/>
-            <a:ext cx="247254" cy="247254"/>
+            <a:off x="9051463" y="5860207"/>
+            <a:ext cx="294803" cy="294803"/>
           </a:xfrm>
           <a:prstGeom prst="rect">
             <a:avLst/>
@@ -22335,8 +22335,8 @@
         </p:nvSpPr>
         <p:spPr>
           <a:xfrm>
-            <a:off x="9976104" y="5815584"/>
-            <a:ext cx="475488" cy="475488"/>
+            <a:off x="9665208" y="5724144"/>
+            <a:ext cx="566928" cy="566928"/>
           </a:xfrm>
           <a:prstGeom prst="ellipse">
             <a:avLst/>
@@ -22368,8 +22368,8 @@
         </p:blipFill>
         <p:spPr>
           <a:xfrm>
-            <a:off x="10090221" y="5929701"/>
-            <a:ext cx="247254" cy="247254"/>
+            <a:off x="9801271" y="5860207"/>
+            <a:ext cx="294803" cy="294803"/>
           </a:xfrm>
           <a:prstGeom prst="rect">
             <a:avLst/>
@@ -22384,8 +22384,8 @@
         </p:nvSpPr>
         <p:spPr>
           <a:xfrm>
-            <a:off x="10616184" y="5815584"/>
-            <a:ext cx="475488" cy="475488"/>
+            <a:off x="10415016" y="5724144"/>
+            <a:ext cx="566928" cy="566928"/>
           </a:xfrm>
           <a:prstGeom prst="ellipse">
             <a:avLst/>
@@ -22417,8 +22417,8 @@
         </p:blipFill>
         <p:spPr>
           <a:xfrm>
-            <a:off x="10730301" y="5929701"/>
-            <a:ext cx="247254" cy="247254"/>
+            <a:off x="10551079" y="5860207"/>
+            <a:ext cx="294803" cy="294803"/>
           </a:xfrm>
           <a:prstGeom prst="rect">
             <a:avLst/>
@@ -22433,8 +22433,8 @@
         </p:nvSpPr>
         <p:spPr>
           <a:xfrm>
-            <a:off x="11256264" y="5815584"/>
-            <a:ext cx="475488" cy="475488"/>
+            <a:off x="11164824" y="5724144"/>
+            <a:ext cx="566928" cy="566928"/>
           </a:xfrm>
           <a:prstGeom prst="ellipse">
             <a:avLst/>
@@ -22466,8 +22466,8 @@
         </p:blipFill>
         <p:spPr>
           <a:xfrm>
-            <a:off x="11370381" y="5929701"/>
-            <a:ext cx="247254" cy="247254"/>
+            <a:off x="11300887" y="5860207"/>
+            <a:ext cx="294803" cy="294803"/>
           </a:xfrm>
           <a:prstGeom prst="rect">
             <a:avLst/>
@@ -22482,7 +22482,7 @@
         </p:nvSpPr>
         <p:spPr>
           <a:xfrm>
-            <a:off x="7132320" y="6355080"/>
+            <a:off x="7132320" y="6373368"/>
             <a:ext cx="4599432" cy="256032"/>
           </a:xfrm>
           <a:prstGeom prst="rect">
@@ -22891,7 +22891,7 @@
         <p:spPr>
           <a:xfrm>
             <a:off x="457200" y="5303520"/>
-            <a:ext cx="8138160" cy="822960"/>
+            <a:ext cx="7589520" cy="822960"/>
           </a:xfrm>
           <a:prstGeom prst="rect">
             <a:avLst/>
@@ -22998,8 +22998,8 @@
         </p:nvSpPr>
         <p:spPr>
           <a:xfrm>
-            <a:off x="8695944" y="5815584"/>
-            <a:ext cx="475488" cy="475488"/>
+            <a:off x="8165592" y="5724144"/>
+            <a:ext cx="566928" cy="566928"/>
           </a:xfrm>
           <a:prstGeom prst="ellipse">
             <a:avLst/>
@@ -23031,8 +23031,8 @@
         </p:blipFill>
         <p:spPr>
           <a:xfrm>
-            <a:off x="8810061" y="5929701"/>
-            <a:ext cx="247254" cy="247254"/>
+            <a:off x="8301655" y="5860207"/>
+            <a:ext cx="294803" cy="294803"/>
           </a:xfrm>
           <a:prstGeom prst="rect">
             <a:avLst/>
@@ -23047,8 +23047,8 @@
         </p:nvSpPr>
         <p:spPr>
           <a:xfrm>
-            <a:off x="9336024" y="5815584"/>
-            <a:ext cx="475488" cy="475488"/>
+            <a:off x="8915400" y="5724144"/>
+            <a:ext cx="566928" cy="566928"/>
           </a:xfrm>
           <a:prstGeom prst="ellipse">
             <a:avLst/>
@@ -23080,8 +23080,8 @@
         </p:blipFill>
         <p:spPr>
           <a:xfrm>
-            <a:off x="9450141" y="5929701"/>
-            <a:ext cx="247254" cy="247254"/>
+            <a:off x="9051463" y="5860207"/>
+            <a:ext cx="294803" cy="294803"/>
           </a:xfrm>
           <a:prstGeom prst="rect">
             <a:avLst/>
@@ -23096,8 +23096,8 @@
         </p:nvSpPr>
         <p:spPr>
           <a:xfrm>
-            <a:off x="9976104" y="5815584"/>
-            <a:ext cx="475488" cy="475488"/>
+            <a:off x="9665208" y="5724144"/>
+            <a:ext cx="566928" cy="566928"/>
           </a:xfrm>
           <a:prstGeom prst="ellipse">
             <a:avLst/>
@@ -23129,8 +23129,8 @@
         </p:blipFill>
         <p:spPr>
           <a:xfrm>
-            <a:off x="10090221" y="5929701"/>
-            <a:ext cx="247254" cy="247254"/>
+            <a:off x="9801271" y="5860207"/>
+            <a:ext cx="294803" cy="294803"/>
           </a:xfrm>
           <a:prstGeom prst="rect">
             <a:avLst/>
@@ -23145,8 +23145,8 @@
         </p:nvSpPr>
         <p:spPr>
           <a:xfrm>
-            <a:off x="10616184" y="5815584"/>
-            <a:ext cx="475488" cy="475488"/>
+            <a:off x="10415016" y="5724144"/>
+            <a:ext cx="566928" cy="566928"/>
           </a:xfrm>
           <a:prstGeom prst="ellipse">
             <a:avLst/>
@@ -23178,8 +23178,8 @@
         </p:blipFill>
         <p:spPr>
           <a:xfrm>
-            <a:off x="10730301" y="5929701"/>
-            <a:ext cx="247254" cy="247254"/>
+            <a:off x="10551079" y="5860207"/>
+            <a:ext cx="294803" cy="294803"/>
           </a:xfrm>
           <a:prstGeom prst="rect">
             <a:avLst/>
@@ -23194,8 +23194,8 @@
         </p:nvSpPr>
         <p:spPr>
           <a:xfrm>
-            <a:off x="11256264" y="5815584"/>
-            <a:ext cx="475488" cy="475488"/>
+            <a:off x="11164824" y="5724144"/>
+            <a:ext cx="566928" cy="566928"/>
           </a:xfrm>
           <a:prstGeom prst="ellipse">
             <a:avLst/>
@@ -23227,8 +23227,8 @@
         </p:blipFill>
         <p:spPr>
           <a:xfrm>
-            <a:off x="11370381" y="5929701"/>
-            <a:ext cx="247254" cy="247254"/>
+            <a:off x="11300887" y="5860207"/>
+            <a:ext cx="294803" cy="294803"/>
           </a:xfrm>
           <a:prstGeom prst="rect">
             <a:avLst/>
@@ -23243,7 +23243,7 @@
         </p:nvSpPr>
         <p:spPr>
           <a:xfrm>
-            <a:off x="7132320" y="6355080"/>
+            <a:off x="7132320" y="6373368"/>
             <a:ext cx="4599432" cy="256032"/>
           </a:xfrm>
           <a:prstGeom prst="rect">
@@ -23670,7 +23670,7 @@
         <p:spPr>
           <a:xfrm>
             <a:off x="457200" y="5303520"/>
-            <a:ext cx="8138160" cy="822960"/>
+            <a:ext cx="7589520" cy="822960"/>
           </a:xfrm>
           <a:prstGeom prst="rect">
             <a:avLst/>
@@ -23722,8 +23722,8 @@
         </p:nvSpPr>
         <p:spPr>
           <a:xfrm>
-            <a:off x="8695944" y="5815584"/>
-            <a:ext cx="475488" cy="475488"/>
+            <a:off x="8165592" y="5724144"/>
+            <a:ext cx="566928" cy="566928"/>
           </a:xfrm>
           <a:prstGeom prst="ellipse">
             <a:avLst/>
@@ -23755,8 +23755,8 @@
         </p:blipFill>
         <p:spPr>
           <a:xfrm>
-            <a:off x="8810061" y="5929701"/>
-            <a:ext cx="247254" cy="247254"/>
+            <a:off x="8301655" y="5860207"/>
+            <a:ext cx="294803" cy="294803"/>
           </a:xfrm>
           <a:prstGeom prst="rect">
             <a:avLst/>
@@ -23771,8 +23771,8 @@
         </p:nvSpPr>
         <p:spPr>
           <a:xfrm>
-            <a:off x="9336024" y="5815584"/>
-            <a:ext cx="475488" cy="475488"/>
+            <a:off x="8915400" y="5724144"/>
+            <a:ext cx="566928" cy="566928"/>
           </a:xfrm>
           <a:prstGeom prst="ellipse">
             <a:avLst/>
@@ -23804,8 +23804,8 @@
         </p:blipFill>
         <p:spPr>
           <a:xfrm>
-            <a:off x="9450141" y="5929701"/>
-            <a:ext cx="247254" cy="247254"/>
+            <a:off x="9051463" y="5860207"/>
+            <a:ext cx="294803" cy="294803"/>
           </a:xfrm>
           <a:prstGeom prst="rect">
             <a:avLst/>
@@ -23820,8 +23820,8 @@
         </p:nvSpPr>
         <p:spPr>
           <a:xfrm>
-            <a:off x="9976104" y="5815584"/>
-            <a:ext cx="475488" cy="475488"/>
+            <a:off x="9665208" y="5724144"/>
+            <a:ext cx="566928" cy="566928"/>
           </a:xfrm>
           <a:prstGeom prst="ellipse">
             <a:avLst/>
@@ -23853,8 +23853,8 @@
         </p:blipFill>
         <p:spPr>
           <a:xfrm>
-            <a:off x="10090221" y="5929701"/>
-            <a:ext cx="247254" cy="247254"/>
+            <a:off x="9801271" y="5860207"/>
+            <a:ext cx="294803" cy="294803"/>
           </a:xfrm>
           <a:prstGeom prst="rect">
             <a:avLst/>
@@ -23869,8 +23869,8 @@
         </p:nvSpPr>
         <p:spPr>
           <a:xfrm>
-            <a:off x="10616184" y="5815584"/>
-            <a:ext cx="475488" cy="475488"/>
+            <a:off x="10415016" y="5724144"/>
+            <a:ext cx="566928" cy="566928"/>
           </a:xfrm>
           <a:prstGeom prst="ellipse">
             <a:avLst/>
@@ -23902,8 +23902,8 @@
         </p:blipFill>
         <p:spPr>
           <a:xfrm>
-            <a:off x="10730301" y="5929701"/>
-            <a:ext cx="247254" cy="247254"/>
+            <a:off x="10551079" y="5860207"/>
+            <a:ext cx="294803" cy="294803"/>
           </a:xfrm>
           <a:prstGeom prst="rect">
             <a:avLst/>
@@ -23918,8 +23918,8 @@
         </p:nvSpPr>
         <p:spPr>
           <a:xfrm>
-            <a:off x="11256264" y="5815584"/>
-            <a:ext cx="475488" cy="475488"/>
+            <a:off x="11164824" y="5724144"/>
+            <a:ext cx="566928" cy="566928"/>
           </a:xfrm>
           <a:prstGeom prst="ellipse">
             <a:avLst/>
@@ -23951,8 +23951,8 @@
         </p:blipFill>
         <p:spPr>
           <a:xfrm>
-            <a:off x="11370381" y="5929701"/>
-            <a:ext cx="247254" cy="247254"/>
+            <a:off x="11300887" y="5860207"/>
+            <a:ext cx="294803" cy="294803"/>
           </a:xfrm>
           <a:prstGeom prst="rect">
             <a:avLst/>
@@ -23967,7 +23967,7 @@
         </p:nvSpPr>
         <p:spPr>
           <a:xfrm>
-            <a:off x="7132320" y="6355080"/>
+            <a:off x="7132320" y="6373368"/>
             <a:ext cx="4599432" cy="256032"/>
           </a:xfrm>
           <a:prstGeom prst="rect">
@@ -33999,7 +33999,7 @@
         <p:spPr>
           <a:xfrm>
             <a:off x="457200" y="5303520"/>
-            <a:ext cx="8138160" cy="822960"/>
+            <a:ext cx="7589520" cy="822960"/>
           </a:xfrm>
           <a:prstGeom prst="rect">
             <a:avLst/>
@@ -34106,8 +34106,8 @@
         </p:nvSpPr>
         <p:spPr>
           <a:xfrm>
-            <a:off x="8695944" y="5815584"/>
-            <a:ext cx="475488" cy="475488"/>
+            <a:off x="8165592" y="5724144"/>
+            <a:ext cx="566928" cy="566928"/>
           </a:xfrm>
           <a:prstGeom prst="ellipse">
             <a:avLst/>
@@ -34139,8 +34139,8 @@
         </p:blipFill>
         <p:spPr>
           <a:xfrm>
-            <a:off x="8810061" y="5929701"/>
-            <a:ext cx="247254" cy="247254"/>
+            <a:off x="8301655" y="5860207"/>
+            <a:ext cx="294803" cy="294803"/>
           </a:xfrm>
           <a:prstGeom prst="rect">
             <a:avLst/>
@@ -34155,8 +34155,8 @@
         </p:nvSpPr>
         <p:spPr>
           <a:xfrm>
-            <a:off x="9336024" y="5815584"/>
-            <a:ext cx="475488" cy="475488"/>
+            <a:off x="8915400" y="5724144"/>
+            <a:ext cx="566928" cy="566928"/>
           </a:xfrm>
           <a:prstGeom prst="ellipse">
             <a:avLst/>
@@ -34188,8 +34188,8 @@
         </p:blipFill>
         <p:spPr>
           <a:xfrm>
-            <a:off x="9450141" y="5929701"/>
-            <a:ext cx="247254" cy="247254"/>
+            <a:off x="9051463" y="5860207"/>
+            <a:ext cx="294803" cy="294803"/>
           </a:xfrm>
           <a:prstGeom prst="rect">
             <a:avLst/>
@@ -34204,8 +34204,8 @@
         </p:nvSpPr>
         <p:spPr>
           <a:xfrm>
-            <a:off x="9976104" y="5815584"/>
-            <a:ext cx="475488" cy="475488"/>
+            <a:off x="9665208" y="5724144"/>
+            <a:ext cx="566928" cy="566928"/>
           </a:xfrm>
           <a:prstGeom prst="ellipse">
             <a:avLst/>
@@ -34237,8 +34237,8 @@
         </p:blipFill>
         <p:spPr>
           <a:xfrm>
-            <a:off x="10090221" y="5929701"/>
-            <a:ext cx="247254" cy="247254"/>
+            <a:off x="9801271" y="5860207"/>
+            <a:ext cx="294803" cy="294803"/>
           </a:xfrm>
           <a:prstGeom prst="rect">
             <a:avLst/>
@@ -34253,8 +34253,8 @@
         </p:nvSpPr>
         <p:spPr>
           <a:xfrm>
-            <a:off x="10616184" y="5815584"/>
-            <a:ext cx="475488" cy="475488"/>
+            <a:off x="10415016" y="5724144"/>
+            <a:ext cx="566928" cy="566928"/>
           </a:xfrm>
           <a:prstGeom prst="ellipse">
             <a:avLst/>
@@ -34286,8 +34286,8 @@
         </p:blipFill>
         <p:spPr>
           <a:xfrm>
-            <a:off x="10730301" y="5929701"/>
-            <a:ext cx="247254" cy="247254"/>
+            <a:off x="10551079" y="5860207"/>
+            <a:ext cx="294803" cy="294803"/>
           </a:xfrm>
           <a:prstGeom prst="rect">
             <a:avLst/>
@@ -34302,8 +34302,8 @@
         </p:nvSpPr>
         <p:spPr>
           <a:xfrm>
-            <a:off x="11256264" y="5815584"/>
-            <a:ext cx="475488" cy="475488"/>
+            <a:off x="11164824" y="5724144"/>
+            <a:ext cx="566928" cy="566928"/>
           </a:xfrm>
           <a:prstGeom prst="ellipse">
             <a:avLst/>
@@ -34335,8 +34335,8 @@
         </p:blipFill>
         <p:spPr>
           <a:xfrm>
-            <a:off x="11370381" y="5929701"/>
-            <a:ext cx="247254" cy="247254"/>
+            <a:off x="11300887" y="5860207"/>
+            <a:ext cx="294803" cy="294803"/>
           </a:xfrm>
           <a:prstGeom prst="rect">
             <a:avLst/>
@@ -34351,7 +34351,7 @@
         </p:nvSpPr>
         <p:spPr>
           <a:xfrm>
-            <a:off x="7132320" y="6355080"/>
+            <a:off x="7132320" y="6373368"/>
             <a:ext cx="4599432" cy="256032"/>
           </a:xfrm>
           <a:prstGeom prst="rect">
@@ -34760,7 +34760,7 @@
         <p:spPr>
           <a:xfrm>
             <a:off x="457200" y="5303520"/>
-            <a:ext cx="8138160" cy="822960"/>
+            <a:ext cx="7589520" cy="822960"/>
           </a:xfrm>
           <a:prstGeom prst="rect">
             <a:avLst/>
@@ -34824,8 +34824,8 @@
         </p:nvSpPr>
         <p:spPr>
           <a:xfrm>
-            <a:off x="8695944" y="5815584"/>
-            <a:ext cx="475488" cy="475488"/>
+            <a:off x="8165592" y="5724144"/>
+            <a:ext cx="566928" cy="566928"/>
           </a:xfrm>
           <a:prstGeom prst="ellipse">
             <a:avLst/>
@@ -34857,8 +34857,8 @@
         </p:blipFill>
         <p:spPr>
           <a:xfrm>
-            <a:off x="8810061" y="5929701"/>
-            <a:ext cx="247254" cy="247254"/>
+            <a:off x="8301655" y="5860207"/>
+            <a:ext cx="294803" cy="294803"/>
           </a:xfrm>
           <a:prstGeom prst="rect">
             <a:avLst/>
@@ -34873,8 +34873,8 @@
         </p:nvSpPr>
         <p:spPr>
           <a:xfrm>
-            <a:off x="9336024" y="5815584"/>
-            <a:ext cx="475488" cy="475488"/>
+            <a:off x="8915400" y="5724144"/>
+            <a:ext cx="566928" cy="566928"/>
           </a:xfrm>
           <a:prstGeom prst="ellipse">
             <a:avLst/>
@@ -34906,8 +34906,8 @@
         </p:blipFill>
         <p:spPr>
           <a:xfrm>
-            <a:off x="9450141" y="5929701"/>
-            <a:ext cx="247254" cy="247254"/>
+            <a:off x="9051463" y="5860207"/>
+            <a:ext cx="294803" cy="294803"/>
           </a:xfrm>
           <a:prstGeom prst="rect">
             <a:avLst/>
@@ -34922,8 +34922,8 @@
         </p:nvSpPr>
         <p:spPr>
           <a:xfrm>
-            <a:off x="9976104" y="5815584"/>
-            <a:ext cx="475488" cy="475488"/>
+            <a:off x="9665208" y="5724144"/>
+            <a:ext cx="566928" cy="566928"/>
           </a:xfrm>
           <a:prstGeom prst="ellipse">
             <a:avLst/>
@@ -34955,8 +34955,8 @@
         </p:blipFill>
         <p:spPr>
           <a:xfrm>
-            <a:off x="10090221" y="5929701"/>
-            <a:ext cx="247254" cy="247254"/>
+            <a:off x="9801271" y="5860207"/>
+            <a:ext cx="294803" cy="294803"/>
           </a:xfrm>
           <a:prstGeom prst="rect">
             <a:avLst/>
@@ -34971,8 +34971,8 @@
         </p:nvSpPr>
         <p:spPr>
           <a:xfrm>
-            <a:off x="10616184" y="5815584"/>
-            <a:ext cx="475488" cy="475488"/>
+            <a:off x="10415016" y="5724144"/>
+            <a:ext cx="566928" cy="566928"/>
           </a:xfrm>
           <a:prstGeom prst="ellipse">
             <a:avLst/>
@@ -35004,8 +35004,8 @@
         </p:blipFill>
         <p:spPr>
           <a:xfrm>
-            <a:off x="10730301" y="5929701"/>
-            <a:ext cx="247254" cy="247254"/>
+            <a:off x="10551079" y="5860207"/>
+            <a:ext cx="294803" cy="294803"/>
           </a:xfrm>
           <a:prstGeom prst="rect">
             <a:avLst/>
@@ -35020,8 +35020,8 @@
         </p:nvSpPr>
         <p:spPr>
           <a:xfrm>
-            <a:off x="11256264" y="5815584"/>
-            <a:ext cx="475488" cy="475488"/>
+            <a:off x="11164824" y="5724144"/>
+            <a:ext cx="566928" cy="566928"/>
           </a:xfrm>
           <a:prstGeom prst="ellipse">
             <a:avLst/>
@@ -35053,8 +35053,8 @@
         </p:blipFill>
         <p:spPr>
           <a:xfrm>
-            <a:off x="11370381" y="5929701"/>
-            <a:ext cx="247254" cy="247254"/>
+            <a:off x="11300887" y="5860207"/>
+            <a:ext cx="294803" cy="294803"/>
           </a:xfrm>
           <a:prstGeom prst="rect">
             <a:avLst/>
@@ -35069,7 +35069,7 @@
         </p:nvSpPr>
         <p:spPr>
           <a:xfrm>
-            <a:off x="7132320" y="6355080"/>
+            <a:off x="7132320" y="6373368"/>
             <a:ext cx="4599432" cy="256032"/>
           </a:xfrm>
           <a:prstGeom prst="rect">
@@ -35439,7 +35439,7 @@
         <p:spPr>
           <a:xfrm>
             <a:off x="457200" y="5303520"/>
-            <a:ext cx="8138160" cy="822960"/>
+            <a:ext cx="7589520" cy="822960"/>
           </a:xfrm>
           <a:prstGeom prst="rect">
             <a:avLst/>
@@ -35589,8 +35589,8 @@
         </p:nvSpPr>
         <p:spPr>
           <a:xfrm>
-            <a:off x="8695944" y="5815584"/>
-            <a:ext cx="475488" cy="475488"/>
+            <a:off x="8165592" y="5724144"/>
+            <a:ext cx="566928" cy="566928"/>
           </a:xfrm>
           <a:prstGeom prst="ellipse">
             <a:avLst/>
@@ -35622,8 +35622,8 @@
         </p:blipFill>
         <p:spPr>
           <a:xfrm>
-            <a:off x="8810061" y="5929701"/>
-            <a:ext cx="247254" cy="247254"/>
+            <a:off x="8301655" y="5860207"/>
+            <a:ext cx="294803" cy="294803"/>
           </a:xfrm>
           <a:prstGeom prst="rect">
             <a:avLst/>
@@ -35638,8 +35638,8 @@
         </p:nvSpPr>
         <p:spPr>
           <a:xfrm>
-            <a:off x="9336024" y="5815584"/>
-            <a:ext cx="475488" cy="475488"/>
+            <a:off x="8915400" y="5724144"/>
+            <a:ext cx="566928" cy="566928"/>
           </a:xfrm>
           <a:prstGeom prst="ellipse">
             <a:avLst/>
@@ -35671,8 +35671,8 @@
         </p:blipFill>
         <p:spPr>
           <a:xfrm>
-            <a:off x="9450141" y="5929701"/>
-            <a:ext cx="247254" cy="247254"/>
+            <a:off x="9051463" y="5860207"/>
+            <a:ext cx="294803" cy="294803"/>
           </a:xfrm>
           <a:prstGeom prst="rect">
             <a:avLst/>
@@ -35687,8 +35687,8 @@
         </p:nvSpPr>
         <p:spPr>
           <a:xfrm>
-            <a:off x="9976104" y="5815584"/>
-            <a:ext cx="475488" cy="475488"/>
+            <a:off x="9665208" y="5724144"/>
+            <a:ext cx="566928" cy="566928"/>
           </a:xfrm>
           <a:prstGeom prst="ellipse">
             <a:avLst/>
@@ -35720,8 +35720,8 @@
         </p:blipFill>
         <p:spPr>
           <a:xfrm>
-            <a:off x="10090221" y="5929701"/>
-            <a:ext cx="247254" cy="247254"/>
+            <a:off x="9801271" y="5860207"/>
+            <a:ext cx="294803" cy="294803"/>
           </a:xfrm>
           <a:prstGeom prst="rect">
             <a:avLst/>
@@ -35736,8 +35736,8 @@
         </p:nvSpPr>
         <p:spPr>
           <a:xfrm>
-            <a:off x="10616184" y="5815584"/>
-            <a:ext cx="475488" cy="475488"/>
+            <a:off x="10415016" y="5724144"/>
+            <a:ext cx="566928" cy="566928"/>
           </a:xfrm>
           <a:prstGeom prst="ellipse">
             <a:avLst/>
@@ -35769,8 +35769,8 @@
         </p:blipFill>
         <p:spPr>
           <a:xfrm>
-            <a:off x="10730301" y="5929701"/>
-            <a:ext cx="247254" cy="247254"/>
+            <a:off x="10551079" y="5860207"/>
+            <a:ext cx="294803" cy="294803"/>
           </a:xfrm>
           <a:prstGeom prst="rect">
             <a:avLst/>
@@ -35785,8 +35785,8 @@
         </p:nvSpPr>
         <p:spPr>
           <a:xfrm>
-            <a:off x="11256264" y="5815584"/>
-            <a:ext cx="475488" cy="475488"/>
+            <a:off x="11164824" y="5724144"/>
+            <a:ext cx="566928" cy="566928"/>
           </a:xfrm>
           <a:prstGeom prst="ellipse">
             <a:avLst/>
@@ -35818,8 +35818,8 @@
         </p:blipFill>
         <p:spPr>
           <a:xfrm>
-            <a:off x="11370381" y="5929701"/>
-            <a:ext cx="247254" cy="247254"/>
+            <a:off x="11300887" y="5860207"/>
+            <a:ext cx="294803" cy="294803"/>
           </a:xfrm>
           <a:prstGeom prst="rect">
             <a:avLst/>
@@ -35834,7 +35834,7 @@
         </p:nvSpPr>
         <p:spPr>
           <a:xfrm>
-            <a:off x="7132320" y="6355080"/>
+            <a:off x="7132320" y="6373368"/>
             <a:ext cx="4599432" cy="256032"/>
           </a:xfrm>
           <a:prstGeom prst="rect">
@@ -36204,7 +36204,7 @@
         <p:spPr>
           <a:xfrm>
             <a:off x="457200" y="5303520"/>
-            <a:ext cx="8138160" cy="822960"/>
+            <a:ext cx="7589520" cy="822960"/>
           </a:xfrm>
           <a:prstGeom prst="rect">
             <a:avLst/>
@@ -36311,8 +36311,8 @@
         </p:nvSpPr>
         <p:spPr>
           <a:xfrm>
-            <a:off x="8695944" y="5815584"/>
-            <a:ext cx="475488" cy="475488"/>
+            <a:off x="8165592" y="5724144"/>
+            <a:ext cx="566928" cy="566928"/>
           </a:xfrm>
           <a:prstGeom prst="ellipse">
             <a:avLst/>
@@ -36344,8 +36344,8 @@
         </p:blipFill>
         <p:spPr>
           <a:xfrm>
-            <a:off x="8810061" y="5929701"/>
-            <a:ext cx="247254" cy="247254"/>
+            <a:off x="8301655" y="5860207"/>
+            <a:ext cx="294803" cy="294803"/>
           </a:xfrm>
           <a:prstGeom prst="rect">
             <a:avLst/>
@@ -36360,8 +36360,8 @@
         </p:nvSpPr>
         <p:spPr>
           <a:xfrm>
-            <a:off x="9336024" y="5815584"/>
-            <a:ext cx="475488" cy="475488"/>
+            <a:off x="8915400" y="5724144"/>
+            <a:ext cx="566928" cy="566928"/>
           </a:xfrm>
           <a:prstGeom prst="ellipse">
             <a:avLst/>
@@ -36393,8 +36393,8 @@
         </p:blipFill>
         <p:spPr>
           <a:xfrm>
-            <a:off x="9450141" y="5929701"/>
-            <a:ext cx="247254" cy="247254"/>
+            <a:off x="9051463" y="5860207"/>
+            <a:ext cx="294803" cy="294803"/>
           </a:xfrm>
           <a:prstGeom prst="rect">
             <a:avLst/>
@@ -36409,8 +36409,8 @@
         </p:nvSpPr>
         <p:spPr>
           <a:xfrm>
-            <a:off x="9976104" y="5815584"/>
-            <a:ext cx="475488" cy="475488"/>
+            <a:off x="9665208" y="5724144"/>
+            <a:ext cx="566928" cy="566928"/>
           </a:xfrm>
           <a:prstGeom prst="ellipse">
             <a:avLst/>
@@ -36442,8 +36442,8 @@
         </p:blipFill>
         <p:spPr>
           <a:xfrm>
-            <a:off x="10090221" y="5929701"/>
-            <a:ext cx="247254" cy="247254"/>
+            <a:off x="9801271" y="5860207"/>
+            <a:ext cx="294803" cy="294803"/>
           </a:xfrm>
           <a:prstGeom prst="rect">
             <a:avLst/>
@@ -36458,8 +36458,8 @@
         </p:nvSpPr>
         <p:spPr>
           <a:xfrm>
-            <a:off x="10616184" y="5815584"/>
-            <a:ext cx="475488" cy="475488"/>
+            <a:off x="10415016" y="5724144"/>
+            <a:ext cx="566928" cy="566928"/>
           </a:xfrm>
           <a:prstGeom prst="ellipse">
             <a:avLst/>
@@ -36491,8 +36491,8 @@
         </p:blipFill>
         <p:spPr>
           <a:xfrm>
-            <a:off x="10730301" y="5929701"/>
-            <a:ext cx="247254" cy="247254"/>
+            <a:off x="10551079" y="5860207"/>
+            <a:ext cx="294803" cy="294803"/>
           </a:xfrm>
           <a:prstGeom prst="rect">
             <a:avLst/>
@@ -36507,8 +36507,8 @@
         </p:nvSpPr>
         <p:spPr>
           <a:xfrm>
-            <a:off x="11256264" y="5815584"/>
-            <a:ext cx="475488" cy="475488"/>
+            <a:off x="11164824" y="5724144"/>
+            <a:ext cx="566928" cy="566928"/>
           </a:xfrm>
           <a:prstGeom prst="ellipse">
             <a:avLst/>
@@ -36540,8 +36540,8 @@
         </p:blipFill>
         <p:spPr>
           <a:xfrm>
-            <a:off x="11370381" y="5929701"/>
-            <a:ext cx="247254" cy="247254"/>
+            <a:off x="11300887" y="5860207"/>
+            <a:ext cx="294803" cy="294803"/>
           </a:xfrm>
           <a:prstGeom prst="rect">
             <a:avLst/>
@@ -36556,7 +36556,7 @@
         </p:nvSpPr>
         <p:spPr>
           <a:xfrm>
-            <a:off x="7132320" y="6355080"/>
+            <a:off x="7132320" y="6373368"/>
             <a:ext cx="4599432" cy="256032"/>
           </a:xfrm>
           <a:prstGeom prst="rect">
@@ -36965,7 +36965,7 @@
         <p:spPr>
           <a:xfrm>
             <a:off x="457200" y="5303520"/>
-            <a:ext cx="8138160" cy="822960"/>
+            <a:ext cx="7589520" cy="822960"/>
           </a:xfrm>
           <a:prstGeom prst="rect">
             <a:avLst/>
@@ -37072,8 +37072,8 @@
         </p:nvSpPr>
         <p:spPr>
           <a:xfrm>
-            <a:off x="8695944" y="5815584"/>
-            <a:ext cx="475488" cy="475488"/>
+            <a:off x="8165592" y="5724144"/>
+            <a:ext cx="566928" cy="566928"/>
           </a:xfrm>
           <a:prstGeom prst="ellipse">
             <a:avLst/>
@@ -37105,8 +37105,8 @@
         </p:blipFill>
         <p:spPr>
           <a:xfrm>
-            <a:off x="8810061" y="5929701"/>
-            <a:ext cx="247254" cy="247254"/>
+            <a:off x="8301655" y="5860207"/>
+            <a:ext cx="294803" cy="294803"/>
           </a:xfrm>
           <a:prstGeom prst="rect">
             <a:avLst/>
@@ -37121,8 +37121,8 @@
         </p:nvSpPr>
         <p:spPr>
           <a:xfrm>
-            <a:off x="9336024" y="5815584"/>
-            <a:ext cx="475488" cy="475488"/>
+            <a:off x="8915400" y="5724144"/>
+            <a:ext cx="566928" cy="566928"/>
           </a:xfrm>
           <a:prstGeom prst="ellipse">
             <a:avLst/>
@@ -37154,8 +37154,8 @@
         </p:blipFill>
         <p:spPr>
           <a:xfrm>
-            <a:off x="9450141" y="5929701"/>
-            <a:ext cx="247254" cy="247254"/>
+            <a:off x="9051463" y="5860207"/>
+            <a:ext cx="294803" cy="294803"/>
           </a:xfrm>
           <a:prstGeom prst="rect">
             <a:avLst/>
@@ -37170,8 +37170,8 @@
         </p:nvSpPr>
         <p:spPr>
           <a:xfrm>
-            <a:off x="9976104" y="5815584"/>
-            <a:ext cx="475488" cy="475488"/>
+            <a:off x="9665208" y="5724144"/>
+            <a:ext cx="566928" cy="566928"/>
           </a:xfrm>
           <a:prstGeom prst="ellipse">
             <a:avLst/>
@@ -37203,8 +37203,8 @@
         </p:blipFill>
         <p:spPr>
           <a:xfrm>
-            <a:off x="10090221" y="5929701"/>
-            <a:ext cx="247254" cy="247254"/>
+            <a:off x="9801271" y="5860207"/>
+            <a:ext cx="294803" cy="294803"/>
           </a:xfrm>
           <a:prstGeom prst="rect">
             <a:avLst/>
@@ -37219,8 +37219,8 @@
         </p:nvSpPr>
         <p:spPr>
           <a:xfrm>
-            <a:off x="10616184" y="5815584"/>
-            <a:ext cx="475488" cy="475488"/>
+            <a:off x="10415016" y="5724144"/>
+            <a:ext cx="566928" cy="566928"/>
           </a:xfrm>
           <a:prstGeom prst="ellipse">
             <a:avLst/>
@@ -37252,8 +37252,8 @@
         </p:blipFill>
         <p:spPr>
           <a:xfrm>
-            <a:off x="10730301" y="5929701"/>
-            <a:ext cx="247254" cy="247254"/>
+            <a:off x="10551079" y="5860207"/>
+            <a:ext cx="294803" cy="294803"/>
           </a:xfrm>
           <a:prstGeom prst="rect">
             <a:avLst/>
@@ -37268,8 +37268,8 @@
         </p:nvSpPr>
         <p:spPr>
           <a:xfrm>
-            <a:off x="11256264" y="5815584"/>
-            <a:ext cx="475488" cy="475488"/>
+            <a:off x="11164824" y="5724144"/>
+            <a:ext cx="566928" cy="566928"/>
           </a:xfrm>
           <a:prstGeom prst="ellipse">
             <a:avLst/>
@@ -37301,8 +37301,8 @@
         </p:blipFill>
         <p:spPr>
           <a:xfrm>
-            <a:off x="11370381" y="5929701"/>
-            <a:ext cx="247254" cy="247254"/>
+            <a:off x="11300887" y="5860207"/>
+            <a:ext cx="294803" cy="294803"/>
           </a:xfrm>
           <a:prstGeom prst="rect">
             <a:avLst/>
@@ -37317,7 +37317,7 @@
         </p:nvSpPr>
         <p:spPr>
           <a:xfrm>
-            <a:off x="7132320" y="6355080"/>
+            <a:off x="7132320" y="6373368"/>
             <a:ext cx="4599432" cy="256032"/>
           </a:xfrm>
           <a:prstGeom prst="rect">

</xml_diff>

<commit_message>
NSW: the 145 returners joined a casual pool serving 600 schools, not 600 placements
The media release of 8 May 2024 says the 145 were "linked with schools to
perform casual and temporary work in more than 600 schools across the state".
The slide said "placed across more than 600 schools", which read as if each
teacher were in several schools. It now says they joined the pool of casual and
temporary teachers that serves those schools; the verbatim sentence is in the
notes.

Co-Authored-By: Claude Fable 5.1 <noreply@anthropic.com>
Claude-Session: https://claude.ai/code/session_01REVwghctKjYh8VQ919ThdA
</commit_message>
<xml_diff>
--- a/policies/Re-attracting_Former_Teachers.pptx
+++ b/policies/Re-attracting_Former_Teachers.pptx
@@ -3319,7 +3319,7 @@
             <a:r>
               <a:rPr lang="en-US" dirty="0"/>
               <a:t>Australia (New South Wales) — Instruments lit: Information &amp; nudges, Flexible re-certification, Flexible positions, Support &amp; training — Target: Switchers, Leavers, Retired.
-Sources: NSW Government media release 'Retired teachers return to classrooms' (1,500+ contacted since November 2023, 260+ interested, 145 linked with schools in 600+ schools) and the department's 'Returning teachers' page (help with re-accreditation). The 60% share returning from retirement is taken from the OECD team's spreadsheet entry, attributed to the department; no follow-up figures after May 2024 were found. Status checked in September 2026: the department's 'Returning teachers' page and the teaching authority's re-accreditation route for returning teachers are still live, so the pathway is treated as ongoing; only the reporting stopped after May 2024.
+Sources: NSW Government media release 'Retired teachers return to classrooms', 8 May 2024, verbatim: 'More than 260 retired teachers have expressed interest in returning to service, with 145 now linked with schools to perform casual and temporary work in more than 600 schools across the state.' The 600 schools are the schools the casual pool serves, not 600 placements and the department's 'Returning teachers' page (help with re-accreditation). The 60% share returning from retirement is taken from the OECD team's spreadsheet entry, attributed to the department; no follow-up figures after May 2024 were found. Status checked in September 2026: the department's 'Returning teachers' page and the teaching authority's re-accreditation route for returning teachers are still live, so the pathway is treated as ongoing; only the reporting stopped after May 2024.
 Euro amounts in brackets are approximate conversions, rounded, for orientation only.</a:t>
             </a:r>
             <a:endParaRPr lang="en-US" dirty="0"/>
@@ -33984,7 +33984,7 @@
                 <a:ea typeface="Calibri" pitchFamily="34" charset="-122"/>
                 <a:cs typeface="Calibri" pitchFamily="34" charset="-120"/>
               </a:rPr>
-              <a:t>The Department of Education contacted teachers who had resigned in the previous five years and asked them to consider coming back. Those interested were offered assistance to renew their accreditation and a placement in casual or temporary work, with the possibility of moving to a permanent post later. The initiative was launched shortly after teachers in that district received one of the largest pay rises in decades and a significant cut in administrative work. More than 1,500 former teachers were contacted; by May 2024, 260 had expressed interest and 145 were placed across more than 600 schools, about sixty percent of them coming out of retirement. As the best of our knowledge the pathway is still open.</a:t>
+              <a:t>The Department of Education contacted teachers who had resigned in the previous five years and asked them to consider coming back. Those interested were offered assistance to renew their accreditation and a placement in casual or temporary work, with the possibility of moving to a permanent post later. The initiative was launched shortly after teachers in that district received one of the largest pay rises in decades and a significant cut in administrative work. More than 1,500 former teachers were contacted; by May 2024, 260 had expressed interest and 145 had joined the pool of casual and temporary teachers that serves more than 600 schools, about sixty percent of them coming out of retirement. As the best of our knowledge the pathway is still open.</a:t>
             </a:r>
             <a:endParaRPr lang="en-US" sz="1500" dirty="0"/>
           </a:p>

</xml_diff>